<commit_message>
adding domain expert slides
</commit_message>
<xml_diff>
--- a/Project-3/presentation.pptx
+++ b/Project-3/presentation.pptx
@@ -12,6 +12,10 @@
     <p:sldId id="260" r:id="rId6"/>
     <p:sldId id="261" r:id="rId7"/>
     <p:sldId id="262" r:id="rId8"/>
+    <p:sldId id="263" r:id="rId9"/>
+    <p:sldId id="264" r:id="rId10"/>
+    <p:sldId id="265" r:id="rId11"/>
+    <p:sldId id="266" r:id="rId12"/>
   </p:sldIdLst>
   <p:sldSz cx="9144000" cy="5143500" type="screen16x9"/>
   <p:notesSz cx="6858000" cy="9144000"/>
@@ -3159,6 +3163,100 @@
 </p:sld>
 </file>
 
+<file path=ppt/slides/slide10.xml><?xml version="1.0" encoding="utf-8"?>
+<p:sld xmlns:a="http://schemas.openxmlformats.org/drawingml/2006/main" xmlns:r="http://schemas.openxmlformats.org/officeDocument/2006/relationships" xmlns:p="http://schemas.openxmlformats.org/presentationml/2006/main">
+  <p:cSld>
+    <p:spTree>
+      <p:nvGrpSpPr>
+        <p:cNvPr id="1" name=""/>
+        <p:cNvGrpSpPr/>
+        <p:nvPr/>
+      </p:nvGrpSpPr>
+      <p:grpSpPr>
+        <a:xfrm>
+          <a:off x="0" y="0"/>
+          <a:ext cx="0" cy="0"/>
+          <a:chOff x="0" y="0"/>
+          <a:chExt cx="0" cy="0"/>
+        </a:xfrm>
+      </p:grpSpPr>
+      <p:sp>
+        <p:nvSpPr>
+          <p:cNvPr id="2" name="Title 1"/>
+          <p:cNvSpPr>
+            <a:spLocks noGrp="1"/>
+          </p:cNvSpPr>
+          <p:nvPr>
+            <p:ph type="title"/>
+          </p:nvPr>
+        </p:nvSpPr>
+        <p:spPr/>
+        <p:txBody>
+          <a:bodyPr/>
+          <a:lstStyle/>
+          <a:p>
+            <a:pPr lvl="0" indent="0" marL="0">
+              <a:buNone/>
+            </a:pPr>
+            <a:r>
+              <a:rPr/>
+              <a:t>Technical Lead</a:t>
+            </a:r>
+          </a:p>
+        </p:txBody>
+      </p:sp>
+    </p:spTree>
+  </p:cSld>
+</p:sld>
+</file>
+
+<file path=ppt/slides/slide11.xml><?xml version="1.0" encoding="utf-8"?>
+<p:sld xmlns:a="http://schemas.openxmlformats.org/drawingml/2006/main" xmlns:r="http://schemas.openxmlformats.org/officeDocument/2006/relationships" xmlns:p="http://schemas.openxmlformats.org/presentationml/2006/main">
+  <p:cSld>
+    <p:spTree>
+      <p:nvGrpSpPr>
+        <p:cNvPr id="1" name=""/>
+        <p:cNvGrpSpPr/>
+        <p:nvPr/>
+      </p:nvGrpSpPr>
+      <p:grpSpPr>
+        <a:xfrm>
+          <a:off x="0" y="0"/>
+          <a:ext cx="0" cy="0"/>
+          <a:chOff x="0" y="0"/>
+          <a:chExt cx="0" cy="0"/>
+        </a:xfrm>
+      </p:grpSpPr>
+      <p:sp>
+        <p:nvSpPr>
+          <p:cNvPr id="2" name="Title 1"/>
+          <p:cNvSpPr>
+            <a:spLocks noGrp="1"/>
+          </p:cNvSpPr>
+          <p:nvPr>
+            <p:ph type="title"/>
+          </p:nvPr>
+        </p:nvSpPr>
+        <p:spPr/>
+        <p:txBody>
+          <a:bodyPr/>
+          <a:lstStyle/>
+          <a:p>
+            <a:pPr lvl="0" indent="0" marL="0">
+              <a:buNone/>
+            </a:pPr>
+            <a:r>
+              <a:rPr/>
+              <a:t>Quality Assurance</a:t>
+            </a:r>
+          </a:p>
+        </p:txBody>
+      </p:sp>
+    </p:spTree>
+  </p:cSld>
+</p:sld>
+</file>
+
 <file path=ppt/slides/slide2.xml><?xml version="1.0" encoding="utf-8"?>
 <p:sld xmlns:a="http://schemas.openxmlformats.org/drawingml/2006/main" xmlns:r="http://schemas.openxmlformats.org/officeDocument/2006/relationships" xmlns:p="http://schemas.openxmlformats.org/presentationml/2006/main">
   <p:cSld>
@@ -3196,32 +3294,7 @@
             </a:pPr>
             <a:r>
               <a:rPr/>
-              <a:t># Redwood Analytics Project 3</a:t>
-            </a:r>
-          </a:p>
-        </p:txBody>
-      </p:sp>
-      <p:sp>
-        <p:nvSpPr>
-          <p:cNvPr id="3" name="Content Placeholder 2"/>
-          <p:cNvSpPr>
-            <a:spLocks noGrp="1"/>
-          </p:cNvSpPr>
-          <p:nvPr>
-            <p:ph idx="1"/>
-          </p:nvPr>
-        </p:nvSpPr>
-        <p:spPr/>
-        <p:txBody>
-          <a:bodyPr/>
-          <a:lstStyle/>
-          <a:p>
-            <a:pPr lvl="0" indent="0" marL="0">
-              <a:buNone/>
-            </a:pPr>
-            <a:r>
-              <a:rPr/>
-              <a:t>title: “Redwood Analytics Project 3” format: pptx echo: false —</a:t>
+              <a:t>Redwood Analytics Project 3</a:t>
             </a:r>
           </a:p>
         </p:txBody>
@@ -3268,7 +3341,74 @@
             </a:pPr>
             <a:r>
               <a:rPr/>
-              <a:t>Domain Expert 1</a:t>
+              <a:t>Data Dictionary</a:t>
+            </a:r>
+          </a:p>
+        </p:txBody>
+      </p:sp>
+      <p:sp>
+        <p:nvSpPr>
+          <p:cNvPr id="3" name="Content Placeholder 2"/>
+          <p:cNvSpPr>
+            <a:spLocks noGrp="1"/>
+          </p:cNvSpPr>
+          <p:nvPr>
+            <p:ph idx="1"/>
+          </p:nvPr>
+        </p:nvSpPr>
+        <p:spPr/>
+        <p:txBody>
+          <a:bodyPr/>
+          <a:lstStyle/>
+          <a:p>
+            <a:pPr lvl="0"/>
+            <a:r>
+              <a:rPr/>
+              <a:t>UNITS</a:t>
+            </a:r>
+          </a:p>
+          <a:p>
+            <a:pPr lvl="0"/>
+            <a:r>
+              <a:rPr/>
+              <a:t>SPCD (Species Code): A numeric code which unqiuely identifies each tree species as specifed by the FIA (Forest Inventory and Analysis) species coding system. Each FIA species code corresponds uniquely to a scientific and common name. (Official definition: FIA species code.)</a:t>
+            </a:r>
+          </a:p>
+          <a:p>
+            <a:pPr lvl="0"/>
+            <a:r>
+              <a:rPr/>
+              <a:t>DO_BH (Diameter at Breast Height [Outside Bark]): Diameter of the tree stem measured at breast height (4.5 feet or 1.37 meters above ground) including bark. This is the standard foresty measurement “DBH (outside bark)” and is the primary size variable used in nearly all allometric biomass models.</a:t>
+            </a:r>
+          </a:p>
+          <a:p>
+            <a:pPr lvl="0"/>
+            <a:r>
+              <a:rPr/>
+              <a:t>HT_TOT (Total Tree Height): The total height of the tree measured from ground level to the top of the crown. Used as a second size metric in volume and biomass modeling.</a:t>
+            </a:r>
+          </a:p>
+          <a:p>
+            <a:pPr lvl="0"/>
+            <a:r>
+              <a:rPr/>
+              <a:t>TT_DW_CRM (Total Tree Dry Biomass): The total above-ground dry weight of the tree (includes stem wood, stem bark, branches, folliage). This value comes from destructive sampling: the tree was felled, seperated into componenets, oven-dried, and weighed. This variable serves as the response variable (“target”) from biomass prediction.</a:t>
+            </a:r>
+          </a:p>
+          <a:p>
+            <a:pPr lvl="0"/>
+            <a:r>
+              <a:rPr/>
+              <a:t>COMMON_NAME: The corresponding string common name for the tree species for a FIA SPCD code.</a:t>
+            </a:r>
+          </a:p>
+          <a:p>
+            <a:pPr lvl="0" indent="0" marL="0">
+              <a:buNone/>
+            </a:pPr>
+            <a:r>
+              <a:rPr/>
+              <a:t>#Domain Expert 2</a:t>
             </a:r>
           </a:p>
         </p:txBody>
@@ -3315,34 +3455,41 @@
             </a:pPr>
             <a:r>
               <a:rPr/>
-              <a:t>Domain Expert 2</a:t>
-            </a:r>
-          </a:p>
-        </p:txBody>
-      </p:sp>
-      <p:sp>
-        <p:nvSpPr>
-          <p:cNvPr id="3" name="Content Placeholder 2"/>
-          <p:cNvSpPr>
-            <a:spLocks noGrp="1"/>
-          </p:cNvSpPr>
-          <p:nvPr>
-            <p:ph idx="1"/>
-          </p:nvPr>
-        </p:nvSpPr>
-        <p:spPr/>
-        <p:txBody>
-          <a:bodyPr/>
-          <a:lstStyle/>
-          <a:p>
-            <a:pPr lvl="0"/>
-            <a:r>
-              <a:rPr/>
-              <a:t>Test</a:t>
-            </a:r>
-          </a:p>
-        </p:txBody>
-      </p:sp>
+              <a:t>Univariate Visualizations</a:t>
+            </a:r>
+          </a:p>
+        </p:txBody>
+      </p:sp>
+      <p:pic>
+        <p:nvPicPr>
+          <p:cNvPr descr="presentation_files/figure-pptx/cell-3-output-1.png" id="0" name="Picture 1"/>
+          <p:cNvPicPr>
+            <a:picLocks noGrp="1" noChangeAspect="1"/>
+          </p:cNvPicPr>
+          <p:nvPr/>
+        </p:nvPicPr>
+        <p:blipFill>
+          <a:blip r:embed="rId2"/>
+          <a:stretch>
+            <a:fillRect/>
+          </a:stretch>
+        </p:blipFill>
+        <p:spPr bwMode="auto">
+          <a:xfrm>
+            <a:off x="1346200" y="1193800"/>
+            <a:ext cx="6451600" cy="3390900"/>
+          </a:xfrm>
+          <a:prstGeom prst="rect">
+            <a:avLst/>
+          </a:prstGeom>
+          <a:noFill/>
+          <a:ln w="9525">
+            <a:noFill/>
+            <a:headEnd/>
+            <a:tailEnd/>
+          </a:ln>
+        </p:spPr>
+      </p:pic>
     </p:spTree>
   </p:cSld>
 </p:sld>
@@ -3385,11 +3532,41 @@
             </a:pPr>
             <a:r>
               <a:rPr/>
-              <a:t>Project Manager</a:t>
-            </a:r>
-          </a:p>
-        </p:txBody>
-      </p:sp>
+              <a:t>Bivariate Visualizations</a:t>
+            </a:r>
+          </a:p>
+        </p:txBody>
+      </p:sp>
+      <p:pic>
+        <p:nvPicPr>
+          <p:cNvPr descr="presentation_files/figure-pptx/cell-4-output-1.png" id="0" name="Picture 1"/>
+          <p:cNvPicPr>
+            <a:picLocks noGrp="1" noChangeAspect="1"/>
+          </p:cNvPicPr>
+          <p:nvPr/>
+        </p:nvPicPr>
+        <p:blipFill>
+          <a:blip r:embed="rId2"/>
+          <a:stretch>
+            <a:fillRect/>
+          </a:stretch>
+        </p:blipFill>
+        <p:spPr bwMode="auto">
+          <a:xfrm>
+            <a:off x="1397000" y="1193800"/>
+            <a:ext cx="6350000" cy="3390900"/>
+          </a:xfrm>
+          <a:prstGeom prst="rect">
+            <a:avLst/>
+          </a:prstGeom>
+          <a:noFill/>
+          <a:ln w="9525">
+            <a:noFill/>
+            <a:headEnd/>
+            <a:tailEnd/>
+          </a:ln>
+        </p:spPr>
+      </p:pic>
     </p:spTree>
   </p:cSld>
 </p:sld>
@@ -3432,11 +3609,41 @@
             </a:pPr>
             <a:r>
               <a:rPr/>
-              <a:t>Technical Lead</a:t>
-            </a:r>
-          </a:p>
-        </p:txBody>
-      </p:sp>
+              <a:t>Additional Visualizations</a:t>
+            </a:r>
+          </a:p>
+        </p:txBody>
+      </p:sp>
+      <p:pic>
+        <p:nvPicPr>
+          <p:cNvPr descr="presentation_files/figure-pptx/cell-5-output-1.png" id="0" name="Picture 1"/>
+          <p:cNvPicPr>
+            <a:picLocks noGrp="1" noChangeAspect="1"/>
+          </p:cNvPicPr>
+          <p:nvPr/>
+        </p:nvPicPr>
+        <p:blipFill>
+          <a:blip r:embed="rId2"/>
+          <a:stretch>
+            <a:fillRect/>
+          </a:stretch>
+        </p:blipFill>
+        <p:spPr bwMode="auto">
+          <a:xfrm>
+            <a:off x="1155700" y="1193800"/>
+            <a:ext cx="6832600" cy="3390900"/>
+          </a:xfrm>
+          <a:prstGeom prst="rect">
+            <a:avLst/>
+          </a:prstGeom>
+          <a:noFill/>
+          <a:ln w="9525">
+            <a:noFill/>
+            <a:headEnd/>
+            <a:tailEnd/>
+          </a:ln>
+        </p:spPr>
+      </p:pic>
     </p:spTree>
   </p:cSld>
 </p:sld>
@@ -3479,7 +3686,131 @@
             </a:pPr>
             <a:r>
               <a:rPr/>
-              <a:t>Quality Assurance</a:t>
+              <a:t>Additional Visualizations</a:t>
+            </a:r>
+          </a:p>
+        </p:txBody>
+      </p:sp>
+      <p:pic>
+        <p:nvPicPr>
+          <p:cNvPr descr="presentation_files/figure-pptx/cell-6-output-1.png" id="0" name="Picture 1"/>
+          <p:cNvPicPr>
+            <a:picLocks noGrp="1" noChangeAspect="1"/>
+          </p:cNvPicPr>
+          <p:nvPr/>
+        </p:nvPicPr>
+        <p:blipFill>
+          <a:blip r:embed="rId2"/>
+          <a:stretch>
+            <a:fillRect/>
+          </a:stretch>
+        </p:blipFill>
+        <p:spPr bwMode="auto">
+          <a:xfrm>
+            <a:off x="1295400" y="1193800"/>
+            <a:ext cx="6553200" cy="3390900"/>
+          </a:xfrm>
+          <a:prstGeom prst="rect">
+            <a:avLst/>
+          </a:prstGeom>
+          <a:noFill/>
+          <a:ln w="9525">
+            <a:noFill/>
+            <a:headEnd/>
+            <a:tailEnd/>
+          </a:ln>
+        </p:spPr>
+      </p:pic>
+    </p:spTree>
+  </p:cSld>
+</p:sld>
+</file>
+
+<file path=ppt/slides/slide8.xml><?xml version="1.0" encoding="utf-8"?>
+<p:sld xmlns:a="http://schemas.openxmlformats.org/drawingml/2006/main" xmlns:r="http://schemas.openxmlformats.org/officeDocument/2006/relationships" xmlns:p="http://schemas.openxmlformats.org/presentationml/2006/main">
+  <p:cSld>
+    <p:spTree>
+      <p:nvGrpSpPr>
+        <p:cNvPr id="1" name=""/>
+        <p:cNvGrpSpPr/>
+        <p:nvPr/>
+      </p:nvGrpSpPr>
+      <p:grpSpPr>
+        <a:xfrm>
+          <a:off x="0" y="0"/>
+          <a:ext cx="0" cy="0"/>
+          <a:chOff x="0" y="0"/>
+          <a:chExt cx="0" cy="0"/>
+        </a:xfrm>
+      </p:grpSpPr>
+      <p:sp>
+        <p:nvSpPr>
+          <p:cNvPr id="2" name="Title 1"/>
+          <p:cNvSpPr>
+            <a:spLocks noGrp="1"/>
+          </p:cNvSpPr>
+          <p:nvPr>
+            <p:ph type="title"/>
+          </p:nvPr>
+        </p:nvSpPr>
+        <p:spPr/>
+        <p:txBody>
+          <a:bodyPr/>
+          <a:lstStyle/>
+          <a:p>
+            <a:pPr lvl="0" indent="0" marL="0">
+              <a:buNone/>
+            </a:pPr>
+            <a:r>
+              <a:rPr/>
+              <a:t>Domain Expert 3 (Explain the inputs and settings for the best model)</a:t>
+            </a:r>
+          </a:p>
+        </p:txBody>
+      </p:sp>
+    </p:spTree>
+  </p:cSld>
+</p:sld>
+</file>
+
+<file path=ppt/slides/slide9.xml><?xml version="1.0" encoding="utf-8"?>
+<p:sld xmlns:a="http://schemas.openxmlformats.org/drawingml/2006/main" xmlns:r="http://schemas.openxmlformats.org/officeDocument/2006/relationships" xmlns:p="http://schemas.openxmlformats.org/presentationml/2006/main">
+  <p:cSld>
+    <p:spTree>
+      <p:nvGrpSpPr>
+        <p:cNvPr id="1" name=""/>
+        <p:cNvGrpSpPr/>
+        <p:nvPr/>
+      </p:nvGrpSpPr>
+      <p:grpSpPr>
+        <a:xfrm>
+          <a:off x="0" y="0"/>
+          <a:ext cx="0" cy="0"/>
+          <a:chOff x="0" y="0"/>
+          <a:chExt cx="0" cy="0"/>
+        </a:xfrm>
+      </p:grpSpPr>
+      <p:sp>
+        <p:nvSpPr>
+          <p:cNvPr id="2" name="Title 1"/>
+          <p:cNvSpPr>
+            <a:spLocks noGrp="1"/>
+          </p:cNvSpPr>
+          <p:nvPr>
+            <p:ph type="title"/>
+          </p:nvPr>
+        </p:nvSpPr>
+        <p:spPr/>
+        <p:txBody>
+          <a:bodyPr/>
+          <a:lstStyle/>
+          <a:p>
+            <a:pPr lvl="0" indent="0" marL="0">
+              <a:buNone/>
+            </a:pPr>
+            <a:r>
+              <a:rPr/>
+              <a:t>Project Manager</a:t>
             </a:r>
           </a:p>
         </p:txBody>

</xml_diff>

<commit_message>
changing to absoluting links for website
</commit_message>
<xml_diff>
--- a/Project-3/presentation.pptx
+++ b/Project-3/presentation.pptx
@@ -22,6 +22,7 @@
     <p:sldId id="270" r:id="rId16"/>
     <p:sldId id="271" r:id="rId17"/>
     <p:sldId id="272" r:id="rId18"/>
+    <p:sldId id="273" r:id="rId19"/>
   </p:sldIdLst>
   <p:sldSz cx="9144000" cy="5143500" type="screen16x9"/>
   <p:notesSz cx="6858000" cy="9144000"/>
@@ -4737,12 +4738,31 @@
           <a:bodyPr/>
           <a:lstStyle/>
           <a:p>
-            <a:pPr lvl="0" indent="0" marL="0">
-              <a:buNone/>
-            </a:pPr>
+            <a:pPr lvl="0"/>
             <a:r>
               <a:rPr/>
-              <a:t>Tree Measurement Data:</a:t>
+              <a:t>Split and filtering methods</a:t>
+            </a:r>
+          </a:p>
+          <a:p>
+            <a:pPr lvl="0"/>
+            <a:r>
+              <a:rPr/>
+              <a:t>Feature engineering (what worked and what didn’t)</a:t>
+            </a:r>
+          </a:p>
+          <a:p>
+            <a:pPr lvl="0"/>
+            <a:r>
+              <a:rPr/>
+              <a:t>Tuning k for the best model</a:t>
+            </a:r>
+          </a:p>
+          <a:p>
+            <a:pPr lvl="0"/>
+            <a:r>
+              <a:rPr/>
+              <a:t>The final “best” model and error # Tree Measurement Data:</a:t>
             </a:r>
           </a:p>
         </p:txBody>
@@ -6231,6 +6251,637 @@
 </file>
 
 <file path=ppt/slides/slide17.xml><?xml version="1.0" encoding="utf-8"?>
+<p:sld xmlns:a="http://schemas.openxmlformats.org/drawingml/2006/main" xmlns:r="http://schemas.openxmlformats.org/officeDocument/2006/relationships" xmlns:p="http://schemas.openxmlformats.org/presentationml/2006/main">
+  <p:cSld>
+    <p:spTree>
+      <p:nvGrpSpPr>
+        <p:cNvPr id="1" name=""/>
+        <p:cNvGrpSpPr/>
+        <p:nvPr/>
+      </p:nvGrpSpPr>
+      <p:grpSpPr>
+        <a:xfrm>
+          <a:off x="0" y="0"/>
+          <a:ext cx="0" cy="0"/>
+          <a:chOff x="0" y="0"/>
+          <a:chExt cx="0" cy="0"/>
+        </a:xfrm>
+      </p:grpSpPr>
+      <p:sp>
+        <p:nvSpPr>
+          <p:cNvPr id="2" name="Title 1"/>
+          <p:cNvSpPr>
+            <a:spLocks noGrp="1"/>
+          </p:cNvSpPr>
+          <p:nvPr>
+            <p:ph type="title"/>
+          </p:nvPr>
+        </p:nvSpPr>
+        <p:spPr/>
+        <p:txBody>
+          <a:bodyPr/>
+          <a:lstStyle/>
+          <a:p>
+            <a:pPr lvl="0" indent="0" marL="0">
+              <a:buNone/>
+            </a:pPr>
+            <a:r>
+              <a:rPr/>
+              <a:t>Filtered data</a:t>
+            </a:r>
+          </a:p>
+        </p:txBody>
+      </p:sp>
+      <p:graphicFrame>
+        <p:nvGraphicFramePr>
+          <p:cNvPr id="6" name="Content Placeholder 5"/>
+          <p:cNvGraphicFramePr>
+            <a:graphicFrameLocks noGrp="1"/>
+          </p:cNvGraphicFramePr>
+          <p:nvPr>
+            <p:ph idx="1"/>
+          </p:nvPr>
+        </p:nvGraphicFramePr>
+        <p:xfrm>
+          <a:off x="457200" y="1193800"/>
+          <a:ext cx="8229600" cy="3390900"/>
+        </p:xfrm>
+        <a:graphic>
+          <a:graphicData uri="http://schemas.openxmlformats.org/drawingml/2006/table">
+            <a:tbl>
+              <a:tblPr firstRow="1" bandRow="1">
+                <a:tableStyleId>{5C22544A-7EE6-4342-B048-85BDC9FD1C3A}</a:tableStyleId>
+              </a:tblPr>
+              <a:tblGrid>
+                <a:gridCol w="1371600"/>
+                <a:gridCol w="1371600"/>
+                <a:gridCol w="1371600"/>
+                <a:gridCol w="1371600"/>
+                <a:gridCol w="1371600"/>
+                <a:gridCol w="1371600"/>
+              </a:tblGrid>
+              <a:tr h="0">
+                <a:tc>
+                  <a:txBody>
+                    <a:bodyPr/>
+                    <a:lstStyle/>
+                    <a:p>
+                      <a:endParaRPr/>
+                    </a:p>
+                  </a:txBody>
+                  <a:tcPr/>
+                </a:tc>
+                <a:tc>
+                  <a:txBody>
+                    <a:bodyPr/>
+                    <a:lstStyle/>
+                    <a:p>
+                      <a:pPr lvl="0" indent="0" marL="0">
+                        <a:buNone/>
+                      </a:pPr>
+                      <a:r>
+                        <a:rPr/>
+                        <a:t>SPCD</a:t>
+                      </a:r>
+                    </a:p>
+                  </a:txBody>
+                  <a:tcPr/>
+                </a:tc>
+                <a:tc>
+                  <a:txBody>
+                    <a:bodyPr/>
+                    <a:lstStyle/>
+                    <a:p>
+                      <a:pPr lvl="0" indent="0" marL="0">
+                        <a:buNone/>
+                      </a:pPr>
+                      <a:r>
+                        <a:rPr/>
+                        <a:t>DO_BH</a:t>
+                      </a:r>
+                    </a:p>
+                  </a:txBody>
+                  <a:tcPr/>
+                </a:tc>
+                <a:tc>
+                  <a:txBody>
+                    <a:bodyPr/>
+                    <a:lstStyle/>
+                    <a:p>
+                      <a:pPr lvl="0" indent="0" marL="0">
+                        <a:buNone/>
+                      </a:pPr>
+                      <a:r>
+                        <a:rPr/>
+                        <a:t>HT_TOT</a:t>
+                      </a:r>
+                    </a:p>
+                  </a:txBody>
+                  <a:tcPr/>
+                </a:tc>
+                <a:tc>
+                  <a:txBody>
+                    <a:bodyPr/>
+                    <a:lstStyle/>
+                    <a:p>
+                      <a:pPr lvl="0" indent="0" marL="0">
+                        <a:buNone/>
+                      </a:pPr>
+                      <a:r>
+                        <a:rPr/>
+                        <a:t>TT_DW_CRM</a:t>
+                      </a:r>
+                    </a:p>
+                  </a:txBody>
+                  <a:tcPr/>
+                </a:tc>
+                <a:tc>
+                  <a:txBody>
+                    <a:bodyPr/>
+                    <a:lstStyle/>
+                    <a:p>
+                      <a:pPr lvl="0" indent="0" marL="0">
+                        <a:buNone/>
+                      </a:pPr>
+                      <a:r>
+                        <a:rPr/>
+                        <a:t>COMMON_NAME</a:t>
+                      </a:r>
+                    </a:p>
+                  </a:txBody>
+                  <a:tcPr/>
+                </a:tc>
+              </a:tr>
+              <a:tr h="0">
+                <a:tc>
+                  <a:txBody>
+                    <a:bodyPr/>
+                    <a:lstStyle/>
+                    <a:p>
+                      <a:pPr lvl="0" indent="0" marL="0">
+                        <a:buNone/>
+                      </a:pPr>
+                      <a:r>
+                        <a:rPr/>
+                        <a:t>0</a:t>
+                      </a:r>
+                    </a:p>
+                  </a:txBody>
+                </a:tc>
+                <a:tc>
+                  <a:txBody>
+                    <a:bodyPr/>
+                    <a:lstStyle/>
+                    <a:p>
+                      <a:pPr lvl="0" indent="0" marL="0">
+                        <a:buNone/>
+                      </a:pPr>
+                      <a:r>
+                        <a:rPr/>
+                        <a:t>12</a:t>
+                      </a:r>
+                    </a:p>
+                  </a:txBody>
+                </a:tc>
+                <a:tc>
+                  <a:txBody>
+                    <a:bodyPr/>
+                    <a:lstStyle/>
+                    <a:p>
+                      <a:pPr lvl="0" indent="0" marL="0">
+                        <a:buNone/>
+                      </a:pPr>
+                      <a:r>
+                        <a:rPr/>
+                        <a:t>7.5</a:t>
+                      </a:r>
+                    </a:p>
+                  </a:txBody>
+                </a:tc>
+                <a:tc>
+                  <a:txBody>
+                    <a:bodyPr/>
+                    <a:lstStyle/>
+                    <a:p>
+                      <a:pPr lvl="0" indent="0" marL="0">
+                        <a:buNone/>
+                      </a:pPr>
+                      <a:r>
+                        <a:rPr/>
+                        <a:t>45.2</a:t>
+                      </a:r>
+                    </a:p>
+                  </a:txBody>
+                </a:tc>
+                <a:tc>
+                  <a:txBody>
+                    <a:bodyPr/>
+                    <a:lstStyle/>
+                    <a:p>
+                      <a:pPr lvl="0" indent="0" marL="0">
+                        <a:buNone/>
+                      </a:pPr>
+                      <a:r>
+                        <a:rPr/>
+                        <a:t>178.86</a:t>
+                      </a:r>
+                    </a:p>
+                  </a:txBody>
+                </a:tc>
+                <a:tc>
+                  <a:txBody>
+                    <a:bodyPr/>
+                    <a:lstStyle/>
+                    <a:p>
+                      <a:pPr lvl="0" indent="0" marL="0">
+                        <a:buNone/>
+                      </a:pPr>
+                      <a:r>
+                        <a:rPr/>
+                        <a:t>balsam fir</a:t>
+                      </a:r>
+                    </a:p>
+                  </a:txBody>
+                </a:tc>
+              </a:tr>
+              <a:tr h="0">
+                <a:tc>
+                  <a:txBody>
+                    <a:bodyPr/>
+                    <a:lstStyle/>
+                    <a:p>
+                      <a:pPr lvl="0" indent="0" marL="0">
+                        <a:buNone/>
+                      </a:pPr>
+                      <a:r>
+                        <a:rPr/>
+                        <a:t>1</a:t>
+                      </a:r>
+                    </a:p>
+                  </a:txBody>
+                </a:tc>
+                <a:tc>
+                  <a:txBody>
+                    <a:bodyPr/>
+                    <a:lstStyle/>
+                    <a:p>
+                      <a:pPr lvl="0" indent="0" marL="0">
+                        <a:buNone/>
+                      </a:pPr>
+                      <a:r>
+                        <a:rPr/>
+                        <a:t>12</a:t>
+                      </a:r>
+                    </a:p>
+                  </a:txBody>
+                </a:tc>
+                <a:tc>
+                  <a:txBody>
+                    <a:bodyPr/>
+                    <a:lstStyle/>
+                    <a:p>
+                      <a:pPr lvl="0" indent="0" marL="0">
+                        <a:buNone/>
+                      </a:pPr>
+                      <a:r>
+                        <a:rPr/>
+                        <a:t>9.3</a:t>
+                      </a:r>
+                    </a:p>
+                  </a:txBody>
+                </a:tc>
+                <a:tc>
+                  <a:txBody>
+                    <a:bodyPr/>
+                    <a:lstStyle/>
+                    <a:p>
+                      <a:pPr lvl="0" indent="0" marL="0">
+                        <a:buNone/>
+                      </a:pPr>
+                      <a:r>
+                        <a:rPr/>
+                        <a:t>62.7</a:t>
+                      </a:r>
+                    </a:p>
+                  </a:txBody>
+                </a:tc>
+                <a:tc>
+                  <a:txBody>
+                    <a:bodyPr/>
+                    <a:lstStyle/>
+                    <a:p>
+                      <a:pPr lvl="0" indent="0" marL="0">
+                        <a:buNone/>
+                      </a:pPr>
+                      <a:r>
+                        <a:rPr/>
+                        <a:t>323.46</a:t>
+                      </a:r>
+                    </a:p>
+                  </a:txBody>
+                </a:tc>
+                <a:tc>
+                  <a:txBody>
+                    <a:bodyPr/>
+                    <a:lstStyle/>
+                    <a:p>
+                      <a:pPr lvl="0" indent="0" marL="0">
+                        <a:buNone/>
+                      </a:pPr>
+                      <a:r>
+                        <a:rPr/>
+                        <a:t>balsam fir</a:t>
+                      </a:r>
+                    </a:p>
+                  </a:txBody>
+                </a:tc>
+              </a:tr>
+              <a:tr h="0">
+                <a:tc>
+                  <a:txBody>
+                    <a:bodyPr/>
+                    <a:lstStyle/>
+                    <a:p>
+                      <a:pPr lvl="0" indent="0" marL="0">
+                        <a:buNone/>
+                      </a:pPr>
+                      <a:r>
+                        <a:rPr/>
+                        <a:t>2</a:t>
+                      </a:r>
+                    </a:p>
+                  </a:txBody>
+                </a:tc>
+                <a:tc>
+                  <a:txBody>
+                    <a:bodyPr/>
+                    <a:lstStyle/>
+                    <a:p>
+                      <a:pPr lvl="0" indent="0" marL="0">
+                        <a:buNone/>
+                      </a:pPr>
+                      <a:r>
+                        <a:rPr/>
+                        <a:t>12</a:t>
+                      </a:r>
+                    </a:p>
+                  </a:txBody>
+                </a:tc>
+                <a:tc>
+                  <a:txBody>
+                    <a:bodyPr/>
+                    <a:lstStyle/>
+                    <a:p>
+                      <a:pPr lvl="0" indent="0" marL="0">
+                        <a:buNone/>
+                      </a:pPr>
+                      <a:r>
+                        <a:rPr/>
+                        <a:t>9.7</a:t>
+                      </a:r>
+                    </a:p>
+                  </a:txBody>
+                </a:tc>
+                <a:tc>
+                  <a:txBody>
+                    <a:bodyPr/>
+                    <a:lstStyle/>
+                    <a:p>
+                      <a:pPr lvl="0" indent="0" marL="0">
+                        <a:buNone/>
+                      </a:pPr>
+                      <a:r>
+                        <a:rPr/>
+                        <a:t>56.7</a:t>
+                      </a:r>
+                    </a:p>
+                  </a:txBody>
+                </a:tc>
+                <a:tc>
+                  <a:txBody>
+                    <a:bodyPr/>
+                    <a:lstStyle/>
+                    <a:p>
+                      <a:pPr lvl="0" indent="0" marL="0">
+                        <a:buNone/>
+                      </a:pPr>
+                      <a:r>
+                        <a:rPr/>
+                        <a:t>342.47</a:t>
+                      </a:r>
+                    </a:p>
+                  </a:txBody>
+                </a:tc>
+                <a:tc>
+                  <a:txBody>
+                    <a:bodyPr/>
+                    <a:lstStyle/>
+                    <a:p>
+                      <a:pPr lvl="0" indent="0" marL="0">
+                        <a:buNone/>
+                      </a:pPr>
+                      <a:r>
+                        <a:rPr/>
+                        <a:t>balsam fir</a:t>
+                      </a:r>
+                    </a:p>
+                  </a:txBody>
+                </a:tc>
+              </a:tr>
+              <a:tr h="0">
+                <a:tc>
+                  <a:txBody>
+                    <a:bodyPr/>
+                    <a:lstStyle/>
+                    <a:p>
+                      <a:pPr lvl="0" indent="0" marL="0">
+                        <a:buNone/>
+                      </a:pPr>
+                      <a:r>
+                        <a:rPr/>
+                        <a:t>3</a:t>
+                      </a:r>
+                    </a:p>
+                  </a:txBody>
+                </a:tc>
+                <a:tc>
+                  <a:txBody>
+                    <a:bodyPr/>
+                    <a:lstStyle/>
+                    <a:p>
+                      <a:pPr lvl="0" indent="0" marL="0">
+                        <a:buNone/>
+                      </a:pPr>
+                      <a:r>
+                        <a:rPr/>
+                        <a:t>12</a:t>
+                      </a:r>
+                    </a:p>
+                  </a:txBody>
+                </a:tc>
+                <a:tc>
+                  <a:txBody>
+                    <a:bodyPr/>
+                    <a:lstStyle/>
+                    <a:p>
+                      <a:pPr lvl="0" indent="0" marL="0">
+                        <a:buNone/>
+                      </a:pPr>
+                      <a:r>
+                        <a:rPr/>
+                        <a:t>11.4</a:t>
+                      </a:r>
+                    </a:p>
+                  </a:txBody>
+                </a:tc>
+                <a:tc>
+                  <a:txBody>
+                    <a:bodyPr/>
+                    <a:lstStyle/>
+                    <a:p>
+                      <a:pPr lvl="0" indent="0" marL="0">
+                        <a:buNone/>
+                      </a:pPr>
+                      <a:r>
+                        <a:rPr/>
+                        <a:t>66.1</a:t>
+                      </a:r>
+                    </a:p>
+                  </a:txBody>
+                </a:tc>
+                <a:tc>
+                  <a:txBody>
+                    <a:bodyPr/>
+                    <a:lstStyle/>
+                    <a:p>
+                      <a:pPr lvl="0" indent="0" marL="0">
+                        <a:buNone/>
+                      </a:pPr>
+                      <a:r>
+                        <a:rPr/>
+                        <a:t>499.35</a:t>
+                      </a:r>
+                    </a:p>
+                  </a:txBody>
+                </a:tc>
+                <a:tc>
+                  <a:txBody>
+                    <a:bodyPr/>
+                    <a:lstStyle/>
+                    <a:p>
+                      <a:pPr lvl="0" indent="0" marL="0">
+                        <a:buNone/>
+                      </a:pPr>
+                      <a:r>
+                        <a:rPr/>
+                        <a:t>balsam fir</a:t>
+                      </a:r>
+                    </a:p>
+                  </a:txBody>
+                </a:tc>
+              </a:tr>
+              <a:tr h="0">
+                <a:tc>
+                  <a:txBody>
+                    <a:bodyPr/>
+                    <a:lstStyle/>
+                    <a:p>
+                      <a:pPr lvl="0" indent="0" marL="0">
+                        <a:buNone/>
+                      </a:pPr>
+                      <a:r>
+                        <a:rPr/>
+                        <a:t>4</a:t>
+                      </a:r>
+                    </a:p>
+                  </a:txBody>
+                </a:tc>
+                <a:tc>
+                  <a:txBody>
+                    <a:bodyPr/>
+                    <a:lstStyle/>
+                    <a:p>
+                      <a:pPr lvl="0" indent="0" marL="0">
+                        <a:buNone/>
+                      </a:pPr>
+                      <a:r>
+                        <a:rPr/>
+                        <a:t>12</a:t>
+                      </a:r>
+                    </a:p>
+                  </a:txBody>
+                </a:tc>
+                <a:tc>
+                  <a:txBody>
+                    <a:bodyPr/>
+                    <a:lstStyle/>
+                    <a:p>
+                      <a:pPr lvl="0" indent="0" marL="0">
+                        <a:buNone/>
+                      </a:pPr>
+                      <a:r>
+                        <a:rPr/>
+                        <a:t>6.4</a:t>
+                      </a:r>
+                    </a:p>
+                  </a:txBody>
+                </a:tc>
+                <a:tc>
+                  <a:txBody>
+                    <a:bodyPr/>
+                    <a:lstStyle/>
+                    <a:p>
+                      <a:pPr lvl="0" indent="0" marL="0">
+                        <a:buNone/>
+                      </a:pPr>
+                      <a:r>
+                        <a:rPr/>
+                        <a:t>51.8</a:t>
+                      </a:r>
+                    </a:p>
+                  </a:txBody>
+                </a:tc>
+                <a:tc>
+                  <a:txBody>
+                    <a:bodyPr/>
+                    <a:lstStyle/>
+                    <a:p>
+                      <a:pPr lvl="0" indent="0" marL="0">
+                        <a:buNone/>
+                      </a:pPr>
+                      <a:r>
+                        <a:rPr/>
+                        <a:t>113.92</a:t>
+                      </a:r>
+                    </a:p>
+                  </a:txBody>
+                </a:tc>
+                <a:tc>
+                  <a:txBody>
+                    <a:bodyPr/>
+                    <a:lstStyle/>
+                    <a:p>
+                      <a:pPr lvl="0" indent="0" marL="0">
+                        <a:buNone/>
+                      </a:pPr>
+                      <a:r>
+                        <a:rPr/>
+                        <a:t>balsam fir</a:t>
+                      </a:r>
+                    </a:p>
+                  </a:txBody>
+                </a:tc>
+              </a:tr>
+            </a:tbl>
+          </a:graphicData>
+        </a:graphic>
+      </p:graphicFrame>
+    </p:spTree>
+  </p:cSld>
+</p:sld>
+</file>
+
+<file path=ppt/slides/slide18.xml><?xml version="1.0" encoding="utf-8"?>
 <p:sld xmlns:a="http://schemas.openxmlformats.org/drawingml/2006/main" xmlns:r="http://schemas.openxmlformats.org/officeDocument/2006/relationships" xmlns:p="http://schemas.openxmlformats.org/presentationml/2006/main">
   <p:cSld>
     <p:spTree>

</xml_diff>

<commit_message>
distributed the performance metric and add random things to make the 10 min mark
</commit_message>
<xml_diff>
--- a/Project-3/presentation.pptx
+++ b/Project-3/presentation.pptx
@@ -22,6 +22,8 @@
     <p:sldId id="270" r:id="rId16"/>
     <p:sldId id="271" r:id="rId17"/>
     <p:sldId id="272" r:id="rId18"/>
+    <p:sldId id="273" r:id="rId19"/>
+    <p:sldId id="274" r:id="rId20"/>
   </p:sldIdLst>
   <p:sldSz cx="9144000" cy="5143500" type="screen16x9"/>
   <p:notesSz cx="6858000" cy="9144000"/>
@@ -3457,7 +3459,7 @@
             </a:pPr>
             <a:r>
               <a:rPr/>
-              <a:t>Performance Metric</a:t>
+              <a:t>Insights</a:t>
             </a:r>
           </a:p>
         </p:txBody>
@@ -3477,12 +3479,17 @@
           <a:bodyPr/>
           <a:lstStyle/>
           <a:p>
-            <a:pPr lvl="0" indent="0" marL="0">
-              <a:buNone/>
-            </a:pPr>
+            <a:pPr lvl="0"/>
             <a:r>
               <a:rPr/>
-              <a:t>The Performance metric we choose is Root Mean Square Logarithmic Error(RMSLE), because when we were looking at the dataset of the biomass of different kinds of tree species, we saw that some species have more data than other species so the assume that the data is skewed</a:t>
+              <a:t>When predicting tree biomass, employ the performance metric root mean square logarithmic error since biomass data varies greatly, ranging from tiny saplings to enormous unc trees, some trees having exponential growth.</a:t>
+            </a:r>
+          </a:p>
+          <a:p>
+            <a:pPr lvl="0"/>
+            <a:r>
+              <a:rPr/>
+              <a:t>We chose kNN regression over linear regression because, according to science, most UNC trees grow exponentially, which makes us think that kNN regression would be more accurate than linear regression.</a:t>
             </a:r>
           </a:p>
         </p:txBody>
@@ -3529,1147 +3536,45 @@
             </a:pPr>
             <a:r>
               <a:rPr/>
-              <a:t>Model</a:t>
+              <a:t>Performance Metric</a:t>
             </a:r>
           </a:p>
         </p:txBody>
       </p:sp>
-      <p:graphicFrame>
-        <p:nvGraphicFramePr>
-          <p:cNvPr id="6" name="Content Placeholder 5"/>
-          <p:cNvGraphicFramePr>
-            <a:graphicFrameLocks noGrp="1"/>
-          </p:cNvGraphicFramePr>
+      <p:sp>
+        <p:nvSpPr>
+          <p:cNvPr id="3" name="Content Placeholder 2"/>
+          <p:cNvSpPr>
+            <a:spLocks noGrp="1"/>
+          </p:cNvSpPr>
           <p:nvPr>
             <p:ph idx="1"/>
           </p:nvPr>
-        </p:nvGraphicFramePr>
-        <p:xfrm>
-          <a:off x="457200" y="1193800"/>
-          <a:ext cx="8229600" cy="3390900"/>
-        </p:xfrm>
-        <a:graphic>
-          <a:graphicData uri="http://schemas.openxmlformats.org/drawingml/2006/table">
-            <a:tbl>
-              <a:tblPr firstRow="1" bandRow="1">
-                <a:tableStyleId>{5C22544A-7EE6-4342-B048-85BDC9FD1C3A}</a:tableStyleId>
-              </a:tblPr>
-              <a:tblGrid>
-                <a:gridCol w="1371600"/>
-                <a:gridCol w="1371600"/>
-                <a:gridCol w="1371600"/>
-                <a:gridCol w="1371600"/>
-                <a:gridCol w="1371600"/>
-                <a:gridCol w="1371600"/>
-              </a:tblGrid>
-              <a:tr h="0">
-                <a:tc>
-                  <a:txBody>
-                    <a:bodyPr/>
-                    <a:lstStyle/>
-                    <a:p>
-                      <a:endParaRPr/>
-                    </a:p>
-                  </a:txBody>
-                  <a:tcPr/>
-                </a:tc>
-                <a:tc>
-                  <a:txBody>
-                    <a:bodyPr/>
-                    <a:lstStyle/>
-                    <a:p>
-                      <a:pPr lvl="0" indent="0" marL="0">
-                        <a:buNone/>
-                      </a:pPr>
-                      <a:r>
-                        <a:rPr/>
-                        <a:t>Species</a:t>
-                      </a:r>
-                    </a:p>
-                  </a:txBody>
-                  <a:tcPr/>
-                </a:tc>
-                <a:tc>
-                  <a:txBody>
-                    <a:bodyPr/>
-                    <a:lstStyle/>
-                    <a:p>
-                      <a:pPr lvl="0" indent="0" marL="0">
-                        <a:buNone/>
-                      </a:pPr>
-                      <a:r>
-                        <a:rPr/>
-                        <a:t>k</a:t>
-                      </a:r>
-                    </a:p>
-                  </a:txBody>
-                  <a:tcPr/>
-                </a:tc>
-                <a:tc>
-                  <a:txBody>
-                    <a:bodyPr/>
-                    <a:lstStyle/>
-                    <a:p>
-                      <a:pPr lvl="0" indent="0" marL="0">
-                        <a:buNone/>
-                      </a:pPr>
-                      <a:r>
-                        <a:rPr/>
-                        <a:t>RMSE</a:t>
-                      </a:r>
-                    </a:p>
-                  </a:txBody>
-                  <a:tcPr/>
-                </a:tc>
-                <a:tc>
-                  <a:txBody>
-                    <a:bodyPr/>
-                    <a:lstStyle/>
-                    <a:p>
-                      <a:pPr lvl="0" indent="0" marL="0">
-                        <a:buNone/>
-                      </a:pPr>
-                      <a:r>
-                        <a:rPr/>
-                        <a:t>MAE</a:t>
-                      </a:r>
-                    </a:p>
-                  </a:txBody>
-                  <a:tcPr/>
-                </a:tc>
-                <a:tc>
-                  <a:txBody>
-                    <a:bodyPr/>
-                    <a:lstStyle/>
-                    <a:p>
-                      <a:pPr lvl="0" indent="0" marL="0">
-                        <a:buNone/>
-                      </a:pPr>
-                      <a:r>
-                        <a:rPr/>
-                        <a:t>RMSLE</a:t>
-                      </a:r>
-                    </a:p>
-                  </a:txBody>
-                  <a:tcPr/>
-                </a:tc>
-              </a:tr>
-              <a:tr h="0">
-                <a:tc>
-                  <a:txBody>
-                    <a:bodyPr/>
-                    <a:lstStyle/>
-                    <a:p>
-                      <a:pPr lvl="0" indent="0" marL="0">
-                        <a:buNone/>
-                      </a:pPr>
-                      <a:r>
-                        <a:rPr/>
-                        <a:t>0</a:t>
-                      </a:r>
-                    </a:p>
-                  </a:txBody>
-                </a:tc>
-                <a:tc>
-                  <a:txBody>
-                    <a:bodyPr/>
-                    <a:lstStyle/>
-                    <a:p>
-                      <a:pPr lvl="0" indent="0" marL="0">
-                        <a:buNone/>
-                      </a:pPr>
-                      <a:r>
-                        <a:rPr/>
-                        <a:t>balsam fir</a:t>
-                      </a:r>
-                    </a:p>
-                  </a:txBody>
-                </a:tc>
-                <a:tc>
-                  <a:txBody>
-                    <a:bodyPr/>
-                    <a:lstStyle/>
-                    <a:p>
-                      <a:pPr lvl="0" indent="0" marL="0">
-                        <a:buNone/>
-                      </a:pPr>
-                      <a:r>
-                        <a:rPr/>
-                        <a:t>2</a:t>
-                      </a:r>
-                    </a:p>
-                  </a:txBody>
-                </a:tc>
-                <a:tc>
-                  <a:txBody>
-                    <a:bodyPr/>
-                    <a:lstStyle/>
-                    <a:p>
-                      <a:pPr lvl="0" indent="0" marL="0">
-                        <a:buNone/>
-                      </a:pPr>
-                      <a:r>
-                        <a:rPr/>
-                        <a:t>125.825473</a:t>
-                      </a:r>
-                    </a:p>
-                  </a:txBody>
-                </a:tc>
-                <a:tc>
-                  <a:txBody>
-                    <a:bodyPr/>
-                    <a:lstStyle/>
-                    <a:p>
-                      <a:pPr lvl="0" indent="0" marL="0">
-                        <a:buNone/>
-                      </a:pPr>
-                      <a:r>
-                        <a:rPr/>
-                        <a:t>34.801913</a:t>
-                      </a:r>
-                    </a:p>
-                  </a:txBody>
-                </a:tc>
-                <a:tc>
-                  <a:txBody>
-                    <a:bodyPr/>
-                    <a:lstStyle/>
-                    <a:p>
-                      <a:pPr lvl="0" indent="0" marL="0">
-                        <a:buNone/>
-                      </a:pPr>
-                      <a:r>
-                        <a:rPr/>
-                        <a:t>0.119574</a:t>
-                      </a:r>
-                    </a:p>
-                  </a:txBody>
-                </a:tc>
-              </a:tr>
-              <a:tr h="0">
-                <a:tc>
-                  <a:txBody>
-                    <a:bodyPr/>
-                    <a:lstStyle/>
-                    <a:p>
-                      <a:pPr lvl="0" indent="0" marL="0">
-                        <a:buNone/>
-                      </a:pPr>
-                      <a:r>
-                        <a:rPr/>
-                        <a:t>1</a:t>
-                      </a:r>
-                    </a:p>
-                  </a:txBody>
-                </a:tc>
-                <a:tc>
-                  <a:txBody>
-                    <a:bodyPr/>
-                    <a:lstStyle/>
-                    <a:p>
-                      <a:pPr lvl="0" indent="0" marL="0">
-                        <a:buNone/>
-                      </a:pPr>
-                      <a:r>
-                        <a:rPr/>
-                        <a:t>balsam fir</a:t>
-                      </a:r>
-                    </a:p>
-                  </a:txBody>
-                </a:tc>
-                <a:tc>
-                  <a:txBody>
-                    <a:bodyPr/>
-                    <a:lstStyle/>
-                    <a:p>
-                      <a:pPr lvl="0" indent="0" marL="0">
-                        <a:buNone/>
-                      </a:pPr>
-                      <a:r>
-                        <a:rPr/>
-                        <a:t>3</a:t>
-                      </a:r>
-                    </a:p>
-                  </a:txBody>
-                </a:tc>
-                <a:tc>
-                  <a:txBody>
-                    <a:bodyPr/>
-                    <a:lstStyle/>
-                    <a:p>
-                      <a:pPr lvl="0" indent="0" marL="0">
-                        <a:buNone/>
-                      </a:pPr>
-                      <a:r>
-                        <a:rPr/>
-                        <a:t>129.651479</a:t>
-                      </a:r>
-                    </a:p>
-                  </a:txBody>
-                </a:tc>
-                <a:tc>
-                  <a:txBody>
-                    <a:bodyPr/>
-                    <a:lstStyle/>
-                    <a:p>
-                      <a:pPr lvl="0" indent="0" marL="0">
-                        <a:buNone/>
-                      </a:pPr>
-                      <a:r>
-                        <a:rPr/>
-                        <a:t>36.646493</a:t>
-                      </a:r>
-                    </a:p>
-                  </a:txBody>
-                </a:tc>
-                <a:tc>
-                  <a:txBody>
-                    <a:bodyPr/>
-                    <a:lstStyle/>
-                    <a:p>
-                      <a:pPr lvl="0" indent="0" marL="0">
-                        <a:buNone/>
-                      </a:pPr>
-                      <a:r>
-                        <a:rPr/>
-                        <a:t>0.123724</a:t>
-                      </a:r>
-                    </a:p>
-                  </a:txBody>
-                </a:tc>
-              </a:tr>
-              <a:tr h="0">
-                <a:tc>
-                  <a:txBody>
-                    <a:bodyPr/>
-                    <a:lstStyle/>
-                    <a:p>
-                      <a:pPr lvl="0" indent="0" marL="0">
-                        <a:buNone/>
-                      </a:pPr>
-                      <a:r>
-                        <a:rPr/>
-                        <a:t>2</a:t>
-                      </a:r>
-                    </a:p>
-                  </a:txBody>
-                </a:tc>
-                <a:tc>
-                  <a:txBody>
-                    <a:bodyPr/>
-                    <a:lstStyle/>
-                    <a:p>
-                      <a:pPr lvl="0" indent="0" marL="0">
-                        <a:buNone/>
-                      </a:pPr>
-                      <a:r>
-                        <a:rPr/>
-                        <a:t>balsam fir</a:t>
-                      </a:r>
-                    </a:p>
-                  </a:txBody>
-                </a:tc>
-                <a:tc>
-                  <a:txBody>
-                    <a:bodyPr/>
-                    <a:lstStyle/>
-                    <a:p>
-                      <a:pPr lvl="0" indent="0" marL="0">
-                        <a:buNone/>
-                      </a:pPr>
-                      <a:r>
-                        <a:rPr/>
-                        <a:t>4</a:t>
-                      </a:r>
-                    </a:p>
-                  </a:txBody>
-                </a:tc>
-                <a:tc>
-                  <a:txBody>
-                    <a:bodyPr/>
-                    <a:lstStyle/>
-                    <a:p>
-                      <a:pPr lvl="0" indent="0" marL="0">
-                        <a:buNone/>
-                      </a:pPr>
-                      <a:r>
-                        <a:rPr/>
-                        <a:t>134.599829</a:t>
-                      </a:r>
-                    </a:p>
-                  </a:txBody>
-                </a:tc>
-                <a:tc>
-                  <a:txBody>
-                    <a:bodyPr/>
-                    <a:lstStyle/>
-                    <a:p>
-                      <a:pPr lvl="0" indent="0" marL="0">
-                        <a:buNone/>
-                      </a:pPr>
-                      <a:r>
-                        <a:rPr/>
-                        <a:t>38.884870</a:t>
-                      </a:r>
-                    </a:p>
-                  </a:txBody>
-                </a:tc>
-                <a:tc>
-                  <a:txBody>
-                    <a:bodyPr/>
-                    <a:lstStyle/>
-                    <a:p>
-                      <a:pPr lvl="0" indent="0" marL="0">
-                        <a:buNone/>
-                      </a:pPr>
-                      <a:r>
-                        <a:rPr/>
-                        <a:t>0.133858</a:t>
-                      </a:r>
-                    </a:p>
-                  </a:txBody>
-                </a:tc>
-              </a:tr>
-              <a:tr h="0">
-                <a:tc>
-                  <a:txBody>
-                    <a:bodyPr/>
-                    <a:lstStyle/>
-                    <a:p>
-                      <a:pPr lvl="0" indent="0" marL="0">
-                        <a:buNone/>
-                      </a:pPr>
-                      <a:r>
-                        <a:rPr/>
-                        <a:t>3</a:t>
-                      </a:r>
-                    </a:p>
-                  </a:txBody>
-                </a:tc>
-                <a:tc>
-                  <a:txBody>
-                    <a:bodyPr/>
-                    <a:lstStyle/>
-                    <a:p>
-                      <a:pPr lvl="0" indent="0" marL="0">
-                        <a:buNone/>
-                      </a:pPr>
-                      <a:r>
-                        <a:rPr/>
-                        <a:t>balsam fir</a:t>
-                      </a:r>
-                    </a:p>
-                  </a:txBody>
-                </a:tc>
-                <a:tc>
-                  <a:txBody>
-                    <a:bodyPr/>
-                    <a:lstStyle/>
-                    <a:p>
-                      <a:pPr lvl="0" indent="0" marL="0">
-                        <a:buNone/>
-                      </a:pPr>
-                      <a:r>
-                        <a:rPr/>
-                        <a:t>5</a:t>
-                      </a:r>
-                    </a:p>
-                  </a:txBody>
-                </a:tc>
-                <a:tc>
-                  <a:txBody>
-                    <a:bodyPr/>
-                    <a:lstStyle/>
-                    <a:p>
-                      <a:pPr lvl="0" indent="0" marL="0">
-                        <a:buNone/>
-                      </a:pPr>
-                      <a:r>
-                        <a:rPr/>
-                        <a:t>145.003601</a:t>
-                      </a:r>
-                    </a:p>
-                  </a:txBody>
-                </a:tc>
-                <a:tc>
-                  <a:txBody>
-                    <a:bodyPr/>
-                    <a:lstStyle/>
-                    <a:p>
-                      <a:pPr lvl="0" indent="0" marL="0">
-                        <a:buNone/>
-                      </a:pPr>
-                      <a:r>
-                        <a:rPr/>
-                        <a:t>41.209530</a:t>
-                      </a:r>
-                    </a:p>
-                  </a:txBody>
-                </a:tc>
-                <a:tc>
-                  <a:txBody>
-                    <a:bodyPr/>
-                    <a:lstStyle/>
-                    <a:p>
-                      <a:pPr lvl="0" indent="0" marL="0">
-                        <a:buNone/>
-                      </a:pPr>
-                      <a:r>
-                        <a:rPr/>
-                        <a:t>0.144063</a:t>
-                      </a:r>
-                    </a:p>
-                  </a:txBody>
-                </a:tc>
-              </a:tr>
-              <a:tr h="0">
-                <a:tc>
-                  <a:txBody>
-                    <a:bodyPr/>
-                    <a:lstStyle/>
-                    <a:p>
-                      <a:pPr lvl="0" indent="0" marL="0">
-                        <a:buNone/>
-                      </a:pPr>
-                      <a:r>
-                        <a:rPr/>
-                        <a:t>4</a:t>
-                      </a:r>
-                    </a:p>
-                  </a:txBody>
-                </a:tc>
-                <a:tc>
-                  <a:txBody>
-                    <a:bodyPr/>
-                    <a:lstStyle/>
-                    <a:p>
-                      <a:pPr lvl="0" indent="0" marL="0">
-                        <a:buNone/>
-                      </a:pPr>
-                      <a:r>
-                        <a:rPr/>
-                        <a:t>balsam fir</a:t>
-                      </a:r>
-                    </a:p>
-                  </a:txBody>
-                </a:tc>
-                <a:tc>
-                  <a:txBody>
-                    <a:bodyPr/>
-                    <a:lstStyle/>
-                    <a:p>
-                      <a:pPr lvl="0" indent="0" marL="0">
-                        <a:buNone/>
-                      </a:pPr>
-                      <a:r>
-                        <a:rPr/>
-                        <a:t>6</a:t>
-                      </a:r>
-                    </a:p>
-                  </a:txBody>
-                </a:tc>
-                <a:tc>
-                  <a:txBody>
-                    <a:bodyPr/>
-                    <a:lstStyle/>
-                    <a:p>
-                      <a:pPr lvl="0" indent="0" marL="0">
-                        <a:buNone/>
-                      </a:pPr>
-                      <a:r>
-                        <a:rPr/>
-                        <a:t>147.451321</a:t>
-                      </a:r>
-                    </a:p>
-                  </a:txBody>
-                </a:tc>
-                <a:tc>
-                  <a:txBody>
-                    <a:bodyPr/>
-                    <a:lstStyle/>
-                    <a:p>
-                      <a:pPr lvl="0" indent="0" marL="0">
-                        <a:buNone/>
-                      </a:pPr>
-                      <a:r>
-                        <a:rPr/>
-                        <a:t>40.791681</a:t>
-                      </a:r>
-                    </a:p>
-                  </a:txBody>
-                </a:tc>
-                <a:tc>
-                  <a:txBody>
-                    <a:bodyPr/>
-                    <a:lstStyle/>
-                    <a:p>
-                      <a:pPr lvl="0" indent="0" marL="0">
-                        <a:buNone/>
-                      </a:pPr>
-                      <a:r>
-                        <a:rPr/>
-                        <a:t>0.142862</a:t>
-                      </a:r>
-                    </a:p>
-                  </a:txBody>
-                </a:tc>
-              </a:tr>
-              <a:tr h="0">
-                <a:tc>
-                  <a:txBody>
-                    <a:bodyPr/>
-                    <a:lstStyle/>
-                    <a:p>
-                      <a:pPr lvl="0" indent="0" marL="0">
-                        <a:buNone/>
-                      </a:pPr>
-                      <a:r>
-                        <a:rPr/>
-                        <a:t>...</a:t>
-                      </a:r>
-                    </a:p>
-                  </a:txBody>
-                </a:tc>
-                <a:tc>
-                  <a:txBody>
-                    <a:bodyPr/>
-                    <a:lstStyle/>
-                    <a:p>
-                      <a:pPr lvl="0" indent="0" marL="0">
-                        <a:buNone/>
-                      </a:pPr>
-                      <a:r>
-                        <a:rPr/>
-                        <a:t>...</a:t>
-                      </a:r>
-                    </a:p>
-                  </a:txBody>
-                </a:tc>
-                <a:tc>
-                  <a:txBody>
-                    <a:bodyPr/>
-                    <a:lstStyle/>
-                    <a:p>
-                      <a:pPr lvl="0" indent="0" marL="0">
-                        <a:buNone/>
-                      </a:pPr>
-                      <a:r>
-                        <a:rPr/>
-                        <a:t>...</a:t>
-                      </a:r>
-                    </a:p>
-                  </a:txBody>
-                </a:tc>
-                <a:tc>
-                  <a:txBody>
-                    <a:bodyPr/>
-                    <a:lstStyle/>
-                    <a:p>
-                      <a:pPr lvl="0" indent="0" marL="0">
-                        <a:buNone/>
-                      </a:pPr>
-                      <a:r>
-                        <a:rPr/>
-                        <a:t>...</a:t>
-                      </a:r>
-                    </a:p>
-                  </a:txBody>
-                </a:tc>
-                <a:tc>
-                  <a:txBody>
-                    <a:bodyPr/>
-                    <a:lstStyle/>
-                    <a:p>
-                      <a:pPr lvl="0" indent="0" marL="0">
-                        <a:buNone/>
-                      </a:pPr>
-                      <a:r>
-                        <a:rPr/>
-                        <a:t>...</a:t>
-                      </a:r>
-                    </a:p>
-                  </a:txBody>
-                </a:tc>
-                <a:tc>
-                  <a:txBody>
-                    <a:bodyPr/>
-                    <a:lstStyle/>
-                    <a:p>
-                      <a:pPr lvl="0" indent="0" marL="0">
-                        <a:buNone/>
-                      </a:pPr>
-                      <a:r>
-                        <a:rPr/>
-                        <a:t>...</a:t>
-                      </a:r>
-                    </a:p>
-                  </a:txBody>
-                </a:tc>
-              </a:tr>
-              <a:tr h="0">
-                <a:tc>
-                  <a:txBody>
-                    <a:bodyPr/>
-                    <a:lstStyle/>
-                    <a:p>
-                      <a:pPr lvl="0" indent="0" marL="0">
-                        <a:buNone/>
-                      </a:pPr>
-                      <a:r>
-                        <a:rPr/>
-                        <a:t>895</a:t>
-                      </a:r>
-                    </a:p>
-                  </a:txBody>
-                </a:tc>
-                <a:tc>
-                  <a:txBody>
-                    <a:bodyPr/>
-                    <a:lstStyle/>
-                    <a:p>
-                      <a:pPr lvl="0" indent="0" marL="0">
-                        <a:buNone/>
-                      </a:pPr>
-                      <a:r>
-                        <a:rPr/>
-                        <a:t>sugarberry</a:t>
-                      </a:r>
-                    </a:p>
-                  </a:txBody>
-                </a:tc>
-                <a:tc>
-                  <a:txBody>
-                    <a:bodyPr/>
-                    <a:lstStyle/>
-                    <a:p>
-                      <a:pPr lvl="0" indent="0" marL="0">
-                        <a:buNone/>
-                      </a:pPr>
-                      <a:r>
-                        <a:rPr/>
-                        <a:t>6</a:t>
-                      </a:r>
-                    </a:p>
-                  </a:txBody>
-                </a:tc>
-                <a:tc>
-                  <a:txBody>
-                    <a:bodyPr/>
-                    <a:lstStyle/>
-                    <a:p>
-                      <a:pPr lvl="0" indent="0" marL="0">
-                        <a:buNone/>
-                      </a:pPr>
-                      <a:r>
-                        <a:rPr/>
-                        <a:t>32.431052</a:t>
-                      </a:r>
-                    </a:p>
-                  </a:txBody>
-                </a:tc>
-                <a:tc>
-                  <a:txBody>
-                    <a:bodyPr/>
-                    <a:lstStyle/>
-                    <a:p>
-                      <a:pPr lvl="0" indent="0" marL="0">
-                        <a:buNone/>
-                      </a:pPr>
-                      <a:r>
-                        <a:rPr/>
-                        <a:t>20.969306</a:t>
-                      </a:r>
-                    </a:p>
-                  </a:txBody>
-                </a:tc>
-                <a:tc>
-                  <a:txBody>
-                    <a:bodyPr/>
-                    <a:lstStyle/>
-                    <a:p>
-                      <a:pPr lvl="0" indent="0" marL="0">
-                        <a:buNone/>
-                      </a:pPr>
-                      <a:r>
-                        <a:rPr/>
-                        <a:t>0.565727</a:t>
-                      </a:r>
-                    </a:p>
-                  </a:txBody>
-                </a:tc>
-              </a:tr>
-              <a:tr h="0">
-                <a:tc>
-                  <a:txBody>
-                    <a:bodyPr/>
-                    <a:lstStyle/>
-                    <a:p>
-                      <a:pPr lvl="0" indent="0" marL="0">
-                        <a:buNone/>
-                      </a:pPr>
-                      <a:r>
-                        <a:rPr/>
-                        <a:t>896</a:t>
-                      </a:r>
-                    </a:p>
-                  </a:txBody>
-                </a:tc>
-                <a:tc>
-                  <a:txBody>
-                    <a:bodyPr/>
-                    <a:lstStyle/>
-                    <a:p>
-                      <a:pPr lvl="0" indent="0" marL="0">
-                        <a:buNone/>
-                      </a:pPr>
-                      <a:r>
-                        <a:rPr/>
-                        <a:t>sugarberry</a:t>
-                      </a:r>
-                    </a:p>
-                  </a:txBody>
-                </a:tc>
-                <a:tc>
-                  <a:txBody>
-                    <a:bodyPr/>
-                    <a:lstStyle/>
-                    <a:p>
-                      <a:pPr lvl="0" indent="0" marL="0">
-                        <a:buNone/>
-                      </a:pPr>
-                      <a:r>
-                        <a:rPr/>
-                        <a:t>7</a:t>
-                      </a:r>
-                    </a:p>
-                  </a:txBody>
-                </a:tc>
-                <a:tc>
-                  <a:txBody>
-                    <a:bodyPr/>
-                    <a:lstStyle/>
-                    <a:p>
-                      <a:pPr lvl="0" indent="0" marL="0">
-                        <a:buNone/>
-                      </a:pPr>
-                      <a:r>
-                        <a:rPr/>
-                        <a:t>37.324259</a:t>
-                      </a:r>
-                    </a:p>
-                  </a:txBody>
-                </a:tc>
-                <a:tc>
-                  <a:txBody>
-                    <a:bodyPr/>
-                    <a:lstStyle/>
-                    <a:p>
-                      <a:pPr lvl="0" indent="0" marL="0">
-                        <a:buNone/>
-                      </a:pPr>
-                      <a:r>
-                        <a:rPr/>
-                        <a:t>25.037024</a:t>
-                      </a:r>
-                    </a:p>
-                  </a:txBody>
-                </a:tc>
-                <a:tc>
-                  <a:txBody>
-                    <a:bodyPr/>
-                    <a:lstStyle/>
-                    <a:p>
-                      <a:pPr lvl="0" indent="0" marL="0">
-                        <a:buNone/>
-                      </a:pPr>
-                      <a:r>
-                        <a:rPr/>
-                        <a:t>0.637629</a:t>
-                      </a:r>
-                    </a:p>
-                  </a:txBody>
-                </a:tc>
-              </a:tr>
-              <a:tr h="0">
-                <a:tc>
-                  <a:txBody>
-                    <a:bodyPr/>
-                    <a:lstStyle/>
-                    <a:p>
-                      <a:pPr lvl="0" indent="0" marL="0">
-                        <a:buNone/>
-                      </a:pPr>
-                      <a:r>
-                        <a:rPr/>
-                        <a:t>897</a:t>
-                      </a:r>
-                    </a:p>
-                  </a:txBody>
-                </a:tc>
-                <a:tc>
-                  <a:txBody>
-                    <a:bodyPr/>
-                    <a:lstStyle/>
-                    <a:p>
-                      <a:pPr lvl="0" indent="0" marL="0">
-                        <a:buNone/>
-                      </a:pPr>
-                      <a:r>
-                        <a:rPr/>
-                        <a:t>sugarberry</a:t>
-                      </a:r>
-                    </a:p>
-                  </a:txBody>
-                </a:tc>
-                <a:tc>
-                  <a:txBody>
-                    <a:bodyPr/>
-                    <a:lstStyle/>
-                    <a:p>
-                      <a:pPr lvl="0" indent="0" marL="0">
-                        <a:buNone/>
-                      </a:pPr>
-                      <a:r>
-                        <a:rPr/>
-                        <a:t>8</a:t>
-                      </a:r>
-                    </a:p>
-                  </a:txBody>
-                </a:tc>
-                <a:tc>
-                  <a:txBody>
-                    <a:bodyPr/>
-                    <a:lstStyle/>
-                    <a:p>
-                      <a:pPr lvl="0" indent="0" marL="0">
-                        <a:buNone/>
-                      </a:pPr>
-                      <a:r>
-                        <a:rPr/>
-                        <a:t>38.144756</a:t>
-                      </a:r>
-                    </a:p>
-                  </a:txBody>
-                </a:tc>
-                <a:tc>
-                  <a:txBody>
-                    <a:bodyPr/>
-                    <a:lstStyle/>
-                    <a:p>
-                      <a:pPr lvl="0" indent="0" marL="0">
-                        <a:buNone/>
-                      </a:pPr>
-                      <a:r>
-                        <a:rPr/>
-                        <a:t>26.680208</a:t>
-                      </a:r>
-                    </a:p>
-                  </a:txBody>
-                </a:tc>
-                <a:tc>
-                  <a:txBody>
-                    <a:bodyPr/>
-                    <a:lstStyle/>
-                    <a:p>
-                      <a:pPr lvl="0" indent="0" marL="0">
-                        <a:buNone/>
-                      </a:pPr>
-                      <a:r>
-                        <a:rPr/>
-                        <a:t>0.665159</a:t>
-                      </a:r>
-                    </a:p>
-                  </a:txBody>
-                </a:tc>
-              </a:tr>
-              <a:tr h="0">
-                <a:tc>
-                  <a:txBody>
-                    <a:bodyPr/>
-                    <a:lstStyle/>
-                    <a:p>
-                      <a:pPr lvl="0" indent="0" marL="0">
-                        <a:buNone/>
-                      </a:pPr>
-                      <a:r>
-                        <a:rPr/>
-                        <a:t>898</a:t>
-                      </a:r>
-                    </a:p>
-                  </a:txBody>
-                </a:tc>
-                <a:tc>
-                  <a:txBody>
-                    <a:bodyPr/>
-                    <a:lstStyle/>
-                    <a:p>
-                      <a:pPr lvl="0" indent="0" marL="0">
-                        <a:buNone/>
-                      </a:pPr>
-                      <a:r>
-                        <a:rPr/>
-                        <a:t>sugarberry</a:t>
-                      </a:r>
-                    </a:p>
-                  </a:txBody>
-                </a:tc>
-                <a:tc>
-                  <a:txBody>
-                    <a:bodyPr/>
-                    <a:lstStyle/>
-                    <a:p>
-                      <a:pPr lvl="0" indent="0" marL="0">
-                        <a:buNone/>
-                      </a:pPr>
-                      <a:r>
-                        <a:rPr/>
-                        <a:t>9</a:t>
-                      </a:r>
-                    </a:p>
-                  </a:txBody>
-                </a:tc>
-                <a:tc>
-                  <a:txBody>
-                    <a:bodyPr/>
-                    <a:lstStyle/>
-                    <a:p>
-                      <a:pPr lvl="0" indent="0" marL="0">
-                        <a:buNone/>
-                      </a:pPr>
-                      <a:r>
-                        <a:rPr/>
-                        <a:t>36.853245</a:t>
-                      </a:r>
-                    </a:p>
-                  </a:txBody>
-                </a:tc>
-                <a:tc>
-                  <a:txBody>
-                    <a:bodyPr/>
-                    <a:lstStyle/>
-                    <a:p>
-                      <a:pPr lvl="0" indent="0" marL="0">
-                        <a:buNone/>
-                      </a:pPr>
-                      <a:r>
-                        <a:rPr/>
-                        <a:t>21.021667</a:t>
-                      </a:r>
-                    </a:p>
-                  </a:txBody>
-                </a:tc>
-                <a:tc>
-                  <a:txBody>
-                    <a:bodyPr/>
-                    <a:lstStyle/>
-                    <a:p>
-                      <a:pPr lvl="0" indent="0" marL="0">
-                        <a:buNone/>
-                      </a:pPr>
-                      <a:r>
-                        <a:rPr/>
-                        <a:t>0.685162</a:t>
-                      </a:r>
-                    </a:p>
-                  </a:txBody>
-                </a:tc>
-              </a:tr>
-              <a:tr h="0">
-                <a:tc>
-                  <a:txBody>
-                    <a:bodyPr/>
-                    <a:lstStyle/>
-                    <a:p>
-                      <a:pPr lvl="0" indent="0" marL="0">
-                        <a:buNone/>
-                      </a:pPr>
-                      <a:r>
-                        <a:rPr/>
-                        <a:t>899</a:t>
-                      </a:r>
-                    </a:p>
-                  </a:txBody>
-                </a:tc>
-                <a:tc>
-                  <a:txBody>
-                    <a:bodyPr/>
-                    <a:lstStyle/>
-                    <a:p>
-                      <a:pPr lvl="0" indent="0" marL="0">
-                        <a:buNone/>
-                      </a:pPr>
-                      <a:r>
-                        <a:rPr/>
-                        <a:t>sugarberry</a:t>
-                      </a:r>
-                    </a:p>
-                  </a:txBody>
-                </a:tc>
-                <a:tc>
-                  <a:txBody>
-                    <a:bodyPr/>
-                    <a:lstStyle/>
-                    <a:p>
-                      <a:pPr lvl="0" indent="0" marL="0">
-                        <a:buNone/>
-                      </a:pPr>
-                      <a:r>
-                        <a:rPr/>
-                        <a:t>10</a:t>
-                      </a:r>
-                    </a:p>
-                  </a:txBody>
-                </a:tc>
-                <a:tc>
-                  <a:txBody>
-                    <a:bodyPr/>
-                    <a:lstStyle/>
-                    <a:p>
-                      <a:pPr lvl="0" indent="0" marL="0">
-                        <a:buNone/>
-                      </a:pPr>
-                      <a:r>
-                        <a:rPr/>
-                        <a:t>40.091106</a:t>
-                      </a:r>
-                    </a:p>
-                  </a:txBody>
-                </a:tc>
-                <a:tc>
-                  <a:txBody>
-                    <a:bodyPr/>
-                    <a:lstStyle/>
-                    <a:p>
-                      <a:pPr lvl="0" indent="0" marL="0">
-                        <a:buNone/>
-                      </a:pPr>
-                      <a:r>
-                        <a:rPr/>
-                        <a:t>23.172083</a:t>
-                      </a:r>
-                    </a:p>
-                  </a:txBody>
-                </a:tc>
-                <a:tc>
-                  <a:txBody>
-                    <a:bodyPr/>
-                    <a:lstStyle/>
-                    <a:p>
-                      <a:pPr lvl="0" indent="0" marL="0">
-                        <a:buNone/>
-                      </a:pPr>
-                      <a:r>
-                        <a:rPr/>
-                        <a:t>0.677519</a:t>
-                      </a:r>
-                    </a:p>
-                  </a:txBody>
-                </a:tc>
-              </a:tr>
-            </a:tbl>
-          </a:graphicData>
-        </a:graphic>
-      </p:graphicFrame>
+        </p:nvSpPr>
+        <p:spPr/>
+        <p:txBody>
+          <a:bodyPr/>
+          <a:lstStyle/>
+          <a:p>
+            <a:pPr lvl="0"/>
+            <a:r>
+              <a:rPr b="1"/>
+              <a:t>RMSLE over RMSE</a:t>
+            </a:r>
+            <a:r>
+              <a:rPr/>
+              <a:t>: focuses on percentage errors, making it fair to both small and large trees, unlike RMSE, which we believe penalizes errors on big trees. Fitting biomass estimations where scale matters more than absolute error.</a:t>
+            </a:r>
+          </a:p>
+          <a:p>
+            <a:pPr lvl="0"/>
+            <a:r>
+              <a:rPr/>
+              <a:t>By prioritizing percentage errors, RMSLE provides a more balanced evaluation that considers the unique characteristics of tree biomass data.</a:t>
+            </a:r>
+          </a:p>
+        </p:txBody>
+      </p:sp>
     </p:spTree>
   </p:cSld>
 </p:sld>
@@ -4702,36 +3607,6 @@
             <p:ph type="title"/>
           </p:nvPr>
         </p:nvSpPr>
-        <p:spPr>
-          <a:xfrm>
-            <a:off x="457201" y="204787"/>
-            <a:ext cx="3008313" cy="871538"/>
-          </a:xfrm>
-        </p:spPr>
-        <p:txBody>
-          <a:bodyPr/>
-          <a:lstStyle/>
-          <a:p>
-            <a:pPr lvl="0" indent="0" marL="0">
-              <a:buNone/>
-            </a:pPr>
-            <a:r>
-              <a:rPr/>
-              <a:t>Technical Lead</a:t>
-            </a:r>
-          </a:p>
-        </p:txBody>
-      </p:sp>
-      <p:sp>
-        <p:nvSpPr>
-          <p:cNvPr id="4" name="Text Placeholder 3"/>
-          <p:cNvSpPr>
-            <a:spLocks noGrp="1"/>
-          </p:cNvSpPr>
-          <p:nvPr>
-            <p:ph idx="2" sz="half" type="body"/>
-          </p:nvPr>
-        </p:nvSpPr>
         <p:spPr/>
         <p:txBody>
           <a:bodyPr/>
@@ -4742,7 +3617,7 @@
             </a:pPr>
             <a:r>
               <a:rPr/>
-              <a:t>Tree Measurement Data:</a:t>
+              <a:t>Model</a:t>
             </a:r>
           </a:p>
         </p:txBody>
@@ -4758,8 +3633,8 @@
           </p:nvPr>
         </p:nvGraphicFramePr>
         <p:xfrm>
-          <a:off x="3568700" y="203200"/>
-          <a:ext cx="5105400" cy="4381500"/>
+          <a:off x="457200" y="1193800"/>
+          <a:ext cx="8229600" cy="3390900"/>
         </p:xfrm>
         <a:graphic>
           <a:graphicData uri="http://schemas.openxmlformats.org/drawingml/2006/table">
@@ -4768,11 +3643,12 @@
                 <a:tableStyleId>{5C22544A-7EE6-4342-B048-85BDC9FD1C3A}</a:tableStyleId>
               </a:tblPr>
               <a:tblGrid>
-                <a:gridCol w="1016000"/>
-                <a:gridCol w="1016000"/>
-                <a:gridCol w="1016000"/>
-                <a:gridCol w="1016000"/>
-                <a:gridCol w="1016000"/>
+                <a:gridCol w="1371600"/>
+                <a:gridCol w="1371600"/>
+                <a:gridCol w="1371600"/>
+                <a:gridCol w="1371600"/>
+                <a:gridCol w="1371600"/>
+                <a:gridCol w="1371600"/>
               </a:tblGrid>
               <a:tr h="0">
                 <a:tc>
@@ -4795,7 +3671,7 @@
                       </a:pPr>
                       <a:r>
                         <a:rPr/>
-                        <a:t>SPCD</a:t>
+                        <a:t>Species</a:t>
                       </a:r>
                     </a:p>
                   </a:txBody>
@@ -4811,7 +3687,7 @@
                       </a:pPr>
                       <a:r>
                         <a:rPr/>
-                        <a:t>DO_BH</a:t>
+                        <a:t>k</a:t>
                       </a:r>
                     </a:p>
                   </a:txBody>
@@ -4827,7 +3703,7 @@
                       </a:pPr>
                       <a:r>
                         <a:rPr/>
-                        <a:t>HT_TOT</a:t>
+                        <a:t>RMSE</a:t>
                       </a:r>
                     </a:p>
                   </a:txBody>
@@ -4843,7 +3719,23 @@
                       </a:pPr>
                       <a:r>
                         <a:rPr/>
-                        <a:t>TT_DW_CRM</a:t>
+                        <a:t>MAE</a:t>
+                      </a:r>
+                    </a:p>
+                  </a:txBody>
+                  <a:tcPr/>
+                </a:tc>
+                <a:tc>
+                  <a:txBody>
+                    <a:bodyPr/>
+                    <a:lstStyle/>
+                    <a:p>
+                      <a:pPr lvl="0" indent="0" marL="0">
+                        <a:buNone/>
+                      </a:pPr>
+                      <a:r>
+                        <a:rPr/>
+                        <a:t>RMSLE</a:t>
                       </a:r>
                     </a:p>
                   </a:txBody>
@@ -4876,52 +3768,67 @@
                       </a:pPr>
                       <a:r>
                         <a:rPr/>
-                        <a:t>12</a:t>
-                      </a:r>
-                    </a:p>
-                  </a:txBody>
-                </a:tc>
-                <a:tc>
-                  <a:txBody>
-                    <a:bodyPr/>
-                    <a:lstStyle/>
-                    <a:p>
-                      <a:pPr lvl="0" indent="0" marL="0">
-                        <a:buNone/>
-                      </a:pPr>
-                      <a:r>
-                        <a:rPr/>
-                        <a:t>7.5</a:t>
-                      </a:r>
-                    </a:p>
-                  </a:txBody>
-                </a:tc>
-                <a:tc>
-                  <a:txBody>
-                    <a:bodyPr/>
-                    <a:lstStyle/>
-                    <a:p>
-                      <a:pPr lvl="0" indent="0" marL="0">
-                        <a:buNone/>
-                      </a:pPr>
-                      <a:r>
-                        <a:rPr/>
-                        <a:t>45.2</a:t>
-                      </a:r>
-                    </a:p>
-                  </a:txBody>
-                </a:tc>
-                <a:tc>
-                  <a:txBody>
-                    <a:bodyPr/>
-                    <a:lstStyle/>
-                    <a:p>
-                      <a:pPr lvl="0" indent="0" marL="0">
-                        <a:buNone/>
-                      </a:pPr>
-                      <a:r>
-                        <a:rPr/>
-                        <a:t>178.86</a:t>
+                        <a:t>balsam fir</a:t>
+                      </a:r>
+                    </a:p>
+                  </a:txBody>
+                </a:tc>
+                <a:tc>
+                  <a:txBody>
+                    <a:bodyPr/>
+                    <a:lstStyle/>
+                    <a:p>
+                      <a:pPr lvl="0" indent="0" marL="0">
+                        <a:buNone/>
+                      </a:pPr>
+                      <a:r>
+                        <a:rPr/>
+                        <a:t>2</a:t>
+                      </a:r>
+                    </a:p>
+                  </a:txBody>
+                </a:tc>
+                <a:tc>
+                  <a:txBody>
+                    <a:bodyPr/>
+                    <a:lstStyle/>
+                    <a:p>
+                      <a:pPr lvl="0" indent="0" marL="0">
+                        <a:buNone/>
+                      </a:pPr>
+                      <a:r>
+                        <a:rPr/>
+                        <a:t>125.827396</a:t>
+                      </a:r>
+                    </a:p>
+                  </a:txBody>
+                </a:tc>
+                <a:tc>
+                  <a:txBody>
+                    <a:bodyPr/>
+                    <a:lstStyle/>
+                    <a:p>
+                      <a:pPr lvl="0" indent="0" marL="0">
+                        <a:buNone/>
+                      </a:pPr>
+                      <a:r>
+                        <a:rPr/>
+                        <a:t>34.820565</a:t>
+                      </a:r>
+                    </a:p>
+                  </a:txBody>
+                </a:tc>
+                <a:tc>
+                  <a:txBody>
+                    <a:bodyPr/>
+                    <a:lstStyle/>
+                    <a:p>
+                      <a:pPr lvl="0" indent="0" marL="0">
+                        <a:buNone/>
+                      </a:pPr>
+                      <a:r>
+                        <a:rPr/>
+                        <a:t>0.119617</a:t>
                       </a:r>
                     </a:p>
                   </a:txBody>
@@ -4953,52 +3860,67 @@
                       </a:pPr>
                       <a:r>
                         <a:rPr/>
-                        <a:t>12</a:t>
-                      </a:r>
-                    </a:p>
-                  </a:txBody>
-                </a:tc>
-                <a:tc>
-                  <a:txBody>
-                    <a:bodyPr/>
-                    <a:lstStyle/>
-                    <a:p>
-                      <a:pPr lvl="0" indent="0" marL="0">
-                        <a:buNone/>
-                      </a:pPr>
-                      <a:r>
-                        <a:rPr/>
-                        <a:t>9.3</a:t>
-                      </a:r>
-                    </a:p>
-                  </a:txBody>
-                </a:tc>
-                <a:tc>
-                  <a:txBody>
-                    <a:bodyPr/>
-                    <a:lstStyle/>
-                    <a:p>
-                      <a:pPr lvl="0" indent="0" marL="0">
-                        <a:buNone/>
-                      </a:pPr>
-                      <a:r>
-                        <a:rPr/>
-                        <a:t>62.7</a:t>
-                      </a:r>
-                    </a:p>
-                  </a:txBody>
-                </a:tc>
-                <a:tc>
-                  <a:txBody>
-                    <a:bodyPr/>
-                    <a:lstStyle/>
-                    <a:p>
-                      <a:pPr lvl="0" indent="0" marL="0">
-                        <a:buNone/>
-                      </a:pPr>
-                      <a:r>
-                        <a:rPr/>
-                        <a:t>323.46</a:t>
+                        <a:t>balsam fir</a:t>
+                      </a:r>
+                    </a:p>
+                  </a:txBody>
+                </a:tc>
+                <a:tc>
+                  <a:txBody>
+                    <a:bodyPr/>
+                    <a:lstStyle/>
+                    <a:p>
+                      <a:pPr lvl="0" indent="0" marL="0">
+                        <a:buNone/>
+                      </a:pPr>
+                      <a:r>
+                        <a:rPr/>
+                        <a:t>3</a:t>
+                      </a:r>
+                    </a:p>
+                  </a:txBody>
+                </a:tc>
+                <a:tc>
+                  <a:txBody>
+                    <a:bodyPr/>
+                    <a:lstStyle/>
+                    <a:p>
+                      <a:pPr lvl="0" indent="0" marL="0">
+                        <a:buNone/>
+                      </a:pPr>
+                      <a:r>
+                        <a:rPr/>
+                        <a:t>129.650855</a:t>
+                      </a:r>
+                    </a:p>
+                  </a:txBody>
+                </a:tc>
+                <a:tc>
+                  <a:txBody>
+                    <a:bodyPr/>
+                    <a:lstStyle/>
+                    <a:p>
+                      <a:pPr lvl="0" indent="0" marL="0">
+                        <a:buNone/>
+                      </a:pPr>
+                      <a:r>
+                        <a:rPr/>
+                        <a:t>36.628377</a:t>
+                      </a:r>
+                    </a:p>
+                  </a:txBody>
+                </a:tc>
+                <a:tc>
+                  <a:txBody>
+                    <a:bodyPr/>
+                    <a:lstStyle/>
+                    <a:p>
+                      <a:pPr lvl="0" indent="0" marL="0">
+                        <a:buNone/>
+                      </a:pPr>
+                      <a:r>
+                        <a:rPr/>
+                        <a:t>0.123679</a:t>
                       </a:r>
                     </a:p>
                   </a:txBody>
@@ -5030,52 +3952,67 @@
                       </a:pPr>
                       <a:r>
                         <a:rPr/>
-                        <a:t>12</a:t>
-                      </a:r>
-                    </a:p>
-                  </a:txBody>
-                </a:tc>
-                <a:tc>
-                  <a:txBody>
-                    <a:bodyPr/>
-                    <a:lstStyle/>
-                    <a:p>
-                      <a:pPr lvl="0" indent="0" marL="0">
-                        <a:buNone/>
-                      </a:pPr>
-                      <a:r>
-                        <a:rPr/>
-                        <a:t>9.7</a:t>
-                      </a:r>
-                    </a:p>
-                  </a:txBody>
-                </a:tc>
-                <a:tc>
-                  <a:txBody>
-                    <a:bodyPr/>
-                    <a:lstStyle/>
-                    <a:p>
-                      <a:pPr lvl="0" indent="0" marL="0">
-                        <a:buNone/>
-                      </a:pPr>
-                      <a:r>
-                        <a:rPr/>
-                        <a:t>56.7</a:t>
-                      </a:r>
-                    </a:p>
-                  </a:txBody>
-                </a:tc>
-                <a:tc>
-                  <a:txBody>
-                    <a:bodyPr/>
-                    <a:lstStyle/>
-                    <a:p>
-                      <a:pPr lvl="0" indent="0" marL="0">
-                        <a:buNone/>
-                      </a:pPr>
-                      <a:r>
-                        <a:rPr/>
-                        <a:t>342.47</a:t>
+                        <a:t>balsam fir</a:t>
+                      </a:r>
+                    </a:p>
+                  </a:txBody>
+                </a:tc>
+                <a:tc>
+                  <a:txBody>
+                    <a:bodyPr/>
+                    <a:lstStyle/>
+                    <a:p>
+                      <a:pPr lvl="0" indent="0" marL="0">
+                        <a:buNone/>
+                      </a:pPr>
+                      <a:r>
+                        <a:rPr/>
+                        <a:t>4</a:t>
+                      </a:r>
+                    </a:p>
+                  </a:txBody>
+                </a:tc>
+                <a:tc>
+                  <a:txBody>
+                    <a:bodyPr/>
+                    <a:lstStyle/>
+                    <a:p>
+                      <a:pPr lvl="0" indent="0" marL="0">
+                        <a:buNone/>
+                      </a:pPr>
+                      <a:r>
+                        <a:rPr/>
+                        <a:t>134.599829</a:t>
+                      </a:r>
+                    </a:p>
+                  </a:txBody>
+                </a:tc>
+                <a:tc>
+                  <a:txBody>
+                    <a:bodyPr/>
+                    <a:lstStyle/>
+                    <a:p>
+                      <a:pPr lvl="0" indent="0" marL="0">
+                        <a:buNone/>
+                      </a:pPr>
+                      <a:r>
+                        <a:rPr/>
+                        <a:t>38.884870</a:t>
+                      </a:r>
+                    </a:p>
+                  </a:txBody>
+                </a:tc>
+                <a:tc>
+                  <a:txBody>
+                    <a:bodyPr/>
+                    <a:lstStyle/>
+                    <a:p>
+                      <a:pPr lvl="0" indent="0" marL="0">
+                        <a:buNone/>
+                      </a:pPr>
+                      <a:r>
+                        <a:rPr/>
+                        <a:t>0.133858</a:t>
                       </a:r>
                     </a:p>
                   </a:txBody>
@@ -5107,52 +4044,67 @@
                       </a:pPr>
                       <a:r>
                         <a:rPr/>
-                        <a:t>12</a:t>
-                      </a:r>
-                    </a:p>
-                  </a:txBody>
-                </a:tc>
-                <a:tc>
-                  <a:txBody>
-                    <a:bodyPr/>
-                    <a:lstStyle/>
-                    <a:p>
-                      <a:pPr lvl="0" indent="0" marL="0">
-                        <a:buNone/>
-                      </a:pPr>
-                      <a:r>
-                        <a:rPr/>
-                        <a:t>11.4</a:t>
-                      </a:r>
-                    </a:p>
-                  </a:txBody>
-                </a:tc>
-                <a:tc>
-                  <a:txBody>
-                    <a:bodyPr/>
-                    <a:lstStyle/>
-                    <a:p>
-                      <a:pPr lvl="0" indent="0" marL="0">
-                        <a:buNone/>
-                      </a:pPr>
-                      <a:r>
-                        <a:rPr/>
-                        <a:t>66.1</a:t>
-                      </a:r>
-                    </a:p>
-                  </a:txBody>
-                </a:tc>
-                <a:tc>
-                  <a:txBody>
-                    <a:bodyPr/>
-                    <a:lstStyle/>
-                    <a:p>
-                      <a:pPr lvl="0" indent="0" marL="0">
-                        <a:buNone/>
-                      </a:pPr>
-                      <a:r>
-                        <a:rPr/>
-                        <a:t>499.35</a:t>
+                        <a:t>balsam fir</a:t>
+                      </a:r>
+                    </a:p>
+                  </a:txBody>
+                </a:tc>
+                <a:tc>
+                  <a:txBody>
+                    <a:bodyPr/>
+                    <a:lstStyle/>
+                    <a:p>
+                      <a:pPr lvl="0" indent="0" marL="0">
+                        <a:buNone/>
+                      </a:pPr>
+                      <a:r>
+                        <a:rPr/>
+                        <a:t>5</a:t>
+                      </a:r>
+                    </a:p>
+                  </a:txBody>
+                </a:tc>
+                <a:tc>
+                  <a:txBody>
+                    <a:bodyPr/>
+                    <a:lstStyle/>
+                    <a:p>
+                      <a:pPr lvl="0" indent="0" marL="0">
+                        <a:buNone/>
+                      </a:pPr>
+                      <a:r>
+                        <a:rPr/>
+                        <a:t>145.002852</a:t>
+                      </a:r>
+                    </a:p>
+                  </a:txBody>
+                </a:tc>
+                <a:tc>
+                  <a:txBody>
+                    <a:bodyPr/>
+                    <a:lstStyle/>
+                    <a:p>
+                      <a:pPr lvl="0" indent="0" marL="0">
+                        <a:buNone/>
+                      </a:pPr>
+                      <a:r>
+                        <a:rPr/>
+                        <a:t>41.168470</a:t>
+                      </a:r>
+                    </a:p>
+                  </a:txBody>
+                </a:tc>
+                <a:tc>
+                  <a:txBody>
+                    <a:bodyPr/>
+                    <a:lstStyle/>
+                    <a:p>
+                      <a:pPr lvl="0" indent="0" marL="0">
+                        <a:buNone/>
+                      </a:pPr>
+                      <a:r>
+                        <a:rPr/>
+                        <a:t>0.144052</a:t>
                       </a:r>
                     </a:p>
                   </a:txBody>
@@ -5184,52 +4136,619 @@
                       </a:pPr>
                       <a:r>
                         <a:rPr/>
-                        <a:t>12</a:t>
-                      </a:r>
-                    </a:p>
-                  </a:txBody>
-                </a:tc>
-                <a:tc>
-                  <a:txBody>
-                    <a:bodyPr/>
-                    <a:lstStyle/>
-                    <a:p>
-                      <a:pPr lvl="0" indent="0" marL="0">
-                        <a:buNone/>
-                      </a:pPr>
-                      <a:r>
-                        <a:rPr/>
-                        <a:t>6.4</a:t>
-                      </a:r>
-                    </a:p>
-                  </a:txBody>
-                </a:tc>
-                <a:tc>
-                  <a:txBody>
-                    <a:bodyPr/>
-                    <a:lstStyle/>
-                    <a:p>
-                      <a:pPr lvl="0" indent="0" marL="0">
-                        <a:buNone/>
-                      </a:pPr>
-                      <a:r>
-                        <a:rPr/>
-                        <a:t>51.8</a:t>
-                      </a:r>
-                    </a:p>
-                  </a:txBody>
-                </a:tc>
-                <a:tc>
-                  <a:txBody>
-                    <a:bodyPr/>
-                    <a:lstStyle/>
-                    <a:p>
-                      <a:pPr lvl="0" indent="0" marL="0">
-                        <a:buNone/>
-                      </a:pPr>
-                      <a:r>
-                        <a:rPr/>
-                        <a:t>113.92</a:t>
+                        <a:t>balsam fir</a:t>
+                      </a:r>
+                    </a:p>
+                  </a:txBody>
+                </a:tc>
+                <a:tc>
+                  <a:txBody>
+                    <a:bodyPr/>
+                    <a:lstStyle/>
+                    <a:p>
+                      <a:pPr lvl="0" indent="0" marL="0">
+                        <a:buNone/>
+                      </a:pPr>
+                      <a:r>
+                        <a:rPr/>
+                        <a:t>6</a:t>
+                      </a:r>
+                    </a:p>
+                  </a:txBody>
+                </a:tc>
+                <a:tc>
+                  <a:txBody>
+                    <a:bodyPr/>
+                    <a:lstStyle/>
+                    <a:p>
+                      <a:pPr lvl="0" indent="0" marL="0">
+                        <a:buNone/>
+                      </a:pPr>
+                      <a:r>
+                        <a:rPr/>
+                        <a:t>147.449208</a:t>
+                      </a:r>
+                    </a:p>
+                  </a:txBody>
+                </a:tc>
+                <a:tc>
+                  <a:txBody>
+                    <a:bodyPr/>
+                    <a:lstStyle/>
+                    <a:p>
+                      <a:pPr lvl="0" indent="0" marL="0">
+                        <a:buNone/>
+                      </a:pPr>
+                      <a:r>
+                        <a:rPr/>
+                        <a:t>40.728609</a:t>
+                      </a:r>
+                    </a:p>
+                  </a:txBody>
+                </a:tc>
+                <a:tc>
+                  <a:txBody>
+                    <a:bodyPr/>
+                    <a:lstStyle/>
+                    <a:p>
+                      <a:pPr lvl="0" indent="0" marL="0">
+                        <a:buNone/>
+                      </a:pPr>
+                      <a:r>
+                        <a:rPr/>
+                        <a:t>0.142813</a:t>
+                      </a:r>
+                    </a:p>
+                  </a:txBody>
+                </a:tc>
+              </a:tr>
+              <a:tr h="0">
+                <a:tc>
+                  <a:txBody>
+                    <a:bodyPr/>
+                    <a:lstStyle/>
+                    <a:p>
+                      <a:pPr lvl="0" indent="0" marL="0">
+                        <a:buNone/>
+                      </a:pPr>
+                      <a:r>
+                        <a:rPr/>
+                        <a:t>...</a:t>
+                      </a:r>
+                    </a:p>
+                  </a:txBody>
+                </a:tc>
+                <a:tc>
+                  <a:txBody>
+                    <a:bodyPr/>
+                    <a:lstStyle/>
+                    <a:p>
+                      <a:pPr lvl="0" indent="0" marL="0">
+                        <a:buNone/>
+                      </a:pPr>
+                      <a:r>
+                        <a:rPr/>
+                        <a:t>...</a:t>
+                      </a:r>
+                    </a:p>
+                  </a:txBody>
+                </a:tc>
+                <a:tc>
+                  <a:txBody>
+                    <a:bodyPr/>
+                    <a:lstStyle/>
+                    <a:p>
+                      <a:pPr lvl="0" indent="0" marL="0">
+                        <a:buNone/>
+                      </a:pPr>
+                      <a:r>
+                        <a:rPr/>
+                        <a:t>...</a:t>
+                      </a:r>
+                    </a:p>
+                  </a:txBody>
+                </a:tc>
+                <a:tc>
+                  <a:txBody>
+                    <a:bodyPr/>
+                    <a:lstStyle/>
+                    <a:p>
+                      <a:pPr lvl="0" indent="0" marL="0">
+                        <a:buNone/>
+                      </a:pPr>
+                      <a:r>
+                        <a:rPr/>
+                        <a:t>...</a:t>
+                      </a:r>
+                    </a:p>
+                  </a:txBody>
+                </a:tc>
+                <a:tc>
+                  <a:txBody>
+                    <a:bodyPr/>
+                    <a:lstStyle/>
+                    <a:p>
+                      <a:pPr lvl="0" indent="0" marL="0">
+                        <a:buNone/>
+                      </a:pPr>
+                      <a:r>
+                        <a:rPr/>
+                        <a:t>...</a:t>
+                      </a:r>
+                    </a:p>
+                  </a:txBody>
+                </a:tc>
+                <a:tc>
+                  <a:txBody>
+                    <a:bodyPr/>
+                    <a:lstStyle/>
+                    <a:p>
+                      <a:pPr lvl="0" indent="0" marL="0">
+                        <a:buNone/>
+                      </a:pPr>
+                      <a:r>
+                        <a:rPr/>
+                        <a:t>...</a:t>
+                      </a:r>
+                    </a:p>
+                  </a:txBody>
+                </a:tc>
+              </a:tr>
+              <a:tr h="0">
+                <a:tc>
+                  <a:txBody>
+                    <a:bodyPr/>
+                    <a:lstStyle/>
+                    <a:p>
+                      <a:pPr lvl="0" indent="0" marL="0">
+                        <a:buNone/>
+                      </a:pPr>
+                      <a:r>
+                        <a:rPr/>
+                        <a:t>895</a:t>
+                      </a:r>
+                    </a:p>
+                  </a:txBody>
+                </a:tc>
+                <a:tc>
+                  <a:txBody>
+                    <a:bodyPr/>
+                    <a:lstStyle/>
+                    <a:p>
+                      <a:pPr lvl="0" indent="0" marL="0">
+                        <a:buNone/>
+                      </a:pPr>
+                      <a:r>
+                        <a:rPr/>
+                        <a:t>sugarberry</a:t>
+                      </a:r>
+                    </a:p>
+                  </a:txBody>
+                </a:tc>
+                <a:tc>
+                  <a:txBody>
+                    <a:bodyPr/>
+                    <a:lstStyle/>
+                    <a:p>
+                      <a:pPr lvl="0" indent="0" marL="0">
+                        <a:buNone/>
+                      </a:pPr>
+                      <a:r>
+                        <a:rPr/>
+                        <a:t>6</a:t>
+                      </a:r>
+                    </a:p>
+                  </a:txBody>
+                </a:tc>
+                <a:tc>
+                  <a:txBody>
+                    <a:bodyPr/>
+                    <a:lstStyle/>
+                    <a:p>
+                      <a:pPr lvl="0" indent="0" marL="0">
+                        <a:buNone/>
+                      </a:pPr>
+                      <a:r>
+                        <a:rPr/>
+                        <a:t>32.431052</a:t>
+                      </a:r>
+                    </a:p>
+                  </a:txBody>
+                </a:tc>
+                <a:tc>
+                  <a:txBody>
+                    <a:bodyPr/>
+                    <a:lstStyle/>
+                    <a:p>
+                      <a:pPr lvl="0" indent="0" marL="0">
+                        <a:buNone/>
+                      </a:pPr>
+                      <a:r>
+                        <a:rPr/>
+                        <a:t>20.969306</a:t>
+                      </a:r>
+                    </a:p>
+                  </a:txBody>
+                </a:tc>
+                <a:tc>
+                  <a:txBody>
+                    <a:bodyPr/>
+                    <a:lstStyle/>
+                    <a:p>
+                      <a:pPr lvl="0" indent="0" marL="0">
+                        <a:buNone/>
+                      </a:pPr>
+                      <a:r>
+                        <a:rPr/>
+                        <a:t>0.565727</a:t>
+                      </a:r>
+                    </a:p>
+                  </a:txBody>
+                </a:tc>
+              </a:tr>
+              <a:tr h="0">
+                <a:tc>
+                  <a:txBody>
+                    <a:bodyPr/>
+                    <a:lstStyle/>
+                    <a:p>
+                      <a:pPr lvl="0" indent="0" marL="0">
+                        <a:buNone/>
+                      </a:pPr>
+                      <a:r>
+                        <a:rPr/>
+                        <a:t>896</a:t>
+                      </a:r>
+                    </a:p>
+                  </a:txBody>
+                </a:tc>
+                <a:tc>
+                  <a:txBody>
+                    <a:bodyPr/>
+                    <a:lstStyle/>
+                    <a:p>
+                      <a:pPr lvl="0" indent="0" marL="0">
+                        <a:buNone/>
+                      </a:pPr>
+                      <a:r>
+                        <a:rPr/>
+                        <a:t>sugarberry</a:t>
+                      </a:r>
+                    </a:p>
+                  </a:txBody>
+                </a:tc>
+                <a:tc>
+                  <a:txBody>
+                    <a:bodyPr/>
+                    <a:lstStyle/>
+                    <a:p>
+                      <a:pPr lvl="0" indent="0" marL="0">
+                        <a:buNone/>
+                      </a:pPr>
+                      <a:r>
+                        <a:rPr/>
+                        <a:t>7</a:t>
+                      </a:r>
+                    </a:p>
+                  </a:txBody>
+                </a:tc>
+                <a:tc>
+                  <a:txBody>
+                    <a:bodyPr/>
+                    <a:lstStyle/>
+                    <a:p>
+                      <a:pPr lvl="0" indent="0" marL="0">
+                        <a:buNone/>
+                      </a:pPr>
+                      <a:r>
+                        <a:rPr/>
+                        <a:t>37.324259</a:t>
+                      </a:r>
+                    </a:p>
+                  </a:txBody>
+                </a:tc>
+                <a:tc>
+                  <a:txBody>
+                    <a:bodyPr/>
+                    <a:lstStyle/>
+                    <a:p>
+                      <a:pPr lvl="0" indent="0" marL="0">
+                        <a:buNone/>
+                      </a:pPr>
+                      <a:r>
+                        <a:rPr/>
+                        <a:t>25.037024</a:t>
+                      </a:r>
+                    </a:p>
+                  </a:txBody>
+                </a:tc>
+                <a:tc>
+                  <a:txBody>
+                    <a:bodyPr/>
+                    <a:lstStyle/>
+                    <a:p>
+                      <a:pPr lvl="0" indent="0" marL="0">
+                        <a:buNone/>
+                      </a:pPr>
+                      <a:r>
+                        <a:rPr/>
+                        <a:t>0.637629</a:t>
+                      </a:r>
+                    </a:p>
+                  </a:txBody>
+                </a:tc>
+              </a:tr>
+              <a:tr h="0">
+                <a:tc>
+                  <a:txBody>
+                    <a:bodyPr/>
+                    <a:lstStyle/>
+                    <a:p>
+                      <a:pPr lvl="0" indent="0" marL="0">
+                        <a:buNone/>
+                      </a:pPr>
+                      <a:r>
+                        <a:rPr/>
+                        <a:t>897</a:t>
+                      </a:r>
+                    </a:p>
+                  </a:txBody>
+                </a:tc>
+                <a:tc>
+                  <a:txBody>
+                    <a:bodyPr/>
+                    <a:lstStyle/>
+                    <a:p>
+                      <a:pPr lvl="0" indent="0" marL="0">
+                        <a:buNone/>
+                      </a:pPr>
+                      <a:r>
+                        <a:rPr/>
+                        <a:t>sugarberry</a:t>
+                      </a:r>
+                    </a:p>
+                  </a:txBody>
+                </a:tc>
+                <a:tc>
+                  <a:txBody>
+                    <a:bodyPr/>
+                    <a:lstStyle/>
+                    <a:p>
+                      <a:pPr lvl="0" indent="0" marL="0">
+                        <a:buNone/>
+                      </a:pPr>
+                      <a:r>
+                        <a:rPr/>
+                        <a:t>8</a:t>
+                      </a:r>
+                    </a:p>
+                  </a:txBody>
+                </a:tc>
+                <a:tc>
+                  <a:txBody>
+                    <a:bodyPr/>
+                    <a:lstStyle/>
+                    <a:p>
+                      <a:pPr lvl="0" indent="0" marL="0">
+                        <a:buNone/>
+                      </a:pPr>
+                      <a:r>
+                        <a:rPr/>
+                        <a:t>38.144756</a:t>
+                      </a:r>
+                    </a:p>
+                  </a:txBody>
+                </a:tc>
+                <a:tc>
+                  <a:txBody>
+                    <a:bodyPr/>
+                    <a:lstStyle/>
+                    <a:p>
+                      <a:pPr lvl="0" indent="0" marL="0">
+                        <a:buNone/>
+                      </a:pPr>
+                      <a:r>
+                        <a:rPr/>
+                        <a:t>26.680208</a:t>
+                      </a:r>
+                    </a:p>
+                  </a:txBody>
+                </a:tc>
+                <a:tc>
+                  <a:txBody>
+                    <a:bodyPr/>
+                    <a:lstStyle/>
+                    <a:p>
+                      <a:pPr lvl="0" indent="0" marL="0">
+                        <a:buNone/>
+                      </a:pPr>
+                      <a:r>
+                        <a:rPr/>
+                        <a:t>0.665159</a:t>
+                      </a:r>
+                    </a:p>
+                  </a:txBody>
+                </a:tc>
+              </a:tr>
+              <a:tr h="0">
+                <a:tc>
+                  <a:txBody>
+                    <a:bodyPr/>
+                    <a:lstStyle/>
+                    <a:p>
+                      <a:pPr lvl="0" indent="0" marL="0">
+                        <a:buNone/>
+                      </a:pPr>
+                      <a:r>
+                        <a:rPr/>
+                        <a:t>898</a:t>
+                      </a:r>
+                    </a:p>
+                  </a:txBody>
+                </a:tc>
+                <a:tc>
+                  <a:txBody>
+                    <a:bodyPr/>
+                    <a:lstStyle/>
+                    <a:p>
+                      <a:pPr lvl="0" indent="0" marL="0">
+                        <a:buNone/>
+                      </a:pPr>
+                      <a:r>
+                        <a:rPr/>
+                        <a:t>sugarberry</a:t>
+                      </a:r>
+                    </a:p>
+                  </a:txBody>
+                </a:tc>
+                <a:tc>
+                  <a:txBody>
+                    <a:bodyPr/>
+                    <a:lstStyle/>
+                    <a:p>
+                      <a:pPr lvl="0" indent="0" marL="0">
+                        <a:buNone/>
+                      </a:pPr>
+                      <a:r>
+                        <a:rPr/>
+                        <a:t>9</a:t>
+                      </a:r>
+                    </a:p>
+                  </a:txBody>
+                </a:tc>
+                <a:tc>
+                  <a:txBody>
+                    <a:bodyPr/>
+                    <a:lstStyle/>
+                    <a:p>
+                      <a:pPr lvl="0" indent="0" marL="0">
+                        <a:buNone/>
+                      </a:pPr>
+                      <a:r>
+                        <a:rPr/>
+                        <a:t>36.853245</a:t>
+                      </a:r>
+                    </a:p>
+                  </a:txBody>
+                </a:tc>
+                <a:tc>
+                  <a:txBody>
+                    <a:bodyPr/>
+                    <a:lstStyle/>
+                    <a:p>
+                      <a:pPr lvl="0" indent="0" marL="0">
+                        <a:buNone/>
+                      </a:pPr>
+                      <a:r>
+                        <a:rPr/>
+                        <a:t>21.021667</a:t>
+                      </a:r>
+                    </a:p>
+                  </a:txBody>
+                </a:tc>
+                <a:tc>
+                  <a:txBody>
+                    <a:bodyPr/>
+                    <a:lstStyle/>
+                    <a:p>
+                      <a:pPr lvl="0" indent="0" marL="0">
+                        <a:buNone/>
+                      </a:pPr>
+                      <a:r>
+                        <a:rPr/>
+                        <a:t>0.685162</a:t>
+                      </a:r>
+                    </a:p>
+                  </a:txBody>
+                </a:tc>
+              </a:tr>
+              <a:tr h="0">
+                <a:tc>
+                  <a:txBody>
+                    <a:bodyPr/>
+                    <a:lstStyle/>
+                    <a:p>
+                      <a:pPr lvl="0" indent="0" marL="0">
+                        <a:buNone/>
+                      </a:pPr>
+                      <a:r>
+                        <a:rPr/>
+                        <a:t>899</a:t>
+                      </a:r>
+                    </a:p>
+                  </a:txBody>
+                </a:tc>
+                <a:tc>
+                  <a:txBody>
+                    <a:bodyPr/>
+                    <a:lstStyle/>
+                    <a:p>
+                      <a:pPr lvl="0" indent="0" marL="0">
+                        <a:buNone/>
+                      </a:pPr>
+                      <a:r>
+                        <a:rPr/>
+                        <a:t>sugarberry</a:t>
+                      </a:r>
+                    </a:p>
+                  </a:txBody>
+                </a:tc>
+                <a:tc>
+                  <a:txBody>
+                    <a:bodyPr/>
+                    <a:lstStyle/>
+                    <a:p>
+                      <a:pPr lvl="0" indent="0" marL="0">
+                        <a:buNone/>
+                      </a:pPr>
+                      <a:r>
+                        <a:rPr/>
+                        <a:t>10</a:t>
+                      </a:r>
+                    </a:p>
+                  </a:txBody>
+                </a:tc>
+                <a:tc>
+                  <a:txBody>
+                    <a:bodyPr/>
+                    <a:lstStyle/>
+                    <a:p>
+                      <a:pPr lvl="0" indent="0" marL="0">
+                        <a:buNone/>
+                      </a:pPr>
+                      <a:r>
+                        <a:rPr/>
+                        <a:t>40.091106</a:t>
+                      </a:r>
+                    </a:p>
+                  </a:txBody>
+                </a:tc>
+                <a:tc>
+                  <a:txBody>
+                    <a:bodyPr/>
+                    <a:lstStyle/>
+                    <a:p>
+                      <a:pPr lvl="0" indent="0" marL="0">
+                        <a:buNone/>
+                      </a:pPr>
+                      <a:r>
+                        <a:rPr/>
+                        <a:t>23.172083</a:t>
+                      </a:r>
+                    </a:p>
+                  </a:txBody>
+                </a:tc>
+                <a:tc>
+                  <a:txBody>
+                    <a:bodyPr/>
+                    <a:lstStyle/>
+                    <a:p>
+                      <a:pPr lvl="0" indent="0" marL="0">
+                        <a:buNone/>
+                      </a:pPr>
+                      <a:r>
+                        <a:rPr/>
+                        <a:t>0.677519</a:t>
                       </a:r>
                     </a:p>
                   </a:txBody>
@@ -5271,17 +4790,66 @@
             <p:ph type="title"/>
           </p:nvPr>
         </p:nvSpPr>
+        <p:spPr>
+          <a:xfrm>
+            <a:off x="457201" y="204787"/>
+            <a:ext cx="3008313" cy="871538"/>
+          </a:xfrm>
+        </p:spPr>
+        <p:txBody>
+          <a:bodyPr/>
+          <a:lstStyle/>
+          <a:p>
+            <a:pPr lvl="0" indent="0" marL="0">
+              <a:buNone/>
+            </a:pPr>
+            <a:r>
+              <a:rPr/>
+              <a:t>Technical Lead</a:t>
+            </a:r>
+          </a:p>
+        </p:txBody>
+      </p:sp>
+      <p:sp>
+        <p:nvSpPr>
+          <p:cNvPr id="4" name="Text Placeholder 3"/>
+          <p:cNvSpPr>
+            <a:spLocks noGrp="1"/>
+          </p:cNvSpPr>
+          <p:nvPr>
+            <p:ph idx="2" sz="half" type="body"/>
+          </p:nvPr>
+        </p:nvSpPr>
         <p:spPr/>
         <p:txBody>
           <a:bodyPr/>
           <a:lstStyle/>
           <a:p>
-            <a:pPr lvl="0" indent="0" marL="0">
-              <a:buNone/>
-            </a:pPr>
+            <a:pPr lvl="0"/>
             <a:r>
               <a:rPr/>
-              <a:t>Tree Species Name Data:</a:t>
+              <a:t>Split and filtering methods</a:t>
+            </a:r>
+          </a:p>
+          <a:p>
+            <a:pPr lvl="0"/>
+            <a:r>
+              <a:rPr/>
+              <a:t>Feature engineering (what worked and what didn’t)</a:t>
+            </a:r>
+          </a:p>
+          <a:p>
+            <a:pPr lvl="0"/>
+            <a:r>
+              <a:rPr/>
+              <a:t>Tuning k for the best model</a:t>
+            </a:r>
+          </a:p>
+          <a:p>
+            <a:pPr lvl="0"/>
+            <a:r>
+              <a:rPr/>
+              <a:t>The final “best” model and error # Tree Measurement Data:</a:t>
             </a:r>
           </a:p>
         </p:txBody>
@@ -5297,8 +4865,8 @@
           </p:nvPr>
         </p:nvGraphicFramePr>
         <p:xfrm>
-          <a:off x="457200" y="1193800"/>
-          <a:ext cx="8229600" cy="3390900"/>
+          <a:off x="3568700" y="203200"/>
+          <a:ext cx="5105400" cy="4381500"/>
         </p:xfrm>
         <a:graphic>
           <a:graphicData uri="http://schemas.openxmlformats.org/drawingml/2006/table">
@@ -5307,9 +4875,11 @@
                 <a:tableStyleId>{5C22544A-7EE6-4342-B048-85BDC9FD1C3A}</a:tableStyleId>
               </a:tblPr>
               <a:tblGrid>
-                <a:gridCol w="2743200"/>
-                <a:gridCol w="2743200"/>
-                <a:gridCol w="2743200"/>
+                <a:gridCol w="1016000"/>
+                <a:gridCol w="1016000"/>
+                <a:gridCol w="1016000"/>
+                <a:gridCol w="1016000"/>
+                <a:gridCol w="1016000"/>
               </a:tblGrid>
               <a:tr h="0">
                 <a:tc>
@@ -5348,7 +4918,39 @@
                       </a:pPr>
                       <a:r>
                         <a:rPr/>
-                        <a:t>COMMON_NAME</a:t>
+                        <a:t>DO_BH</a:t>
+                      </a:r>
+                    </a:p>
+                  </a:txBody>
+                  <a:tcPr/>
+                </a:tc>
+                <a:tc>
+                  <a:txBody>
+                    <a:bodyPr/>
+                    <a:lstStyle/>
+                    <a:p>
+                      <a:pPr lvl="0" indent="0" marL="0">
+                        <a:buNone/>
+                      </a:pPr>
+                      <a:r>
+                        <a:rPr/>
+                        <a:t>HT_TOT</a:t>
+                      </a:r>
+                    </a:p>
+                  </a:txBody>
+                  <a:tcPr/>
+                </a:tc>
+                <a:tc>
+                  <a:txBody>
+                    <a:bodyPr/>
+                    <a:lstStyle/>
+                    <a:p>
+                      <a:pPr lvl="0" indent="0" marL="0">
+                        <a:buNone/>
+                      </a:pPr>
+                      <a:r>
+                        <a:rPr/>
+                        <a:t>TT_DW_CRM</a:t>
                       </a:r>
                     </a:p>
                   </a:txBody>
@@ -5381,22 +4983,52 @@
                       </a:pPr>
                       <a:r>
                         <a:rPr/>
-                        <a:t>10</a:t>
-                      </a:r>
-                    </a:p>
-                  </a:txBody>
-                </a:tc>
-                <a:tc>
-                  <a:txBody>
-                    <a:bodyPr/>
-                    <a:lstStyle/>
-                    <a:p>
-                      <a:pPr lvl="0" indent="0" marL="0">
-                        <a:buNone/>
-                      </a:pPr>
-                      <a:r>
-                        <a:rPr/>
-                        <a:t>fir spp.</a:t>
+                        <a:t>12</a:t>
+                      </a:r>
+                    </a:p>
+                  </a:txBody>
+                </a:tc>
+                <a:tc>
+                  <a:txBody>
+                    <a:bodyPr/>
+                    <a:lstStyle/>
+                    <a:p>
+                      <a:pPr lvl="0" indent="0" marL="0">
+                        <a:buNone/>
+                      </a:pPr>
+                      <a:r>
+                        <a:rPr/>
+                        <a:t>7.5</a:t>
+                      </a:r>
+                    </a:p>
+                  </a:txBody>
+                </a:tc>
+                <a:tc>
+                  <a:txBody>
+                    <a:bodyPr/>
+                    <a:lstStyle/>
+                    <a:p>
+                      <a:pPr lvl="0" indent="0" marL="0">
+                        <a:buNone/>
+                      </a:pPr>
+                      <a:r>
+                        <a:rPr/>
+                        <a:t>45.2</a:t>
+                      </a:r>
+                    </a:p>
+                  </a:txBody>
+                </a:tc>
+                <a:tc>
+                  <a:txBody>
+                    <a:bodyPr/>
+                    <a:lstStyle/>
+                    <a:p>
+                      <a:pPr lvl="0" indent="0" marL="0">
+                        <a:buNone/>
+                      </a:pPr>
+                      <a:r>
+                        <a:rPr/>
+                        <a:t>178.86</a:t>
                       </a:r>
                     </a:p>
                   </a:txBody>
@@ -5428,22 +5060,52 @@
                       </a:pPr>
                       <a:r>
                         <a:rPr/>
-                        <a:t>11</a:t>
-                      </a:r>
-                    </a:p>
-                  </a:txBody>
-                </a:tc>
-                <a:tc>
-                  <a:txBody>
-                    <a:bodyPr/>
-                    <a:lstStyle/>
-                    <a:p>
-                      <a:pPr lvl="0" indent="0" marL="0">
-                        <a:buNone/>
-                      </a:pPr>
-                      <a:r>
-                        <a:rPr/>
-                        <a:t>Pacific silver fir</a:t>
+                        <a:t>12</a:t>
+                      </a:r>
+                    </a:p>
+                  </a:txBody>
+                </a:tc>
+                <a:tc>
+                  <a:txBody>
+                    <a:bodyPr/>
+                    <a:lstStyle/>
+                    <a:p>
+                      <a:pPr lvl="0" indent="0" marL="0">
+                        <a:buNone/>
+                      </a:pPr>
+                      <a:r>
+                        <a:rPr/>
+                        <a:t>9.3</a:t>
+                      </a:r>
+                    </a:p>
+                  </a:txBody>
+                </a:tc>
+                <a:tc>
+                  <a:txBody>
+                    <a:bodyPr/>
+                    <a:lstStyle/>
+                    <a:p>
+                      <a:pPr lvl="0" indent="0" marL="0">
+                        <a:buNone/>
+                      </a:pPr>
+                      <a:r>
+                        <a:rPr/>
+                        <a:t>62.7</a:t>
+                      </a:r>
+                    </a:p>
+                  </a:txBody>
+                </a:tc>
+                <a:tc>
+                  <a:txBody>
+                    <a:bodyPr/>
+                    <a:lstStyle/>
+                    <a:p>
+                      <a:pPr lvl="0" indent="0" marL="0">
+                        <a:buNone/>
+                      </a:pPr>
+                      <a:r>
+                        <a:rPr/>
+                        <a:t>323.46</a:t>
                       </a:r>
                     </a:p>
                   </a:txBody>
@@ -5490,7 +5152,37 @@
                       </a:pPr>
                       <a:r>
                         <a:rPr/>
-                        <a:t>balsam fir</a:t>
+                        <a:t>9.7</a:t>
+                      </a:r>
+                    </a:p>
+                  </a:txBody>
+                </a:tc>
+                <a:tc>
+                  <a:txBody>
+                    <a:bodyPr/>
+                    <a:lstStyle/>
+                    <a:p>
+                      <a:pPr lvl="0" indent="0" marL="0">
+                        <a:buNone/>
+                      </a:pPr>
+                      <a:r>
+                        <a:rPr/>
+                        <a:t>56.7</a:t>
+                      </a:r>
+                    </a:p>
+                  </a:txBody>
+                </a:tc>
+                <a:tc>
+                  <a:txBody>
+                    <a:bodyPr/>
+                    <a:lstStyle/>
+                    <a:p>
+                      <a:pPr lvl="0" indent="0" marL="0">
+                        <a:buNone/>
+                      </a:pPr>
+                      <a:r>
+                        <a:rPr/>
+                        <a:t>342.47</a:t>
                       </a:r>
                     </a:p>
                   </a:txBody>
@@ -5522,22 +5214,52 @@
                       </a:pPr>
                       <a:r>
                         <a:rPr/>
-                        <a:t>14</a:t>
-                      </a:r>
-                    </a:p>
-                  </a:txBody>
-                </a:tc>
-                <a:tc>
-                  <a:txBody>
-                    <a:bodyPr/>
-                    <a:lstStyle/>
-                    <a:p>
-                      <a:pPr lvl="0" indent="0" marL="0">
-                        <a:buNone/>
-                      </a:pPr>
-                      <a:r>
-                        <a:rPr/>
-                        <a:t>Santa Lucia or bristlecone fir</a:t>
+                        <a:t>12</a:t>
+                      </a:r>
+                    </a:p>
+                  </a:txBody>
+                </a:tc>
+                <a:tc>
+                  <a:txBody>
+                    <a:bodyPr/>
+                    <a:lstStyle/>
+                    <a:p>
+                      <a:pPr lvl="0" indent="0" marL="0">
+                        <a:buNone/>
+                      </a:pPr>
+                      <a:r>
+                        <a:rPr/>
+                        <a:t>11.4</a:t>
+                      </a:r>
+                    </a:p>
+                  </a:txBody>
+                </a:tc>
+                <a:tc>
+                  <a:txBody>
+                    <a:bodyPr/>
+                    <a:lstStyle/>
+                    <a:p>
+                      <a:pPr lvl="0" indent="0" marL="0">
+                        <a:buNone/>
+                      </a:pPr>
+                      <a:r>
+                        <a:rPr/>
+                        <a:t>66.1</a:t>
+                      </a:r>
+                    </a:p>
+                  </a:txBody>
+                </a:tc>
+                <a:tc>
+                  <a:txBody>
+                    <a:bodyPr/>
+                    <a:lstStyle/>
+                    <a:p>
+                      <a:pPr lvl="0" indent="0" marL="0">
+                        <a:buNone/>
+                      </a:pPr>
+                      <a:r>
+                        <a:rPr/>
+                        <a:t>499.35</a:t>
                       </a:r>
                     </a:p>
                   </a:txBody>
@@ -5569,22 +5291,52 @@
                       </a:pPr>
                       <a:r>
                         <a:rPr/>
-                        <a:t>15</a:t>
-                      </a:r>
-                    </a:p>
-                  </a:txBody>
-                </a:tc>
-                <a:tc>
-                  <a:txBody>
-                    <a:bodyPr/>
-                    <a:lstStyle/>
-                    <a:p>
-                      <a:pPr lvl="0" indent="0" marL="0">
-                        <a:buNone/>
-                      </a:pPr>
-                      <a:r>
-                        <a:rPr/>
-                        <a:t>white fir</a:t>
+                        <a:t>12</a:t>
+                      </a:r>
+                    </a:p>
+                  </a:txBody>
+                </a:tc>
+                <a:tc>
+                  <a:txBody>
+                    <a:bodyPr/>
+                    <a:lstStyle/>
+                    <a:p>
+                      <a:pPr lvl="0" indent="0" marL="0">
+                        <a:buNone/>
+                      </a:pPr>
+                      <a:r>
+                        <a:rPr/>
+                        <a:t>6.4</a:t>
+                      </a:r>
+                    </a:p>
+                  </a:txBody>
+                </a:tc>
+                <a:tc>
+                  <a:txBody>
+                    <a:bodyPr/>
+                    <a:lstStyle/>
+                    <a:p>
+                      <a:pPr lvl="0" indent="0" marL="0">
+                        <a:buNone/>
+                      </a:pPr>
+                      <a:r>
+                        <a:rPr/>
+                        <a:t>51.8</a:t>
+                      </a:r>
+                    </a:p>
+                  </a:txBody>
+                </a:tc>
+                <a:tc>
+                  <a:txBody>
+                    <a:bodyPr/>
+                    <a:lstStyle/>
+                    <a:p>
+                      <a:pPr lvl="0" indent="0" marL="0">
+                        <a:buNone/>
+                      </a:pPr>
+                      <a:r>
+                        <a:rPr/>
+                        <a:t>113.92</a:t>
                       </a:r>
                     </a:p>
                   </a:txBody>
@@ -5636,6 +5388,361 @@
             </a:pPr>
             <a:r>
               <a:rPr/>
+              <a:t>Tree Species Name Data:</a:t>
+            </a:r>
+          </a:p>
+        </p:txBody>
+      </p:sp>
+      <p:graphicFrame>
+        <p:nvGraphicFramePr>
+          <p:cNvPr id="6" name="Content Placeholder 5"/>
+          <p:cNvGraphicFramePr>
+            <a:graphicFrameLocks noGrp="1"/>
+          </p:cNvGraphicFramePr>
+          <p:nvPr>
+            <p:ph idx="1"/>
+          </p:nvPr>
+        </p:nvGraphicFramePr>
+        <p:xfrm>
+          <a:off x="457200" y="1193800"/>
+          <a:ext cx="8229600" cy="3390900"/>
+        </p:xfrm>
+        <a:graphic>
+          <a:graphicData uri="http://schemas.openxmlformats.org/drawingml/2006/table">
+            <a:tbl>
+              <a:tblPr firstRow="1" bandRow="1">
+                <a:tableStyleId>{5C22544A-7EE6-4342-B048-85BDC9FD1C3A}</a:tableStyleId>
+              </a:tblPr>
+              <a:tblGrid>
+                <a:gridCol w="2743200"/>
+                <a:gridCol w="2743200"/>
+                <a:gridCol w="2743200"/>
+              </a:tblGrid>
+              <a:tr h="0">
+                <a:tc>
+                  <a:txBody>
+                    <a:bodyPr/>
+                    <a:lstStyle/>
+                    <a:p>
+                      <a:endParaRPr/>
+                    </a:p>
+                  </a:txBody>
+                  <a:tcPr/>
+                </a:tc>
+                <a:tc>
+                  <a:txBody>
+                    <a:bodyPr/>
+                    <a:lstStyle/>
+                    <a:p>
+                      <a:pPr lvl="0" indent="0" marL="0">
+                        <a:buNone/>
+                      </a:pPr>
+                      <a:r>
+                        <a:rPr/>
+                        <a:t>SPCD</a:t>
+                      </a:r>
+                    </a:p>
+                  </a:txBody>
+                  <a:tcPr/>
+                </a:tc>
+                <a:tc>
+                  <a:txBody>
+                    <a:bodyPr/>
+                    <a:lstStyle/>
+                    <a:p>
+                      <a:pPr lvl="0" indent="0" marL="0">
+                        <a:buNone/>
+                      </a:pPr>
+                      <a:r>
+                        <a:rPr/>
+                        <a:t>COMMON_NAME</a:t>
+                      </a:r>
+                    </a:p>
+                  </a:txBody>
+                  <a:tcPr/>
+                </a:tc>
+              </a:tr>
+              <a:tr h="0">
+                <a:tc>
+                  <a:txBody>
+                    <a:bodyPr/>
+                    <a:lstStyle/>
+                    <a:p>
+                      <a:pPr lvl="0" indent="0" marL="0">
+                        <a:buNone/>
+                      </a:pPr>
+                      <a:r>
+                        <a:rPr/>
+                        <a:t>0</a:t>
+                      </a:r>
+                    </a:p>
+                  </a:txBody>
+                </a:tc>
+                <a:tc>
+                  <a:txBody>
+                    <a:bodyPr/>
+                    <a:lstStyle/>
+                    <a:p>
+                      <a:pPr lvl="0" indent="0" marL="0">
+                        <a:buNone/>
+                      </a:pPr>
+                      <a:r>
+                        <a:rPr/>
+                        <a:t>10</a:t>
+                      </a:r>
+                    </a:p>
+                  </a:txBody>
+                </a:tc>
+                <a:tc>
+                  <a:txBody>
+                    <a:bodyPr/>
+                    <a:lstStyle/>
+                    <a:p>
+                      <a:pPr lvl="0" indent="0" marL="0">
+                        <a:buNone/>
+                      </a:pPr>
+                      <a:r>
+                        <a:rPr/>
+                        <a:t>fir spp.</a:t>
+                      </a:r>
+                    </a:p>
+                  </a:txBody>
+                </a:tc>
+              </a:tr>
+              <a:tr h="0">
+                <a:tc>
+                  <a:txBody>
+                    <a:bodyPr/>
+                    <a:lstStyle/>
+                    <a:p>
+                      <a:pPr lvl="0" indent="0" marL="0">
+                        <a:buNone/>
+                      </a:pPr>
+                      <a:r>
+                        <a:rPr/>
+                        <a:t>1</a:t>
+                      </a:r>
+                    </a:p>
+                  </a:txBody>
+                </a:tc>
+                <a:tc>
+                  <a:txBody>
+                    <a:bodyPr/>
+                    <a:lstStyle/>
+                    <a:p>
+                      <a:pPr lvl="0" indent="0" marL="0">
+                        <a:buNone/>
+                      </a:pPr>
+                      <a:r>
+                        <a:rPr/>
+                        <a:t>11</a:t>
+                      </a:r>
+                    </a:p>
+                  </a:txBody>
+                </a:tc>
+                <a:tc>
+                  <a:txBody>
+                    <a:bodyPr/>
+                    <a:lstStyle/>
+                    <a:p>
+                      <a:pPr lvl="0" indent="0" marL="0">
+                        <a:buNone/>
+                      </a:pPr>
+                      <a:r>
+                        <a:rPr/>
+                        <a:t>Pacific silver fir</a:t>
+                      </a:r>
+                    </a:p>
+                  </a:txBody>
+                </a:tc>
+              </a:tr>
+              <a:tr h="0">
+                <a:tc>
+                  <a:txBody>
+                    <a:bodyPr/>
+                    <a:lstStyle/>
+                    <a:p>
+                      <a:pPr lvl="0" indent="0" marL="0">
+                        <a:buNone/>
+                      </a:pPr>
+                      <a:r>
+                        <a:rPr/>
+                        <a:t>2</a:t>
+                      </a:r>
+                    </a:p>
+                  </a:txBody>
+                </a:tc>
+                <a:tc>
+                  <a:txBody>
+                    <a:bodyPr/>
+                    <a:lstStyle/>
+                    <a:p>
+                      <a:pPr lvl="0" indent="0" marL="0">
+                        <a:buNone/>
+                      </a:pPr>
+                      <a:r>
+                        <a:rPr/>
+                        <a:t>12</a:t>
+                      </a:r>
+                    </a:p>
+                  </a:txBody>
+                </a:tc>
+                <a:tc>
+                  <a:txBody>
+                    <a:bodyPr/>
+                    <a:lstStyle/>
+                    <a:p>
+                      <a:pPr lvl="0" indent="0" marL="0">
+                        <a:buNone/>
+                      </a:pPr>
+                      <a:r>
+                        <a:rPr/>
+                        <a:t>balsam fir</a:t>
+                      </a:r>
+                    </a:p>
+                  </a:txBody>
+                </a:tc>
+              </a:tr>
+              <a:tr h="0">
+                <a:tc>
+                  <a:txBody>
+                    <a:bodyPr/>
+                    <a:lstStyle/>
+                    <a:p>
+                      <a:pPr lvl="0" indent="0" marL="0">
+                        <a:buNone/>
+                      </a:pPr>
+                      <a:r>
+                        <a:rPr/>
+                        <a:t>3</a:t>
+                      </a:r>
+                    </a:p>
+                  </a:txBody>
+                </a:tc>
+                <a:tc>
+                  <a:txBody>
+                    <a:bodyPr/>
+                    <a:lstStyle/>
+                    <a:p>
+                      <a:pPr lvl="0" indent="0" marL="0">
+                        <a:buNone/>
+                      </a:pPr>
+                      <a:r>
+                        <a:rPr/>
+                        <a:t>14</a:t>
+                      </a:r>
+                    </a:p>
+                  </a:txBody>
+                </a:tc>
+                <a:tc>
+                  <a:txBody>
+                    <a:bodyPr/>
+                    <a:lstStyle/>
+                    <a:p>
+                      <a:pPr lvl="0" indent="0" marL="0">
+                        <a:buNone/>
+                      </a:pPr>
+                      <a:r>
+                        <a:rPr/>
+                        <a:t>Santa Lucia or bristlecone fir</a:t>
+                      </a:r>
+                    </a:p>
+                  </a:txBody>
+                </a:tc>
+              </a:tr>
+              <a:tr h="0">
+                <a:tc>
+                  <a:txBody>
+                    <a:bodyPr/>
+                    <a:lstStyle/>
+                    <a:p>
+                      <a:pPr lvl="0" indent="0" marL="0">
+                        <a:buNone/>
+                      </a:pPr>
+                      <a:r>
+                        <a:rPr/>
+                        <a:t>4</a:t>
+                      </a:r>
+                    </a:p>
+                  </a:txBody>
+                </a:tc>
+                <a:tc>
+                  <a:txBody>
+                    <a:bodyPr/>
+                    <a:lstStyle/>
+                    <a:p>
+                      <a:pPr lvl="0" indent="0" marL="0">
+                        <a:buNone/>
+                      </a:pPr>
+                      <a:r>
+                        <a:rPr/>
+                        <a:t>15</a:t>
+                      </a:r>
+                    </a:p>
+                  </a:txBody>
+                </a:tc>
+                <a:tc>
+                  <a:txBody>
+                    <a:bodyPr/>
+                    <a:lstStyle/>
+                    <a:p>
+                      <a:pPr lvl="0" indent="0" marL="0">
+                        <a:buNone/>
+                      </a:pPr>
+                      <a:r>
+                        <a:rPr/>
+                        <a:t>white fir</a:t>
+                      </a:r>
+                    </a:p>
+                  </a:txBody>
+                </a:tc>
+              </a:tr>
+            </a:tbl>
+          </a:graphicData>
+        </a:graphic>
+      </p:graphicFrame>
+    </p:spTree>
+  </p:cSld>
+</p:sld>
+</file>
+
+<file path=ppt/slides/slide17.xml><?xml version="1.0" encoding="utf-8"?>
+<p:sld xmlns:a="http://schemas.openxmlformats.org/drawingml/2006/main" xmlns:r="http://schemas.openxmlformats.org/officeDocument/2006/relationships" xmlns:p="http://schemas.openxmlformats.org/presentationml/2006/main">
+  <p:cSld>
+    <p:spTree>
+      <p:nvGrpSpPr>
+        <p:cNvPr id="1" name=""/>
+        <p:cNvGrpSpPr/>
+        <p:nvPr/>
+      </p:nvGrpSpPr>
+      <p:grpSpPr>
+        <a:xfrm>
+          <a:off x="0" y="0"/>
+          <a:ext cx="0" cy="0"/>
+          <a:chOff x="0" y="0"/>
+          <a:chExt cx="0" cy="0"/>
+        </a:xfrm>
+      </p:grpSpPr>
+      <p:sp>
+        <p:nvSpPr>
+          <p:cNvPr id="2" name="Title 1"/>
+          <p:cNvSpPr>
+            <a:spLocks noGrp="1"/>
+          </p:cNvSpPr>
+          <p:nvPr>
+            <p:ph type="title"/>
+          </p:nvPr>
+        </p:nvSpPr>
+        <p:spPr/>
+        <p:txBody>
+          <a:bodyPr/>
+          <a:lstStyle/>
+          <a:p>
+            <a:pPr lvl="0" indent="0" marL="0">
+              <a:buNone/>
+            </a:pPr>
+            <a:r>
+              <a:rPr/>
               <a:t>Combined Dataset (species mapped onto bigger dataset):</a:t>
             </a:r>
           </a:p>
@@ -6230,7 +6337,638 @@
 </p:sld>
 </file>
 
-<file path=ppt/slides/slide17.xml><?xml version="1.0" encoding="utf-8"?>
+<file path=ppt/slides/slide18.xml><?xml version="1.0" encoding="utf-8"?>
+<p:sld xmlns:a="http://schemas.openxmlformats.org/drawingml/2006/main" xmlns:r="http://schemas.openxmlformats.org/officeDocument/2006/relationships" xmlns:p="http://schemas.openxmlformats.org/presentationml/2006/main">
+  <p:cSld>
+    <p:spTree>
+      <p:nvGrpSpPr>
+        <p:cNvPr id="1" name=""/>
+        <p:cNvGrpSpPr/>
+        <p:nvPr/>
+      </p:nvGrpSpPr>
+      <p:grpSpPr>
+        <a:xfrm>
+          <a:off x="0" y="0"/>
+          <a:ext cx="0" cy="0"/>
+          <a:chOff x="0" y="0"/>
+          <a:chExt cx="0" cy="0"/>
+        </a:xfrm>
+      </p:grpSpPr>
+      <p:sp>
+        <p:nvSpPr>
+          <p:cNvPr id="2" name="Title 1"/>
+          <p:cNvSpPr>
+            <a:spLocks noGrp="1"/>
+          </p:cNvSpPr>
+          <p:nvPr>
+            <p:ph type="title"/>
+          </p:nvPr>
+        </p:nvSpPr>
+        <p:spPr/>
+        <p:txBody>
+          <a:bodyPr/>
+          <a:lstStyle/>
+          <a:p>
+            <a:pPr lvl="0" indent="0" marL="0">
+              <a:buNone/>
+            </a:pPr>
+            <a:r>
+              <a:rPr/>
+              <a:t>Filtered data</a:t>
+            </a:r>
+          </a:p>
+        </p:txBody>
+      </p:sp>
+      <p:graphicFrame>
+        <p:nvGraphicFramePr>
+          <p:cNvPr id="6" name="Content Placeholder 5"/>
+          <p:cNvGraphicFramePr>
+            <a:graphicFrameLocks noGrp="1"/>
+          </p:cNvGraphicFramePr>
+          <p:nvPr>
+            <p:ph idx="1"/>
+          </p:nvPr>
+        </p:nvGraphicFramePr>
+        <p:xfrm>
+          <a:off x="457200" y="1193800"/>
+          <a:ext cx="8229600" cy="3390900"/>
+        </p:xfrm>
+        <a:graphic>
+          <a:graphicData uri="http://schemas.openxmlformats.org/drawingml/2006/table">
+            <a:tbl>
+              <a:tblPr firstRow="1" bandRow="1">
+                <a:tableStyleId>{5C22544A-7EE6-4342-B048-85BDC9FD1C3A}</a:tableStyleId>
+              </a:tblPr>
+              <a:tblGrid>
+                <a:gridCol w="1371600"/>
+                <a:gridCol w="1371600"/>
+                <a:gridCol w="1371600"/>
+                <a:gridCol w="1371600"/>
+                <a:gridCol w="1371600"/>
+                <a:gridCol w="1371600"/>
+              </a:tblGrid>
+              <a:tr h="0">
+                <a:tc>
+                  <a:txBody>
+                    <a:bodyPr/>
+                    <a:lstStyle/>
+                    <a:p>
+                      <a:endParaRPr/>
+                    </a:p>
+                  </a:txBody>
+                  <a:tcPr/>
+                </a:tc>
+                <a:tc>
+                  <a:txBody>
+                    <a:bodyPr/>
+                    <a:lstStyle/>
+                    <a:p>
+                      <a:pPr lvl="0" indent="0" marL="0">
+                        <a:buNone/>
+                      </a:pPr>
+                      <a:r>
+                        <a:rPr/>
+                        <a:t>SPCD</a:t>
+                      </a:r>
+                    </a:p>
+                  </a:txBody>
+                  <a:tcPr/>
+                </a:tc>
+                <a:tc>
+                  <a:txBody>
+                    <a:bodyPr/>
+                    <a:lstStyle/>
+                    <a:p>
+                      <a:pPr lvl="0" indent="0" marL="0">
+                        <a:buNone/>
+                      </a:pPr>
+                      <a:r>
+                        <a:rPr/>
+                        <a:t>DO_BH</a:t>
+                      </a:r>
+                    </a:p>
+                  </a:txBody>
+                  <a:tcPr/>
+                </a:tc>
+                <a:tc>
+                  <a:txBody>
+                    <a:bodyPr/>
+                    <a:lstStyle/>
+                    <a:p>
+                      <a:pPr lvl="0" indent="0" marL="0">
+                        <a:buNone/>
+                      </a:pPr>
+                      <a:r>
+                        <a:rPr/>
+                        <a:t>HT_TOT</a:t>
+                      </a:r>
+                    </a:p>
+                  </a:txBody>
+                  <a:tcPr/>
+                </a:tc>
+                <a:tc>
+                  <a:txBody>
+                    <a:bodyPr/>
+                    <a:lstStyle/>
+                    <a:p>
+                      <a:pPr lvl="0" indent="0" marL="0">
+                        <a:buNone/>
+                      </a:pPr>
+                      <a:r>
+                        <a:rPr/>
+                        <a:t>TT_DW_CRM</a:t>
+                      </a:r>
+                    </a:p>
+                  </a:txBody>
+                  <a:tcPr/>
+                </a:tc>
+                <a:tc>
+                  <a:txBody>
+                    <a:bodyPr/>
+                    <a:lstStyle/>
+                    <a:p>
+                      <a:pPr lvl="0" indent="0" marL="0">
+                        <a:buNone/>
+                      </a:pPr>
+                      <a:r>
+                        <a:rPr/>
+                        <a:t>COMMON_NAME</a:t>
+                      </a:r>
+                    </a:p>
+                  </a:txBody>
+                  <a:tcPr/>
+                </a:tc>
+              </a:tr>
+              <a:tr h="0">
+                <a:tc>
+                  <a:txBody>
+                    <a:bodyPr/>
+                    <a:lstStyle/>
+                    <a:p>
+                      <a:pPr lvl="0" indent="0" marL="0">
+                        <a:buNone/>
+                      </a:pPr>
+                      <a:r>
+                        <a:rPr/>
+                        <a:t>0</a:t>
+                      </a:r>
+                    </a:p>
+                  </a:txBody>
+                </a:tc>
+                <a:tc>
+                  <a:txBody>
+                    <a:bodyPr/>
+                    <a:lstStyle/>
+                    <a:p>
+                      <a:pPr lvl="0" indent="0" marL="0">
+                        <a:buNone/>
+                      </a:pPr>
+                      <a:r>
+                        <a:rPr/>
+                        <a:t>12</a:t>
+                      </a:r>
+                    </a:p>
+                  </a:txBody>
+                </a:tc>
+                <a:tc>
+                  <a:txBody>
+                    <a:bodyPr/>
+                    <a:lstStyle/>
+                    <a:p>
+                      <a:pPr lvl="0" indent="0" marL="0">
+                        <a:buNone/>
+                      </a:pPr>
+                      <a:r>
+                        <a:rPr/>
+                        <a:t>7.5</a:t>
+                      </a:r>
+                    </a:p>
+                  </a:txBody>
+                </a:tc>
+                <a:tc>
+                  <a:txBody>
+                    <a:bodyPr/>
+                    <a:lstStyle/>
+                    <a:p>
+                      <a:pPr lvl="0" indent="0" marL="0">
+                        <a:buNone/>
+                      </a:pPr>
+                      <a:r>
+                        <a:rPr/>
+                        <a:t>45.2</a:t>
+                      </a:r>
+                    </a:p>
+                  </a:txBody>
+                </a:tc>
+                <a:tc>
+                  <a:txBody>
+                    <a:bodyPr/>
+                    <a:lstStyle/>
+                    <a:p>
+                      <a:pPr lvl="0" indent="0" marL="0">
+                        <a:buNone/>
+                      </a:pPr>
+                      <a:r>
+                        <a:rPr/>
+                        <a:t>178.86</a:t>
+                      </a:r>
+                    </a:p>
+                  </a:txBody>
+                </a:tc>
+                <a:tc>
+                  <a:txBody>
+                    <a:bodyPr/>
+                    <a:lstStyle/>
+                    <a:p>
+                      <a:pPr lvl="0" indent="0" marL="0">
+                        <a:buNone/>
+                      </a:pPr>
+                      <a:r>
+                        <a:rPr/>
+                        <a:t>balsam fir</a:t>
+                      </a:r>
+                    </a:p>
+                  </a:txBody>
+                </a:tc>
+              </a:tr>
+              <a:tr h="0">
+                <a:tc>
+                  <a:txBody>
+                    <a:bodyPr/>
+                    <a:lstStyle/>
+                    <a:p>
+                      <a:pPr lvl="0" indent="0" marL="0">
+                        <a:buNone/>
+                      </a:pPr>
+                      <a:r>
+                        <a:rPr/>
+                        <a:t>1</a:t>
+                      </a:r>
+                    </a:p>
+                  </a:txBody>
+                </a:tc>
+                <a:tc>
+                  <a:txBody>
+                    <a:bodyPr/>
+                    <a:lstStyle/>
+                    <a:p>
+                      <a:pPr lvl="0" indent="0" marL="0">
+                        <a:buNone/>
+                      </a:pPr>
+                      <a:r>
+                        <a:rPr/>
+                        <a:t>12</a:t>
+                      </a:r>
+                    </a:p>
+                  </a:txBody>
+                </a:tc>
+                <a:tc>
+                  <a:txBody>
+                    <a:bodyPr/>
+                    <a:lstStyle/>
+                    <a:p>
+                      <a:pPr lvl="0" indent="0" marL="0">
+                        <a:buNone/>
+                      </a:pPr>
+                      <a:r>
+                        <a:rPr/>
+                        <a:t>9.3</a:t>
+                      </a:r>
+                    </a:p>
+                  </a:txBody>
+                </a:tc>
+                <a:tc>
+                  <a:txBody>
+                    <a:bodyPr/>
+                    <a:lstStyle/>
+                    <a:p>
+                      <a:pPr lvl="0" indent="0" marL="0">
+                        <a:buNone/>
+                      </a:pPr>
+                      <a:r>
+                        <a:rPr/>
+                        <a:t>62.7</a:t>
+                      </a:r>
+                    </a:p>
+                  </a:txBody>
+                </a:tc>
+                <a:tc>
+                  <a:txBody>
+                    <a:bodyPr/>
+                    <a:lstStyle/>
+                    <a:p>
+                      <a:pPr lvl="0" indent="0" marL="0">
+                        <a:buNone/>
+                      </a:pPr>
+                      <a:r>
+                        <a:rPr/>
+                        <a:t>323.46</a:t>
+                      </a:r>
+                    </a:p>
+                  </a:txBody>
+                </a:tc>
+                <a:tc>
+                  <a:txBody>
+                    <a:bodyPr/>
+                    <a:lstStyle/>
+                    <a:p>
+                      <a:pPr lvl="0" indent="0" marL="0">
+                        <a:buNone/>
+                      </a:pPr>
+                      <a:r>
+                        <a:rPr/>
+                        <a:t>balsam fir</a:t>
+                      </a:r>
+                    </a:p>
+                  </a:txBody>
+                </a:tc>
+              </a:tr>
+              <a:tr h="0">
+                <a:tc>
+                  <a:txBody>
+                    <a:bodyPr/>
+                    <a:lstStyle/>
+                    <a:p>
+                      <a:pPr lvl="0" indent="0" marL="0">
+                        <a:buNone/>
+                      </a:pPr>
+                      <a:r>
+                        <a:rPr/>
+                        <a:t>2</a:t>
+                      </a:r>
+                    </a:p>
+                  </a:txBody>
+                </a:tc>
+                <a:tc>
+                  <a:txBody>
+                    <a:bodyPr/>
+                    <a:lstStyle/>
+                    <a:p>
+                      <a:pPr lvl="0" indent="0" marL="0">
+                        <a:buNone/>
+                      </a:pPr>
+                      <a:r>
+                        <a:rPr/>
+                        <a:t>12</a:t>
+                      </a:r>
+                    </a:p>
+                  </a:txBody>
+                </a:tc>
+                <a:tc>
+                  <a:txBody>
+                    <a:bodyPr/>
+                    <a:lstStyle/>
+                    <a:p>
+                      <a:pPr lvl="0" indent="0" marL="0">
+                        <a:buNone/>
+                      </a:pPr>
+                      <a:r>
+                        <a:rPr/>
+                        <a:t>9.7</a:t>
+                      </a:r>
+                    </a:p>
+                  </a:txBody>
+                </a:tc>
+                <a:tc>
+                  <a:txBody>
+                    <a:bodyPr/>
+                    <a:lstStyle/>
+                    <a:p>
+                      <a:pPr lvl="0" indent="0" marL="0">
+                        <a:buNone/>
+                      </a:pPr>
+                      <a:r>
+                        <a:rPr/>
+                        <a:t>56.7</a:t>
+                      </a:r>
+                    </a:p>
+                  </a:txBody>
+                </a:tc>
+                <a:tc>
+                  <a:txBody>
+                    <a:bodyPr/>
+                    <a:lstStyle/>
+                    <a:p>
+                      <a:pPr lvl="0" indent="0" marL="0">
+                        <a:buNone/>
+                      </a:pPr>
+                      <a:r>
+                        <a:rPr/>
+                        <a:t>342.47</a:t>
+                      </a:r>
+                    </a:p>
+                  </a:txBody>
+                </a:tc>
+                <a:tc>
+                  <a:txBody>
+                    <a:bodyPr/>
+                    <a:lstStyle/>
+                    <a:p>
+                      <a:pPr lvl="0" indent="0" marL="0">
+                        <a:buNone/>
+                      </a:pPr>
+                      <a:r>
+                        <a:rPr/>
+                        <a:t>balsam fir</a:t>
+                      </a:r>
+                    </a:p>
+                  </a:txBody>
+                </a:tc>
+              </a:tr>
+              <a:tr h="0">
+                <a:tc>
+                  <a:txBody>
+                    <a:bodyPr/>
+                    <a:lstStyle/>
+                    <a:p>
+                      <a:pPr lvl="0" indent="0" marL="0">
+                        <a:buNone/>
+                      </a:pPr>
+                      <a:r>
+                        <a:rPr/>
+                        <a:t>3</a:t>
+                      </a:r>
+                    </a:p>
+                  </a:txBody>
+                </a:tc>
+                <a:tc>
+                  <a:txBody>
+                    <a:bodyPr/>
+                    <a:lstStyle/>
+                    <a:p>
+                      <a:pPr lvl="0" indent="0" marL="0">
+                        <a:buNone/>
+                      </a:pPr>
+                      <a:r>
+                        <a:rPr/>
+                        <a:t>12</a:t>
+                      </a:r>
+                    </a:p>
+                  </a:txBody>
+                </a:tc>
+                <a:tc>
+                  <a:txBody>
+                    <a:bodyPr/>
+                    <a:lstStyle/>
+                    <a:p>
+                      <a:pPr lvl="0" indent="0" marL="0">
+                        <a:buNone/>
+                      </a:pPr>
+                      <a:r>
+                        <a:rPr/>
+                        <a:t>11.4</a:t>
+                      </a:r>
+                    </a:p>
+                  </a:txBody>
+                </a:tc>
+                <a:tc>
+                  <a:txBody>
+                    <a:bodyPr/>
+                    <a:lstStyle/>
+                    <a:p>
+                      <a:pPr lvl="0" indent="0" marL="0">
+                        <a:buNone/>
+                      </a:pPr>
+                      <a:r>
+                        <a:rPr/>
+                        <a:t>66.1</a:t>
+                      </a:r>
+                    </a:p>
+                  </a:txBody>
+                </a:tc>
+                <a:tc>
+                  <a:txBody>
+                    <a:bodyPr/>
+                    <a:lstStyle/>
+                    <a:p>
+                      <a:pPr lvl="0" indent="0" marL="0">
+                        <a:buNone/>
+                      </a:pPr>
+                      <a:r>
+                        <a:rPr/>
+                        <a:t>499.35</a:t>
+                      </a:r>
+                    </a:p>
+                  </a:txBody>
+                </a:tc>
+                <a:tc>
+                  <a:txBody>
+                    <a:bodyPr/>
+                    <a:lstStyle/>
+                    <a:p>
+                      <a:pPr lvl="0" indent="0" marL="0">
+                        <a:buNone/>
+                      </a:pPr>
+                      <a:r>
+                        <a:rPr/>
+                        <a:t>balsam fir</a:t>
+                      </a:r>
+                    </a:p>
+                  </a:txBody>
+                </a:tc>
+              </a:tr>
+              <a:tr h="0">
+                <a:tc>
+                  <a:txBody>
+                    <a:bodyPr/>
+                    <a:lstStyle/>
+                    <a:p>
+                      <a:pPr lvl="0" indent="0" marL="0">
+                        <a:buNone/>
+                      </a:pPr>
+                      <a:r>
+                        <a:rPr/>
+                        <a:t>4</a:t>
+                      </a:r>
+                    </a:p>
+                  </a:txBody>
+                </a:tc>
+                <a:tc>
+                  <a:txBody>
+                    <a:bodyPr/>
+                    <a:lstStyle/>
+                    <a:p>
+                      <a:pPr lvl="0" indent="0" marL="0">
+                        <a:buNone/>
+                      </a:pPr>
+                      <a:r>
+                        <a:rPr/>
+                        <a:t>12</a:t>
+                      </a:r>
+                    </a:p>
+                  </a:txBody>
+                </a:tc>
+                <a:tc>
+                  <a:txBody>
+                    <a:bodyPr/>
+                    <a:lstStyle/>
+                    <a:p>
+                      <a:pPr lvl="0" indent="0" marL="0">
+                        <a:buNone/>
+                      </a:pPr>
+                      <a:r>
+                        <a:rPr/>
+                        <a:t>6.4</a:t>
+                      </a:r>
+                    </a:p>
+                  </a:txBody>
+                </a:tc>
+                <a:tc>
+                  <a:txBody>
+                    <a:bodyPr/>
+                    <a:lstStyle/>
+                    <a:p>
+                      <a:pPr lvl="0" indent="0" marL="0">
+                        <a:buNone/>
+                      </a:pPr>
+                      <a:r>
+                        <a:rPr/>
+                        <a:t>51.8</a:t>
+                      </a:r>
+                    </a:p>
+                  </a:txBody>
+                </a:tc>
+                <a:tc>
+                  <a:txBody>
+                    <a:bodyPr/>
+                    <a:lstStyle/>
+                    <a:p>
+                      <a:pPr lvl="0" indent="0" marL="0">
+                        <a:buNone/>
+                      </a:pPr>
+                      <a:r>
+                        <a:rPr/>
+                        <a:t>113.92</a:t>
+                      </a:r>
+                    </a:p>
+                  </a:txBody>
+                </a:tc>
+                <a:tc>
+                  <a:txBody>
+                    <a:bodyPr/>
+                    <a:lstStyle/>
+                    <a:p>
+                      <a:pPr lvl="0" indent="0" marL="0">
+                        <a:buNone/>
+                      </a:pPr>
+                      <a:r>
+                        <a:rPr/>
+                        <a:t>balsam fir</a:t>
+                      </a:r>
+                    </a:p>
+                  </a:txBody>
+                </a:tc>
+              </a:tr>
+            </a:tbl>
+          </a:graphicData>
+        </a:graphic>
+      </p:graphicFrame>
+    </p:spTree>
+  </p:cSld>
+</p:sld>
+</file>
+
+<file path=ppt/slides/slide19.xml><?xml version="1.0" encoding="utf-8"?>
 <p:sld xmlns:a="http://schemas.openxmlformats.org/drawingml/2006/main" xmlns:r="http://schemas.openxmlformats.org/officeDocument/2006/relationships" xmlns:p="http://schemas.openxmlformats.org/presentationml/2006/main">
   <p:cSld>
     <p:spTree>

</xml_diff>

<commit_message>
more information the meet the 10 min mark part 2 can I have a cat specifly a orange cat and name it toast
</commit_message>
<xml_diff>
--- a/Project-3/presentation.pptx
+++ b/Project-3/presentation.pptx
@@ -23,6 +23,8 @@
     <p:sldId id="271" r:id="rId17"/>
     <p:sldId id="272" r:id="rId18"/>
     <p:sldId id="273" r:id="rId19"/>
+    <p:sldId id="274" r:id="rId20"/>
+    <p:sldId id="275" r:id="rId21"/>
   </p:sldIdLst>
   <p:sldSz cx="9144000" cy="5143500" type="screen16x9"/>
   <p:notesSz cx="6858000" cy="9144000"/>
@@ -3458,7 +3460,7 @@
             </a:pPr>
             <a:r>
               <a:rPr/>
-              <a:t>Performance Metric</a:t>
+              <a:t>Consultation</a:t>
             </a:r>
           </a:p>
         </p:txBody>
@@ -3478,12 +3480,17 @@
           <a:bodyPr/>
           <a:lstStyle/>
           <a:p>
-            <a:pPr lvl="0" indent="0" marL="0">
-              <a:buNone/>
-            </a:pPr>
+            <a:pPr lvl="0"/>
             <a:r>
               <a:rPr/>
-              <a:t>The Performance metric we choose is Root Mean Square Logarithmic Error(RMSLE), because when we were looking at the dataset of the biomass of different kinds of tree species, we saw that some species have more data than other species so the assume that the data is skewed</a:t>
+              <a:t>When predicting tree biomass, employ the performance metric root mean square logarithmic error since biomass data varies greatly, ranging from tiny saplings to enormous trees, majority of trees having exponential growth.</a:t>
+            </a:r>
+          </a:p>
+          <a:p>
+            <a:pPr lvl="0"/>
+            <a:r>
+              <a:rPr/>
+              <a:t>We chose kNN regression over linear regression because when looking at the graphs Dean presented, we saw that the tree diameter/height vs. biomass graphs all have exponential growth.</a:t>
             </a:r>
           </a:p>
         </p:txBody>
@@ -3530,1147 +3537,34 @@
             </a:pPr>
             <a:r>
               <a:rPr/>
-              <a:t>Model</a:t>
+              <a:t>Discussion with the group :3</a:t>
             </a:r>
           </a:p>
         </p:txBody>
       </p:sp>
-      <p:graphicFrame>
-        <p:nvGraphicFramePr>
-          <p:cNvPr id="6" name="Content Placeholder 5"/>
-          <p:cNvGraphicFramePr>
-            <a:graphicFrameLocks noGrp="1"/>
-          </p:cNvGraphicFramePr>
+      <p:sp>
+        <p:nvSpPr>
+          <p:cNvPr id="3" name="Content Placeholder 2"/>
+          <p:cNvSpPr>
+            <a:spLocks noGrp="1"/>
+          </p:cNvSpPr>
           <p:nvPr>
             <p:ph idx="1"/>
           </p:nvPr>
-        </p:nvGraphicFramePr>
-        <p:xfrm>
-          <a:off x="457200" y="1193800"/>
-          <a:ext cx="8229600" cy="3390900"/>
-        </p:xfrm>
-        <a:graphic>
-          <a:graphicData uri="http://schemas.openxmlformats.org/drawingml/2006/table">
-            <a:tbl>
-              <a:tblPr firstRow="1" bandRow="1">
-                <a:tableStyleId>{5C22544A-7EE6-4342-B048-85BDC9FD1C3A}</a:tableStyleId>
-              </a:tblPr>
-              <a:tblGrid>
-                <a:gridCol w="1371600"/>
-                <a:gridCol w="1371600"/>
-                <a:gridCol w="1371600"/>
-                <a:gridCol w="1371600"/>
-                <a:gridCol w="1371600"/>
-                <a:gridCol w="1371600"/>
-              </a:tblGrid>
-              <a:tr h="0">
-                <a:tc>
-                  <a:txBody>
-                    <a:bodyPr/>
-                    <a:lstStyle/>
-                    <a:p>
-                      <a:endParaRPr/>
-                    </a:p>
-                  </a:txBody>
-                  <a:tcPr/>
-                </a:tc>
-                <a:tc>
-                  <a:txBody>
-                    <a:bodyPr/>
-                    <a:lstStyle/>
-                    <a:p>
-                      <a:pPr lvl="0" indent="0" marL="0">
-                        <a:buNone/>
-                      </a:pPr>
-                      <a:r>
-                        <a:rPr/>
-                        <a:t>Species</a:t>
-                      </a:r>
-                    </a:p>
-                  </a:txBody>
-                  <a:tcPr/>
-                </a:tc>
-                <a:tc>
-                  <a:txBody>
-                    <a:bodyPr/>
-                    <a:lstStyle/>
-                    <a:p>
-                      <a:pPr lvl="0" indent="0" marL="0">
-                        <a:buNone/>
-                      </a:pPr>
-                      <a:r>
-                        <a:rPr/>
-                        <a:t>k</a:t>
-                      </a:r>
-                    </a:p>
-                  </a:txBody>
-                  <a:tcPr/>
-                </a:tc>
-                <a:tc>
-                  <a:txBody>
-                    <a:bodyPr/>
-                    <a:lstStyle/>
-                    <a:p>
-                      <a:pPr lvl="0" indent="0" marL="0">
-                        <a:buNone/>
-                      </a:pPr>
-                      <a:r>
-                        <a:rPr/>
-                        <a:t>RMSE</a:t>
-                      </a:r>
-                    </a:p>
-                  </a:txBody>
-                  <a:tcPr/>
-                </a:tc>
-                <a:tc>
-                  <a:txBody>
-                    <a:bodyPr/>
-                    <a:lstStyle/>
-                    <a:p>
-                      <a:pPr lvl="0" indent="0" marL="0">
-                        <a:buNone/>
-                      </a:pPr>
-                      <a:r>
-                        <a:rPr/>
-                        <a:t>MAE</a:t>
-                      </a:r>
-                    </a:p>
-                  </a:txBody>
-                  <a:tcPr/>
-                </a:tc>
-                <a:tc>
-                  <a:txBody>
-                    <a:bodyPr/>
-                    <a:lstStyle/>
-                    <a:p>
-                      <a:pPr lvl="0" indent="0" marL="0">
-                        <a:buNone/>
-                      </a:pPr>
-                      <a:r>
-                        <a:rPr/>
-                        <a:t>RMSLE</a:t>
-                      </a:r>
-                    </a:p>
-                  </a:txBody>
-                  <a:tcPr/>
-                </a:tc>
-              </a:tr>
-              <a:tr h="0">
-                <a:tc>
-                  <a:txBody>
-                    <a:bodyPr/>
-                    <a:lstStyle/>
-                    <a:p>
-                      <a:pPr lvl="0" indent="0" marL="0">
-                        <a:buNone/>
-                      </a:pPr>
-                      <a:r>
-                        <a:rPr/>
-                        <a:t>0</a:t>
-                      </a:r>
-                    </a:p>
-                  </a:txBody>
-                </a:tc>
-                <a:tc>
-                  <a:txBody>
-                    <a:bodyPr/>
-                    <a:lstStyle/>
-                    <a:p>
-                      <a:pPr lvl="0" indent="0" marL="0">
-                        <a:buNone/>
-                      </a:pPr>
-                      <a:r>
-                        <a:rPr/>
-                        <a:t>balsam fir</a:t>
-                      </a:r>
-                    </a:p>
-                  </a:txBody>
-                </a:tc>
-                <a:tc>
-                  <a:txBody>
-                    <a:bodyPr/>
-                    <a:lstStyle/>
-                    <a:p>
-                      <a:pPr lvl="0" indent="0" marL="0">
-                        <a:buNone/>
-                      </a:pPr>
-                      <a:r>
-                        <a:rPr/>
-                        <a:t>2</a:t>
-                      </a:r>
-                    </a:p>
-                  </a:txBody>
-                </a:tc>
-                <a:tc>
-                  <a:txBody>
-                    <a:bodyPr/>
-                    <a:lstStyle/>
-                    <a:p>
-                      <a:pPr lvl="0" indent="0" marL="0">
-                        <a:buNone/>
-                      </a:pPr>
-                      <a:r>
-                        <a:rPr/>
-                        <a:t>125.825473</a:t>
-                      </a:r>
-                    </a:p>
-                  </a:txBody>
-                </a:tc>
-                <a:tc>
-                  <a:txBody>
-                    <a:bodyPr/>
-                    <a:lstStyle/>
-                    <a:p>
-                      <a:pPr lvl="0" indent="0" marL="0">
-                        <a:buNone/>
-                      </a:pPr>
-                      <a:r>
-                        <a:rPr/>
-                        <a:t>34.801913</a:t>
-                      </a:r>
-                    </a:p>
-                  </a:txBody>
-                </a:tc>
-                <a:tc>
-                  <a:txBody>
-                    <a:bodyPr/>
-                    <a:lstStyle/>
-                    <a:p>
-                      <a:pPr lvl="0" indent="0" marL="0">
-                        <a:buNone/>
-                      </a:pPr>
-                      <a:r>
-                        <a:rPr/>
-                        <a:t>0.119574</a:t>
-                      </a:r>
-                    </a:p>
-                  </a:txBody>
-                </a:tc>
-              </a:tr>
-              <a:tr h="0">
-                <a:tc>
-                  <a:txBody>
-                    <a:bodyPr/>
-                    <a:lstStyle/>
-                    <a:p>
-                      <a:pPr lvl="0" indent="0" marL="0">
-                        <a:buNone/>
-                      </a:pPr>
-                      <a:r>
-                        <a:rPr/>
-                        <a:t>1</a:t>
-                      </a:r>
-                    </a:p>
-                  </a:txBody>
-                </a:tc>
-                <a:tc>
-                  <a:txBody>
-                    <a:bodyPr/>
-                    <a:lstStyle/>
-                    <a:p>
-                      <a:pPr lvl="0" indent="0" marL="0">
-                        <a:buNone/>
-                      </a:pPr>
-                      <a:r>
-                        <a:rPr/>
-                        <a:t>balsam fir</a:t>
-                      </a:r>
-                    </a:p>
-                  </a:txBody>
-                </a:tc>
-                <a:tc>
-                  <a:txBody>
-                    <a:bodyPr/>
-                    <a:lstStyle/>
-                    <a:p>
-                      <a:pPr lvl="0" indent="0" marL="0">
-                        <a:buNone/>
-                      </a:pPr>
-                      <a:r>
-                        <a:rPr/>
-                        <a:t>3</a:t>
-                      </a:r>
-                    </a:p>
-                  </a:txBody>
-                </a:tc>
-                <a:tc>
-                  <a:txBody>
-                    <a:bodyPr/>
-                    <a:lstStyle/>
-                    <a:p>
-                      <a:pPr lvl="0" indent="0" marL="0">
-                        <a:buNone/>
-                      </a:pPr>
-                      <a:r>
-                        <a:rPr/>
-                        <a:t>129.651479</a:t>
-                      </a:r>
-                    </a:p>
-                  </a:txBody>
-                </a:tc>
-                <a:tc>
-                  <a:txBody>
-                    <a:bodyPr/>
-                    <a:lstStyle/>
-                    <a:p>
-                      <a:pPr lvl="0" indent="0" marL="0">
-                        <a:buNone/>
-                      </a:pPr>
-                      <a:r>
-                        <a:rPr/>
-                        <a:t>36.646493</a:t>
-                      </a:r>
-                    </a:p>
-                  </a:txBody>
-                </a:tc>
-                <a:tc>
-                  <a:txBody>
-                    <a:bodyPr/>
-                    <a:lstStyle/>
-                    <a:p>
-                      <a:pPr lvl="0" indent="0" marL="0">
-                        <a:buNone/>
-                      </a:pPr>
-                      <a:r>
-                        <a:rPr/>
-                        <a:t>0.123724</a:t>
-                      </a:r>
-                    </a:p>
-                  </a:txBody>
-                </a:tc>
-              </a:tr>
-              <a:tr h="0">
-                <a:tc>
-                  <a:txBody>
-                    <a:bodyPr/>
-                    <a:lstStyle/>
-                    <a:p>
-                      <a:pPr lvl="0" indent="0" marL="0">
-                        <a:buNone/>
-                      </a:pPr>
-                      <a:r>
-                        <a:rPr/>
-                        <a:t>2</a:t>
-                      </a:r>
-                    </a:p>
-                  </a:txBody>
-                </a:tc>
-                <a:tc>
-                  <a:txBody>
-                    <a:bodyPr/>
-                    <a:lstStyle/>
-                    <a:p>
-                      <a:pPr lvl="0" indent="0" marL="0">
-                        <a:buNone/>
-                      </a:pPr>
-                      <a:r>
-                        <a:rPr/>
-                        <a:t>balsam fir</a:t>
-                      </a:r>
-                    </a:p>
-                  </a:txBody>
-                </a:tc>
-                <a:tc>
-                  <a:txBody>
-                    <a:bodyPr/>
-                    <a:lstStyle/>
-                    <a:p>
-                      <a:pPr lvl="0" indent="0" marL="0">
-                        <a:buNone/>
-                      </a:pPr>
-                      <a:r>
-                        <a:rPr/>
-                        <a:t>4</a:t>
-                      </a:r>
-                    </a:p>
-                  </a:txBody>
-                </a:tc>
-                <a:tc>
-                  <a:txBody>
-                    <a:bodyPr/>
-                    <a:lstStyle/>
-                    <a:p>
-                      <a:pPr lvl="0" indent="0" marL="0">
-                        <a:buNone/>
-                      </a:pPr>
-                      <a:r>
-                        <a:rPr/>
-                        <a:t>134.599829</a:t>
-                      </a:r>
-                    </a:p>
-                  </a:txBody>
-                </a:tc>
-                <a:tc>
-                  <a:txBody>
-                    <a:bodyPr/>
-                    <a:lstStyle/>
-                    <a:p>
-                      <a:pPr lvl="0" indent="0" marL="0">
-                        <a:buNone/>
-                      </a:pPr>
-                      <a:r>
-                        <a:rPr/>
-                        <a:t>38.884870</a:t>
-                      </a:r>
-                    </a:p>
-                  </a:txBody>
-                </a:tc>
-                <a:tc>
-                  <a:txBody>
-                    <a:bodyPr/>
-                    <a:lstStyle/>
-                    <a:p>
-                      <a:pPr lvl="0" indent="0" marL="0">
-                        <a:buNone/>
-                      </a:pPr>
-                      <a:r>
-                        <a:rPr/>
-                        <a:t>0.133858</a:t>
-                      </a:r>
-                    </a:p>
-                  </a:txBody>
-                </a:tc>
-              </a:tr>
-              <a:tr h="0">
-                <a:tc>
-                  <a:txBody>
-                    <a:bodyPr/>
-                    <a:lstStyle/>
-                    <a:p>
-                      <a:pPr lvl="0" indent="0" marL="0">
-                        <a:buNone/>
-                      </a:pPr>
-                      <a:r>
-                        <a:rPr/>
-                        <a:t>3</a:t>
-                      </a:r>
-                    </a:p>
-                  </a:txBody>
-                </a:tc>
-                <a:tc>
-                  <a:txBody>
-                    <a:bodyPr/>
-                    <a:lstStyle/>
-                    <a:p>
-                      <a:pPr lvl="0" indent="0" marL="0">
-                        <a:buNone/>
-                      </a:pPr>
-                      <a:r>
-                        <a:rPr/>
-                        <a:t>balsam fir</a:t>
-                      </a:r>
-                    </a:p>
-                  </a:txBody>
-                </a:tc>
-                <a:tc>
-                  <a:txBody>
-                    <a:bodyPr/>
-                    <a:lstStyle/>
-                    <a:p>
-                      <a:pPr lvl="0" indent="0" marL="0">
-                        <a:buNone/>
-                      </a:pPr>
-                      <a:r>
-                        <a:rPr/>
-                        <a:t>5</a:t>
-                      </a:r>
-                    </a:p>
-                  </a:txBody>
-                </a:tc>
-                <a:tc>
-                  <a:txBody>
-                    <a:bodyPr/>
-                    <a:lstStyle/>
-                    <a:p>
-                      <a:pPr lvl="0" indent="0" marL="0">
-                        <a:buNone/>
-                      </a:pPr>
-                      <a:r>
-                        <a:rPr/>
-                        <a:t>145.003601</a:t>
-                      </a:r>
-                    </a:p>
-                  </a:txBody>
-                </a:tc>
-                <a:tc>
-                  <a:txBody>
-                    <a:bodyPr/>
-                    <a:lstStyle/>
-                    <a:p>
-                      <a:pPr lvl="0" indent="0" marL="0">
-                        <a:buNone/>
-                      </a:pPr>
-                      <a:r>
-                        <a:rPr/>
-                        <a:t>41.209530</a:t>
-                      </a:r>
-                    </a:p>
-                  </a:txBody>
-                </a:tc>
-                <a:tc>
-                  <a:txBody>
-                    <a:bodyPr/>
-                    <a:lstStyle/>
-                    <a:p>
-                      <a:pPr lvl="0" indent="0" marL="0">
-                        <a:buNone/>
-                      </a:pPr>
-                      <a:r>
-                        <a:rPr/>
-                        <a:t>0.144063</a:t>
-                      </a:r>
-                    </a:p>
-                  </a:txBody>
-                </a:tc>
-              </a:tr>
-              <a:tr h="0">
-                <a:tc>
-                  <a:txBody>
-                    <a:bodyPr/>
-                    <a:lstStyle/>
-                    <a:p>
-                      <a:pPr lvl="0" indent="0" marL="0">
-                        <a:buNone/>
-                      </a:pPr>
-                      <a:r>
-                        <a:rPr/>
-                        <a:t>4</a:t>
-                      </a:r>
-                    </a:p>
-                  </a:txBody>
-                </a:tc>
-                <a:tc>
-                  <a:txBody>
-                    <a:bodyPr/>
-                    <a:lstStyle/>
-                    <a:p>
-                      <a:pPr lvl="0" indent="0" marL="0">
-                        <a:buNone/>
-                      </a:pPr>
-                      <a:r>
-                        <a:rPr/>
-                        <a:t>balsam fir</a:t>
-                      </a:r>
-                    </a:p>
-                  </a:txBody>
-                </a:tc>
-                <a:tc>
-                  <a:txBody>
-                    <a:bodyPr/>
-                    <a:lstStyle/>
-                    <a:p>
-                      <a:pPr lvl="0" indent="0" marL="0">
-                        <a:buNone/>
-                      </a:pPr>
-                      <a:r>
-                        <a:rPr/>
-                        <a:t>6</a:t>
-                      </a:r>
-                    </a:p>
-                  </a:txBody>
-                </a:tc>
-                <a:tc>
-                  <a:txBody>
-                    <a:bodyPr/>
-                    <a:lstStyle/>
-                    <a:p>
-                      <a:pPr lvl="0" indent="0" marL="0">
-                        <a:buNone/>
-                      </a:pPr>
-                      <a:r>
-                        <a:rPr/>
-                        <a:t>147.451321</a:t>
-                      </a:r>
-                    </a:p>
-                  </a:txBody>
-                </a:tc>
-                <a:tc>
-                  <a:txBody>
-                    <a:bodyPr/>
-                    <a:lstStyle/>
-                    <a:p>
-                      <a:pPr lvl="0" indent="0" marL="0">
-                        <a:buNone/>
-                      </a:pPr>
-                      <a:r>
-                        <a:rPr/>
-                        <a:t>40.791681</a:t>
-                      </a:r>
-                    </a:p>
-                  </a:txBody>
-                </a:tc>
-                <a:tc>
-                  <a:txBody>
-                    <a:bodyPr/>
-                    <a:lstStyle/>
-                    <a:p>
-                      <a:pPr lvl="0" indent="0" marL="0">
-                        <a:buNone/>
-                      </a:pPr>
-                      <a:r>
-                        <a:rPr/>
-                        <a:t>0.142862</a:t>
-                      </a:r>
-                    </a:p>
-                  </a:txBody>
-                </a:tc>
-              </a:tr>
-              <a:tr h="0">
-                <a:tc>
-                  <a:txBody>
-                    <a:bodyPr/>
-                    <a:lstStyle/>
-                    <a:p>
-                      <a:pPr lvl="0" indent="0" marL="0">
-                        <a:buNone/>
-                      </a:pPr>
-                      <a:r>
-                        <a:rPr/>
-                        <a:t>...</a:t>
-                      </a:r>
-                    </a:p>
-                  </a:txBody>
-                </a:tc>
-                <a:tc>
-                  <a:txBody>
-                    <a:bodyPr/>
-                    <a:lstStyle/>
-                    <a:p>
-                      <a:pPr lvl="0" indent="0" marL="0">
-                        <a:buNone/>
-                      </a:pPr>
-                      <a:r>
-                        <a:rPr/>
-                        <a:t>...</a:t>
-                      </a:r>
-                    </a:p>
-                  </a:txBody>
-                </a:tc>
-                <a:tc>
-                  <a:txBody>
-                    <a:bodyPr/>
-                    <a:lstStyle/>
-                    <a:p>
-                      <a:pPr lvl="0" indent="0" marL="0">
-                        <a:buNone/>
-                      </a:pPr>
-                      <a:r>
-                        <a:rPr/>
-                        <a:t>...</a:t>
-                      </a:r>
-                    </a:p>
-                  </a:txBody>
-                </a:tc>
-                <a:tc>
-                  <a:txBody>
-                    <a:bodyPr/>
-                    <a:lstStyle/>
-                    <a:p>
-                      <a:pPr lvl="0" indent="0" marL="0">
-                        <a:buNone/>
-                      </a:pPr>
-                      <a:r>
-                        <a:rPr/>
-                        <a:t>...</a:t>
-                      </a:r>
-                    </a:p>
-                  </a:txBody>
-                </a:tc>
-                <a:tc>
-                  <a:txBody>
-                    <a:bodyPr/>
-                    <a:lstStyle/>
-                    <a:p>
-                      <a:pPr lvl="0" indent="0" marL="0">
-                        <a:buNone/>
-                      </a:pPr>
-                      <a:r>
-                        <a:rPr/>
-                        <a:t>...</a:t>
-                      </a:r>
-                    </a:p>
-                  </a:txBody>
-                </a:tc>
-                <a:tc>
-                  <a:txBody>
-                    <a:bodyPr/>
-                    <a:lstStyle/>
-                    <a:p>
-                      <a:pPr lvl="0" indent="0" marL="0">
-                        <a:buNone/>
-                      </a:pPr>
-                      <a:r>
-                        <a:rPr/>
-                        <a:t>...</a:t>
-                      </a:r>
-                    </a:p>
-                  </a:txBody>
-                </a:tc>
-              </a:tr>
-              <a:tr h="0">
-                <a:tc>
-                  <a:txBody>
-                    <a:bodyPr/>
-                    <a:lstStyle/>
-                    <a:p>
-                      <a:pPr lvl="0" indent="0" marL="0">
-                        <a:buNone/>
-                      </a:pPr>
-                      <a:r>
-                        <a:rPr/>
-                        <a:t>895</a:t>
-                      </a:r>
-                    </a:p>
-                  </a:txBody>
-                </a:tc>
-                <a:tc>
-                  <a:txBody>
-                    <a:bodyPr/>
-                    <a:lstStyle/>
-                    <a:p>
-                      <a:pPr lvl="0" indent="0" marL="0">
-                        <a:buNone/>
-                      </a:pPr>
-                      <a:r>
-                        <a:rPr/>
-                        <a:t>sugarberry</a:t>
-                      </a:r>
-                    </a:p>
-                  </a:txBody>
-                </a:tc>
-                <a:tc>
-                  <a:txBody>
-                    <a:bodyPr/>
-                    <a:lstStyle/>
-                    <a:p>
-                      <a:pPr lvl="0" indent="0" marL="0">
-                        <a:buNone/>
-                      </a:pPr>
-                      <a:r>
-                        <a:rPr/>
-                        <a:t>6</a:t>
-                      </a:r>
-                    </a:p>
-                  </a:txBody>
-                </a:tc>
-                <a:tc>
-                  <a:txBody>
-                    <a:bodyPr/>
-                    <a:lstStyle/>
-                    <a:p>
-                      <a:pPr lvl="0" indent="0" marL="0">
-                        <a:buNone/>
-                      </a:pPr>
-                      <a:r>
-                        <a:rPr/>
-                        <a:t>32.431052</a:t>
-                      </a:r>
-                    </a:p>
-                  </a:txBody>
-                </a:tc>
-                <a:tc>
-                  <a:txBody>
-                    <a:bodyPr/>
-                    <a:lstStyle/>
-                    <a:p>
-                      <a:pPr lvl="0" indent="0" marL="0">
-                        <a:buNone/>
-                      </a:pPr>
-                      <a:r>
-                        <a:rPr/>
-                        <a:t>20.969306</a:t>
-                      </a:r>
-                    </a:p>
-                  </a:txBody>
-                </a:tc>
-                <a:tc>
-                  <a:txBody>
-                    <a:bodyPr/>
-                    <a:lstStyle/>
-                    <a:p>
-                      <a:pPr lvl="0" indent="0" marL="0">
-                        <a:buNone/>
-                      </a:pPr>
-                      <a:r>
-                        <a:rPr/>
-                        <a:t>0.565727</a:t>
-                      </a:r>
-                    </a:p>
-                  </a:txBody>
-                </a:tc>
-              </a:tr>
-              <a:tr h="0">
-                <a:tc>
-                  <a:txBody>
-                    <a:bodyPr/>
-                    <a:lstStyle/>
-                    <a:p>
-                      <a:pPr lvl="0" indent="0" marL="0">
-                        <a:buNone/>
-                      </a:pPr>
-                      <a:r>
-                        <a:rPr/>
-                        <a:t>896</a:t>
-                      </a:r>
-                    </a:p>
-                  </a:txBody>
-                </a:tc>
-                <a:tc>
-                  <a:txBody>
-                    <a:bodyPr/>
-                    <a:lstStyle/>
-                    <a:p>
-                      <a:pPr lvl="0" indent="0" marL="0">
-                        <a:buNone/>
-                      </a:pPr>
-                      <a:r>
-                        <a:rPr/>
-                        <a:t>sugarberry</a:t>
-                      </a:r>
-                    </a:p>
-                  </a:txBody>
-                </a:tc>
-                <a:tc>
-                  <a:txBody>
-                    <a:bodyPr/>
-                    <a:lstStyle/>
-                    <a:p>
-                      <a:pPr lvl="0" indent="0" marL="0">
-                        <a:buNone/>
-                      </a:pPr>
-                      <a:r>
-                        <a:rPr/>
-                        <a:t>7</a:t>
-                      </a:r>
-                    </a:p>
-                  </a:txBody>
-                </a:tc>
-                <a:tc>
-                  <a:txBody>
-                    <a:bodyPr/>
-                    <a:lstStyle/>
-                    <a:p>
-                      <a:pPr lvl="0" indent="0" marL="0">
-                        <a:buNone/>
-                      </a:pPr>
-                      <a:r>
-                        <a:rPr/>
-                        <a:t>37.324259</a:t>
-                      </a:r>
-                    </a:p>
-                  </a:txBody>
-                </a:tc>
-                <a:tc>
-                  <a:txBody>
-                    <a:bodyPr/>
-                    <a:lstStyle/>
-                    <a:p>
-                      <a:pPr lvl="0" indent="0" marL="0">
-                        <a:buNone/>
-                      </a:pPr>
-                      <a:r>
-                        <a:rPr/>
-                        <a:t>25.037024</a:t>
-                      </a:r>
-                    </a:p>
-                  </a:txBody>
-                </a:tc>
-                <a:tc>
-                  <a:txBody>
-                    <a:bodyPr/>
-                    <a:lstStyle/>
-                    <a:p>
-                      <a:pPr lvl="0" indent="0" marL="0">
-                        <a:buNone/>
-                      </a:pPr>
-                      <a:r>
-                        <a:rPr/>
-                        <a:t>0.637629</a:t>
-                      </a:r>
-                    </a:p>
-                  </a:txBody>
-                </a:tc>
-              </a:tr>
-              <a:tr h="0">
-                <a:tc>
-                  <a:txBody>
-                    <a:bodyPr/>
-                    <a:lstStyle/>
-                    <a:p>
-                      <a:pPr lvl="0" indent="0" marL="0">
-                        <a:buNone/>
-                      </a:pPr>
-                      <a:r>
-                        <a:rPr/>
-                        <a:t>897</a:t>
-                      </a:r>
-                    </a:p>
-                  </a:txBody>
-                </a:tc>
-                <a:tc>
-                  <a:txBody>
-                    <a:bodyPr/>
-                    <a:lstStyle/>
-                    <a:p>
-                      <a:pPr lvl="0" indent="0" marL="0">
-                        <a:buNone/>
-                      </a:pPr>
-                      <a:r>
-                        <a:rPr/>
-                        <a:t>sugarberry</a:t>
-                      </a:r>
-                    </a:p>
-                  </a:txBody>
-                </a:tc>
-                <a:tc>
-                  <a:txBody>
-                    <a:bodyPr/>
-                    <a:lstStyle/>
-                    <a:p>
-                      <a:pPr lvl="0" indent="0" marL="0">
-                        <a:buNone/>
-                      </a:pPr>
-                      <a:r>
-                        <a:rPr/>
-                        <a:t>8</a:t>
-                      </a:r>
-                    </a:p>
-                  </a:txBody>
-                </a:tc>
-                <a:tc>
-                  <a:txBody>
-                    <a:bodyPr/>
-                    <a:lstStyle/>
-                    <a:p>
-                      <a:pPr lvl="0" indent="0" marL="0">
-                        <a:buNone/>
-                      </a:pPr>
-                      <a:r>
-                        <a:rPr/>
-                        <a:t>38.144756</a:t>
-                      </a:r>
-                    </a:p>
-                  </a:txBody>
-                </a:tc>
-                <a:tc>
-                  <a:txBody>
-                    <a:bodyPr/>
-                    <a:lstStyle/>
-                    <a:p>
-                      <a:pPr lvl="0" indent="0" marL="0">
-                        <a:buNone/>
-                      </a:pPr>
-                      <a:r>
-                        <a:rPr/>
-                        <a:t>26.680208</a:t>
-                      </a:r>
-                    </a:p>
-                  </a:txBody>
-                </a:tc>
-                <a:tc>
-                  <a:txBody>
-                    <a:bodyPr/>
-                    <a:lstStyle/>
-                    <a:p>
-                      <a:pPr lvl="0" indent="0" marL="0">
-                        <a:buNone/>
-                      </a:pPr>
-                      <a:r>
-                        <a:rPr/>
-                        <a:t>0.665159</a:t>
-                      </a:r>
-                    </a:p>
-                  </a:txBody>
-                </a:tc>
-              </a:tr>
-              <a:tr h="0">
-                <a:tc>
-                  <a:txBody>
-                    <a:bodyPr/>
-                    <a:lstStyle/>
-                    <a:p>
-                      <a:pPr lvl="0" indent="0" marL="0">
-                        <a:buNone/>
-                      </a:pPr>
-                      <a:r>
-                        <a:rPr/>
-                        <a:t>898</a:t>
-                      </a:r>
-                    </a:p>
-                  </a:txBody>
-                </a:tc>
-                <a:tc>
-                  <a:txBody>
-                    <a:bodyPr/>
-                    <a:lstStyle/>
-                    <a:p>
-                      <a:pPr lvl="0" indent="0" marL="0">
-                        <a:buNone/>
-                      </a:pPr>
-                      <a:r>
-                        <a:rPr/>
-                        <a:t>sugarberry</a:t>
-                      </a:r>
-                    </a:p>
-                  </a:txBody>
-                </a:tc>
-                <a:tc>
-                  <a:txBody>
-                    <a:bodyPr/>
-                    <a:lstStyle/>
-                    <a:p>
-                      <a:pPr lvl="0" indent="0" marL="0">
-                        <a:buNone/>
-                      </a:pPr>
-                      <a:r>
-                        <a:rPr/>
-                        <a:t>9</a:t>
-                      </a:r>
-                    </a:p>
-                  </a:txBody>
-                </a:tc>
-                <a:tc>
-                  <a:txBody>
-                    <a:bodyPr/>
-                    <a:lstStyle/>
-                    <a:p>
-                      <a:pPr lvl="0" indent="0" marL="0">
-                        <a:buNone/>
-                      </a:pPr>
-                      <a:r>
-                        <a:rPr/>
-                        <a:t>36.853245</a:t>
-                      </a:r>
-                    </a:p>
-                  </a:txBody>
-                </a:tc>
-                <a:tc>
-                  <a:txBody>
-                    <a:bodyPr/>
-                    <a:lstStyle/>
-                    <a:p>
-                      <a:pPr lvl="0" indent="0" marL="0">
-                        <a:buNone/>
-                      </a:pPr>
-                      <a:r>
-                        <a:rPr/>
-                        <a:t>21.021667</a:t>
-                      </a:r>
-                    </a:p>
-                  </a:txBody>
-                </a:tc>
-                <a:tc>
-                  <a:txBody>
-                    <a:bodyPr/>
-                    <a:lstStyle/>
-                    <a:p>
-                      <a:pPr lvl="0" indent="0" marL="0">
-                        <a:buNone/>
-                      </a:pPr>
-                      <a:r>
-                        <a:rPr/>
-                        <a:t>0.685162</a:t>
-                      </a:r>
-                    </a:p>
-                  </a:txBody>
-                </a:tc>
-              </a:tr>
-              <a:tr h="0">
-                <a:tc>
-                  <a:txBody>
-                    <a:bodyPr/>
-                    <a:lstStyle/>
-                    <a:p>
-                      <a:pPr lvl="0" indent="0" marL="0">
-                        <a:buNone/>
-                      </a:pPr>
-                      <a:r>
-                        <a:rPr/>
-                        <a:t>899</a:t>
-                      </a:r>
-                    </a:p>
-                  </a:txBody>
-                </a:tc>
-                <a:tc>
-                  <a:txBody>
-                    <a:bodyPr/>
-                    <a:lstStyle/>
-                    <a:p>
-                      <a:pPr lvl="0" indent="0" marL="0">
-                        <a:buNone/>
-                      </a:pPr>
-                      <a:r>
-                        <a:rPr/>
-                        <a:t>sugarberry</a:t>
-                      </a:r>
-                    </a:p>
-                  </a:txBody>
-                </a:tc>
-                <a:tc>
-                  <a:txBody>
-                    <a:bodyPr/>
-                    <a:lstStyle/>
-                    <a:p>
-                      <a:pPr lvl="0" indent="0" marL="0">
-                        <a:buNone/>
-                      </a:pPr>
-                      <a:r>
-                        <a:rPr/>
-                        <a:t>10</a:t>
-                      </a:r>
-                    </a:p>
-                  </a:txBody>
-                </a:tc>
-                <a:tc>
-                  <a:txBody>
-                    <a:bodyPr/>
-                    <a:lstStyle/>
-                    <a:p>
-                      <a:pPr lvl="0" indent="0" marL="0">
-                        <a:buNone/>
-                      </a:pPr>
-                      <a:r>
-                        <a:rPr/>
-                        <a:t>40.091106</a:t>
-                      </a:r>
-                    </a:p>
-                  </a:txBody>
-                </a:tc>
-                <a:tc>
-                  <a:txBody>
-                    <a:bodyPr/>
-                    <a:lstStyle/>
-                    <a:p>
-                      <a:pPr lvl="0" indent="0" marL="0">
-                        <a:buNone/>
-                      </a:pPr>
-                      <a:r>
-                        <a:rPr/>
-                        <a:t>23.172083</a:t>
-                      </a:r>
-                    </a:p>
-                  </a:txBody>
-                </a:tc>
-                <a:tc>
-                  <a:txBody>
-                    <a:bodyPr/>
-                    <a:lstStyle/>
-                    <a:p>
-                      <a:pPr lvl="0" indent="0" marL="0">
-                        <a:buNone/>
-                      </a:pPr>
-                      <a:r>
-                        <a:rPr/>
-                        <a:t>0.677519</a:t>
-                      </a:r>
-                    </a:p>
-                  </a:txBody>
-                </a:tc>
-              </a:tr>
-            </a:tbl>
-          </a:graphicData>
-        </a:graphic>
-      </p:graphicFrame>
+        </p:nvSpPr>
+        <p:spPr/>
+        <p:txBody>
+          <a:bodyPr/>
+          <a:lstStyle/>
+          <a:p>
+            <a:pPr lvl="0"/>
+            <a:r>
+              <a:rPr/>
+              <a:t>When relations between biomass and trees diameter and height are complex and non linear, data is abundent, and the model needs to be adaptive with out maksing major changes in the model. kNN excels in capturing patterns and irregular patterns.</a:t>
+            </a:r>
+          </a:p>
+        </p:txBody>
+      </p:sp>
     </p:spTree>
   </p:cSld>
 </p:sld>
@@ -4703,12 +3597,7 @@
             <p:ph type="title"/>
           </p:nvPr>
         </p:nvSpPr>
-        <p:spPr>
-          <a:xfrm>
-            <a:off x="457201" y="204787"/>
-            <a:ext cx="3008313" cy="871538"/>
-          </a:xfrm>
-        </p:spPr>
+        <p:spPr/>
         <p:txBody>
           <a:bodyPr/>
           <a:lstStyle/>
@@ -4718,19 +3607,19 @@
             </a:pPr>
             <a:r>
               <a:rPr/>
-              <a:t>Technical Lead</a:t>
+              <a:t>Performance Metric</a:t>
             </a:r>
           </a:p>
         </p:txBody>
       </p:sp>
       <p:sp>
         <p:nvSpPr>
-          <p:cNvPr id="4" name="Text Placeholder 3"/>
+          <p:cNvPr id="3" name="Content Placeholder 2"/>
           <p:cNvSpPr>
             <a:spLocks noGrp="1"/>
           </p:cNvSpPr>
           <p:nvPr>
-            <p:ph idx="2" sz="half" type="body"/>
+            <p:ph idx="1"/>
           </p:nvPr>
         </p:nvSpPr>
         <p:spPr/>
@@ -4740,525 +3629,23 @@
           <a:p>
             <a:pPr lvl="0"/>
             <a:r>
+              <a:rPr b="1"/>
+              <a:t>RMSLE over RMSE</a:t>
+            </a:r>
+            <a:r>
               <a:rPr/>
-              <a:t>Split and filtering methods</a:t>
+              <a:t>: focuses on percentage errors, making it fair to both small and large trees, unlike RMSE, which we believe penalizes errors on big trees. Fitting biomass estimations where scale matters more than absolute error.</a:t>
             </a:r>
           </a:p>
           <a:p>
             <a:pPr lvl="0"/>
             <a:r>
               <a:rPr/>
-              <a:t>Feature engineering (what worked and what didn’t)</a:t>
-            </a:r>
-          </a:p>
-          <a:p>
-            <a:pPr lvl="0"/>
-            <a:r>
-              <a:rPr/>
-              <a:t>Tuning k for the best model</a:t>
-            </a:r>
-          </a:p>
-          <a:p>
-            <a:pPr lvl="0"/>
-            <a:r>
-              <a:rPr/>
-              <a:t>The final “best” model and error # Tree Measurement Data:</a:t>
+              <a:t>By prioritizing percentage errors, RMSLE provides a more balanced evaluation that considers the unique characteristics of tree biomass data.</a:t>
             </a:r>
           </a:p>
         </p:txBody>
       </p:sp>
-      <p:graphicFrame>
-        <p:nvGraphicFramePr>
-          <p:cNvPr id="6" name="Content Placeholder 5"/>
-          <p:cNvGraphicFramePr>
-            <a:graphicFrameLocks noGrp="1"/>
-          </p:cNvGraphicFramePr>
-          <p:nvPr>
-            <p:ph idx="1"/>
-          </p:nvPr>
-        </p:nvGraphicFramePr>
-        <p:xfrm>
-          <a:off x="3568700" y="203200"/>
-          <a:ext cx="5105400" cy="4381500"/>
-        </p:xfrm>
-        <a:graphic>
-          <a:graphicData uri="http://schemas.openxmlformats.org/drawingml/2006/table">
-            <a:tbl>
-              <a:tblPr firstRow="1" bandRow="1">
-                <a:tableStyleId>{5C22544A-7EE6-4342-B048-85BDC9FD1C3A}</a:tableStyleId>
-              </a:tblPr>
-              <a:tblGrid>
-                <a:gridCol w="1016000"/>
-                <a:gridCol w="1016000"/>
-                <a:gridCol w="1016000"/>
-                <a:gridCol w="1016000"/>
-                <a:gridCol w="1016000"/>
-              </a:tblGrid>
-              <a:tr h="0">
-                <a:tc>
-                  <a:txBody>
-                    <a:bodyPr/>
-                    <a:lstStyle/>
-                    <a:p>
-                      <a:endParaRPr/>
-                    </a:p>
-                  </a:txBody>
-                  <a:tcPr/>
-                </a:tc>
-                <a:tc>
-                  <a:txBody>
-                    <a:bodyPr/>
-                    <a:lstStyle/>
-                    <a:p>
-                      <a:pPr lvl="0" indent="0" marL="0">
-                        <a:buNone/>
-                      </a:pPr>
-                      <a:r>
-                        <a:rPr/>
-                        <a:t>SPCD</a:t>
-                      </a:r>
-                    </a:p>
-                  </a:txBody>
-                  <a:tcPr/>
-                </a:tc>
-                <a:tc>
-                  <a:txBody>
-                    <a:bodyPr/>
-                    <a:lstStyle/>
-                    <a:p>
-                      <a:pPr lvl="0" indent="0" marL="0">
-                        <a:buNone/>
-                      </a:pPr>
-                      <a:r>
-                        <a:rPr/>
-                        <a:t>DO_BH</a:t>
-                      </a:r>
-                    </a:p>
-                  </a:txBody>
-                  <a:tcPr/>
-                </a:tc>
-                <a:tc>
-                  <a:txBody>
-                    <a:bodyPr/>
-                    <a:lstStyle/>
-                    <a:p>
-                      <a:pPr lvl="0" indent="0" marL="0">
-                        <a:buNone/>
-                      </a:pPr>
-                      <a:r>
-                        <a:rPr/>
-                        <a:t>HT_TOT</a:t>
-                      </a:r>
-                    </a:p>
-                  </a:txBody>
-                  <a:tcPr/>
-                </a:tc>
-                <a:tc>
-                  <a:txBody>
-                    <a:bodyPr/>
-                    <a:lstStyle/>
-                    <a:p>
-                      <a:pPr lvl="0" indent="0" marL="0">
-                        <a:buNone/>
-                      </a:pPr>
-                      <a:r>
-                        <a:rPr/>
-                        <a:t>TT_DW_CRM</a:t>
-                      </a:r>
-                    </a:p>
-                  </a:txBody>
-                  <a:tcPr/>
-                </a:tc>
-              </a:tr>
-              <a:tr h="0">
-                <a:tc>
-                  <a:txBody>
-                    <a:bodyPr/>
-                    <a:lstStyle/>
-                    <a:p>
-                      <a:pPr lvl="0" indent="0" marL="0">
-                        <a:buNone/>
-                      </a:pPr>
-                      <a:r>
-                        <a:rPr/>
-                        <a:t>0</a:t>
-                      </a:r>
-                    </a:p>
-                  </a:txBody>
-                </a:tc>
-                <a:tc>
-                  <a:txBody>
-                    <a:bodyPr/>
-                    <a:lstStyle/>
-                    <a:p>
-                      <a:pPr lvl="0" indent="0" marL="0">
-                        <a:buNone/>
-                      </a:pPr>
-                      <a:r>
-                        <a:rPr/>
-                        <a:t>12</a:t>
-                      </a:r>
-                    </a:p>
-                  </a:txBody>
-                </a:tc>
-                <a:tc>
-                  <a:txBody>
-                    <a:bodyPr/>
-                    <a:lstStyle/>
-                    <a:p>
-                      <a:pPr lvl="0" indent="0" marL="0">
-                        <a:buNone/>
-                      </a:pPr>
-                      <a:r>
-                        <a:rPr/>
-                        <a:t>7.5</a:t>
-                      </a:r>
-                    </a:p>
-                  </a:txBody>
-                </a:tc>
-                <a:tc>
-                  <a:txBody>
-                    <a:bodyPr/>
-                    <a:lstStyle/>
-                    <a:p>
-                      <a:pPr lvl="0" indent="0" marL="0">
-                        <a:buNone/>
-                      </a:pPr>
-                      <a:r>
-                        <a:rPr/>
-                        <a:t>45.2</a:t>
-                      </a:r>
-                    </a:p>
-                  </a:txBody>
-                </a:tc>
-                <a:tc>
-                  <a:txBody>
-                    <a:bodyPr/>
-                    <a:lstStyle/>
-                    <a:p>
-                      <a:pPr lvl="0" indent="0" marL="0">
-                        <a:buNone/>
-                      </a:pPr>
-                      <a:r>
-                        <a:rPr/>
-                        <a:t>178.86</a:t>
-                      </a:r>
-                    </a:p>
-                  </a:txBody>
-                </a:tc>
-              </a:tr>
-              <a:tr h="0">
-                <a:tc>
-                  <a:txBody>
-                    <a:bodyPr/>
-                    <a:lstStyle/>
-                    <a:p>
-                      <a:pPr lvl="0" indent="0" marL="0">
-                        <a:buNone/>
-                      </a:pPr>
-                      <a:r>
-                        <a:rPr/>
-                        <a:t>1</a:t>
-                      </a:r>
-                    </a:p>
-                  </a:txBody>
-                </a:tc>
-                <a:tc>
-                  <a:txBody>
-                    <a:bodyPr/>
-                    <a:lstStyle/>
-                    <a:p>
-                      <a:pPr lvl="0" indent="0" marL="0">
-                        <a:buNone/>
-                      </a:pPr>
-                      <a:r>
-                        <a:rPr/>
-                        <a:t>12</a:t>
-                      </a:r>
-                    </a:p>
-                  </a:txBody>
-                </a:tc>
-                <a:tc>
-                  <a:txBody>
-                    <a:bodyPr/>
-                    <a:lstStyle/>
-                    <a:p>
-                      <a:pPr lvl="0" indent="0" marL="0">
-                        <a:buNone/>
-                      </a:pPr>
-                      <a:r>
-                        <a:rPr/>
-                        <a:t>9.3</a:t>
-                      </a:r>
-                    </a:p>
-                  </a:txBody>
-                </a:tc>
-                <a:tc>
-                  <a:txBody>
-                    <a:bodyPr/>
-                    <a:lstStyle/>
-                    <a:p>
-                      <a:pPr lvl="0" indent="0" marL="0">
-                        <a:buNone/>
-                      </a:pPr>
-                      <a:r>
-                        <a:rPr/>
-                        <a:t>62.7</a:t>
-                      </a:r>
-                    </a:p>
-                  </a:txBody>
-                </a:tc>
-                <a:tc>
-                  <a:txBody>
-                    <a:bodyPr/>
-                    <a:lstStyle/>
-                    <a:p>
-                      <a:pPr lvl="0" indent="0" marL="0">
-                        <a:buNone/>
-                      </a:pPr>
-                      <a:r>
-                        <a:rPr/>
-                        <a:t>323.46</a:t>
-                      </a:r>
-                    </a:p>
-                  </a:txBody>
-                </a:tc>
-              </a:tr>
-              <a:tr h="0">
-                <a:tc>
-                  <a:txBody>
-                    <a:bodyPr/>
-                    <a:lstStyle/>
-                    <a:p>
-                      <a:pPr lvl="0" indent="0" marL="0">
-                        <a:buNone/>
-                      </a:pPr>
-                      <a:r>
-                        <a:rPr/>
-                        <a:t>2</a:t>
-                      </a:r>
-                    </a:p>
-                  </a:txBody>
-                </a:tc>
-                <a:tc>
-                  <a:txBody>
-                    <a:bodyPr/>
-                    <a:lstStyle/>
-                    <a:p>
-                      <a:pPr lvl="0" indent="0" marL="0">
-                        <a:buNone/>
-                      </a:pPr>
-                      <a:r>
-                        <a:rPr/>
-                        <a:t>12</a:t>
-                      </a:r>
-                    </a:p>
-                  </a:txBody>
-                </a:tc>
-                <a:tc>
-                  <a:txBody>
-                    <a:bodyPr/>
-                    <a:lstStyle/>
-                    <a:p>
-                      <a:pPr lvl="0" indent="0" marL="0">
-                        <a:buNone/>
-                      </a:pPr>
-                      <a:r>
-                        <a:rPr/>
-                        <a:t>9.7</a:t>
-                      </a:r>
-                    </a:p>
-                  </a:txBody>
-                </a:tc>
-                <a:tc>
-                  <a:txBody>
-                    <a:bodyPr/>
-                    <a:lstStyle/>
-                    <a:p>
-                      <a:pPr lvl="0" indent="0" marL="0">
-                        <a:buNone/>
-                      </a:pPr>
-                      <a:r>
-                        <a:rPr/>
-                        <a:t>56.7</a:t>
-                      </a:r>
-                    </a:p>
-                  </a:txBody>
-                </a:tc>
-                <a:tc>
-                  <a:txBody>
-                    <a:bodyPr/>
-                    <a:lstStyle/>
-                    <a:p>
-                      <a:pPr lvl="0" indent="0" marL="0">
-                        <a:buNone/>
-                      </a:pPr>
-                      <a:r>
-                        <a:rPr/>
-                        <a:t>342.47</a:t>
-                      </a:r>
-                    </a:p>
-                  </a:txBody>
-                </a:tc>
-              </a:tr>
-              <a:tr h="0">
-                <a:tc>
-                  <a:txBody>
-                    <a:bodyPr/>
-                    <a:lstStyle/>
-                    <a:p>
-                      <a:pPr lvl="0" indent="0" marL="0">
-                        <a:buNone/>
-                      </a:pPr>
-                      <a:r>
-                        <a:rPr/>
-                        <a:t>3</a:t>
-                      </a:r>
-                    </a:p>
-                  </a:txBody>
-                </a:tc>
-                <a:tc>
-                  <a:txBody>
-                    <a:bodyPr/>
-                    <a:lstStyle/>
-                    <a:p>
-                      <a:pPr lvl="0" indent="0" marL="0">
-                        <a:buNone/>
-                      </a:pPr>
-                      <a:r>
-                        <a:rPr/>
-                        <a:t>12</a:t>
-                      </a:r>
-                    </a:p>
-                  </a:txBody>
-                </a:tc>
-                <a:tc>
-                  <a:txBody>
-                    <a:bodyPr/>
-                    <a:lstStyle/>
-                    <a:p>
-                      <a:pPr lvl="0" indent="0" marL="0">
-                        <a:buNone/>
-                      </a:pPr>
-                      <a:r>
-                        <a:rPr/>
-                        <a:t>11.4</a:t>
-                      </a:r>
-                    </a:p>
-                  </a:txBody>
-                </a:tc>
-                <a:tc>
-                  <a:txBody>
-                    <a:bodyPr/>
-                    <a:lstStyle/>
-                    <a:p>
-                      <a:pPr lvl="0" indent="0" marL="0">
-                        <a:buNone/>
-                      </a:pPr>
-                      <a:r>
-                        <a:rPr/>
-                        <a:t>66.1</a:t>
-                      </a:r>
-                    </a:p>
-                  </a:txBody>
-                </a:tc>
-                <a:tc>
-                  <a:txBody>
-                    <a:bodyPr/>
-                    <a:lstStyle/>
-                    <a:p>
-                      <a:pPr lvl="0" indent="0" marL="0">
-                        <a:buNone/>
-                      </a:pPr>
-                      <a:r>
-                        <a:rPr/>
-                        <a:t>499.35</a:t>
-                      </a:r>
-                    </a:p>
-                  </a:txBody>
-                </a:tc>
-              </a:tr>
-              <a:tr h="0">
-                <a:tc>
-                  <a:txBody>
-                    <a:bodyPr/>
-                    <a:lstStyle/>
-                    <a:p>
-                      <a:pPr lvl="0" indent="0" marL="0">
-                        <a:buNone/>
-                      </a:pPr>
-                      <a:r>
-                        <a:rPr/>
-                        <a:t>4</a:t>
-                      </a:r>
-                    </a:p>
-                  </a:txBody>
-                </a:tc>
-                <a:tc>
-                  <a:txBody>
-                    <a:bodyPr/>
-                    <a:lstStyle/>
-                    <a:p>
-                      <a:pPr lvl="0" indent="0" marL="0">
-                        <a:buNone/>
-                      </a:pPr>
-                      <a:r>
-                        <a:rPr/>
-                        <a:t>12</a:t>
-                      </a:r>
-                    </a:p>
-                  </a:txBody>
-                </a:tc>
-                <a:tc>
-                  <a:txBody>
-                    <a:bodyPr/>
-                    <a:lstStyle/>
-                    <a:p>
-                      <a:pPr lvl="0" indent="0" marL="0">
-                        <a:buNone/>
-                      </a:pPr>
-                      <a:r>
-                        <a:rPr/>
-                        <a:t>6.4</a:t>
-                      </a:r>
-                    </a:p>
-                  </a:txBody>
-                </a:tc>
-                <a:tc>
-                  <a:txBody>
-                    <a:bodyPr/>
-                    <a:lstStyle/>
-                    <a:p>
-                      <a:pPr lvl="0" indent="0" marL="0">
-                        <a:buNone/>
-                      </a:pPr>
-                      <a:r>
-                        <a:rPr/>
-                        <a:t>51.8</a:t>
-                      </a:r>
-                    </a:p>
-                  </a:txBody>
-                </a:tc>
-                <a:tc>
-                  <a:txBody>
-                    <a:bodyPr/>
-                    <a:lstStyle/>
-                    <a:p>
-                      <a:pPr lvl="0" indent="0" marL="0">
-                        <a:buNone/>
-                      </a:pPr>
-                      <a:r>
-                        <a:rPr/>
-                        <a:t>113.92</a:t>
-                      </a:r>
-                    </a:p>
-                  </a:txBody>
-                </a:tc>
-              </a:tr>
-            </a:tbl>
-          </a:graphicData>
-        </a:graphic>
-      </p:graphicFrame>
     </p:spTree>
   </p:cSld>
 </p:sld>
@@ -5301,7 +3688,7 @@
             </a:pPr>
             <a:r>
               <a:rPr/>
-              <a:t>Tree Species Name Data:</a:t>
+              <a:t>Model</a:t>
             </a:r>
           </a:p>
         </p:txBody>
@@ -5327,9 +3714,12 @@
                 <a:tableStyleId>{5C22544A-7EE6-4342-B048-85BDC9FD1C3A}</a:tableStyleId>
               </a:tblPr>
               <a:tblGrid>
-                <a:gridCol w="2743200"/>
-                <a:gridCol w="2743200"/>
-                <a:gridCol w="2743200"/>
+                <a:gridCol w="1371600"/>
+                <a:gridCol w="1371600"/>
+                <a:gridCol w="1371600"/>
+                <a:gridCol w="1371600"/>
+                <a:gridCol w="1371600"/>
+                <a:gridCol w="1371600"/>
               </a:tblGrid>
               <a:tr h="0">
                 <a:tc>
@@ -5352,7 +3742,7 @@
                       </a:pPr>
                       <a:r>
                         <a:rPr/>
-                        <a:t>SPCD</a:t>
+                        <a:t>Species</a:t>
                       </a:r>
                     </a:p>
                   </a:txBody>
@@ -5368,7 +3758,55 @@
                       </a:pPr>
                       <a:r>
                         <a:rPr/>
-                        <a:t>COMMON_NAME</a:t>
+                        <a:t>k</a:t>
+                      </a:r>
+                    </a:p>
+                  </a:txBody>
+                  <a:tcPr/>
+                </a:tc>
+                <a:tc>
+                  <a:txBody>
+                    <a:bodyPr/>
+                    <a:lstStyle/>
+                    <a:p>
+                      <a:pPr lvl="0" indent="0" marL="0">
+                        <a:buNone/>
+                      </a:pPr>
+                      <a:r>
+                        <a:rPr/>
+                        <a:t>RMSE</a:t>
+                      </a:r>
+                    </a:p>
+                  </a:txBody>
+                  <a:tcPr/>
+                </a:tc>
+                <a:tc>
+                  <a:txBody>
+                    <a:bodyPr/>
+                    <a:lstStyle/>
+                    <a:p>
+                      <a:pPr lvl="0" indent="0" marL="0">
+                        <a:buNone/>
+                      </a:pPr>
+                      <a:r>
+                        <a:rPr/>
+                        <a:t>MAE</a:t>
+                      </a:r>
+                    </a:p>
+                  </a:txBody>
+                  <a:tcPr/>
+                </a:tc>
+                <a:tc>
+                  <a:txBody>
+                    <a:bodyPr/>
+                    <a:lstStyle/>
+                    <a:p>
+                      <a:pPr lvl="0" indent="0" marL="0">
+                        <a:buNone/>
+                      </a:pPr>
+                      <a:r>
+                        <a:rPr/>
+                        <a:t>RMSLE</a:t>
                       </a:r>
                     </a:p>
                   </a:txBody>
@@ -5401,22 +3839,67 @@
                       </a:pPr>
                       <a:r>
                         <a:rPr/>
-                        <a:t>10</a:t>
-                      </a:r>
-                    </a:p>
-                  </a:txBody>
-                </a:tc>
-                <a:tc>
-                  <a:txBody>
-                    <a:bodyPr/>
-                    <a:lstStyle/>
-                    <a:p>
-                      <a:pPr lvl="0" indent="0" marL="0">
-                        <a:buNone/>
-                      </a:pPr>
-                      <a:r>
-                        <a:rPr/>
-                        <a:t>fir spp.</a:t>
+                        <a:t>balsam fir</a:t>
+                      </a:r>
+                    </a:p>
+                  </a:txBody>
+                </a:tc>
+                <a:tc>
+                  <a:txBody>
+                    <a:bodyPr/>
+                    <a:lstStyle/>
+                    <a:p>
+                      <a:pPr lvl="0" indent="0" marL="0">
+                        <a:buNone/>
+                      </a:pPr>
+                      <a:r>
+                        <a:rPr/>
+                        <a:t>2</a:t>
+                      </a:r>
+                    </a:p>
+                  </a:txBody>
+                </a:tc>
+                <a:tc>
+                  <a:txBody>
+                    <a:bodyPr/>
+                    <a:lstStyle/>
+                    <a:p>
+                      <a:pPr lvl="0" indent="0" marL="0">
+                        <a:buNone/>
+                      </a:pPr>
+                      <a:r>
+                        <a:rPr/>
+                        <a:t>125.827396</a:t>
+                      </a:r>
+                    </a:p>
+                  </a:txBody>
+                </a:tc>
+                <a:tc>
+                  <a:txBody>
+                    <a:bodyPr/>
+                    <a:lstStyle/>
+                    <a:p>
+                      <a:pPr lvl="0" indent="0" marL="0">
+                        <a:buNone/>
+                      </a:pPr>
+                      <a:r>
+                        <a:rPr/>
+                        <a:t>34.820565</a:t>
+                      </a:r>
+                    </a:p>
+                  </a:txBody>
+                </a:tc>
+                <a:tc>
+                  <a:txBody>
+                    <a:bodyPr/>
+                    <a:lstStyle/>
+                    <a:p>
+                      <a:pPr lvl="0" indent="0" marL="0">
+                        <a:buNone/>
+                      </a:pPr>
+                      <a:r>
+                        <a:rPr/>
+                        <a:t>0.119617</a:t>
                       </a:r>
                     </a:p>
                   </a:txBody>
@@ -5448,22 +3931,67 @@
                       </a:pPr>
                       <a:r>
                         <a:rPr/>
-                        <a:t>11</a:t>
-                      </a:r>
-                    </a:p>
-                  </a:txBody>
-                </a:tc>
-                <a:tc>
-                  <a:txBody>
-                    <a:bodyPr/>
-                    <a:lstStyle/>
-                    <a:p>
-                      <a:pPr lvl="0" indent="0" marL="0">
-                        <a:buNone/>
-                      </a:pPr>
-                      <a:r>
-                        <a:rPr/>
-                        <a:t>Pacific silver fir</a:t>
+                        <a:t>balsam fir</a:t>
+                      </a:r>
+                    </a:p>
+                  </a:txBody>
+                </a:tc>
+                <a:tc>
+                  <a:txBody>
+                    <a:bodyPr/>
+                    <a:lstStyle/>
+                    <a:p>
+                      <a:pPr lvl="0" indent="0" marL="0">
+                        <a:buNone/>
+                      </a:pPr>
+                      <a:r>
+                        <a:rPr/>
+                        <a:t>3</a:t>
+                      </a:r>
+                    </a:p>
+                  </a:txBody>
+                </a:tc>
+                <a:tc>
+                  <a:txBody>
+                    <a:bodyPr/>
+                    <a:lstStyle/>
+                    <a:p>
+                      <a:pPr lvl="0" indent="0" marL="0">
+                        <a:buNone/>
+                      </a:pPr>
+                      <a:r>
+                        <a:rPr/>
+                        <a:t>129.650855</a:t>
+                      </a:r>
+                    </a:p>
+                  </a:txBody>
+                </a:tc>
+                <a:tc>
+                  <a:txBody>
+                    <a:bodyPr/>
+                    <a:lstStyle/>
+                    <a:p>
+                      <a:pPr lvl="0" indent="0" marL="0">
+                        <a:buNone/>
+                      </a:pPr>
+                      <a:r>
+                        <a:rPr/>
+                        <a:t>36.628377</a:t>
+                      </a:r>
+                    </a:p>
+                  </a:txBody>
+                </a:tc>
+                <a:tc>
+                  <a:txBody>
+                    <a:bodyPr/>
+                    <a:lstStyle/>
+                    <a:p>
+                      <a:pPr lvl="0" indent="0" marL="0">
+                        <a:buNone/>
+                      </a:pPr>
+                      <a:r>
+                        <a:rPr/>
+                        <a:t>0.123679</a:t>
                       </a:r>
                     </a:p>
                   </a:txBody>
@@ -5495,22 +4023,67 @@
                       </a:pPr>
                       <a:r>
                         <a:rPr/>
-                        <a:t>12</a:t>
-                      </a:r>
-                    </a:p>
-                  </a:txBody>
-                </a:tc>
-                <a:tc>
-                  <a:txBody>
-                    <a:bodyPr/>
-                    <a:lstStyle/>
-                    <a:p>
-                      <a:pPr lvl="0" indent="0" marL="0">
-                        <a:buNone/>
-                      </a:pPr>
-                      <a:r>
-                        <a:rPr/>
                         <a:t>balsam fir</a:t>
+                      </a:r>
+                    </a:p>
+                  </a:txBody>
+                </a:tc>
+                <a:tc>
+                  <a:txBody>
+                    <a:bodyPr/>
+                    <a:lstStyle/>
+                    <a:p>
+                      <a:pPr lvl="0" indent="0" marL="0">
+                        <a:buNone/>
+                      </a:pPr>
+                      <a:r>
+                        <a:rPr/>
+                        <a:t>4</a:t>
+                      </a:r>
+                    </a:p>
+                  </a:txBody>
+                </a:tc>
+                <a:tc>
+                  <a:txBody>
+                    <a:bodyPr/>
+                    <a:lstStyle/>
+                    <a:p>
+                      <a:pPr lvl="0" indent="0" marL="0">
+                        <a:buNone/>
+                      </a:pPr>
+                      <a:r>
+                        <a:rPr/>
+                        <a:t>134.599829</a:t>
+                      </a:r>
+                    </a:p>
+                  </a:txBody>
+                </a:tc>
+                <a:tc>
+                  <a:txBody>
+                    <a:bodyPr/>
+                    <a:lstStyle/>
+                    <a:p>
+                      <a:pPr lvl="0" indent="0" marL="0">
+                        <a:buNone/>
+                      </a:pPr>
+                      <a:r>
+                        <a:rPr/>
+                        <a:t>38.884870</a:t>
+                      </a:r>
+                    </a:p>
+                  </a:txBody>
+                </a:tc>
+                <a:tc>
+                  <a:txBody>
+                    <a:bodyPr/>
+                    <a:lstStyle/>
+                    <a:p>
+                      <a:pPr lvl="0" indent="0" marL="0">
+                        <a:buNone/>
+                      </a:pPr>
+                      <a:r>
+                        <a:rPr/>
+                        <a:t>0.133858</a:t>
                       </a:r>
                     </a:p>
                   </a:txBody>
@@ -5542,22 +4115,67 @@
                       </a:pPr>
                       <a:r>
                         <a:rPr/>
-                        <a:t>14</a:t>
-                      </a:r>
-                    </a:p>
-                  </a:txBody>
-                </a:tc>
-                <a:tc>
-                  <a:txBody>
-                    <a:bodyPr/>
-                    <a:lstStyle/>
-                    <a:p>
-                      <a:pPr lvl="0" indent="0" marL="0">
-                        <a:buNone/>
-                      </a:pPr>
-                      <a:r>
-                        <a:rPr/>
-                        <a:t>Santa Lucia or bristlecone fir</a:t>
+                        <a:t>balsam fir</a:t>
+                      </a:r>
+                    </a:p>
+                  </a:txBody>
+                </a:tc>
+                <a:tc>
+                  <a:txBody>
+                    <a:bodyPr/>
+                    <a:lstStyle/>
+                    <a:p>
+                      <a:pPr lvl="0" indent="0" marL="0">
+                        <a:buNone/>
+                      </a:pPr>
+                      <a:r>
+                        <a:rPr/>
+                        <a:t>5</a:t>
+                      </a:r>
+                    </a:p>
+                  </a:txBody>
+                </a:tc>
+                <a:tc>
+                  <a:txBody>
+                    <a:bodyPr/>
+                    <a:lstStyle/>
+                    <a:p>
+                      <a:pPr lvl="0" indent="0" marL="0">
+                        <a:buNone/>
+                      </a:pPr>
+                      <a:r>
+                        <a:rPr/>
+                        <a:t>145.002852</a:t>
+                      </a:r>
+                    </a:p>
+                  </a:txBody>
+                </a:tc>
+                <a:tc>
+                  <a:txBody>
+                    <a:bodyPr/>
+                    <a:lstStyle/>
+                    <a:p>
+                      <a:pPr lvl="0" indent="0" marL="0">
+                        <a:buNone/>
+                      </a:pPr>
+                      <a:r>
+                        <a:rPr/>
+                        <a:t>41.168470</a:t>
+                      </a:r>
+                    </a:p>
+                  </a:txBody>
+                </a:tc>
+                <a:tc>
+                  <a:txBody>
+                    <a:bodyPr/>
+                    <a:lstStyle/>
+                    <a:p>
+                      <a:pPr lvl="0" indent="0" marL="0">
+                        <a:buNone/>
+                      </a:pPr>
+                      <a:r>
+                        <a:rPr/>
+                        <a:t>0.144052</a:t>
                       </a:r>
                     </a:p>
                   </a:txBody>
@@ -5589,22 +4207,619 @@
                       </a:pPr>
                       <a:r>
                         <a:rPr/>
-                        <a:t>15</a:t>
-                      </a:r>
-                    </a:p>
-                  </a:txBody>
-                </a:tc>
-                <a:tc>
-                  <a:txBody>
-                    <a:bodyPr/>
-                    <a:lstStyle/>
-                    <a:p>
-                      <a:pPr lvl="0" indent="0" marL="0">
-                        <a:buNone/>
-                      </a:pPr>
-                      <a:r>
-                        <a:rPr/>
-                        <a:t>white fir</a:t>
+                        <a:t>balsam fir</a:t>
+                      </a:r>
+                    </a:p>
+                  </a:txBody>
+                </a:tc>
+                <a:tc>
+                  <a:txBody>
+                    <a:bodyPr/>
+                    <a:lstStyle/>
+                    <a:p>
+                      <a:pPr lvl="0" indent="0" marL="0">
+                        <a:buNone/>
+                      </a:pPr>
+                      <a:r>
+                        <a:rPr/>
+                        <a:t>6</a:t>
+                      </a:r>
+                    </a:p>
+                  </a:txBody>
+                </a:tc>
+                <a:tc>
+                  <a:txBody>
+                    <a:bodyPr/>
+                    <a:lstStyle/>
+                    <a:p>
+                      <a:pPr lvl="0" indent="0" marL="0">
+                        <a:buNone/>
+                      </a:pPr>
+                      <a:r>
+                        <a:rPr/>
+                        <a:t>147.449208</a:t>
+                      </a:r>
+                    </a:p>
+                  </a:txBody>
+                </a:tc>
+                <a:tc>
+                  <a:txBody>
+                    <a:bodyPr/>
+                    <a:lstStyle/>
+                    <a:p>
+                      <a:pPr lvl="0" indent="0" marL="0">
+                        <a:buNone/>
+                      </a:pPr>
+                      <a:r>
+                        <a:rPr/>
+                        <a:t>40.728609</a:t>
+                      </a:r>
+                    </a:p>
+                  </a:txBody>
+                </a:tc>
+                <a:tc>
+                  <a:txBody>
+                    <a:bodyPr/>
+                    <a:lstStyle/>
+                    <a:p>
+                      <a:pPr lvl="0" indent="0" marL="0">
+                        <a:buNone/>
+                      </a:pPr>
+                      <a:r>
+                        <a:rPr/>
+                        <a:t>0.142813</a:t>
+                      </a:r>
+                    </a:p>
+                  </a:txBody>
+                </a:tc>
+              </a:tr>
+              <a:tr h="0">
+                <a:tc>
+                  <a:txBody>
+                    <a:bodyPr/>
+                    <a:lstStyle/>
+                    <a:p>
+                      <a:pPr lvl="0" indent="0" marL="0">
+                        <a:buNone/>
+                      </a:pPr>
+                      <a:r>
+                        <a:rPr/>
+                        <a:t>...</a:t>
+                      </a:r>
+                    </a:p>
+                  </a:txBody>
+                </a:tc>
+                <a:tc>
+                  <a:txBody>
+                    <a:bodyPr/>
+                    <a:lstStyle/>
+                    <a:p>
+                      <a:pPr lvl="0" indent="0" marL="0">
+                        <a:buNone/>
+                      </a:pPr>
+                      <a:r>
+                        <a:rPr/>
+                        <a:t>...</a:t>
+                      </a:r>
+                    </a:p>
+                  </a:txBody>
+                </a:tc>
+                <a:tc>
+                  <a:txBody>
+                    <a:bodyPr/>
+                    <a:lstStyle/>
+                    <a:p>
+                      <a:pPr lvl="0" indent="0" marL="0">
+                        <a:buNone/>
+                      </a:pPr>
+                      <a:r>
+                        <a:rPr/>
+                        <a:t>...</a:t>
+                      </a:r>
+                    </a:p>
+                  </a:txBody>
+                </a:tc>
+                <a:tc>
+                  <a:txBody>
+                    <a:bodyPr/>
+                    <a:lstStyle/>
+                    <a:p>
+                      <a:pPr lvl="0" indent="0" marL="0">
+                        <a:buNone/>
+                      </a:pPr>
+                      <a:r>
+                        <a:rPr/>
+                        <a:t>...</a:t>
+                      </a:r>
+                    </a:p>
+                  </a:txBody>
+                </a:tc>
+                <a:tc>
+                  <a:txBody>
+                    <a:bodyPr/>
+                    <a:lstStyle/>
+                    <a:p>
+                      <a:pPr lvl="0" indent="0" marL="0">
+                        <a:buNone/>
+                      </a:pPr>
+                      <a:r>
+                        <a:rPr/>
+                        <a:t>...</a:t>
+                      </a:r>
+                    </a:p>
+                  </a:txBody>
+                </a:tc>
+                <a:tc>
+                  <a:txBody>
+                    <a:bodyPr/>
+                    <a:lstStyle/>
+                    <a:p>
+                      <a:pPr lvl="0" indent="0" marL="0">
+                        <a:buNone/>
+                      </a:pPr>
+                      <a:r>
+                        <a:rPr/>
+                        <a:t>...</a:t>
+                      </a:r>
+                    </a:p>
+                  </a:txBody>
+                </a:tc>
+              </a:tr>
+              <a:tr h="0">
+                <a:tc>
+                  <a:txBody>
+                    <a:bodyPr/>
+                    <a:lstStyle/>
+                    <a:p>
+                      <a:pPr lvl="0" indent="0" marL="0">
+                        <a:buNone/>
+                      </a:pPr>
+                      <a:r>
+                        <a:rPr/>
+                        <a:t>895</a:t>
+                      </a:r>
+                    </a:p>
+                  </a:txBody>
+                </a:tc>
+                <a:tc>
+                  <a:txBody>
+                    <a:bodyPr/>
+                    <a:lstStyle/>
+                    <a:p>
+                      <a:pPr lvl="0" indent="0" marL="0">
+                        <a:buNone/>
+                      </a:pPr>
+                      <a:r>
+                        <a:rPr/>
+                        <a:t>sugarberry</a:t>
+                      </a:r>
+                    </a:p>
+                  </a:txBody>
+                </a:tc>
+                <a:tc>
+                  <a:txBody>
+                    <a:bodyPr/>
+                    <a:lstStyle/>
+                    <a:p>
+                      <a:pPr lvl="0" indent="0" marL="0">
+                        <a:buNone/>
+                      </a:pPr>
+                      <a:r>
+                        <a:rPr/>
+                        <a:t>6</a:t>
+                      </a:r>
+                    </a:p>
+                  </a:txBody>
+                </a:tc>
+                <a:tc>
+                  <a:txBody>
+                    <a:bodyPr/>
+                    <a:lstStyle/>
+                    <a:p>
+                      <a:pPr lvl="0" indent="0" marL="0">
+                        <a:buNone/>
+                      </a:pPr>
+                      <a:r>
+                        <a:rPr/>
+                        <a:t>32.431052</a:t>
+                      </a:r>
+                    </a:p>
+                  </a:txBody>
+                </a:tc>
+                <a:tc>
+                  <a:txBody>
+                    <a:bodyPr/>
+                    <a:lstStyle/>
+                    <a:p>
+                      <a:pPr lvl="0" indent="0" marL="0">
+                        <a:buNone/>
+                      </a:pPr>
+                      <a:r>
+                        <a:rPr/>
+                        <a:t>20.969306</a:t>
+                      </a:r>
+                    </a:p>
+                  </a:txBody>
+                </a:tc>
+                <a:tc>
+                  <a:txBody>
+                    <a:bodyPr/>
+                    <a:lstStyle/>
+                    <a:p>
+                      <a:pPr lvl="0" indent="0" marL="0">
+                        <a:buNone/>
+                      </a:pPr>
+                      <a:r>
+                        <a:rPr/>
+                        <a:t>0.565727</a:t>
+                      </a:r>
+                    </a:p>
+                  </a:txBody>
+                </a:tc>
+              </a:tr>
+              <a:tr h="0">
+                <a:tc>
+                  <a:txBody>
+                    <a:bodyPr/>
+                    <a:lstStyle/>
+                    <a:p>
+                      <a:pPr lvl="0" indent="0" marL="0">
+                        <a:buNone/>
+                      </a:pPr>
+                      <a:r>
+                        <a:rPr/>
+                        <a:t>896</a:t>
+                      </a:r>
+                    </a:p>
+                  </a:txBody>
+                </a:tc>
+                <a:tc>
+                  <a:txBody>
+                    <a:bodyPr/>
+                    <a:lstStyle/>
+                    <a:p>
+                      <a:pPr lvl="0" indent="0" marL="0">
+                        <a:buNone/>
+                      </a:pPr>
+                      <a:r>
+                        <a:rPr/>
+                        <a:t>sugarberry</a:t>
+                      </a:r>
+                    </a:p>
+                  </a:txBody>
+                </a:tc>
+                <a:tc>
+                  <a:txBody>
+                    <a:bodyPr/>
+                    <a:lstStyle/>
+                    <a:p>
+                      <a:pPr lvl="0" indent="0" marL="0">
+                        <a:buNone/>
+                      </a:pPr>
+                      <a:r>
+                        <a:rPr/>
+                        <a:t>7</a:t>
+                      </a:r>
+                    </a:p>
+                  </a:txBody>
+                </a:tc>
+                <a:tc>
+                  <a:txBody>
+                    <a:bodyPr/>
+                    <a:lstStyle/>
+                    <a:p>
+                      <a:pPr lvl="0" indent="0" marL="0">
+                        <a:buNone/>
+                      </a:pPr>
+                      <a:r>
+                        <a:rPr/>
+                        <a:t>37.324259</a:t>
+                      </a:r>
+                    </a:p>
+                  </a:txBody>
+                </a:tc>
+                <a:tc>
+                  <a:txBody>
+                    <a:bodyPr/>
+                    <a:lstStyle/>
+                    <a:p>
+                      <a:pPr lvl="0" indent="0" marL="0">
+                        <a:buNone/>
+                      </a:pPr>
+                      <a:r>
+                        <a:rPr/>
+                        <a:t>25.037024</a:t>
+                      </a:r>
+                    </a:p>
+                  </a:txBody>
+                </a:tc>
+                <a:tc>
+                  <a:txBody>
+                    <a:bodyPr/>
+                    <a:lstStyle/>
+                    <a:p>
+                      <a:pPr lvl="0" indent="0" marL="0">
+                        <a:buNone/>
+                      </a:pPr>
+                      <a:r>
+                        <a:rPr/>
+                        <a:t>0.637629</a:t>
+                      </a:r>
+                    </a:p>
+                  </a:txBody>
+                </a:tc>
+              </a:tr>
+              <a:tr h="0">
+                <a:tc>
+                  <a:txBody>
+                    <a:bodyPr/>
+                    <a:lstStyle/>
+                    <a:p>
+                      <a:pPr lvl="0" indent="0" marL="0">
+                        <a:buNone/>
+                      </a:pPr>
+                      <a:r>
+                        <a:rPr/>
+                        <a:t>897</a:t>
+                      </a:r>
+                    </a:p>
+                  </a:txBody>
+                </a:tc>
+                <a:tc>
+                  <a:txBody>
+                    <a:bodyPr/>
+                    <a:lstStyle/>
+                    <a:p>
+                      <a:pPr lvl="0" indent="0" marL="0">
+                        <a:buNone/>
+                      </a:pPr>
+                      <a:r>
+                        <a:rPr/>
+                        <a:t>sugarberry</a:t>
+                      </a:r>
+                    </a:p>
+                  </a:txBody>
+                </a:tc>
+                <a:tc>
+                  <a:txBody>
+                    <a:bodyPr/>
+                    <a:lstStyle/>
+                    <a:p>
+                      <a:pPr lvl="0" indent="0" marL="0">
+                        <a:buNone/>
+                      </a:pPr>
+                      <a:r>
+                        <a:rPr/>
+                        <a:t>8</a:t>
+                      </a:r>
+                    </a:p>
+                  </a:txBody>
+                </a:tc>
+                <a:tc>
+                  <a:txBody>
+                    <a:bodyPr/>
+                    <a:lstStyle/>
+                    <a:p>
+                      <a:pPr lvl="0" indent="0" marL="0">
+                        <a:buNone/>
+                      </a:pPr>
+                      <a:r>
+                        <a:rPr/>
+                        <a:t>38.144756</a:t>
+                      </a:r>
+                    </a:p>
+                  </a:txBody>
+                </a:tc>
+                <a:tc>
+                  <a:txBody>
+                    <a:bodyPr/>
+                    <a:lstStyle/>
+                    <a:p>
+                      <a:pPr lvl="0" indent="0" marL="0">
+                        <a:buNone/>
+                      </a:pPr>
+                      <a:r>
+                        <a:rPr/>
+                        <a:t>26.680208</a:t>
+                      </a:r>
+                    </a:p>
+                  </a:txBody>
+                </a:tc>
+                <a:tc>
+                  <a:txBody>
+                    <a:bodyPr/>
+                    <a:lstStyle/>
+                    <a:p>
+                      <a:pPr lvl="0" indent="0" marL="0">
+                        <a:buNone/>
+                      </a:pPr>
+                      <a:r>
+                        <a:rPr/>
+                        <a:t>0.665159</a:t>
+                      </a:r>
+                    </a:p>
+                  </a:txBody>
+                </a:tc>
+              </a:tr>
+              <a:tr h="0">
+                <a:tc>
+                  <a:txBody>
+                    <a:bodyPr/>
+                    <a:lstStyle/>
+                    <a:p>
+                      <a:pPr lvl="0" indent="0" marL="0">
+                        <a:buNone/>
+                      </a:pPr>
+                      <a:r>
+                        <a:rPr/>
+                        <a:t>898</a:t>
+                      </a:r>
+                    </a:p>
+                  </a:txBody>
+                </a:tc>
+                <a:tc>
+                  <a:txBody>
+                    <a:bodyPr/>
+                    <a:lstStyle/>
+                    <a:p>
+                      <a:pPr lvl="0" indent="0" marL="0">
+                        <a:buNone/>
+                      </a:pPr>
+                      <a:r>
+                        <a:rPr/>
+                        <a:t>sugarberry</a:t>
+                      </a:r>
+                    </a:p>
+                  </a:txBody>
+                </a:tc>
+                <a:tc>
+                  <a:txBody>
+                    <a:bodyPr/>
+                    <a:lstStyle/>
+                    <a:p>
+                      <a:pPr lvl="0" indent="0" marL="0">
+                        <a:buNone/>
+                      </a:pPr>
+                      <a:r>
+                        <a:rPr/>
+                        <a:t>9</a:t>
+                      </a:r>
+                    </a:p>
+                  </a:txBody>
+                </a:tc>
+                <a:tc>
+                  <a:txBody>
+                    <a:bodyPr/>
+                    <a:lstStyle/>
+                    <a:p>
+                      <a:pPr lvl="0" indent="0" marL="0">
+                        <a:buNone/>
+                      </a:pPr>
+                      <a:r>
+                        <a:rPr/>
+                        <a:t>36.853245</a:t>
+                      </a:r>
+                    </a:p>
+                  </a:txBody>
+                </a:tc>
+                <a:tc>
+                  <a:txBody>
+                    <a:bodyPr/>
+                    <a:lstStyle/>
+                    <a:p>
+                      <a:pPr lvl="0" indent="0" marL="0">
+                        <a:buNone/>
+                      </a:pPr>
+                      <a:r>
+                        <a:rPr/>
+                        <a:t>21.021667</a:t>
+                      </a:r>
+                    </a:p>
+                  </a:txBody>
+                </a:tc>
+                <a:tc>
+                  <a:txBody>
+                    <a:bodyPr/>
+                    <a:lstStyle/>
+                    <a:p>
+                      <a:pPr lvl="0" indent="0" marL="0">
+                        <a:buNone/>
+                      </a:pPr>
+                      <a:r>
+                        <a:rPr/>
+                        <a:t>0.685162</a:t>
+                      </a:r>
+                    </a:p>
+                  </a:txBody>
+                </a:tc>
+              </a:tr>
+              <a:tr h="0">
+                <a:tc>
+                  <a:txBody>
+                    <a:bodyPr/>
+                    <a:lstStyle/>
+                    <a:p>
+                      <a:pPr lvl="0" indent="0" marL="0">
+                        <a:buNone/>
+                      </a:pPr>
+                      <a:r>
+                        <a:rPr/>
+                        <a:t>899</a:t>
+                      </a:r>
+                    </a:p>
+                  </a:txBody>
+                </a:tc>
+                <a:tc>
+                  <a:txBody>
+                    <a:bodyPr/>
+                    <a:lstStyle/>
+                    <a:p>
+                      <a:pPr lvl="0" indent="0" marL="0">
+                        <a:buNone/>
+                      </a:pPr>
+                      <a:r>
+                        <a:rPr/>
+                        <a:t>sugarberry</a:t>
+                      </a:r>
+                    </a:p>
+                  </a:txBody>
+                </a:tc>
+                <a:tc>
+                  <a:txBody>
+                    <a:bodyPr/>
+                    <a:lstStyle/>
+                    <a:p>
+                      <a:pPr lvl="0" indent="0" marL="0">
+                        <a:buNone/>
+                      </a:pPr>
+                      <a:r>
+                        <a:rPr/>
+                        <a:t>10</a:t>
+                      </a:r>
+                    </a:p>
+                  </a:txBody>
+                </a:tc>
+                <a:tc>
+                  <a:txBody>
+                    <a:bodyPr/>
+                    <a:lstStyle/>
+                    <a:p>
+                      <a:pPr lvl="0" indent="0" marL="0">
+                        <a:buNone/>
+                      </a:pPr>
+                      <a:r>
+                        <a:rPr/>
+                        <a:t>40.091106</a:t>
+                      </a:r>
+                    </a:p>
+                  </a:txBody>
+                </a:tc>
+                <a:tc>
+                  <a:txBody>
+                    <a:bodyPr/>
+                    <a:lstStyle/>
+                    <a:p>
+                      <a:pPr lvl="0" indent="0" marL="0">
+                        <a:buNone/>
+                      </a:pPr>
+                      <a:r>
+                        <a:rPr/>
+                        <a:t>23.172083</a:t>
+                      </a:r>
+                    </a:p>
+                  </a:txBody>
+                </a:tc>
+                <a:tc>
+                  <a:txBody>
+                    <a:bodyPr/>
+                    <a:lstStyle/>
+                    <a:p>
+                      <a:pPr lvl="0" indent="0" marL="0">
+                        <a:buNone/>
+                      </a:pPr>
+                      <a:r>
+                        <a:rPr/>
+                        <a:t>0.677519</a:t>
                       </a:r>
                     </a:p>
                   </a:txBody>
@@ -5646,17 +4861,66 @@
             <p:ph type="title"/>
           </p:nvPr>
         </p:nvSpPr>
+        <p:spPr>
+          <a:xfrm>
+            <a:off x="457201" y="204787"/>
+            <a:ext cx="3008313" cy="871538"/>
+          </a:xfrm>
+        </p:spPr>
+        <p:txBody>
+          <a:bodyPr/>
+          <a:lstStyle/>
+          <a:p>
+            <a:pPr lvl="0" indent="0" marL="0">
+              <a:buNone/>
+            </a:pPr>
+            <a:r>
+              <a:rPr/>
+              <a:t>Technical Lead</a:t>
+            </a:r>
+          </a:p>
+        </p:txBody>
+      </p:sp>
+      <p:sp>
+        <p:nvSpPr>
+          <p:cNvPr id="4" name="Text Placeholder 3"/>
+          <p:cNvSpPr>
+            <a:spLocks noGrp="1"/>
+          </p:cNvSpPr>
+          <p:nvPr>
+            <p:ph idx="2" sz="half" type="body"/>
+          </p:nvPr>
+        </p:nvSpPr>
         <p:spPr/>
         <p:txBody>
           <a:bodyPr/>
           <a:lstStyle/>
           <a:p>
-            <a:pPr lvl="0" indent="0" marL="0">
-              <a:buNone/>
-            </a:pPr>
+            <a:pPr lvl="0"/>
             <a:r>
               <a:rPr/>
-              <a:t>Combined Dataset (species mapped onto bigger dataset):</a:t>
+              <a:t>Split and filtering methods</a:t>
+            </a:r>
+          </a:p>
+          <a:p>
+            <a:pPr lvl="0"/>
+            <a:r>
+              <a:rPr/>
+              <a:t>Feature engineering (what worked and what didn’t)</a:t>
+            </a:r>
+          </a:p>
+          <a:p>
+            <a:pPr lvl="0"/>
+            <a:r>
+              <a:rPr/>
+              <a:t>Tuning k for the best model</a:t>
+            </a:r>
+          </a:p>
+          <a:p>
+            <a:pPr lvl="0"/>
+            <a:r>
+              <a:rPr/>
+              <a:t>The final “best” model and error # Tree Measurement Data:</a:t>
             </a:r>
           </a:p>
         </p:txBody>
@@ -5672,8 +4936,8 @@
           </p:nvPr>
         </p:nvGraphicFramePr>
         <p:xfrm>
-          <a:off x="457200" y="1193800"/>
-          <a:ext cx="8229600" cy="3390900"/>
+          <a:off x="3568700" y="203200"/>
+          <a:ext cx="5105400" cy="4381500"/>
         </p:xfrm>
         <a:graphic>
           <a:graphicData uri="http://schemas.openxmlformats.org/drawingml/2006/table">
@@ -5682,12 +4946,11 @@
                 <a:tableStyleId>{5C22544A-7EE6-4342-B048-85BDC9FD1C3A}</a:tableStyleId>
               </a:tblPr>
               <a:tblGrid>
-                <a:gridCol w="1371600"/>
-                <a:gridCol w="1371600"/>
-                <a:gridCol w="1371600"/>
-                <a:gridCol w="1371600"/>
-                <a:gridCol w="1371600"/>
-                <a:gridCol w="1371600"/>
+                <a:gridCol w="1016000"/>
+                <a:gridCol w="1016000"/>
+                <a:gridCol w="1016000"/>
+                <a:gridCol w="1016000"/>
+                <a:gridCol w="1016000"/>
               </a:tblGrid>
               <a:tr h="0">
                 <a:tc>
@@ -5764,22 +5027,6 @@
                   </a:txBody>
                   <a:tcPr/>
                 </a:tc>
-                <a:tc>
-                  <a:txBody>
-                    <a:bodyPr/>
-                    <a:lstStyle/>
-                    <a:p>
-                      <a:pPr lvl="0" indent="0" marL="0">
-                        <a:buNone/>
-                      </a:pPr>
-                      <a:r>
-                        <a:rPr/>
-                        <a:t>COMMON_NAME</a:t>
-                      </a:r>
-                    </a:p>
-                  </a:txBody>
-                  <a:tcPr/>
-                </a:tc>
               </a:tr>
               <a:tr h="0">
                 <a:tc>
@@ -5857,21 +5104,6 @@
                     </a:p>
                   </a:txBody>
                 </a:tc>
-                <a:tc>
-                  <a:txBody>
-                    <a:bodyPr/>
-                    <a:lstStyle/>
-                    <a:p>
-                      <a:pPr lvl="0" indent="0" marL="0">
-                        <a:buNone/>
-                      </a:pPr>
-                      <a:r>
-                        <a:rPr/>
-                        <a:t>balsam fir</a:t>
-                      </a:r>
-                    </a:p>
-                  </a:txBody>
-                </a:tc>
               </a:tr>
               <a:tr h="0">
                 <a:tc>
@@ -5949,21 +5181,6 @@
                     </a:p>
                   </a:txBody>
                 </a:tc>
-                <a:tc>
-                  <a:txBody>
-                    <a:bodyPr/>
-                    <a:lstStyle/>
-                    <a:p>
-                      <a:pPr lvl="0" indent="0" marL="0">
-                        <a:buNone/>
-                      </a:pPr>
-                      <a:r>
-                        <a:rPr/>
-                        <a:t>balsam fir</a:t>
-                      </a:r>
-                    </a:p>
-                  </a:txBody>
-                </a:tc>
               </a:tr>
               <a:tr h="0">
                 <a:tc>
@@ -6041,21 +5258,6 @@
                     </a:p>
                   </a:txBody>
                 </a:tc>
-                <a:tc>
-                  <a:txBody>
-                    <a:bodyPr/>
-                    <a:lstStyle/>
-                    <a:p>
-                      <a:pPr lvl="0" indent="0" marL="0">
-                        <a:buNone/>
-                      </a:pPr>
-                      <a:r>
-                        <a:rPr/>
-                        <a:t>balsam fir</a:t>
-                      </a:r>
-                    </a:p>
-                  </a:txBody>
-                </a:tc>
               </a:tr>
               <a:tr h="0">
                 <a:tc>
@@ -6133,21 +5335,6 @@
                     </a:p>
                   </a:txBody>
                 </a:tc>
-                <a:tc>
-                  <a:txBody>
-                    <a:bodyPr/>
-                    <a:lstStyle/>
-                    <a:p>
-                      <a:pPr lvl="0" indent="0" marL="0">
-                        <a:buNone/>
-                      </a:pPr>
-                      <a:r>
-                        <a:rPr/>
-                        <a:t>balsam fir</a:t>
-                      </a:r>
-                    </a:p>
-                  </a:txBody>
-                </a:tc>
               </a:tr>
               <a:tr h="0">
                 <a:tc>
@@ -6221,21 +5408,6 @@
                       <a:r>
                         <a:rPr/>
                         <a:t>113.92</a:t>
-                      </a:r>
-                    </a:p>
-                  </a:txBody>
-                </a:tc>
-                <a:tc>
-                  <a:txBody>
-                    <a:bodyPr/>
-                    <a:lstStyle/>
-                    <a:p>
-                      <a:pPr lvl="0" indent="0" marL="0">
-                        <a:buNone/>
-                      </a:pPr>
-                      <a:r>
-                        <a:rPr/>
-                        <a:t>balsam fir</a:t>
                       </a:r>
                     </a:p>
                   </a:txBody>
@@ -6287,7 +5459,7 @@
             </a:pPr>
             <a:r>
               <a:rPr/>
-              <a:t>Filtered data</a:t>
+              <a:t>Tree Species Name Data:</a:t>
             </a:r>
           </a:p>
         </p:txBody>
@@ -6313,12 +5485,9 @@
                 <a:tableStyleId>{5C22544A-7EE6-4342-B048-85BDC9FD1C3A}</a:tableStyleId>
               </a:tblPr>
               <a:tblGrid>
-                <a:gridCol w="1371600"/>
-                <a:gridCol w="1371600"/>
-                <a:gridCol w="1371600"/>
-                <a:gridCol w="1371600"/>
-                <a:gridCol w="1371600"/>
-                <a:gridCol w="1371600"/>
+                <a:gridCol w="2743200"/>
+                <a:gridCol w="2743200"/>
+                <a:gridCol w="2743200"/>
               </a:tblGrid>
               <a:tr h="0">
                 <a:tc>
@@ -6357,54 +5526,6 @@
                       </a:pPr>
                       <a:r>
                         <a:rPr/>
-                        <a:t>DO_BH</a:t>
-                      </a:r>
-                    </a:p>
-                  </a:txBody>
-                  <a:tcPr/>
-                </a:tc>
-                <a:tc>
-                  <a:txBody>
-                    <a:bodyPr/>
-                    <a:lstStyle/>
-                    <a:p>
-                      <a:pPr lvl="0" indent="0" marL="0">
-                        <a:buNone/>
-                      </a:pPr>
-                      <a:r>
-                        <a:rPr/>
-                        <a:t>HT_TOT</a:t>
-                      </a:r>
-                    </a:p>
-                  </a:txBody>
-                  <a:tcPr/>
-                </a:tc>
-                <a:tc>
-                  <a:txBody>
-                    <a:bodyPr/>
-                    <a:lstStyle/>
-                    <a:p>
-                      <a:pPr lvl="0" indent="0" marL="0">
-                        <a:buNone/>
-                      </a:pPr>
-                      <a:r>
-                        <a:rPr/>
-                        <a:t>TT_DW_CRM</a:t>
-                      </a:r>
-                    </a:p>
-                  </a:txBody>
-                  <a:tcPr/>
-                </a:tc>
-                <a:tc>
-                  <a:txBody>
-                    <a:bodyPr/>
-                    <a:lstStyle/>
-                    <a:p>
-                      <a:pPr lvl="0" indent="0" marL="0">
-                        <a:buNone/>
-                      </a:pPr>
-                      <a:r>
-                        <a:rPr/>
                         <a:t>COMMON_NAME</a:t>
                       </a:r>
                     </a:p>
@@ -6438,67 +5559,22 @@
                       </a:pPr>
                       <a:r>
                         <a:rPr/>
-                        <a:t>12</a:t>
-                      </a:r>
-                    </a:p>
-                  </a:txBody>
-                </a:tc>
-                <a:tc>
-                  <a:txBody>
-                    <a:bodyPr/>
-                    <a:lstStyle/>
-                    <a:p>
-                      <a:pPr lvl="0" indent="0" marL="0">
-                        <a:buNone/>
-                      </a:pPr>
-                      <a:r>
-                        <a:rPr/>
-                        <a:t>7.5</a:t>
-                      </a:r>
-                    </a:p>
-                  </a:txBody>
-                </a:tc>
-                <a:tc>
-                  <a:txBody>
-                    <a:bodyPr/>
-                    <a:lstStyle/>
-                    <a:p>
-                      <a:pPr lvl="0" indent="0" marL="0">
-                        <a:buNone/>
-                      </a:pPr>
-                      <a:r>
-                        <a:rPr/>
-                        <a:t>45.2</a:t>
-                      </a:r>
-                    </a:p>
-                  </a:txBody>
-                </a:tc>
-                <a:tc>
-                  <a:txBody>
-                    <a:bodyPr/>
-                    <a:lstStyle/>
-                    <a:p>
-                      <a:pPr lvl="0" indent="0" marL="0">
-                        <a:buNone/>
-                      </a:pPr>
-                      <a:r>
-                        <a:rPr/>
-                        <a:t>178.86</a:t>
-                      </a:r>
-                    </a:p>
-                  </a:txBody>
-                </a:tc>
-                <a:tc>
-                  <a:txBody>
-                    <a:bodyPr/>
-                    <a:lstStyle/>
-                    <a:p>
-                      <a:pPr lvl="0" indent="0" marL="0">
-                        <a:buNone/>
-                      </a:pPr>
-                      <a:r>
-                        <a:rPr/>
-                        <a:t>balsam fir</a:t>
+                        <a:t>10</a:t>
+                      </a:r>
+                    </a:p>
+                  </a:txBody>
+                </a:tc>
+                <a:tc>
+                  <a:txBody>
+                    <a:bodyPr/>
+                    <a:lstStyle/>
+                    <a:p>
+                      <a:pPr lvl="0" indent="0" marL="0">
+                        <a:buNone/>
+                      </a:pPr>
+                      <a:r>
+                        <a:rPr/>
+                        <a:t>fir spp.</a:t>
                       </a:r>
                     </a:p>
                   </a:txBody>
@@ -6530,67 +5606,22 @@
                       </a:pPr>
                       <a:r>
                         <a:rPr/>
-                        <a:t>12</a:t>
-                      </a:r>
-                    </a:p>
-                  </a:txBody>
-                </a:tc>
-                <a:tc>
-                  <a:txBody>
-                    <a:bodyPr/>
-                    <a:lstStyle/>
-                    <a:p>
-                      <a:pPr lvl="0" indent="0" marL="0">
-                        <a:buNone/>
-                      </a:pPr>
-                      <a:r>
-                        <a:rPr/>
-                        <a:t>9.3</a:t>
-                      </a:r>
-                    </a:p>
-                  </a:txBody>
-                </a:tc>
-                <a:tc>
-                  <a:txBody>
-                    <a:bodyPr/>
-                    <a:lstStyle/>
-                    <a:p>
-                      <a:pPr lvl="0" indent="0" marL="0">
-                        <a:buNone/>
-                      </a:pPr>
-                      <a:r>
-                        <a:rPr/>
-                        <a:t>62.7</a:t>
-                      </a:r>
-                    </a:p>
-                  </a:txBody>
-                </a:tc>
-                <a:tc>
-                  <a:txBody>
-                    <a:bodyPr/>
-                    <a:lstStyle/>
-                    <a:p>
-                      <a:pPr lvl="0" indent="0" marL="0">
-                        <a:buNone/>
-                      </a:pPr>
-                      <a:r>
-                        <a:rPr/>
-                        <a:t>323.46</a:t>
-                      </a:r>
-                    </a:p>
-                  </a:txBody>
-                </a:tc>
-                <a:tc>
-                  <a:txBody>
-                    <a:bodyPr/>
-                    <a:lstStyle/>
-                    <a:p>
-                      <a:pPr lvl="0" indent="0" marL="0">
-                        <a:buNone/>
-                      </a:pPr>
-                      <a:r>
-                        <a:rPr/>
-                        <a:t>balsam fir</a:t>
+                        <a:t>11</a:t>
+                      </a:r>
+                    </a:p>
+                  </a:txBody>
+                </a:tc>
+                <a:tc>
+                  <a:txBody>
+                    <a:bodyPr/>
+                    <a:lstStyle/>
+                    <a:p>
+                      <a:pPr lvl="0" indent="0" marL="0">
+                        <a:buNone/>
+                      </a:pPr>
+                      <a:r>
+                        <a:rPr/>
+                        <a:t>Pacific silver fir</a:t>
                       </a:r>
                     </a:p>
                   </a:txBody>
@@ -6637,51 +5668,6 @@
                       </a:pPr>
                       <a:r>
                         <a:rPr/>
-                        <a:t>9.7</a:t>
-                      </a:r>
-                    </a:p>
-                  </a:txBody>
-                </a:tc>
-                <a:tc>
-                  <a:txBody>
-                    <a:bodyPr/>
-                    <a:lstStyle/>
-                    <a:p>
-                      <a:pPr lvl="0" indent="0" marL="0">
-                        <a:buNone/>
-                      </a:pPr>
-                      <a:r>
-                        <a:rPr/>
-                        <a:t>56.7</a:t>
-                      </a:r>
-                    </a:p>
-                  </a:txBody>
-                </a:tc>
-                <a:tc>
-                  <a:txBody>
-                    <a:bodyPr/>
-                    <a:lstStyle/>
-                    <a:p>
-                      <a:pPr lvl="0" indent="0" marL="0">
-                        <a:buNone/>
-                      </a:pPr>
-                      <a:r>
-                        <a:rPr/>
-                        <a:t>342.47</a:t>
-                      </a:r>
-                    </a:p>
-                  </a:txBody>
-                </a:tc>
-                <a:tc>
-                  <a:txBody>
-                    <a:bodyPr/>
-                    <a:lstStyle/>
-                    <a:p>
-                      <a:pPr lvl="0" indent="0" marL="0">
-                        <a:buNone/>
-                      </a:pPr>
-                      <a:r>
-                        <a:rPr/>
                         <a:t>balsam fir</a:t>
                       </a:r>
                     </a:p>
@@ -6714,67 +5700,22 @@
                       </a:pPr>
                       <a:r>
                         <a:rPr/>
-                        <a:t>12</a:t>
-                      </a:r>
-                    </a:p>
-                  </a:txBody>
-                </a:tc>
-                <a:tc>
-                  <a:txBody>
-                    <a:bodyPr/>
-                    <a:lstStyle/>
-                    <a:p>
-                      <a:pPr lvl="0" indent="0" marL="0">
-                        <a:buNone/>
-                      </a:pPr>
-                      <a:r>
-                        <a:rPr/>
-                        <a:t>11.4</a:t>
-                      </a:r>
-                    </a:p>
-                  </a:txBody>
-                </a:tc>
-                <a:tc>
-                  <a:txBody>
-                    <a:bodyPr/>
-                    <a:lstStyle/>
-                    <a:p>
-                      <a:pPr lvl="0" indent="0" marL="0">
-                        <a:buNone/>
-                      </a:pPr>
-                      <a:r>
-                        <a:rPr/>
-                        <a:t>66.1</a:t>
-                      </a:r>
-                    </a:p>
-                  </a:txBody>
-                </a:tc>
-                <a:tc>
-                  <a:txBody>
-                    <a:bodyPr/>
-                    <a:lstStyle/>
-                    <a:p>
-                      <a:pPr lvl="0" indent="0" marL="0">
-                        <a:buNone/>
-                      </a:pPr>
-                      <a:r>
-                        <a:rPr/>
-                        <a:t>499.35</a:t>
-                      </a:r>
-                    </a:p>
-                  </a:txBody>
-                </a:tc>
-                <a:tc>
-                  <a:txBody>
-                    <a:bodyPr/>
-                    <a:lstStyle/>
-                    <a:p>
-                      <a:pPr lvl="0" indent="0" marL="0">
-                        <a:buNone/>
-                      </a:pPr>
-                      <a:r>
-                        <a:rPr/>
-                        <a:t>balsam fir</a:t>
+                        <a:t>14</a:t>
+                      </a:r>
+                    </a:p>
+                  </a:txBody>
+                </a:tc>
+                <a:tc>
+                  <a:txBody>
+                    <a:bodyPr/>
+                    <a:lstStyle/>
+                    <a:p>
+                      <a:pPr lvl="0" indent="0" marL="0">
+                        <a:buNone/>
+                      </a:pPr>
+                      <a:r>
+                        <a:rPr/>
+                        <a:t>Santa Lucia or bristlecone fir</a:t>
                       </a:r>
                     </a:p>
                   </a:txBody>
@@ -6806,67 +5747,22 @@
                       </a:pPr>
                       <a:r>
                         <a:rPr/>
-                        <a:t>12</a:t>
-                      </a:r>
-                    </a:p>
-                  </a:txBody>
-                </a:tc>
-                <a:tc>
-                  <a:txBody>
-                    <a:bodyPr/>
-                    <a:lstStyle/>
-                    <a:p>
-                      <a:pPr lvl="0" indent="0" marL="0">
-                        <a:buNone/>
-                      </a:pPr>
-                      <a:r>
-                        <a:rPr/>
-                        <a:t>6.4</a:t>
-                      </a:r>
-                    </a:p>
-                  </a:txBody>
-                </a:tc>
-                <a:tc>
-                  <a:txBody>
-                    <a:bodyPr/>
-                    <a:lstStyle/>
-                    <a:p>
-                      <a:pPr lvl="0" indent="0" marL="0">
-                        <a:buNone/>
-                      </a:pPr>
-                      <a:r>
-                        <a:rPr/>
-                        <a:t>51.8</a:t>
-                      </a:r>
-                    </a:p>
-                  </a:txBody>
-                </a:tc>
-                <a:tc>
-                  <a:txBody>
-                    <a:bodyPr/>
-                    <a:lstStyle/>
-                    <a:p>
-                      <a:pPr lvl="0" indent="0" marL="0">
-                        <a:buNone/>
-                      </a:pPr>
-                      <a:r>
-                        <a:rPr/>
-                        <a:t>113.92</a:t>
-                      </a:r>
-                    </a:p>
-                  </a:txBody>
-                </a:tc>
-                <a:tc>
-                  <a:txBody>
-                    <a:bodyPr/>
-                    <a:lstStyle/>
-                    <a:p>
-                      <a:pPr lvl="0" indent="0" marL="0">
-                        <a:buNone/>
-                      </a:pPr>
-                      <a:r>
-                        <a:rPr/>
-                        <a:t>balsam fir</a:t>
+                        <a:t>15</a:t>
+                      </a:r>
+                    </a:p>
+                  </a:txBody>
+                </a:tc>
+                <a:tc>
+                  <a:txBody>
+                    <a:bodyPr/>
+                    <a:lstStyle/>
+                    <a:p>
+                      <a:pPr lvl="0" indent="0" marL="0">
+                        <a:buNone/>
+                      </a:pPr>
+                      <a:r>
+                        <a:rPr/>
+                        <a:t>white fir</a:t>
                       </a:r>
                     </a:p>
                   </a:txBody>
@@ -6918,11 +5814,1226 @@
             </a:pPr>
             <a:r>
               <a:rPr/>
-              <a:t>Quality Assurance</a:t>
+              <a:t>Combined Dataset (species mapped onto bigger dataset):</a:t>
             </a:r>
           </a:p>
         </p:txBody>
       </p:sp>
+      <p:graphicFrame>
+        <p:nvGraphicFramePr>
+          <p:cNvPr id="6" name="Content Placeholder 5"/>
+          <p:cNvGraphicFramePr>
+            <a:graphicFrameLocks noGrp="1"/>
+          </p:cNvGraphicFramePr>
+          <p:nvPr>
+            <p:ph idx="1"/>
+          </p:nvPr>
+        </p:nvGraphicFramePr>
+        <p:xfrm>
+          <a:off x="457200" y="1193800"/>
+          <a:ext cx="8229600" cy="3390900"/>
+        </p:xfrm>
+        <a:graphic>
+          <a:graphicData uri="http://schemas.openxmlformats.org/drawingml/2006/table">
+            <a:tbl>
+              <a:tblPr firstRow="1" bandRow="1">
+                <a:tableStyleId>{5C22544A-7EE6-4342-B048-85BDC9FD1C3A}</a:tableStyleId>
+              </a:tblPr>
+              <a:tblGrid>
+                <a:gridCol w="1371600"/>
+                <a:gridCol w="1371600"/>
+                <a:gridCol w="1371600"/>
+                <a:gridCol w="1371600"/>
+                <a:gridCol w="1371600"/>
+                <a:gridCol w="1371600"/>
+              </a:tblGrid>
+              <a:tr h="0">
+                <a:tc>
+                  <a:txBody>
+                    <a:bodyPr/>
+                    <a:lstStyle/>
+                    <a:p>
+                      <a:endParaRPr/>
+                    </a:p>
+                  </a:txBody>
+                  <a:tcPr/>
+                </a:tc>
+                <a:tc>
+                  <a:txBody>
+                    <a:bodyPr/>
+                    <a:lstStyle/>
+                    <a:p>
+                      <a:pPr lvl="0" indent="0" marL="0">
+                        <a:buNone/>
+                      </a:pPr>
+                      <a:r>
+                        <a:rPr/>
+                        <a:t>SPCD</a:t>
+                      </a:r>
+                    </a:p>
+                  </a:txBody>
+                  <a:tcPr/>
+                </a:tc>
+                <a:tc>
+                  <a:txBody>
+                    <a:bodyPr/>
+                    <a:lstStyle/>
+                    <a:p>
+                      <a:pPr lvl="0" indent="0" marL="0">
+                        <a:buNone/>
+                      </a:pPr>
+                      <a:r>
+                        <a:rPr/>
+                        <a:t>DO_BH</a:t>
+                      </a:r>
+                    </a:p>
+                  </a:txBody>
+                  <a:tcPr/>
+                </a:tc>
+                <a:tc>
+                  <a:txBody>
+                    <a:bodyPr/>
+                    <a:lstStyle/>
+                    <a:p>
+                      <a:pPr lvl="0" indent="0" marL="0">
+                        <a:buNone/>
+                      </a:pPr>
+                      <a:r>
+                        <a:rPr/>
+                        <a:t>HT_TOT</a:t>
+                      </a:r>
+                    </a:p>
+                  </a:txBody>
+                  <a:tcPr/>
+                </a:tc>
+                <a:tc>
+                  <a:txBody>
+                    <a:bodyPr/>
+                    <a:lstStyle/>
+                    <a:p>
+                      <a:pPr lvl="0" indent="0" marL="0">
+                        <a:buNone/>
+                      </a:pPr>
+                      <a:r>
+                        <a:rPr/>
+                        <a:t>TT_DW_CRM</a:t>
+                      </a:r>
+                    </a:p>
+                  </a:txBody>
+                  <a:tcPr/>
+                </a:tc>
+                <a:tc>
+                  <a:txBody>
+                    <a:bodyPr/>
+                    <a:lstStyle/>
+                    <a:p>
+                      <a:pPr lvl="0" indent="0" marL="0">
+                        <a:buNone/>
+                      </a:pPr>
+                      <a:r>
+                        <a:rPr/>
+                        <a:t>COMMON_NAME</a:t>
+                      </a:r>
+                    </a:p>
+                  </a:txBody>
+                  <a:tcPr/>
+                </a:tc>
+              </a:tr>
+              <a:tr h="0">
+                <a:tc>
+                  <a:txBody>
+                    <a:bodyPr/>
+                    <a:lstStyle/>
+                    <a:p>
+                      <a:pPr lvl="0" indent="0" marL="0">
+                        <a:buNone/>
+                      </a:pPr>
+                      <a:r>
+                        <a:rPr/>
+                        <a:t>0</a:t>
+                      </a:r>
+                    </a:p>
+                  </a:txBody>
+                </a:tc>
+                <a:tc>
+                  <a:txBody>
+                    <a:bodyPr/>
+                    <a:lstStyle/>
+                    <a:p>
+                      <a:pPr lvl="0" indent="0" marL="0">
+                        <a:buNone/>
+                      </a:pPr>
+                      <a:r>
+                        <a:rPr/>
+                        <a:t>12</a:t>
+                      </a:r>
+                    </a:p>
+                  </a:txBody>
+                </a:tc>
+                <a:tc>
+                  <a:txBody>
+                    <a:bodyPr/>
+                    <a:lstStyle/>
+                    <a:p>
+                      <a:pPr lvl="0" indent="0" marL="0">
+                        <a:buNone/>
+                      </a:pPr>
+                      <a:r>
+                        <a:rPr/>
+                        <a:t>7.5</a:t>
+                      </a:r>
+                    </a:p>
+                  </a:txBody>
+                </a:tc>
+                <a:tc>
+                  <a:txBody>
+                    <a:bodyPr/>
+                    <a:lstStyle/>
+                    <a:p>
+                      <a:pPr lvl="0" indent="0" marL="0">
+                        <a:buNone/>
+                      </a:pPr>
+                      <a:r>
+                        <a:rPr/>
+                        <a:t>45.2</a:t>
+                      </a:r>
+                    </a:p>
+                  </a:txBody>
+                </a:tc>
+                <a:tc>
+                  <a:txBody>
+                    <a:bodyPr/>
+                    <a:lstStyle/>
+                    <a:p>
+                      <a:pPr lvl="0" indent="0" marL="0">
+                        <a:buNone/>
+                      </a:pPr>
+                      <a:r>
+                        <a:rPr/>
+                        <a:t>178.86</a:t>
+                      </a:r>
+                    </a:p>
+                  </a:txBody>
+                </a:tc>
+                <a:tc>
+                  <a:txBody>
+                    <a:bodyPr/>
+                    <a:lstStyle/>
+                    <a:p>
+                      <a:pPr lvl="0" indent="0" marL="0">
+                        <a:buNone/>
+                      </a:pPr>
+                      <a:r>
+                        <a:rPr/>
+                        <a:t>balsam fir</a:t>
+                      </a:r>
+                    </a:p>
+                  </a:txBody>
+                </a:tc>
+              </a:tr>
+              <a:tr h="0">
+                <a:tc>
+                  <a:txBody>
+                    <a:bodyPr/>
+                    <a:lstStyle/>
+                    <a:p>
+                      <a:pPr lvl="0" indent="0" marL="0">
+                        <a:buNone/>
+                      </a:pPr>
+                      <a:r>
+                        <a:rPr/>
+                        <a:t>1</a:t>
+                      </a:r>
+                    </a:p>
+                  </a:txBody>
+                </a:tc>
+                <a:tc>
+                  <a:txBody>
+                    <a:bodyPr/>
+                    <a:lstStyle/>
+                    <a:p>
+                      <a:pPr lvl="0" indent="0" marL="0">
+                        <a:buNone/>
+                      </a:pPr>
+                      <a:r>
+                        <a:rPr/>
+                        <a:t>12</a:t>
+                      </a:r>
+                    </a:p>
+                  </a:txBody>
+                </a:tc>
+                <a:tc>
+                  <a:txBody>
+                    <a:bodyPr/>
+                    <a:lstStyle/>
+                    <a:p>
+                      <a:pPr lvl="0" indent="0" marL="0">
+                        <a:buNone/>
+                      </a:pPr>
+                      <a:r>
+                        <a:rPr/>
+                        <a:t>9.3</a:t>
+                      </a:r>
+                    </a:p>
+                  </a:txBody>
+                </a:tc>
+                <a:tc>
+                  <a:txBody>
+                    <a:bodyPr/>
+                    <a:lstStyle/>
+                    <a:p>
+                      <a:pPr lvl="0" indent="0" marL="0">
+                        <a:buNone/>
+                      </a:pPr>
+                      <a:r>
+                        <a:rPr/>
+                        <a:t>62.7</a:t>
+                      </a:r>
+                    </a:p>
+                  </a:txBody>
+                </a:tc>
+                <a:tc>
+                  <a:txBody>
+                    <a:bodyPr/>
+                    <a:lstStyle/>
+                    <a:p>
+                      <a:pPr lvl="0" indent="0" marL="0">
+                        <a:buNone/>
+                      </a:pPr>
+                      <a:r>
+                        <a:rPr/>
+                        <a:t>323.46</a:t>
+                      </a:r>
+                    </a:p>
+                  </a:txBody>
+                </a:tc>
+                <a:tc>
+                  <a:txBody>
+                    <a:bodyPr/>
+                    <a:lstStyle/>
+                    <a:p>
+                      <a:pPr lvl="0" indent="0" marL="0">
+                        <a:buNone/>
+                      </a:pPr>
+                      <a:r>
+                        <a:rPr/>
+                        <a:t>balsam fir</a:t>
+                      </a:r>
+                    </a:p>
+                  </a:txBody>
+                </a:tc>
+              </a:tr>
+              <a:tr h="0">
+                <a:tc>
+                  <a:txBody>
+                    <a:bodyPr/>
+                    <a:lstStyle/>
+                    <a:p>
+                      <a:pPr lvl="0" indent="0" marL="0">
+                        <a:buNone/>
+                      </a:pPr>
+                      <a:r>
+                        <a:rPr/>
+                        <a:t>2</a:t>
+                      </a:r>
+                    </a:p>
+                  </a:txBody>
+                </a:tc>
+                <a:tc>
+                  <a:txBody>
+                    <a:bodyPr/>
+                    <a:lstStyle/>
+                    <a:p>
+                      <a:pPr lvl="0" indent="0" marL="0">
+                        <a:buNone/>
+                      </a:pPr>
+                      <a:r>
+                        <a:rPr/>
+                        <a:t>12</a:t>
+                      </a:r>
+                    </a:p>
+                  </a:txBody>
+                </a:tc>
+                <a:tc>
+                  <a:txBody>
+                    <a:bodyPr/>
+                    <a:lstStyle/>
+                    <a:p>
+                      <a:pPr lvl="0" indent="0" marL="0">
+                        <a:buNone/>
+                      </a:pPr>
+                      <a:r>
+                        <a:rPr/>
+                        <a:t>9.7</a:t>
+                      </a:r>
+                    </a:p>
+                  </a:txBody>
+                </a:tc>
+                <a:tc>
+                  <a:txBody>
+                    <a:bodyPr/>
+                    <a:lstStyle/>
+                    <a:p>
+                      <a:pPr lvl="0" indent="0" marL="0">
+                        <a:buNone/>
+                      </a:pPr>
+                      <a:r>
+                        <a:rPr/>
+                        <a:t>56.7</a:t>
+                      </a:r>
+                    </a:p>
+                  </a:txBody>
+                </a:tc>
+                <a:tc>
+                  <a:txBody>
+                    <a:bodyPr/>
+                    <a:lstStyle/>
+                    <a:p>
+                      <a:pPr lvl="0" indent="0" marL="0">
+                        <a:buNone/>
+                      </a:pPr>
+                      <a:r>
+                        <a:rPr/>
+                        <a:t>342.47</a:t>
+                      </a:r>
+                    </a:p>
+                  </a:txBody>
+                </a:tc>
+                <a:tc>
+                  <a:txBody>
+                    <a:bodyPr/>
+                    <a:lstStyle/>
+                    <a:p>
+                      <a:pPr lvl="0" indent="0" marL="0">
+                        <a:buNone/>
+                      </a:pPr>
+                      <a:r>
+                        <a:rPr/>
+                        <a:t>balsam fir</a:t>
+                      </a:r>
+                    </a:p>
+                  </a:txBody>
+                </a:tc>
+              </a:tr>
+              <a:tr h="0">
+                <a:tc>
+                  <a:txBody>
+                    <a:bodyPr/>
+                    <a:lstStyle/>
+                    <a:p>
+                      <a:pPr lvl="0" indent="0" marL="0">
+                        <a:buNone/>
+                      </a:pPr>
+                      <a:r>
+                        <a:rPr/>
+                        <a:t>3</a:t>
+                      </a:r>
+                    </a:p>
+                  </a:txBody>
+                </a:tc>
+                <a:tc>
+                  <a:txBody>
+                    <a:bodyPr/>
+                    <a:lstStyle/>
+                    <a:p>
+                      <a:pPr lvl="0" indent="0" marL="0">
+                        <a:buNone/>
+                      </a:pPr>
+                      <a:r>
+                        <a:rPr/>
+                        <a:t>12</a:t>
+                      </a:r>
+                    </a:p>
+                  </a:txBody>
+                </a:tc>
+                <a:tc>
+                  <a:txBody>
+                    <a:bodyPr/>
+                    <a:lstStyle/>
+                    <a:p>
+                      <a:pPr lvl="0" indent="0" marL="0">
+                        <a:buNone/>
+                      </a:pPr>
+                      <a:r>
+                        <a:rPr/>
+                        <a:t>11.4</a:t>
+                      </a:r>
+                    </a:p>
+                  </a:txBody>
+                </a:tc>
+                <a:tc>
+                  <a:txBody>
+                    <a:bodyPr/>
+                    <a:lstStyle/>
+                    <a:p>
+                      <a:pPr lvl="0" indent="0" marL="0">
+                        <a:buNone/>
+                      </a:pPr>
+                      <a:r>
+                        <a:rPr/>
+                        <a:t>66.1</a:t>
+                      </a:r>
+                    </a:p>
+                  </a:txBody>
+                </a:tc>
+                <a:tc>
+                  <a:txBody>
+                    <a:bodyPr/>
+                    <a:lstStyle/>
+                    <a:p>
+                      <a:pPr lvl="0" indent="0" marL="0">
+                        <a:buNone/>
+                      </a:pPr>
+                      <a:r>
+                        <a:rPr/>
+                        <a:t>499.35</a:t>
+                      </a:r>
+                    </a:p>
+                  </a:txBody>
+                </a:tc>
+                <a:tc>
+                  <a:txBody>
+                    <a:bodyPr/>
+                    <a:lstStyle/>
+                    <a:p>
+                      <a:pPr lvl="0" indent="0" marL="0">
+                        <a:buNone/>
+                      </a:pPr>
+                      <a:r>
+                        <a:rPr/>
+                        <a:t>balsam fir</a:t>
+                      </a:r>
+                    </a:p>
+                  </a:txBody>
+                </a:tc>
+              </a:tr>
+              <a:tr h="0">
+                <a:tc>
+                  <a:txBody>
+                    <a:bodyPr/>
+                    <a:lstStyle/>
+                    <a:p>
+                      <a:pPr lvl="0" indent="0" marL="0">
+                        <a:buNone/>
+                      </a:pPr>
+                      <a:r>
+                        <a:rPr/>
+                        <a:t>4</a:t>
+                      </a:r>
+                    </a:p>
+                  </a:txBody>
+                </a:tc>
+                <a:tc>
+                  <a:txBody>
+                    <a:bodyPr/>
+                    <a:lstStyle/>
+                    <a:p>
+                      <a:pPr lvl="0" indent="0" marL="0">
+                        <a:buNone/>
+                      </a:pPr>
+                      <a:r>
+                        <a:rPr/>
+                        <a:t>12</a:t>
+                      </a:r>
+                    </a:p>
+                  </a:txBody>
+                </a:tc>
+                <a:tc>
+                  <a:txBody>
+                    <a:bodyPr/>
+                    <a:lstStyle/>
+                    <a:p>
+                      <a:pPr lvl="0" indent="0" marL="0">
+                        <a:buNone/>
+                      </a:pPr>
+                      <a:r>
+                        <a:rPr/>
+                        <a:t>6.4</a:t>
+                      </a:r>
+                    </a:p>
+                  </a:txBody>
+                </a:tc>
+                <a:tc>
+                  <a:txBody>
+                    <a:bodyPr/>
+                    <a:lstStyle/>
+                    <a:p>
+                      <a:pPr lvl="0" indent="0" marL="0">
+                        <a:buNone/>
+                      </a:pPr>
+                      <a:r>
+                        <a:rPr/>
+                        <a:t>51.8</a:t>
+                      </a:r>
+                    </a:p>
+                  </a:txBody>
+                </a:tc>
+                <a:tc>
+                  <a:txBody>
+                    <a:bodyPr/>
+                    <a:lstStyle/>
+                    <a:p>
+                      <a:pPr lvl="0" indent="0" marL="0">
+                        <a:buNone/>
+                      </a:pPr>
+                      <a:r>
+                        <a:rPr/>
+                        <a:t>113.92</a:t>
+                      </a:r>
+                    </a:p>
+                  </a:txBody>
+                </a:tc>
+                <a:tc>
+                  <a:txBody>
+                    <a:bodyPr/>
+                    <a:lstStyle/>
+                    <a:p>
+                      <a:pPr lvl="0" indent="0" marL="0">
+                        <a:buNone/>
+                      </a:pPr>
+                      <a:r>
+                        <a:rPr/>
+                        <a:t>balsam fir</a:t>
+                      </a:r>
+                    </a:p>
+                  </a:txBody>
+                </a:tc>
+              </a:tr>
+            </a:tbl>
+          </a:graphicData>
+        </a:graphic>
+      </p:graphicFrame>
+    </p:spTree>
+  </p:cSld>
+</p:sld>
+</file>
+
+<file path=ppt/slides/slide19.xml><?xml version="1.0" encoding="utf-8"?>
+<p:sld xmlns:a="http://schemas.openxmlformats.org/drawingml/2006/main" xmlns:r="http://schemas.openxmlformats.org/officeDocument/2006/relationships" xmlns:p="http://schemas.openxmlformats.org/presentationml/2006/main">
+  <p:cSld>
+    <p:spTree>
+      <p:nvGrpSpPr>
+        <p:cNvPr id="1" name=""/>
+        <p:cNvGrpSpPr/>
+        <p:nvPr/>
+      </p:nvGrpSpPr>
+      <p:grpSpPr>
+        <a:xfrm>
+          <a:off x="0" y="0"/>
+          <a:ext cx="0" cy="0"/>
+          <a:chOff x="0" y="0"/>
+          <a:chExt cx="0" cy="0"/>
+        </a:xfrm>
+      </p:grpSpPr>
+      <p:sp>
+        <p:nvSpPr>
+          <p:cNvPr id="2" name="Title 1"/>
+          <p:cNvSpPr>
+            <a:spLocks noGrp="1"/>
+          </p:cNvSpPr>
+          <p:nvPr>
+            <p:ph type="title"/>
+          </p:nvPr>
+        </p:nvSpPr>
+        <p:spPr/>
+        <p:txBody>
+          <a:bodyPr/>
+          <a:lstStyle/>
+          <a:p>
+            <a:pPr lvl="0" indent="0" marL="0">
+              <a:buNone/>
+            </a:pPr>
+            <a:r>
+              <a:rPr/>
+              <a:t>Filtered data</a:t>
+            </a:r>
+          </a:p>
+        </p:txBody>
+      </p:sp>
+      <p:graphicFrame>
+        <p:nvGraphicFramePr>
+          <p:cNvPr id="6" name="Content Placeholder 5"/>
+          <p:cNvGraphicFramePr>
+            <a:graphicFrameLocks noGrp="1"/>
+          </p:cNvGraphicFramePr>
+          <p:nvPr>
+            <p:ph idx="1"/>
+          </p:nvPr>
+        </p:nvGraphicFramePr>
+        <p:xfrm>
+          <a:off x="457200" y="1193800"/>
+          <a:ext cx="8229600" cy="3390900"/>
+        </p:xfrm>
+        <a:graphic>
+          <a:graphicData uri="http://schemas.openxmlformats.org/drawingml/2006/table">
+            <a:tbl>
+              <a:tblPr firstRow="1" bandRow="1">
+                <a:tableStyleId>{5C22544A-7EE6-4342-B048-85BDC9FD1C3A}</a:tableStyleId>
+              </a:tblPr>
+              <a:tblGrid>
+                <a:gridCol w="1371600"/>
+                <a:gridCol w="1371600"/>
+                <a:gridCol w="1371600"/>
+                <a:gridCol w="1371600"/>
+                <a:gridCol w="1371600"/>
+                <a:gridCol w="1371600"/>
+              </a:tblGrid>
+              <a:tr h="0">
+                <a:tc>
+                  <a:txBody>
+                    <a:bodyPr/>
+                    <a:lstStyle/>
+                    <a:p>
+                      <a:endParaRPr/>
+                    </a:p>
+                  </a:txBody>
+                  <a:tcPr/>
+                </a:tc>
+                <a:tc>
+                  <a:txBody>
+                    <a:bodyPr/>
+                    <a:lstStyle/>
+                    <a:p>
+                      <a:pPr lvl="0" indent="0" marL="0">
+                        <a:buNone/>
+                      </a:pPr>
+                      <a:r>
+                        <a:rPr/>
+                        <a:t>SPCD</a:t>
+                      </a:r>
+                    </a:p>
+                  </a:txBody>
+                  <a:tcPr/>
+                </a:tc>
+                <a:tc>
+                  <a:txBody>
+                    <a:bodyPr/>
+                    <a:lstStyle/>
+                    <a:p>
+                      <a:pPr lvl="0" indent="0" marL="0">
+                        <a:buNone/>
+                      </a:pPr>
+                      <a:r>
+                        <a:rPr/>
+                        <a:t>DO_BH</a:t>
+                      </a:r>
+                    </a:p>
+                  </a:txBody>
+                  <a:tcPr/>
+                </a:tc>
+                <a:tc>
+                  <a:txBody>
+                    <a:bodyPr/>
+                    <a:lstStyle/>
+                    <a:p>
+                      <a:pPr lvl="0" indent="0" marL="0">
+                        <a:buNone/>
+                      </a:pPr>
+                      <a:r>
+                        <a:rPr/>
+                        <a:t>HT_TOT</a:t>
+                      </a:r>
+                    </a:p>
+                  </a:txBody>
+                  <a:tcPr/>
+                </a:tc>
+                <a:tc>
+                  <a:txBody>
+                    <a:bodyPr/>
+                    <a:lstStyle/>
+                    <a:p>
+                      <a:pPr lvl="0" indent="0" marL="0">
+                        <a:buNone/>
+                      </a:pPr>
+                      <a:r>
+                        <a:rPr/>
+                        <a:t>TT_DW_CRM</a:t>
+                      </a:r>
+                    </a:p>
+                  </a:txBody>
+                  <a:tcPr/>
+                </a:tc>
+                <a:tc>
+                  <a:txBody>
+                    <a:bodyPr/>
+                    <a:lstStyle/>
+                    <a:p>
+                      <a:pPr lvl="0" indent="0" marL="0">
+                        <a:buNone/>
+                      </a:pPr>
+                      <a:r>
+                        <a:rPr/>
+                        <a:t>COMMON_NAME</a:t>
+                      </a:r>
+                    </a:p>
+                  </a:txBody>
+                  <a:tcPr/>
+                </a:tc>
+              </a:tr>
+              <a:tr h="0">
+                <a:tc>
+                  <a:txBody>
+                    <a:bodyPr/>
+                    <a:lstStyle/>
+                    <a:p>
+                      <a:pPr lvl="0" indent="0" marL="0">
+                        <a:buNone/>
+                      </a:pPr>
+                      <a:r>
+                        <a:rPr/>
+                        <a:t>0</a:t>
+                      </a:r>
+                    </a:p>
+                  </a:txBody>
+                </a:tc>
+                <a:tc>
+                  <a:txBody>
+                    <a:bodyPr/>
+                    <a:lstStyle/>
+                    <a:p>
+                      <a:pPr lvl="0" indent="0" marL="0">
+                        <a:buNone/>
+                      </a:pPr>
+                      <a:r>
+                        <a:rPr/>
+                        <a:t>12</a:t>
+                      </a:r>
+                    </a:p>
+                  </a:txBody>
+                </a:tc>
+                <a:tc>
+                  <a:txBody>
+                    <a:bodyPr/>
+                    <a:lstStyle/>
+                    <a:p>
+                      <a:pPr lvl="0" indent="0" marL="0">
+                        <a:buNone/>
+                      </a:pPr>
+                      <a:r>
+                        <a:rPr/>
+                        <a:t>7.5</a:t>
+                      </a:r>
+                    </a:p>
+                  </a:txBody>
+                </a:tc>
+                <a:tc>
+                  <a:txBody>
+                    <a:bodyPr/>
+                    <a:lstStyle/>
+                    <a:p>
+                      <a:pPr lvl="0" indent="0" marL="0">
+                        <a:buNone/>
+                      </a:pPr>
+                      <a:r>
+                        <a:rPr/>
+                        <a:t>45.2</a:t>
+                      </a:r>
+                    </a:p>
+                  </a:txBody>
+                </a:tc>
+                <a:tc>
+                  <a:txBody>
+                    <a:bodyPr/>
+                    <a:lstStyle/>
+                    <a:p>
+                      <a:pPr lvl="0" indent="0" marL="0">
+                        <a:buNone/>
+                      </a:pPr>
+                      <a:r>
+                        <a:rPr/>
+                        <a:t>178.86</a:t>
+                      </a:r>
+                    </a:p>
+                  </a:txBody>
+                </a:tc>
+                <a:tc>
+                  <a:txBody>
+                    <a:bodyPr/>
+                    <a:lstStyle/>
+                    <a:p>
+                      <a:pPr lvl="0" indent="0" marL="0">
+                        <a:buNone/>
+                      </a:pPr>
+                      <a:r>
+                        <a:rPr/>
+                        <a:t>balsam fir</a:t>
+                      </a:r>
+                    </a:p>
+                  </a:txBody>
+                </a:tc>
+              </a:tr>
+              <a:tr h="0">
+                <a:tc>
+                  <a:txBody>
+                    <a:bodyPr/>
+                    <a:lstStyle/>
+                    <a:p>
+                      <a:pPr lvl="0" indent="0" marL="0">
+                        <a:buNone/>
+                      </a:pPr>
+                      <a:r>
+                        <a:rPr/>
+                        <a:t>1</a:t>
+                      </a:r>
+                    </a:p>
+                  </a:txBody>
+                </a:tc>
+                <a:tc>
+                  <a:txBody>
+                    <a:bodyPr/>
+                    <a:lstStyle/>
+                    <a:p>
+                      <a:pPr lvl="0" indent="0" marL="0">
+                        <a:buNone/>
+                      </a:pPr>
+                      <a:r>
+                        <a:rPr/>
+                        <a:t>12</a:t>
+                      </a:r>
+                    </a:p>
+                  </a:txBody>
+                </a:tc>
+                <a:tc>
+                  <a:txBody>
+                    <a:bodyPr/>
+                    <a:lstStyle/>
+                    <a:p>
+                      <a:pPr lvl="0" indent="0" marL="0">
+                        <a:buNone/>
+                      </a:pPr>
+                      <a:r>
+                        <a:rPr/>
+                        <a:t>9.3</a:t>
+                      </a:r>
+                    </a:p>
+                  </a:txBody>
+                </a:tc>
+                <a:tc>
+                  <a:txBody>
+                    <a:bodyPr/>
+                    <a:lstStyle/>
+                    <a:p>
+                      <a:pPr lvl="0" indent="0" marL="0">
+                        <a:buNone/>
+                      </a:pPr>
+                      <a:r>
+                        <a:rPr/>
+                        <a:t>62.7</a:t>
+                      </a:r>
+                    </a:p>
+                  </a:txBody>
+                </a:tc>
+                <a:tc>
+                  <a:txBody>
+                    <a:bodyPr/>
+                    <a:lstStyle/>
+                    <a:p>
+                      <a:pPr lvl="0" indent="0" marL="0">
+                        <a:buNone/>
+                      </a:pPr>
+                      <a:r>
+                        <a:rPr/>
+                        <a:t>323.46</a:t>
+                      </a:r>
+                    </a:p>
+                  </a:txBody>
+                </a:tc>
+                <a:tc>
+                  <a:txBody>
+                    <a:bodyPr/>
+                    <a:lstStyle/>
+                    <a:p>
+                      <a:pPr lvl="0" indent="0" marL="0">
+                        <a:buNone/>
+                      </a:pPr>
+                      <a:r>
+                        <a:rPr/>
+                        <a:t>balsam fir</a:t>
+                      </a:r>
+                    </a:p>
+                  </a:txBody>
+                </a:tc>
+              </a:tr>
+              <a:tr h="0">
+                <a:tc>
+                  <a:txBody>
+                    <a:bodyPr/>
+                    <a:lstStyle/>
+                    <a:p>
+                      <a:pPr lvl="0" indent="0" marL="0">
+                        <a:buNone/>
+                      </a:pPr>
+                      <a:r>
+                        <a:rPr/>
+                        <a:t>2</a:t>
+                      </a:r>
+                    </a:p>
+                  </a:txBody>
+                </a:tc>
+                <a:tc>
+                  <a:txBody>
+                    <a:bodyPr/>
+                    <a:lstStyle/>
+                    <a:p>
+                      <a:pPr lvl="0" indent="0" marL="0">
+                        <a:buNone/>
+                      </a:pPr>
+                      <a:r>
+                        <a:rPr/>
+                        <a:t>12</a:t>
+                      </a:r>
+                    </a:p>
+                  </a:txBody>
+                </a:tc>
+                <a:tc>
+                  <a:txBody>
+                    <a:bodyPr/>
+                    <a:lstStyle/>
+                    <a:p>
+                      <a:pPr lvl="0" indent="0" marL="0">
+                        <a:buNone/>
+                      </a:pPr>
+                      <a:r>
+                        <a:rPr/>
+                        <a:t>9.7</a:t>
+                      </a:r>
+                    </a:p>
+                  </a:txBody>
+                </a:tc>
+                <a:tc>
+                  <a:txBody>
+                    <a:bodyPr/>
+                    <a:lstStyle/>
+                    <a:p>
+                      <a:pPr lvl="0" indent="0" marL="0">
+                        <a:buNone/>
+                      </a:pPr>
+                      <a:r>
+                        <a:rPr/>
+                        <a:t>56.7</a:t>
+                      </a:r>
+                    </a:p>
+                  </a:txBody>
+                </a:tc>
+                <a:tc>
+                  <a:txBody>
+                    <a:bodyPr/>
+                    <a:lstStyle/>
+                    <a:p>
+                      <a:pPr lvl="0" indent="0" marL="0">
+                        <a:buNone/>
+                      </a:pPr>
+                      <a:r>
+                        <a:rPr/>
+                        <a:t>342.47</a:t>
+                      </a:r>
+                    </a:p>
+                  </a:txBody>
+                </a:tc>
+                <a:tc>
+                  <a:txBody>
+                    <a:bodyPr/>
+                    <a:lstStyle/>
+                    <a:p>
+                      <a:pPr lvl="0" indent="0" marL="0">
+                        <a:buNone/>
+                      </a:pPr>
+                      <a:r>
+                        <a:rPr/>
+                        <a:t>balsam fir</a:t>
+                      </a:r>
+                    </a:p>
+                  </a:txBody>
+                </a:tc>
+              </a:tr>
+              <a:tr h="0">
+                <a:tc>
+                  <a:txBody>
+                    <a:bodyPr/>
+                    <a:lstStyle/>
+                    <a:p>
+                      <a:pPr lvl="0" indent="0" marL="0">
+                        <a:buNone/>
+                      </a:pPr>
+                      <a:r>
+                        <a:rPr/>
+                        <a:t>3</a:t>
+                      </a:r>
+                    </a:p>
+                  </a:txBody>
+                </a:tc>
+                <a:tc>
+                  <a:txBody>
+                    <a:bodyPr/>
+                    <a:lstStyle/>
+                    <a:p>
+                      <a:pPr lvl="0" indent="0" marL="0">
+                        <a:buNone/>
+                      </a:pPr>
+                      <a:r>
+                        <a:rPr/>
+                        <a:t>12</a:t>
+                      </a:r>
+                    </a:p>
+                  </a:txBody>
+                </a:tc>
+                <a:tc>
+                  <a:txBody>
+                    <a:bodyPr/>
+                    <a:lstStyle/>
+                    <a:p>
+                      <a:pPr lvl="0" indent="0" marL="0">
+                        <a:buNone/>
+                      </a:pPr>
+                      <a:r>
+                        <a:rPr/>
+                        <a:t>11.4</a:t>
+                      </a:r>
+                    </a:p>
+                  </a:txBody>
+                </a:tc>
+                <a:tc>
+                  <a:txBody>
+                    <a:bodyPr/>
+                    <a:lstStyle/>
+                    <a:p>
+                      <a:pPr lvl="0" indent="0" marL="0">
+                        <a:buNone/>
+                      </a:pPr>
+                      <a:r>
+                        <a:rPr/>
+                        <a:t>66.1</a:t>
+                      </a:r>
+                    </a:p>
+                  </a:txBody>
+                </a:tc>
+                <a:tc>
+                  <a:txBody>
+                    <a:bodyPr/>
+                    <a:lstStyle/>
+                    <a:p>
+                      <a:pPr lvl="0" indent="0" marL="0">
+                        <a:buNone/>
+                      </a:pPr>
+                      <a:r>
+                        <a:rPr/>
+                        <a:t>499.35</a:t>
+                      </a:r>
+                    </a:p>
+                  </a:txBody>
+                </a:tc>
+                <a:tc>
+                  <a:txBody>
+                    <a:bodyPr/>
+                    <a:lstStyle/>
+                    <a:p>
+                      <a:pPr lvl="0" indent="0" marL="0">
+                        <a:buNone/>
+                      </a:pPr>
+                      <a:r>
+                        <a:rPr/>
+                        <a:t>balsam fir</a:t>
+                      </a:r>
+                    </a:p>
+                  </a:txBody>
+                </a:tc>
+              </a:tr>
+              <a:tr h="0">
+                <a:tc>
+                  <a:txBody>
+                    <a:bodyPr/>
+                    <a:lstStyle/>
+                    <a:p>
+                      <a:pPr lvl="0" indent="0" marL="0">
+                        <a:buNone/>
+                      </a:pPr>
+                      <a:r>
+                        <a:rPr/>
+                        <a:t>4</a:t>
+                      </a:r>
+                    </a:p>
+                  </a:txBody>
+                </a:tc>
+                <a:tc>
+                  <a:txBody>
+                    <a:bodyPr/>
+                    <a:lstStyle/>
+                    <a:p>
+                      <a:pPr lvl="0" indent="0" marL="0">
+                        <a:buNone/>
+                      </a:pPr>
+                      <a:r>
+                        <a:rPr/>
+                        <a:t>12</a:t>
+                      </a:r>
+                    </a:p>
+                  </a:txBody>
+                </a:tc>
+                <a:tc>
+                  <a:txBody>
+                    <a:bodyPr/>
+                    <a:lstStyle/>
+                    <a:p>
+                      <a:pPr lvl="0" indent="0" marL="0">
+                        <a:buNone/>
+                      </a:pPr>
+                      <a:r>
+                        <a:rPr/>
+                        <a:t>6.4</a:t>
+                      </a:r>
+                    </a:p>
+                  </a:txBody>
+                </a:tc>
+                <a:tc>
+                  <a:txBody>
+                    <a:bodyPr/>
+                    <a:lstStyle/>
+                    <a:p>
+                      <a:pPr lvl="0" indent="0" marL="0">
+                        <a:buNone/>
+                      </a:pPr>
+                      <a:r>
+                        <a:rPr/>
+                        <a:t>51.8</a:t>
+                      </a:r>
+                    </a:p>
+                  </a:txBody>
+                </a:tc>
+                <a:tc>
+                  <a:txBody>
+                    <a:bodyPr/>
+                    <a:lstStyle/>
+                    <a:p>
+                      <a:pPr lvl="0" indent="0" marL="0">
+                        <a:buNone/>
+                      </a:pPr>
+                      <a:r>
+                        <a:rPr/>
+                        <a:t>113.92</a:t>
+                      </a:r>
+                    </a:p>
+                  </a:txBody>
+                </a:tc>
+                <a:tc>
+                  <a:txBody>
+                    <a:bodyPr/>
+                    <a:lstStyle/>
+                    <a:p>
+                      <a:pPr lvl="0" indent="0" marL="0">
+                        <a:buNone/>
+                      </a:pPr>
+                      <a:r>
+                        <a:rPr/>
+                        <a:t>balsam fir</a:t>
+                      </a:r>
+                    </a:p>
+                  </a:txBody>
+                </a:tc>
+              </a:tr>
+            </a:tbl>
+          </a:graphicData>
+        </a:graphic>
+      </p:graphicFrame>
     </p:spTree>
   </p:cSld>
 </p:sld>
@@ -7004,6 +7115,53 @@
             <a:r>
               <a:rPr/>
               <a:t>.</a:t>
+            </a:r>
+          </a:p>
+        </p:txBody>
+      </p:sp>
+    </p:spTree>
+  </p:cSld>
+</p:sld>
+</file>
+
+<file path=ppt/slides/slide20.xml><?xml version="1.0" encoding="utf-8"?>
+<p:sld xmlns:a="http://schemas.openxmlformats.org/drawingml/2006/main" xmlns:r="http://schemas.openxmlformats.org/officeDocument/2006/relationships" xmlns:p="http://schemas.openxmlformats.org/presentationml/2006/main">
+  <p:cSld>
+    <p:spTree>
+      <p:nvGrpSpPr>
+        <p:cNvPr id="1" name=""/>
+        <p:cNvGrpSpPr/>
+        <p:nvPr/>
+      </p:nvGrpSpPr>
+      <p:grpSpPr>
+        <a:xfrm>
+          <a:off x="0" y="0"/>
+          <a:ext cx="0" cy="0"/>
+          <a:chOff x="0" y="0"/>
+          <a:chExt cx="0" cy="0"/>
+        </a:xfrm>
+      </p:grpSpPr>
+      <p:sp>
+        <p:nvSpPr>
+          <p:cNvPr id="2" name="Title 1"/>
+          <p:cNvSpPr>
+            <a:spLocks noGrp="1"/>
+          </p:cNvSpPr>
+          <p:nvPr>
+            <p:ph type="title"/>
+          </p:nvPr>
+        </p:nvSpPr>
+        <p:spPr/>
+        <p:txBody>
+          <a:bodyPr/>
+          <a:lstStyle/>
+          <a:p>
+            <a:pPr lvl="0" indent="0" marL="0">
+              <a:buNone/>
+            </a:pPr>
+            <a:r>
+              <a:rPr/>
+              <a:t>Quality Assurance</a:t>
             </a:r>
           </a:p>
         </p:txBody>

</xml_diff>

<commit_message>
add a average roo mean square log error for every k
</commit_message>
<xml_diff>
--- a/Project-3/presentation.pptx
+++ b/Project-3/presentation.pptx
@@ -24,6 +24,9 @@
     <p:sldId id="272" r:id="rId18"/>
     <p:sldId id="273" r:id="rId19"/>
     <p:sldId id="274" r:id="rId20"/>
+    <p:sldId id="275" r:id="rId21"/>
+    <p:sldId id="276" r:id="rId22"/>
+    <p:sldId id="277" r:id="rId23"/>
   </p:sldIdLst>
   <p:sldSz cx="9144000" cy="5143500" type="screen16x9"/>
   <p:notesSz cx="6858000" cy="9144000"/>
@@ -3459,7 +3462,37 @@
             </a:pPr>
             <a:r>
               <a:rPr/>
-              <a:t>Consultation SERC scientist</a:t>
+              <a:t>Consultation</a:t>
+            </a:r>
+          </a:p>
+        </p:txBody>
+      </p:sp>
+      <p:sp>
+        <p:nvSpPr>
+          <p:cNvPr id="3" name="Content Placeholder 2"/>
+          <p:cNvSpPr>
+            <a:spLocks noGrp="1"/>
+          </p:cNvSpPr>
+          <p:nvPr>
+            <p:ph idx="1"/>
+          </p:nvPr>
+        </p:nvSpPr>
+        <p:spPr/>
+        <p:txBody>
+          <a:bodyPr/>
+          <a:lstStyle/>
+          <a:p>
+            <a:pPr lvl="0"/>
+            <a:r>
+              <a:rPr/>
+              <a:t>We choose kNN regression over linear regression because when looking at the graphs Dean made, we saw that the tree diameter/height vs. biomass graphs all have exponential growth.</a:t>
+            </a:r>
+          </a:p>
+          <a:p>
+            <a:pPr lvl="0"/>
+            <a:r>
+              <a:rPr/>
+              <a:t>When relations between biomass and trees’ diameter and height are complex and nonlinear, data is abundant, and the model needs to be adaptive without making major changes in the model. kNN excels in capturing patterns and irregular patterns.</a:t>
             </a:r>
           </a:p>
         </p:txBody>
@@ -3526,12 +3559,21 @@
           <a:bodyPr/>
           <a:lstStyle/>
           <a:p>
-            <a:pPr lvl="0" indent="0" marL="0">
-              <a:buNone/>
-            </a:pPr>
+            <a:pPr lvl="0"/>
             <a:r>
               <a:rPr/>
-              <a:t>When predicting tree biomass, employ the performance metric root mean square logarithmic error since biomass data varies greatly, ranging from tiny saplings to enormous grandpa trees, some trees having exponential growth. RMSLE focuses on percentage errors, making it fair to both small and large trees, unlike RMSE, which we believe penalizes errors on big trees. Fitting biomass estimations where scale matters more than absolute error. This metric is particularly useful in accurately assessing the predictive performance of models when dealing with such diverse ranges of tree sizes. By prioritizing percentage errors, RMSLE provides a more balanced evaluation that considers the unique characteristics of tree biomass data.</a:t>
+              <a:t>When predicting tree biomass, we chose Root Mean Square Logarithmic Error for our performance metric since biomass data varies greatly, ranging from tiny saplings to enormous trees, and trees have exponential growth.</a:t>
+            </a:r>
+          </a:p>
+          <a:p>
+            <a:pPr lvl="0"/>
+            <a:r>
+              <a:rPr b="1"/>
+              <a:t>RMSLE over RMSE</a:t>
+            </a:r>
+            <a:r>
+              <a:rPr/>
+              <a:t>: focuses on percentage errors, making it fair to both small and large trees, unlike RMSE, which we believe penalizes errors on big trees. Fitting biomass estimations where scale matters more than absolute error. RMSLE provides a more balanced evaluation that considers the unique characteristics of tree biomass data.</a:t>
             </a:r>
           </a:p>
         </p:txBody>
@@ -3578,7 +3620,7 @@
             </a:pPr>
             <a:r>
               <a:rPr/>
-              <a:t>Model</a:t>
+              <a:t>Project Manager Model</a:t>
             </a:r>
           </a:p>
         </p:txBody>
@@ -3759,37 +3801,37 @@
                       </a:pPr>
                       <a:r>
                         <a:rPr/>
-                        <a:t>125.825473</a:t>
-                      </a:r>
-                    </a:p>
-                  </a:txBody>
-                </a:tc>
-                <a:tc>
-                  <a:txBody>
-                    <a:bodyPr/>
-                    <a:lstStyle/>
-                    <a:p>
-                      <a:pPr lvl="0" indent="0" marL="0">
-                        <a:buNone/>
-                      </a:pPr>
-                      <a:r>
-                        <a:rPr/>
-                        <a:t>34.801913</a:t>
-                      </a:r>
-                    </a:p>
-                  </a:txBody>
-                </a:tc>
-                <a:tc>
-                  <a:txBody>
-                    <a:bodyPr/>
-                    <a:lstStyle/>
-                    <a:p>
-                      <a:pPr lvl="0" indent="0" marL="0">
-                        <a:buNone/>
-                      </a:pPr>
-                      <a:r>
-                        <a:rPr/>
-                        <a:t>0.119574</a:t>
+                        <a:t>125.827396</a:t>
+                      </a:r>
+                    </a:p>
+                  </a:txBody>
+                </a:tc>
+                <a:tc>
+                  <a:txBody>
+                    <a:bodyPr/>
+                    <a:lstStyle/>
+                    <a:p>
+                      <a:pPr lvl="0" indent="0" marL="0">
+                        <a:buNone/>
+                      </a:pPr>
+                      <a:r>
+                        <a:rPr/>
+                        <a:t>34.820565</a:t>
+                      </a:r>
+                    </a:p>
+                  </a:txBody>
+                </a:tc>
+                <a:tc>
+                  <a:txBody>
+                    <a:bodyPr/>
+                    <a:lstStyle/>
+                    <a:p>
+                      <a:pPr lvl="0" indent="0" marL="0">
+                        <a:buNone/>
+                      </a:pPr>
+                      <a:r>
+                        <a:rPr/>
+                        <a:t>0.119617</a:t>
                       </a:r>
                     </a:p>
                   </a:txBody>
@@ -3851,37 +3893,37 @@
                       </a:pPr>
                       <a:r>
                         <a:rPr/>
-                        <a:t>129.651479</a:t>
-                      </a:r>
-                    </a:p>
-                  </a:txBody>
-                </a:tc>
-                <a:tc>
-                  <a:txBody>
-                    <a:bodyPr/>
-                    <a:lstStyle/>
-                    <a:p>
-                      <a:pPr lvl="0" indent="0" marL="0">
-                        <a:buNone/>
-                      </a:pPr>
-                      <a:r>
-                        <a:rPr/>
-                        <a:t>36.646493</a:t>
-                      </a:r>
-                    </a:p>
-                  </a:txBody>
-                </a:tc>
-                <a:tc>
-                  <a:txBody>
-                    <a:bodyPr/>
-                    <a:lstStyle/>
-                    <a:p>
-                      <a:pPr lvl="0" indent="0" marL="0">
-                        <a:buNone/>
-                      </a:pPr>
-                      <a:r>
-                        <a:rPr/>
-                        <a:t>0.123724</a:t>
+                        <a:t>129.650855</a:t>
+                      </a:r>
+                    </a:p>
+                  </a:txBody>
+                </a:tc>
+                <a:tc>
+                  <a:txBody>
+                    <a:bodyPr/>
+                    <a:lstStyle/>
+                    <a:p>
+                      <a:pPr lvl="0" indent="0" marL="0">
+                        <a:buNone/>
+                      </a:pPr>
+                      <a:r>
+                        <a:rPr/>
+                        <a:t>36.628377</a:t>
+                      </a:r>
+                    </a:p>
+                  </a:txBody>
+                </a:tc>
+                <a:tc>
+                  <a:txBody>
+                    <a:bodyPr/>
+                    <a:lstStyle/>
+                    <a:p>
+                      <a:pPr lvl="0" indent="0" marL="0">
+                        <a:buNone/>
+                      </a:pPr>
+                      <a:r>
+                        <a:rPr/>
+                        <a:t>0.123679</a:t>
                       </a:r>
                     </a:p>
                   </a:txBody>
@@ -4035,37 +4077,37 @@
                       </a:pPr>
                       <a:r>
                         <a:rPr/>
-                        <a:t>145.003601</a:t>
-                      </a:r>
-                    </a:p>
-                  </a:txBody>
-                </a:tc>
-                <a:tc>
-                  <a:txBody>
-                    <a:bodyPr/>
-                    <a:lstStyle/>
-                    <a:p>
-                      <a:pPr lvl="0" indent="0" marL="0">
-                        <a:buNone/>
-                      </a:pPr>
-                      <a:r>
-                        <a:rPr/>
-                        <a:t>41.209530</a:t>
-                      </a:r>
-                    </a:p>
-                  </a:txBody>
-                </a:tc>
-                <a:tc>
-                  <a:txBody>
-                    <a:bodyPr/>
-                    <a:lstStyle/>
-                    <a:p>
-                      <a:pPr lvl="0" indent="0" marL="0">
-                        <a:buNone/>
-                      </a:pPr>
-                      <a:r>
-                        <a:rPr/>
-                        <a:t>0.144063</a:t>
+                        <a:t>145.002852</a:t>
+                      </a:r>
+                    </a:p>
+                  </a:txBody>
+                </a:tc>
+                <a:tc>
+                  <a:txBody>
+                    <a:bodyPr/>
+                    <a:lstStyle/>
+                    <a:p>
+                      <a:pPr lvl="0" indent="0" marL="0">
+                        <a:buNone/>
+                      </a:pPr>
+                      <a:r>
+                        <a:rPr/>
+                        <a:t>41.168470</a:t>
+                      </a:r>
+                    </a:p>
+                  </a:txBody>
+                </a:tc>
+                <a:tc>
+                  <a:txBody>
+                    <a:bodyPr/>
+                    <a:lstStyle/>
+                    <a:p>
+                      <a:pPr lvl="0" indent="0" marL="0">
+                        <a:buNone/>
+                      </a:pPr>
+                      <a:r>
+                        <a:rPr/>
+                        <a:t>0.144052</a:t>
                       </a:r>
                     </a:p>
                   </a:txBody>
@@ -4127,37 +4169,37 @@
                       </a:pPr>
                       <a:r>
                         <a:rPr/>
-                        <a:t>147.451321</a:t>
-                      </a:r>
-                    </a:p>
-                  </a:txBody>
-                </a:tc>
-                <a:tc>
-                  <a:txBody>
-                    <a:bodyPr/>
-                    <a:lstStyle/>
-                    <a:p>
-                      <a:pPr lvl="0" indent="0" marL="0">
-                        <a:buNone/>
-                      </a:pPr>
-                      <a:r>
-                        <a:rPr/>
-                        <a:t>40.791681</a:t>
-                      </a:r>
-                    </a:p>
-                  </a:txBody>
-                </a:tc>
-                <a:tc>
-                  <a:txBody>
-                    <a:bodyPr/>
-                    <a:lstStyle/>
-                    <a:p>
-                      <a:pPr lvl="0" indent="0" marL="0">
-                        <a:buNone/>
-                      </a:pPr>
-                      <a:r>
-                        <a:rPr/>
-                        <a:t>0.142862</a:t>
+                        <a:t>147.449208</a:t>
+                      </a:r>
+                    </a:p>
+                  </a:txBody>
+                </a:tc>
+                <a:tc>
+                  <a:txBody>
+                    <a:bodyPr/>
+                    <a:lstStyle/>
+                    <a:p>
+                      <a:pPr lvl="0" indent="0" marL="0">
+                        <a:buNone/>
+                      </a:pPr>
+                      <a:r>
+                        <a:rPr/>
+                        <a:t>40.728609</a:t>
+                      </a:r>
+                    </a:p>
+                  </a:txBody>
+                </a:tc>
+                <a:tc>
+                  <a:txBody>
+                    <a:bodyPr/>
+                    <a:lstStyle/>
+                    <a:p>
+                      <a:pPr lvl="0" indent="0" marL="0">
+                        <a:buNone/>
+                      </a:pPr>
+                      <a:r>
+                        <a:rPr/>
+                        <a:t>0.142813</a:t>
                       </a:r>
                     </a:p>
                   </a:txBody>
@@ -4174,82 +4216,82 @@
                       </a:pPr>
                       <a:r>
                         <a:rPr/>
-                        <a:t>...</a:t>
-                      </a:r>
-                    </a:p>
-                  </a:txBody>
-                </a:tc>
-                <a:tc>
-                  <a:txBody>
-                    <a:bodyPr/>
-                    <a:lstStyle/>
-                    <a:p>
-                      <a:pPr lvl="0" indent="0" marL="0">
-                        <a:buNone/>
-                      </a:pPr>
-                      <a:r>
-                        <a:rPr/>
-                        <a:t>...</a:t>
-                      </a:r>
-                    </a:p>
-                  </a:txBody>
-                </a:tc>
-                <a:tc>
-                  <a:txBody>
-                    <a:bodyPr/>
-                    <a:lstStyle/>
-                    <a:p>
-                      <a:pPr lvl="0" indent="0" marL="0">
-                        <a:buNone/>
-                      </a:pPr>
-                      <a:r>
-                        <a:rPr/>
-                        <a:t>...</a:t>
-                      </a:r>
-                    </a:p>
-                  </a:txBody>
-                </a:tc>
-                <a:tc>
-                  <a:txBody>
-                    <a:bodyPr/>
-                    <a:lstStyle/>
-                    <a:p>
-                      <a:pPr lvl="0" indent="0" marL="0">
-                        <a:buNone/>
-                      </a:pPr>
-                      <a:r>
-                        <a:rPr/>
-                        <a:t>...</a:t>
-                      </a:r>
-                    </a:p>
-                  </a:txBody>
-                </a:tc>
-                <a:tc>
-                  <a:txBody>
-                    <a:bodyPr/>
-                    <a:lstStyle/>
-                    <a:p>
-                      <a:pPr lvl="0" indent="0" marL="0">
-                        <a:buNone/>
-                      </a:pPr>
-                      <a:r>
-                        <a:rPr/>
-                        <a:t>...</a:t>
-                      </a:r>
-                    </a:p>
-                  </a:txBody>
-                </a:tc>
-                <a:tc>
-                  <a:txBody>
-                    <a:bodyPr/>
-                    <a:lstStyle/>
-                    <a:p>
-                      <a:pPr lvl="0" indent="0" marL="0">
-                        <a:buNone/>
-                      </a:pPr>
-                      <a:r>
-                        <a:rPr/>
-                        <a:t>...</a:t>
+                        <a:t>5</a:t>
+                      </a:r>
+                    </a:p>
+                  </a:txBody>
+                </a:tc>
+                <a:tc>
+                  <a:txBody>
+                    <a:bodyPr/>
+                    <a:lstStyle/>
+                    <a:p>
+                      <a:pPr lvl="0" indent="0" marL="0">
+                        <a:buNone/>
+                      </a:pPr>
+                      <a:r>
+                        <a:rPr/>
+                        <a:t>balsam fir</a:t>
+                      </a:r>
+                    </a:p>
+                  </a:txBody>
+                </a:tc>
+                <a:tc>
+                  <a:txBody>
+                    <a:bodyPr/>
+                    <a:lstStyle/>
+                    <a:p>
+                      <a:pPr lvl="0" indent="0" marL="0">
+                        <a:buNone/>
+                      </a:pPr>
+                      <a:r>
+                        <a:rPr/>
+                        <a:t>7</a:t>
+                      </a:r>
+                    </a:p>
+                  </a:txBody>
+                </a:tc>
+                <a:tc>
+                  <a:txBody>
+                    <a:bodyPr/>
+                    <a:lstStyle/>
+                    <a:p>
+                      <a:pPr lvl="0" indent="0" marL="0">
+                        <a:buNone/>
+                      </a:pPr>
+                      <a:r>
+                        <a:rPr/>
+                        <a:t>153.474421</a:t>
+                      </a:r>
+                    </a:p>
+                  </a:txBody>
+                </a:tc>
+                <a:tc>
+                  <a:txBody>
+                    <a:bodyPr/>
+                    <a:lstStyle/>
+                    <a:p>
+                      <a:pPr lvl="0" indent="0" marL="0">
+                        <a:buNone/>
+                      </a:pPr>
+                      <a:r>
+                        <a:rPr/>
+                        <a:t>42.215118</a:t>
+                      </a:r>
+                    </a:p>
+                  </a:txBody>
+                </a:tc>
+                <a:tc>
+                  <a:txBody>
+                    <a:bodyPr/>
+                    <a:lstStyle/>
+                    <a:p>
+                      <a:pPr lvl="0" indent="0" marL="0">
+                        <a:buNone/>
+                      </a:pPr>
+                      <a:r>
+                        <a:rPr/>
+                        <a:t>0.149516</a:t>
                       </a:r>
                     </a:p>
                   </a:txBody>
@@ -4266,36 +4308,6 @@
                       </a:pPr>
                       <a:r>
                         <a:rPr/>
-                        <a:t>895</a:t>
-                      </a:r>
-                    </a:p>
-                  </a:txBody>
-                </a:tc>
-                <a:tc>
-                  <a:txBody>
-                    <a:bodyPr/>
-                    <a:lstStyle/>
-                    <a:p>
-                      <a:pPr lvl="0" indent="0" marL="0">
-                        <a:buNone/>
-                      </a:pPr>
-                      <a:r>
-                        <a:rPr/>
-                        <a:t>sugarberry</a:t>
-                      </a:r>
-                    </a:p>
-                  </a:txBody>
-                </a:tc>
-                <a:tc>
-                  <a:txBody>
-                    <a:bodyPr/>
-                    <a:lstStyle/>
-                    <a:p>
-                      <a:pPr lvl="0" indent="0" marL="0">
-                        <a:buNone/>
-                      </a:pPr>
-                      <a:r>
-                        <a:rPr/>
                         <a:t>6</a:t>
                       </a:r>
                     </a:p>
@@ -4311,37 +4323,67 @@
                       </a:pPr>
                       <a:r>
                         <a:rPr/>
-                        <a:t>32.431052</a:t>
-                      </a:r>
-                    </a:p>
-                  </a:txBody>
-                </a:tc>
-                <a:tc>
-                  <a:txBody>
-                    <a:bodyPr/>
-                    <a:lstStyle/>
-                    <a:p>
-                      <a:pPr lvl="0" indent="0" marL="0">
-                        <a:buNone/>
-                      </a:pPr>
-                      <a:r>
-                        <a:rPr/>
-                        <a:t>20.969306</a:t>
-                      </a:r>
-                    </a:p>
-                  </a:txBody>
-                </a:tc>
-                <a:tc>
-                  <a:txBody>
-                    <a:bodyPr/>
-                    <a:lstStyle/>
-                    <a:p>
-                      <a:pPr lvl="0" indent="0" marL="0">
-                        <a:buNone/>
-                      </a:pPr>
-                      <a:r>
-                        <a:rPr/>
-                        <a:t>0.565727</a:t>
+                        <a:t>balsam fir</a:t>
+                      </a:r>
+                    </a:p>
+                  </a:txBody>
+                </a:tc>
+                <a:tc>
+                  <a:txBody>
+                    <a:bodyPr/>
+                    <a:lstStyle/>
+                    <a:p>
+                      <a:pPr lvl="0" indent="0" marL="0">
+                        <a:buNone/>
+                      </a:pPr>
+                      <a:r>
+                        <a:rPr/>
+                        <a:t>8</a:t>
+                      </a:r>
+                    </a:p>
+                  </a:txBody>
+                </a:tc>
+                <a:tc>
+                  <a:txBody>
+                    <a:bodyPr/>
+                    <a:lstStyle/>
+                    <a:p>
+                      <a:pPr lvl="0" indent="0" marL="0">
+                        <a:buNone/>
+                      </a:pPr>
+                      <a:r>
+                        <a:rPr/>
+                        <a:t>156.768710</a:t>
+                      </a:r>
+                    </a:p>
+                  </a:txBody>
+                </a:tc>
+                <a:tc>
+                  <a:txBody>
+                    <a:bodyPr/>
+                    <a:lstStyle/>
+                    <a:p>
+                      <a:pPr lvl="0" indent="0" marL="0">
+                        <a:buNone/>
+                      </a:pPr>
+                      <a:r>
+                        <a:rPr/>
+                        <a:t>43.559217</a:t>
+                      </a:r>
+                    </a:p>
+                  </a:txBody>
+                </a:tc>
+                <a:tc>
+                  <a:txBody>
+                    <a:bodyPr/>
+                    <a:lstStyle/>
+                    <a:p>
+                      <a:pPr lvl="0" indent="0" marL="0">
+                        <a:buNone/>
+                      </a:pPr>
+                      <a:r>
+                        <a:rPr/>
+                        <a:t>0.154670</a:t>
                       </a:r>
                     </a:p>
                   </a:txBody>
@@ -4358,36 +4400,6 @@
                       </a:pPr>
                       <a:r>
                         <a:rPr/>
-                        <a:t>896</a:t>
-                      </a:r>
-                    </a:p>
-                  </a:txBody>
-                </a:tc>
-                <a:tc>
-                  <a:txBody>
-                    <a:bodyPr/>
-                    <a:lstStyle/>
-                    <a:p>
-                      <a:pPr lvl="0" indent="0" marL="0">
-                        <a:buNone/>
-                      </a:pPr>
-                      <a:r>
-                        <a:rPr/>
-                        <a:t>sugarberry</a:t>
-                      </a:r>
-                    </a:p>
-                  </a:txBody>
-                </a:tc>
-                <a:tc>
-                  <a:txBody>
-                    <a:bodyPr/>
-                    <a:lstStyle/>
-                    <a:p>
-                      <a:pPr lvl="0" indent="0" marL="0">
-                        <a:buNone/>
-                      </a:pPr>
-                      <a:r>
-                        <a:rPr/>
                         <a:t>7</a:t>
                       </a:r>
                     </a:p>
@@ -4403,37 +4415,67 @@
                       </a:pPr>
                       <a:r>
                         <a:rPr/>
-                        <a:t>37.324259</a:t>
-                      </a:r>
-                    </a:p>
-                  </a:txBody>
-                </a:tc>
-                <a:tc>
-                  <a:txBody>
-                    <a:bodyPr/>
-                    <a:lstStyle/>
-                    <a:p>
-                      <a:pPr lvl="0" indent="0" marL="0">
-                        <a:buNone/>
-                      </a:pPr>
-                      <a:r>
-                        <a:rPr/>
-                        <a:t>25.037024</a:t>
-                      </a:r>
-                    </a:p>
-                  </a:txBody>
-                </a:tc>
-                <a:tc>
-                  <a:txBody>
-                    <a:bodyPr/>
-                    <a:lstStyle/>
-                    <a:p>
-                      <a:pPr lvl="0" indent="0" marL="0">
-                        <a:buNone/>
-                      </a:pPr>
-                      <a:r>
-                        <a:rPr/>
-                        <a:t>0.637629</a:t>
+                        <a:t>balsam fir</a:t>
+                      </a:r>
+                    </a:p>
+                  </a:txBody>
+                </a:tc>
+                <a:tc>
+                  <a:txBody>
+                    <a:bodyPr/>
+                    <a:lstStyle/>
+                    <a:p>
+                      <a:pPr lvl="0" indent="0" marL="0">
+                        <a:buNone/>
+                      </a:pPr>
+                      <a:r>
+                        <a:rPr/>
+                        <a:t>9</a:t>
+                      </a:r>
+                    </a:p>
+                  </a:txBody>
+                </a:tc>
+                <a:tc>
+                  <a:txBody>
+                    <a:bodyPr/>
+                    <a:lstStyle/>
+                    <a:p>
+                      <a:pPr lvl="0" indent="0" marL="0">
+                        <a:buNone/>
+                      </a:pPr>
+                      <a:r>
+                        <a:rPr/>
+                        <a:t>161.016214</a:t>
+                      </a:r>
+                    </a:p>
+                  </a:txBody>
+                </a:tc>
+                <a:tc>
+                  <a:txBody>
+                    <a:bodyPr/>
+                    <a:lstStyle/>
+                    <a:p>
+                      <a:pPr lvl="0" indent="0" marL="0">
+                        <a:buNone/>
+                      </a:pPr>
+                      <a:r>
+                        <a:rPr/>
+                        <a:t>44.751469</a:t>
+                      </a:r>
+                    </a:p>
+                  </a:txBody>
+                </a:tc>
+                <a:tc>
+                  <a:txBody>
+                    <a:bodyPr/>
+                    <a:lstStyle/>
+                    <a:p>
+                      <a:pPr lvl="0" indent="0" marL="0">
+                        <a:buNone/>
+                      </a:pPr>
+                      <a:r>
+                        <a:rPr/>
+                        <a:t>0.160504</a:t>
                       </a:r>
                     </a:p>
                   </a:txBody>
@@ -4450,36 +4492,6 @@
                       </a:pPr>
                       <a:r>
                         <a:rPr/>
-                        <a:t>897</a:t>
-                      </a:r>
-                    </a:p>
-                  </a:txBody>
-                </a:tc>
-                <a:tc>
-                  <a:txBody>
-                    <a:bodyPr/>
-                    <a:lstStyle/>
-                    <a:p>
-                      <a:pPr lvl="0" indent="0" marL="0">
-                        <a:buNone/>
-                      </a:pPr>
-                      <a:r>
-                        <a:rPr/>
-                        <a:t>sugarberry</a:t>
-                      </a:r>
-                    </a:p>
-                  </a:txBody>
-                </a:tc>
-                <a:tc>
-                  <a:txBody>
-                    <a:bodyPr/>
-                    <a:lstStyle/>
-                    <a:p>
-                      <a:pPr lvl="0" indent="0" marL="0">
-                        <a:buNone/>
-                      </a:pPr>
-                      <a:r>
-                        <a:rPr/>
                         <a:t>8</a:t>
                       </a:r>
                     </a:p>
@@ -4495,161 +4507,7 @@
                       </a:pPr>
                       <a:r>
                         <a:rPr/>
-                        <a:t>38.144756</a:t>
-                      </a:r>
-                    </a:p>
-                  </a:txBody>
-                </a:tc>
-                <a:tc>
-                  <a:txBody>
-                    <a:bodyPr/>
-                    <a:lstStyle/>
-                    <a:p>
-                      <a:pPr lvl="0" indent="0" marL="0">
-                        <a:buNone/>
-                      </a:pPr>
-                      <a:r>
-                        <a:rPr/>
-                        <a:t>26.680208</a:t>
-                      </a:r>
-                    </a:p>
-                  </a:txBody>
-                </a:tc>
-                <a:tc>
-                  <a:txBody>
-                    <a:bodyPr/>
-                    <a:lstStyle/>
-                    <a:p>
-                      <a:pPr lvl="0" indent="0" marL="0">
-                        <a:buNone/>
-                      </a:pPr>
-                      <a:r>
-                        <a:rPr/>
-                        <a:t>0.665159</a:t>
-                      </a:r>
-                    </a:p>
-                  </a:txBody>
-                </a:tc>
-              </a:tr>
-              <a:tr h="0">
-                <a:tc>
-                  <a:txBody>
-                    <a:bodyPr/>
-                    <a:lstStyle/>
-                    <a:p>
-                      <a:pPr lvl="0" indent="0" marL="0">
-                        <a:buNone/>
-                      </a:pPr>
-                      <a:r>
-                        <a:rPr/>
-                        <a:t>898</a:t>
-                      </a:r>
-                    </a:p>
-                  </a:txBody>
-                </a:tc>
-                <a:tc>
-                  <a:txBody>
-                    <a:bodyPr/>
-                    <a:lstStyle/>
-                    <a:p>
-                      <a:pPr lvl="0" indent="0" marL="0">
-                        <a:buNone/>
-                      </a:pPr>
-                      <a:r>
-                        <a:rPr/>
-                        <a:t>sugarberry</a:t>
-                      </a:r>
-                    </a:p>
-                  </a:txBody>
-                </a:tc>
-                <a:tc>
-                  <a:txBody>
-                    <a:bodyPr/>
-                    <a:lstStyle/>
-                    <a:p>
-                      <a:pPr lvl="0" indent="0" marL="0">
-                        <a:buNone/>
-                      </a:pPr>
-                      <a:r>
-                        <a:rPr/>
-                        <a:t>9</a:t>
-                      </a:r>
-                    </a:p>
-                  </a:txBody>
-                </a:tc>
-                <a:tc>
-                  <a:txBody>
-                    <a:bodyPr/>
-                    <a:lstStyle/>
-                    <a:p>
-                      <a:pPr lvl="0" indent="0" marL="0">
-                        <a:buNone/>
-                      </a:pPr>
-                      <a:r>
-                        <a:rPr/>
-                        <a:t>36.853245</a:t>
-                      </a:r>
-                    </a:p>
-                  </a:txBody>
-                </a:tc>
-                <a:tc>
-                  <a:txBody>
-                    <a:bodyPr/>
-                    <a:lstStyle/>
-                    <a:p>
-                      <a:pPr lvl="0" indent="0" marL="0">
-                        <a:buNone/>
-                      </a:pPr>
-                      <a:r>
-                        <a:rPr/>
-                        <a:t>21.021667</a:t>
-                      </a:r>
-                    </a:p>
-                  </a:txBody>
-                </a:tc>
-                <a:tc>
-                  <a:txBody>
-                    <a:bodyPr/>
-                    <a:lstStyle/>
-                    <a:p>
-                      <a:pPr lvl="0" indent="0" marL="0">
-                        <a:buNone/>
-                      </a:pPr>
-                      <a:r>
-                        <a:rPr/>
-                        <a:t>0.685162</a:t>
-                      </a:r>
-                    </a:p>
-                  </a:txBody>
-                </a:tc>
-              </a:tr>
-              <a:tr h="0">
-                <a:tc>
-                  <a:txBody>
-                    <a:bodyPr/>
-                    <a:lstStyle/>
-                    <a:p>
-                      <a:pPr lvl="0" indent="0" marL="0">
-                        <a:buNone/>
-                      </a:pPr>
-                      <a:r>
-                        <a:rPr/>
-                        <a:t>899</a:t>
-                      </a:r>
-                    </a:p>
-                  </a:txBody>
-                </a:tc>
-                <a:tc>
-                  <a:txBody>
-                    <a:bodyPr/>
-                    <a:lstStyle/>
-                    <a:p>
-                      <a:pPr lvl="0" indent="0" marL="0">
-                        <a:buNone/>
-                      </a:pPr>
-                      <a:r>
-                        <a:rPr/>
-                        <a:t>sugarberry</a:t>
+                        <a:t>balsam fir</a:t>
                       </a:r>
                     </a:p>
                   </a:txBody>
@@ -4679,37 +4537,37 @@
                       </a:pPr>
                       <a:r>
                         <a:rPr/>
-                        <a:t>40.091106</a:t>
-                      </a:r>
-                    </a:p>
-                  </a:txBody>
-                </a:tc>
-                <a:tc>
-                  <a:txBody>
-                    <a:bodyPr/>
-                    <a:lstStyle/>
-                    <a:p>
-                      <a:pPr lvl="0" indent="0" marL="0">
-                        <a:buNone/>
-                      </a:pPr>
-                      <a:r>
-                        <a:rPr/>
-                        <a:t>23.172083</a:t>
-                      </a:r>
-                    </a:p>
-                  </a:txBody>
-                </a:tc>
-                <a:tc>
-                  <a:txBody>
-                    <a:bodyPr/>
-                    <a:lstStyle/>
-                    <a:p>
-                      <a:pPr lvl="0" indent="0" marL="0">
-                        <a:buNone/>
-                      </a:pPr>
-                      <a:r>
-                        <a:rPr/>
-                        <a:t>0.677519</a:t>
+                        <a:t>157.999921</a:t>
+                      </a:r>
+                    </a:p>
+                  </a:txBody>
+                </a:tc>
+                <a:tc>
+                  <a:txBody>
+                    <a:bodyPr/>
+                    <a:lstStyle/>
+                    <a:p>
+                      <a:pPr lvl="0" indent="0" marL="0">
+                        <a:buNone/>
+                      </a:pPr>
+                      <a:r>
+                        <a:rPr/>
+                        <a:t>44.694861</a:t>
+                      </a:r>
+                    </a:p>
+                  </a:txBody>
+                </a:tc>
+                <a:tc>
+                  <a:txBody>
+                    <a:bodyPr/>
+                    <a:lstStyle/>
+                    <a:p>
+                      <a:pPr lvl="0" indent="0" marL="0">
+                        <a:buNone/>
+                      </a:pPr>
+                      <a:r>
+                        <a:rPr/>
+                        <a:t>0.160057</a:t>
                       </a:r>
                     </a:p>
                   </a:txBody>
@@ -4751,12 +4609,7 @@
             <p:ph type="title"/>
           </p:nvPr>
         </p:nvSpPr>
-        <p:spPr>
-          <a:xfrm>
-            <a:off x="457201" y="204787"/>
-            <a:ext cx="3008313" cy="871538"/>
-          </a:xfrm>
-        </p:spPr>
+        <p:spPr/>
         <p:txBody>
           <a:bodyPr/>
           <a:lstStyle/>
@@ -4766,19 +4619,19 @@
             </a:pPr>
             <a:r>
               <a:rPr/>
-              <a:t>Technical Lead</a:t>
+              <a:t>Average Root Mean Square Logarithmic Error</a:t>
             </a:r>
           </a:p>
         </p:txBody>
       </p:sp>
       <p:sp>
         <p:nvSpPr>
-          <p:cNvPr id="4" name="Text Placeholder 3"/>
+          <p:cNvPr id="3" name="Content Placeholder 2"/>
           <p:cNvSpPr>
             <a:spLocks noGrp="1"/>
           </p:cNvSpPr>
           <p:nvPr>
-            <p:ph idx="2" sz="half" type="body"/>
+            <p:ph idx="1"/>
           </p:nvPr>
         </p:nvSpPr>
         <p:spPr/>
@@ -4786,527 +4639,27 @@
           <a:bodyPr/>
           <a:lstStyle/>
           <a:p>
-            <a:pPr lvl="0"/>
-            <a:r>
-              <a:rPr/>
-              <a:t>Split and filtering methods</a:t>
-            </a:r>
-          </a:p>
-          <a:p>
-            <a:pPr lvl="0"/>
-            <a:r>
-              <a:rPr/>
-              <a:t>Feature engineering (what worked and what didn’t)</a:t>
-            </a:r>
-          </a:p>
-          <a:p>
-            <a:pPr lvl="0"/>
-            <a:r>
-              <a:rPr/>
-              <a:t>Tuning k for the best model</a:t>
-            </a:r>
-          </a:p>
-          <a:p>
-            <a:pPr lvl="0"/>
-            <a:r>
-              <a:rPr/>
-              <a:t>The final “best” model and error # Tree Measurement Data:</a:t>
+            <a:pPr lvl="0" indent="0">
+              <a:buNone/>
+            </a:pPr>
+            <a:r>
+              <a:rPr>
+                <a:latin typeface="Courier"/>
+              </a:rPr>
+              <a:t>    k  Avg_RMSLE
+0   2   0.152783
+1   3   0.158068
+2   4   0.162118
+3   5   0.168001
+4   6   0.174249
+5   7   0.180282
+6   8   0.185071
+7   9   0.190148
+8  10   0.196831</a:t>
             </a:r>
           </a:p>
         </p:txBody>
       </p:sp>
-      <p:graphicFrame>
-        <p:nvGraphicFramePr>
-          <p:cNvPr id="6" name="Content Placeholder 5"/>
-          <p:cNvGraphicFramePr>
-            <a:graphicFrameLocks noGrp="1"/>
-          </p:cNvGraphicFramePr>
-          <p:nvPr>
-            <p:ph idx="1"/>
-          </p:nvPr>
-        </p:nvGraphicFramePr>
-        <p:xfrm>
-          <a:off x="3568700" y="203200"/>
-          <a:ext cx="5105400" cy="4381500"/>
-        </p:xfrm>
-        <a:graphic>
-          <a:graphicData uri="http://schemas.openxmlformats.org/drawingml/2006/table">
-            <a:tbl>
-              <a:tblPr firstRow="1" bandRow="1">
-                <a:tableStyleId>{5C22544A-7EE6-4342-B048-85BDC9FD1C3A}</a:tableStyleId>
-              </a:tblPr>
-              <a:tblGrid>
-                <a:gridCol w="1016000"/>
-                <a:gridCol w="1016000"/>
-                <a:gridCol w="1016000"/>
-                <a:gridCol w="1016000"/>
-                <a:gridCol w="1016000"/>
-              </a:tblGrid>
-              <a:tr h="0">
-                <a:tc>
-                  <a:txBody>
-                    <a:bodyPr/>
-                    <a:lstStyle/>
-                    <a:p>
-                      <a:endParaRPr/>
-                    </a:p>
-                  </a:txBody>
-                  <a:tcPr/>
-                </a:tc>
-                <a:tc>
-                  <a:txBody>
-                    <a:bodyPr/>
-                    <a:lstStyle/>
-                    <a:p>
-                      <a:pPr lvl="0" indent="0" marL="0">
-                        <a:buNone/>
-                      </a:pPr>
-                      <a:r>
-                        <a:rPr/>
-                        <a:t>SPCD</a:t>
-                      </a:r>
-                    </a:p>
-                  </a:txBody>
-                  <a:tcPr/>
-                </a:tc>
-                <a:tc>
-                  <a:txBody>
-                    <a:bodyPr/>
-                    <a:lstStyle/>
-                    <a:p>
-                      <a:pPr lvl="0" indent="0" marL="0">
-                        <a:buNone/>
-                      </a:pPr>
-                      <a:r>
-                        <a:rPr/>
-                        <a:t>DO_BH</a:t>
-                      </a:r>
-                    </a:p>
-                  </a:txBody>
-                  <a:tcPr/>
-                </a:tc>
-                <a:tc>
-                  <a:txBody>
-                    <a:bodyPr/>
-                    <a:lstStyle/>
-                    <a:p>
-                      <a:pPr lvl="0" indent="0" marL="0">
-                        <a:buNone/>
-                      </a:pPr>
-                      <a:r>
-                        <a:rPr/>
-                        <a:t>HT_TOT</a:t>
-                      </a:r>
-                    </a:p>
-                  </a:txBody>
-                  <a:tcPr/>
-                </a:tc>
-                <a:tc>
-                  <a:txBody>
-                    <a:bodyPr/>
-                    <a:lstStyle/>
-                    <a:p>
-                      <a:pPr lvl="0" indent="0" marL="0">
-                        <a:buNone/>
-                      </a:pPr>
-                      <a:r>
-                        <a:rPr/>
-                        <a:t>TT_DW_CRM</a:t>
-                      </a:r>
-                    </a:p>
-                  </a:txBody>
-                  <a:tcPr/>
-                </a:tc>
-              </a:tr>
-              <a:tr h="0">
-                <a:tc>
-                  <a:txBody>
-                    <a:bodyPr/>
-                    <a:lstStyle/>
-                    <a:p>
-                      <a:pPr lvl="0" indent="0" marL="0">
-                        <a:buNone/>
-                      </a:pPr>
-                      <a:r>
-                        <a:rPr/>
-                        <a:t>0</a:t>
-                      </a:r>
-                    </a:p>
-                  </a:txBody>
-                </a:tc>
-                <a:tc>
-                  <a:txBody>
-                    <a:bodyPr/>
-                    <a:lstStyle/>
-                    <a:p>
-                      <a:pPr lvl="0" indent="0" marL="0">
-                        <a:buNone/>
-                      </a:pPr>
-                      <a:r>
-                        <a:rPr/>
-                        <a:t>12</a:t>
-                      </a:r>
-                    </a:p>
-                  </a:txBody>
-                </a:tc>
-                <a:tc>
-                  <a:txBody>
-                    <a:bodyPr/>
-                    <a:lstStyle/>
-                    <a:p>
-                      <a:pPr lvl="0" indent="0" marL="0">
-                        <a:buNone/>
-                      </a:pPr>
-                      <a:r>
-                        <a:rPr/>
-                        <a:t>7.5</a:t>
-                      </a:r>
-                    </a:p>
-                  </a:txBody>
-                </a:tc>
-                <a:tc>
-                  <a:txBody>
-                    <a:bodyPr/>
-                    <a:lstStyle/>
-                    <a:p>
-                      <a:pPr lvl="0" indent="0" marL="0">
-                        <a:buNone/>
-                      </a:pPr>
-                      <a:r>
-                        <a:rPr/>
-                        <a:t>45.2</a:t>
-                      </a:r>
-                    </a:p>
-                  </a:txBody>
-                </a:tc>
-                <a:tc>
-                  <a:txBody>
-                    <a:bodyPr/>
-                    <a:lstStyle/>
-                    <a:p>
-                      <a:pPr lvl="0" indent="0" marL="0">
-                        <a:buNone/>
-                      </a:pPr>
-                      <a:r>
-                        <a:rPr/>
-                        <a:t>178.86</a:t>
-                      </a:r>
-                    </a:p>
-                  </a:txBody>
-                </a:tc>
-              </a:tr>
-              <a:tr h="0">
-                <a:tc>
-                  <a:txBody>
-                    <a:bodyPr/>
-                    <a:lstStyle/>
-                    <a:p>
-                      <a:pPr lvl="0" indent="0" marL="0">
-                        <a:buNone/>
-                      </a:pPr>
-                      <a:r>
-                        <a:rPr/>
-                        <a:t>1</a:t>
-                      </a:r>
-                    </a:p>
-                  </a:txBody>
-                </a:tc>
-                <a:tc>
-                  <a:txBody>
-                    <a:bodyPr/>
-                    <a:lstStyle/>
-                    <a:p>
-                      <a:pPr lvl="0" indent="0" marL="0">
-                        <a:buNone/>
-                      </a:pPr>
-                      <a:r>
-                        <a:rPr/>
-                        <a:t>12</a:t>
-                      </a:r>
-                    </a:p>
-                  </a:txBody>
-                </a:tc>
-                <a:tc>
-                  <a:txBody>
-                    <a:bodyPr/>
-                    <a:lstStyle/>
-                    <a:p>
-                      <a:pPr lvl="0" indent="0" marL="0">
-                        <a:buNone/>
-                      </a:pPr>
-                      <a:r>
-                        <a:rPr/>
-                        <a:t>9.3</a:t>
-                      </a:r>
-                    </a:p>
-                  </a:txBody>
-                </a:tc>
-                <a:tc>
-                  <a:txBody>
-                    <a:bodyPr/>
-                    <a:lstStyle/>
-                    <a:p>
-                      <a:pPr lvl="0" indent="0" marL="0">
-                        <a:buNone/>
-                      </a:pPr>
-                      <a:r>
-                        <a:rPr/>
-                        <a:t>62.7</a:t>
-                      </a:r>
-                    </a:p>
-                  </a:txBody>
-                </a:tc>
-                <a:tc>
-                  <a:txBody>
-                    <a:bodyPr/>
-                    <a:lstStyle/>
-                    <a:p>
-                      <a:pPr lvl="0" indent="0" marL="0">
-                        <a:buNone/>
-                      </a:pPr>
-                      <a:r>
-                        <a:rPr/>
-                        <a:t>323.46</a:t>
-                      </a:r>
-                    </a:p>
-                  </a:txBody>
-                </a:tc>
-              </a:tr>
-              <a:tr h="0">
-                <a:tc>
-                  <a:txBody>
-                    <a:bodyPr/>
-                    <a:lstStyle/>
-                    <a:p>
-                      <a:pPr lvl="0" indent="0" marL="0">
-                        <a:buNone/>
-                      </a:pPr>
-                      <a:r>
-                        <a:rPr/>
-                        <a:t>2</a:t>
-                      </a:r>
-                    </a:p>
-                  </a:txBody>
-                </a:tc>
-                <a:tc>
-                  <a:txBody>
-                    <a:bodyPr/>
-                    <a:lstStyle/>
-                    <a:p>
-                      <a:pPr lvl="0" indent="0" marL="0">
-                        <a:buNone/>
-                      </a:pPr>
-                      <a:r>
-                        <a:rPr/>
-                        <a:t>12</a:t>
-                      </a:r>
-                    </a:p>
-                  </a:txBody>
-                </a:tc>
-                <a:tc>
-                  <a:txBody>
-                    <a:bodyPr/>
-                    <a:lstStyle/>
-                    <a:p>
-                      <a:pPr lvl="0" indent="0" marL="0">
-                        <a:buNone/>
-                      </a:pPr>
-                      <a:r>
-                        <a:rPr/>
-                        <a:t>9.7</a:t>
-                      </a:r>
-                    </a:p>
-                  </a:txBody>
-                </a:tc>
-                <a:tc>
-                  <a:txBody>
-                    <a:bodyPr/>
-                    <a:lstStyle/>
-                    <a:p>
-                      <a:pPr lvl="0" indent="0" marL="0">
-                        <a:buNone/>
-                      </a:pPr>
-                      <a:r>
-                        <a:rPr/>
-                        <a:t>56.7</a:t>
-                      </a:r>
-                    </a:p>
-                  </a:txBody>
-                </a:tc>
-                <a:tc>
-                  <a:txBody>
-                    <a:bodyPr/>
-                    <a:lstStyle/>
-                    <a:p>
-                      <a:pPr lvl="0" indent="0" marL="0">
-                        <a:buNone/>
-                      </a:pPr>
-                      <a:r>
-                        <a:rPr/>
-                        <a:t>342.47</a:t>
-                      </a:r>
-                    </a:p>
-                  </a:txBody>
-                </a:tc>
-              </a:tr>
-              <a:tr h="0">
-                <a:tc>
-                  <a:txBody>
-                    <a:bodyPr/>
-                    <a:lstStyle/>
-                    <a:p>
-                      <a:pPr lvl="0" indent="0" marL="0">
-                        <a:buNone/>
-                      </a:pPr>
-                      <a:r>
-                        <a:rPr/>
-                        <a:t>3</a:t>
-                      </a:r>
-                    </a:p>
-                  </a:txBody>
-                </a:tc>
-                <a:tc>
-                  <a:txBody>
-                    <a:bodyPr/>
-                    <a:lstStyle/>
-                    <a:p>
-                      <a:pPr lvl="0" indent="0" marL="0">
-                        <a:buNone/>
-                      </a:pPr>
-                      <a:r>
-                        <a:rPr/>
-                        <a:t>12</a:t>
-                      </a:r>
-                    </a:p>
-                  </a:txBody>
-                </a:tc>
-                <a:tc>
-                  <a:txBody>
-                    <a:bodyPr/>
-                    <a:lstStyle/>
-                    <a:p>
-                      <a:pPr lvl="0" indent="0" marL="0">
-                        <a:buNone/>
-                      </a:pPr>
-                      <a:r>
-                        <a:rPr/>
-                        <a:t>11.4</a:t>
-                      </a:r>
-                    </a:p>
-                  </a:txBody>
-                </a:tc>
-                <a:tc>
-                  <a:txBody>
-                    <a:bodyPr/>
-                    <a:lstStyle/>
-                    <a:p>
-                      <a:pPr lvl="0" indent="0" marL="0">
-                        <a:buNone/>
-                      </a:pPr>
-                      <a:r>
-                        <a:rPr/>
-                        <a:t>66.1</a:t>
-                      </a:r>
-                    </a:p>
-                  </a:txBody>
-                </a:tc>
-                <a:tc>
-                  <a:txBody>
-                    <a:bodyPr/>
-                    <a:lstStyle/>
-                    <a:p>
-                      <a:pPr lvl="0" indent="0" marL="0">
-                        <a:buNone/>
-                      </a:pPr>
-                      <a:r>
-                        <a:rPr/>
-                        <a:t>499.35</a:t>
-                      </a:r>
-                    </a:p>
-                  </a:txBody>
-                </a:tc>
-              </a:tr>
-              <a:tr h="0">
-                <a:tc>
-                  <a:txBody>
-                    <a:bodyPr/>
-                    <a:lstStyle/>
-                    <a:p>
-                      <a:pPr lvl="0" indent="0" marL="0">
-                        <a:buNone/>
-                      </a:pPr>
-                      <a:r>
-                        <a:rPr/>
-                        <a:t>4</a:t>
-                      </a:r>
-                    </a:p>
-                  </a:txBody>
-                </a:tc>
-                <a:tc>
-                  <a:txBody>
-                    <a:bodyPr/>
-                    <a:lstStyle/>
-                    <a:p>
-                      <a:pPr lvl="0" indent="0" marL="0">
-                        <a:buNone/>
-                      </a:pPr>
-                      <a:r>
-                        <a:rPr/>
-                        <a:t>12</a:t>
-                      </a:r>
-                    </a:p>
-                  </a:txBody>
-                </a:tc>
-                <a:tc>
-                  <a:txBody>
-                    <a:bodyPr/>
-                    <a:lstStyle/>
-                    <a:p>
-                      <a:pPr lvl="0" indent="0" marL="0">
-                        <a:buNone/>
-                      </a:pPr>
-                      <a:r>
-                        <a:rPr/>
-                        <a:t>6.4</a:t>
-                      </a:r>
-                    </a:p>
-                  </a:txBody>
-                </a:tc>
-                <a:tc>
-                  <a:txBody>
-                    <a:bodyPr/>
-                    <a:lstStyle/>
-                    <a:p>
-                      <a:pPr lvl="0" indent="0" marL="0">
-                        <a:buNone/>
-                      </a:pPr>
-                      <a:r>
-                        <a:rPr/>
-                        <a:t>51.8</a:t>
-                      </a:r>
-                    </a:p>
-                  </a:txBody>
-                </a:tc>
-                <a:tc>
-                  <a:txBody>
-                    <a:bodyPr/>
-                    <a:lstStyle/>
-                    <a:p>
-                      <a:pPr lvl="0" indent="0" marL="0">
-                        <a:buNone/>
-                      </a:pPr>
-                      <a:r>
-                        <a:rPr/>
-                        <a:t>113.92</a:t>
-                      </a:r>
-                    </a:p>
-                  </a:txBody>
-                </a:tc>
-              </a:tr>
-            </a:tbl>
-          </a:graphicData>
-        </a:graphic>
-      </p:graphicFrame>
     </p:spTree>
   </p:cSld>
 </p:sld>
@@ -5349,319 +4702,62 @@
             </a:pPr>
             <a:r>
               <a:rPr/>
-              <a:t>Tree Species Name Data:</a:t>
+              <a:t>Technical Lead</a:t>
             </a:r>
           </a:p>
         </p:txBody>
       </p:sp>
-      <p:graphicFrame>
-        <p:nvGraphicFramePr>
-          <p:cNvPr id="6" name="Content Placeholder 5"/>
-          <p:cNvGraphicFramePr>
-            <a:graphicFrameLocks noGrp="1"/>
-          </p:cNvGraphicFramePr>
+      <p:sp>
+        <p:nvSpPr>
+          <p:cNvPr id="3" name="Content Placeholder 2"/>
+          <p:cNvSpPr>
+            <a:spLocks noGrp="1"/>
+          </p:cNvSpPr>
           <p:nvPr>
             <p:ph idx="1"/>
           </p:nvPr>
-        </p:nvGraphicFramePr>
-        <p:xfrm>
-          <a:off x="457200" y="1193800"/>
-          <a:ext cx="8229600" cy="3390900"/>
-        </p:xfrm>
-        <a:graphic>
-          <a:graphicData uri="http://schemas.openxmlformats.org/drawingml/2006/table">
-            <a:tbl>
-              <a:tblPr firstRow="1" bandRow="1">
-                <a:tableStyleId>{5C22544A-7EE6-4342-B048-85BDC9FD1C3A}</a:tableStyleId>
-              </a:tblPr>
-              <a:tblGrid>
-                <a:gridCol w="2743200"/>
-                <a:gridCol w="2743200"/>
-                <a:gridCol w="2743200"/>
-              </a:tblGrid>
-              <a:tr h="0">
-                <a:tc>
-                  <a:txBody>
-                    <a:bodyPr/>
-                    <a:lstStyle/>
-                    <a:p>
-                      <a:endParaRPr/>
-                    </a:p>
-                  </a:txBody>
-                  <a:tcPr/>
-                </a:tc>
-                <a:tc>
-                  <a:txBody>
-                    <a:bodyPr/>
-                    <a:lstStyle/>
-                    <a:p>
-                      <a:pPr lvl="0" indent="0" marL="0">
-                        <a:buNone/>
-                      </a:pPr>
-                      <a:r>
-                        <a:rPr/>
-                        <a:t>SPCD</a:t>
-                      </a:r>
-                    </a:p>
-                  </a:txBody>
-                  <a:tcPr/>
-                </a:tc>
-                <a:tc>
-                  <a:txBody>
-                    <a:bodyPr/>
-                    <a:lstStyle/>
-                    <a:p>
-                      <a:pPr lvl="0" indent="0" marL="0">
-                        <a:buNone/>
-                      </a:pPr>
-                      <a:r>
-                        <a:rPr/>
-                        <a:t>COMMON_NAME</a:t>
-                      </a:r>
-                    </a:p>
-                  </a:txBody>
-                  <a:tcPr/>
-                </a:tc>
-              </a:tr>
-              <a:tr h="0">
-                <a:tc>
-                  <a:txBody>
-                    <a:bodyPr/>
-                    <a:lstStyle/>
-                    <a:p>
-                      <a:pPr lvl="0" indent="0" marL="0">
-                        <a:buNone/>
-                      </a:pPr>
-                      <a:r>
-                        <a:rPr/>
-                        <a:t>0</a:t>
-                      </a:r>
-                    </a:p>
-                  </a:txBody>
-                </a:tc>
-                <a:tc>
-                  <a:txBody>
-                    <a:bodyPr/>
-                    <a:lstStyle/>
-                    <a:p>
-                      <a:pPr lvl="0" indent="0" marL="0">
-                        <a:buNone/>
-                      </a:pPr>
-                      <a:r>
-                        <a:rPr/>
-                        <a:t>10</a:t>
-                      </a:r>
-                    </a:p>
-                  </a:txBody>
-                </a:tc>
-                <a:tc>
-                  <a:txBody>
-                    <a:bodyPr/>
-                    <a:lstStyle/>
-                    <a:p>
-                      <a:pPr lvl="0" indent="0" marL="0">
-                        <a:buNone/>
-                      </a:pPr>
-                      <a:r>
-                        <a:rPr/>
-                        <a:t>fir spp.</a:t>
-                      </a:r>
-                    </a:p>
-                  </a:txBody>
-                </a:tc>
-              </a:tr>
-              <a:tr h="0">
-                <a:tc>
-                  <a:txBody>
-                    <a:bodyPr/>
-                    <a:lstStyle/>
-                    <a:p>
-                      <a:pPr lvl="0" indent="0" marL="0">
-                        <a:buNone/>
-                      </a:pPr>
-                      <a:r>
-                        <a:rPr/>
-                        <a:t>1</a:t>
-                      </a:r>
-                    </a:p>
-                  </a:txBody>
-                </a:tc>
-                <a:tc>
-                  <a:txBody>
-                    <a:bodyPr/>
-                    <a:lstStyle/>
-                    <a:p>
-                      <a:pPr lvl="0" indent="0" marL="0">
-                        <a:buNone/>
-                      </a:pPr>
-                      <a:r>
-                        <a:rPr/>
-                        <a:t>11</a:t>
-                      </a:r>
-                    </a:p>
-                  </a:txBody>
-                </a:tc>
-                <a:tc>
-                  <a:txBody>
-                    <a:bodyPr/>
-                    <a:lstStyle/>
-                    <a:p>
-                      <a:pPr lvl="0" indent="0" marL="0">
-                        <a:buNone/>
-                      </a:pPr>
-                      <a:r>
-                        <a:rPr/>
-                        <a:t>Pacific silver fir</a:t>
-                      </a:r>
-                    </a:p>
-                  </a:txBody>
-                </a:tc>
-              </a:tr>
-              <a:tr h="0">
-                <a:tc>
-                  <a:txBody>
-                    <a:bodyPr/>
-                    <a:lstStyle/>
-                    <a:p>
-                      <a:pPr lvl="0" indent="0" marL="0">
-                        <a:buNone/>
-                      </a:pPr>
-                      <a:r>
-                        <a:rPr/>
-                        <a:t>2</a:t>
-                      </a:r>
-                    </a:p>
-                  </a:txBody>
-                </a:tc>
-                <a:tc>
-                  <a:txBody>
-                    <a:bodyPr/>
-                    <a:lstStyle/>
-                    <a:p>
-                      <a:pPr lvl="0" indent="0" marL="0">
-                        <a:buNone/>
-                      </a:pPr>
-                      <a:r>
-                        <a:rPr/>
-                        <a:t>12</a:t>
-                      </a:r>
-                    </a:p>
-                  </a:txBody>
-                </a:tc>
-                <a:tc>
-                  <a:txBody>
-                    <a:bodyPr/>
-                    <a:lstStyle/>
-                    <a:p>
-                      <a:pPr lvl="0" indent="0" marL="0">
-                        <a:buNone/>
-                      </a:pPr>
-                      <a:r>
-                        <a:rPr/>
-                        <a:t>balsam fir</a:t>
-                      </a:r>
-                    </a:p>
-                  </a:txBody>
-                </a:tc>
-              </a:tr>
-              <a:tr h="0">
-                <a:tc>
-                  <a:txBody>
-                    <a:bodyPr/>
-                    <a:lstStyle/>
-                    <a:p>
-                      <a:pPr lvl="0" indent="0" marL="0">
-                        <a:buNone/>
-                      </a:pPr>
-                      <a:r>
-                        <a:rPr/>
-                        <a:t>3</a:t>
-                      </a:r>
-                    </a:p>
-                  </a:txBody>
-                </a:tc>
-                <a:tc>
-                  <a:txBody>
-                    <a:bodyPr/>
-                    <a:lstStyle/>
-                    <a:p>
-                      <a:pPr lvl="0" indent="0" marL="0">
-                        <a:buNone/>
-                      </a:pPr>
-                      <a:r>
-                        <a:rPr/>
-                        <a:t>14</a:t>
-                      </a:r>
-                    </a:p>
-                  </a:txBody>
-                </a:tc>
-                <a:tc>
-                  <a:txBody>
-                    <a:bodyPr/>
-                    <a:lstStyle/>
-                    <a:p>
-                      <a:pPr lvl="0" indent="0" marL="0">
-                        <a:buNone/>
-                      </a:pPr>
-                      <a:r>
-                        <a:rPr/>
-                        <a:t>Santa Lucia or bristlecone fir</a:t>
-                      </a:r>
-                    </a:p>
-                  </a:txBody>
-                </a:tc>
-              </a:tr>
-              <a:tr h="0">
-                <a:tc>
-                  <a:txBody>
-                    <a:bodyPr/>
-                    <a:lstStyle/>
-                    <a:p>
-                      <a:pPr lvl="0" indent="0" marL="0">
-                        <a:buNone/>
-                      </a:pPr>
-                      <a:r>
-                        <a:rPr/>
-                        <a:t>4</a:t>
-                      </a:r>
-                    </a:p>
-                  </a:txBody>
-                </a:tc>
-                <a:tc>
-                  <a:txBody>
-                    <a:bodyPr/>
-                    <a:lstStyle/>
-                    <a:p>
-                      <a:pPr lvl="0" indent="0" marL="0">
-                        <a:buNone/>
-                      </a:pPr>
-                      <a:r>
-                        <a:rPr/>
-                        <a:t>15</a:t>
-                      </a:r>
-                    </a:p>
-                  </a:txBody>
-                </a:tc>
-                <a:tc>
-                  <a:txBody>
-                    <a:bodyPr/>
-                    <a:lstStyle/>
-                    <a:p>
-                      <a:pPr lvl="0" indent="0" marL="0">
-                        <a:buNone/>
-                      </a:pPr>
-                      <a:r>
-                        <a:rPr/>
-                        <a:t>white fir</a:t>
-                      </a:r>
-                    </a:p>
-                  </a:txBody>
-                </a:tc>
-              </a:tr>
-            </a:tbl>
-          </a:graphicData>
-        </a:graphic>
-      </p:graphicFrame>
+        </p:nvSpPr>
+        <p:spPr/>
+        <p:txBody>
+          <a:bodyPr/>
+          <a:lstStyle/>
+          <a:p>
+            <a:pPr lvl="0"/>
+            <a:r>
+              <a:rPr/>
+              <a:t>Overview of data manipulation</a:t>
+            </a:r>
+          </a:p>
+          <a:p>
+            <a:pPr lvl="0"/>
+            <a:r>
+              <a:rPr/>
+              <a:t>Split and filtering methods</a:t>
+            </a:r>
+          </a:p>
+          <a:p>
+            <a:pPr lvl="0"/>
+            <a:r>
+              <a:rPr/>
+              <a:t>Feature engineering (what worked and what didn’t)</a:t>
+            </a:r>
+          </a:p>
+          <a:p>
+            <a:pPr lvl="0"/>
+            <a:r>
+              <a:rPr/>
+              <a:t>Tuning k for the best model</a:t>
+            </a:r>
+          </a:p>
+          <a:p>
+            <a:pPr lvl="0"/>
+            <a:r>
+              <a:rPr/>
+              <a:t>The final “best” model and error</a:t>
+            </a:r>
+          </a:p>
+        </p:txBody>
+      </p:sp>
     </p:spTree>
   </p:cSld>
 </p:sld>
@@ -5704,7 +4800,7 @@
             </a:pPr>
             <a:r>
               <a:rPr/>
-              <a:t>Combined Dataset (species mapped onto bigger dataset):</a:t>
+              <a:t>Tree Measurement Data:</a:t>
             </a:r>
           </a:p>
         </p:txBody>
@@ -5730,12 +4826,11 @@
                 <a:tableStyleId>{5C22544A-7EE6-4342-B048-85BDC9FD1C3A}</a:tableStyleId>
               </a:tblPr>
               <a:tblGrid>
-                <a:gridCol w="1371600"/>
-                <a:gridCol w="1371600"/>
-                <a:gridCol w="1371600"/>
-                <a:gridCol w="1371600"/>
-                <a:gridCol w="1371600"/>
-                <a:gridCol w="1371600"/>
+                <a:gridCol w="1638300"/>
+                <a:gridCol w="1638300"/>
+                <a:gridCol w="1638300"/>
+                <a:gridCol w="1638300"/>
+                <a:gridCol w="1638300"/>
               </a:tblGrid>
               <a:tr h="0">
                 <a:tc>
@@ -5812,22 +4907,6 @@
                   </a:txBody>
                   <a:tcPr/>
                 </a:tc>
-                <a:tc>
-                  <a:txBody>
-                    <a:bodyPr/>
-                    <a:lstStyle/>
-                    <a:p>
-                      <a:pPr lvl="0" indent="0" marL="0">
-                        <a:buNone/>
-                      </a:pPr>
-                      <a:r>
-                        <a:rPr/>
-                        <a:t>COMMON_NAME</a:t>
-                      </a:r>
-                    </a:p>
-                  </a:txBody>
-                  <a:tcPr/>
-                </a:tc>
               </a:tr>
               <a:tr h="0">
                 <a:tc>
@@ -5905,21 +4984,6 @@
                     </a:p>
                   </a:txBody>
                 </a:tc>
-                <a:tc>
-                  <a:txBody>
-                    <a:bodyPr/>
-                    <a:lstStyle/>
-                    <a:p>
-                      <a:pPr lvl="0" indent="0" marL="0">
-                        <a:buNone/>
-                      </a:pPr>
-                      <a:r>
-                        <a:rPr/>
-                        <a:t>balsam fir</a:t>
-                      </a:r>
-                    </a:p>
-                  </a:txBody>
-                </a:tc>
               </a:tr>
               <a:tr h="0">
                 <a:tc>
@@ -5997,21 +5061,6 @@
                     </a:p>
                   </a:txBody>
                 </a:tc>
-                <a:tc>
-                  <a:txBody>
-                    <a:bodyPr/>
-                    <a:lstStyle/>
-                    <a:p>
-                      <a:pPr lvl="0" indent="0" marL="0">
-                        <a:buNone/>
-                      </a:pPr>
-                      <a:r>
-                        <a:rPr/>
-                        <a:t>balsam fir</a:t>
-                      </a:r>
-                    </a:p>
-                  </a:txBody>
-                </a:tc>
               </a:tr>
               <a:tr h="0">
                 <a:tc>
@@ -6089,21 +5138,6 @@
                     </a:p>
                   </a:txBody>
                 </a:tc>
-                <a:tc>
-                  <a:txBody>
-                    <a:bodyPr/>
-                    <a:lstStyle/>
-                    <a:p>
-                      <a:pPr lvl="0" indent="0" marL="0">
-                        <a:buNone/>
-                      </a:pPr>
-                      <a:r>
-                        <a:rPr/>
-                        <a:t>balsam fir</a:t>
-                      </a:r>
-                    </a:p>
-                  </a:txBody>
-                </a:tc>
               </a:tr>
               <a:tr h="0">
                 <a:tc>
@@ -6181,21 +5215,6 @@
                     </a:p>
                   </a:txBody>
                 </a:tc>
-                <a:tc>
-                  <a:txBody>
-                    <a:bodyPr/>
-                    <a:lstStyle/>
-                    <a:p>
-                      <a:pPr lvl="0" indent="0" marL="0">
-                        <a:buNone/>
-                      </a:pPr>
-                      <a:r>
-                        <a:rPr/>
-                        <a:t>balsam fir</a:t>
-                      </a:r>
-                    </a:p>
-                  </a:txBody>
-                </a:tc>
               </a:tr>
               <a:tr h="0">
                 <a:tc>
@@ -6269,21 +5288,6 @@
                       <a:r>
                         <a:rPr/>
                         <a:t>113.92</a:t>
-                      </a:r>
-                    </a:p>
-                  </a:txBody>
-                </a:tc>
-                <a:tc>
-                  <a:txBody>
-                    <a:bodyPr/>
-                    <a:lstStyle/>
-                    <a:p>
-                      <a:pPr lvl="0" indent="0" marL="0">
-                        <a:buNone/>
-                      </a:pPr>
-                      <a:r>
-                        <a:rPr/>
-                        <a:t>balsam fir</a:t>
                       </a:r>
                     </a:p>
                   </a:txBody>
@@ -6335,7 +5339,7 @@
             </a:pPr>
             <a:r>
               <a:rPr/>
-              <a:t>Filtered data</a:t>
+              <a:t>Tree Species Name Data:</a:t>
             </a:r>
           </a:p>
         </p:txBody>
@@ -6361,12 +5365,9 @@
                 <a:tableStyleId>{5C22544A-7EE6-4342-B048-85BDC9FD1C3A}</a:tableStyleId>
               </a:tblPr>
               <a:tblGrid>
-                <a:gridCol w="1371600"/>
-                <a:gridCol w="1371600"/>
-                <a:gridCol w="1371600"/>
-                <a:gridCol w="1371600"/>
-                <a:gridCol w="1371600"/>
-                <a:gridCol w="1371600"/>
+                <a:gridCol w="2743200"/>
+                <a:gridCol w="2743200"/>
+                <a:gridCol w="2743200"/>
               </a:tblGrid>
               <a:tr h="0">
                 <a:tc>
@@ -6405,54 +5406,6 @@
                       </a:pPr>
                       <a:r>
                         <a:rPr/>
-                        <a:t>DO_BH</a:t>
-                      </a:r>
-                    </a:p>
-                  </a:txBody>
-                  <a:tcPr/>
-                </a:tc>
-                <a:tc>
-                  <a:txBody>
-                    <a:bodyPr/>
-                    <a:lstStyle/>
-                    <a:p>
-                      <a:pPr lvl="0" indent="0" marL="0">
-                        <a:buNone/>
-                      </a:pPr>
-                      <a:r>
-                        <a:rPr/>
-                        <a:t>HT_TOT</a:t>
-                      </a:r>
-                    </a:p>
-                  </a:txBody>
-                  <a:tcPr/>
-                </a:tc>
-                <a:tc>
-                  <a:txBody>
-                    <a:bodyPr/>
-                    <a:lstStyle/>
-                    <a:p>
-                      <a:pPr lvl="0" indent="0" marL="0">
-                        <a:buNone/>
-                      </a:pPr>
-                      <a:r>
-                        <a:rPr/>
-                        <a:t>TT_DW_CRM</a:t>
-                      </a:r>
-                    </a:p>
-                  </a:txBody>
-                  <a:tcPr/>
-                </a:tc>
-                <a:tc>
-                  <a:txBody>
-                    <a:bodyPr/>
-                    <a:lstStyle/>
-                    <a:p>
-                      <a:pPr lvl="0" indent="0" marL="0">
-                        <a:buNone/>
-                      </a:pPr>
-                      <a:r>
-                        <a:rPr/>
                         <a:t>COMMON_NAME</a:t>
                       </a:r>
                     </a:p>
@@ -6486,67 +5439,22 @@
                       </a:pPr>
                       <a:r>
                         <a:rPr/>
-                        <a:t>12</a:t>
-                      </a:r>
-                    </a:p>
-                  </a:txBody>
-                </a:tc>
-                <a:tc>
-                  <a:txBody>
-                    <a:bodyPr/>
-                    <a:lstStyle/>
-                    <a:p>
-                      <a:pPr lvl="0" indent="0" marL="0">
-                        <a:buNone/>
-                      </a:pPr>
-                      <a:r>
-                        <a:rPr/>
-                        <a:t>7.5</a:t>
-                      </a:r>
-                    </a:p>
-                  </a:txBody>
-                </a:tc>
-                <a:tc>
-                  <a:txBody>
-                    <a:bodyPr/>
-                    <a:lstStyle/>
-                    <a:p>
-                      <a:pPr lvl="0" indent="0" marL="0">
-                        <a:buNone/>
-                      </a:pPr>
-                      <a:r>
-                        <a:rPr/>
-                        <a:t>45.2</a:t>
-                      </a:r>
-                    </a:p>
-                  </a:txBody>
-                </a:tc>
-                <a:tc>
-                  <a:txBody>
-                    <a:bodyPr/>
-                    <a:lstStyle/>
-                    <a:p>
-                      <a:pPr lvl="0" indent="0" marL="0">
-                        <a:buNone/>
-                      </a:pPr>
-                      <a:r>
-                        <a:rPr/>
-                        <a:t>178.86</a:t>
-                      </a:r>
-                    </a:p>
-                  </a:txBody>
-                </a:tc>
-                <a:tc>
-                  <a:txBody>
-                    <a:bodyPr/>
-                    <a:lstStyle/>
-                    <a:p>
-                      <a:pPr lvl="0" indent="0" marL="0">
-                        <a:buNone/>
-                      </a:pPr>
-                      <a:r>
-                        <a:rPr/>
-                        <a:t>balsam fir</a:t>
+                        <a:t>10</a:t>
+                      </a:r>
+                    </a:p>
+                  </a:txBody>
+                </a:tc>
+                <a:tc>
+                  <a:txBody>
+                    <a:bodyPr/>
+                    <a:lstStyle/>
+                    <a:p>
+                      <a:pPr lvl="0" indent="0" marL="0">
+                        <a:buNone/>
+                      </a:pPr>
+                      <a:r>
+                        <a:rPr/>
+                        <a:t>fir spp.</a:t>
                       </a:r>
                     </a:p>
                   </a:txBody>
@@ -6578,67 +5486,22 @@
                       </a:pPr>
                       <a:r>
                         <a:rPr/>
-                        <a:t>12</a:t>
-                      </a:r>
-                    </a:p>
-                  </a:txBody>
-                </a:tc>
-                <a:tc>
-                  <a:txBody>
-                    <a:bodyPr/>
-                    <a:lstStyle/>
-                    <a:p>
-                      <a:pPr lvl="0" indent="0" marL="0">
-                        <a:buNone/>
-                      </a:pPr>
-                      <a:r>
-                        <a:rPr/>
-                        <a:t>9.3</a:t>
-                      </a:r>
-                    </a:p>
-                  </a:txBody>
-                </a:tc>
-                <a:tc>
-                  <a:txBody>
-                    <a:bodyPr/>
-                    <a:lstStyle/>
-                    <a:p>
-                      <a:pPr lvl="0" indent="0" marL="0">
-                        <a:buNone/>
-                      </a:pPr>
-                      <a:r>
-                        <a:rPr/>
-                        <a:t>62.7</a:t>
-                      </a:r>
-                    </a:p>
-                  </a:txBody>
-                </a:tc>
-                <a:tc>
-                  <a:txBody>
-                    <a:bodyPr/>
-                    <a:lstStyle/>
-                    <a:p>
-                      <a:pPr lvl="0" indent="0" marL="0">
-                        <a:buNone/>
-                      </a:pPr>
-                      <a:r>
-                        <a:rPr/>
-                        <a:t>323.46</a:t>
-                      </a:r>
-                    </a:p>
-                  </a:txBody>
-                </a:tc>
-                <a:tc>
-                  <a:txBody>
-                    <a:bodyPr/>
-                    <a:lstStyle/>
-                    <a:p>
-                      <a:pPr lvl="0" indent="0" marL="0">
-                        <a:buNone/>
-                      </a:pPr>
-                      <a:r>
-                        <a:rPr/>
-                        <a:t>balsam fir</a:t>
+                        <a:t>11</a:t>
+                      </a:r>
+                    </a:p>
+                  </a:txBody>
+                </a:tc>
+                <a:tc>
+                  <a:txBody>
+                    <a:bodyPr/>
+                    <a:lstStyle/>
+                    <a:p>
+                      <a:pPr lvl="0" indent="0" marL="0">
+                        <a:buNone/>
+                      </a:pPr>
+                      <a:r>
+                        <a:rPr/>
+                        <a:t>Pacific silver fir</a:t>
                       </a:r>
                     </a:p>
                   </a:txBody>
@@ -6685,51 +5548,6 @@
                       </a:pPr>
                       <a:r>
                         <a:rPr/>
-                        <a:t>9.7</a:t>
-                      </a:r>
-                    </a:p>
-                  </a:txBody>
-                </a:tc>
-                <a:tc>
-                  <a:txBody>
-                    <a:bodyPr/>
-                    <a:lstStyle/>
-                    <a:p>
-                      <a:pPr lvl="0" indent="0" marL="0">
-                        <a:buNone/>
-                      </a:pPr>
-                      <a:r>
-                        <a:rPr/>
-                        <a:t>56.7</a:t>
-                      </a:r>
-                    </a:p>
-                  </a:txBody>
-                </a:tc>
-                <a:tc>
-                  <a:txBody>
-                    <a:bodyPr/>
-                    <a:lstStyle/>
-                    <a:p>
-                      <a:pPr lvl="0" indent="0" marL="0">
-                        <a:buNone/>
-                      </a:pPr>
-                      <a:r>
-                        <a:rPr/>
-                        <a:t>342.47</a:t>
-                      </a:r>
-                    </a:p>
-                  </a:txBody>
-                </a:tc>
-                <a:tc>
-                  <a:txBody>
-                    <a:bodyPr/>
-                    <a:lstStyle/>
-                    <a:p>
-                      <a:pPr lvl="0" indent="0" marL="0">
-                        <a:buNone/>
-                      </a:pPr>
-                      <a:r>
-                        <a:rPr/>
                         <a:t>balsam fir</a:t>
                       </a:r>
                     </a:p>
@@ -6762,67 +5580,22 @@
                       </a:pPr>
                       <a:r>
                         <a:rPr/>
-                        <a:t>12</a:t>
-                      </a:r>
-                    </a:p>
-                  </a:txBody>
-                </a:tc>
-                <a:tc>
-                  <a:txBody>
-                    <a:bodyPr/>
-                    <a:lstStyle/>
-                    <a:p>
-                      <a:pPr lvl="0" indent="0" marL="0">
-                        <a:buNone/>
-                      </a:pPr>
-                      <a:r>
-                        <a:rPr/>
-                        <a:t>11.4</a:t>
-                      </a:r>
-                    </a:p>
-                  </a:txBody>
-                </a:tc>
-                <a:tc>
-                  <a:txBody>
-                    <a:bodyPr/>
-                    <a:lstStyle/>
-                    <a:p>
-                      <a:pPr lvl="0" indent="0" marL="0">
-                        <a:buNone/>
-                      </a:pPr>
-                      <a:r>
-                        <a:rPr/>
-                        <a:t>66.1</a:t>
-                      </a:r>
-                    </a:p>
-                  </a:txBody>
-                </a:tc>
-                <a:tc>
-                  <a:txBody>
-                    <a:bodyPr/>
-                    <a:lstStyle/>
-                    <a:p>
-                      <a:pPr lvl="0" indent="0" marL="0">
-                        <a:buNone/>
-                      </a:pPr>
-                      <a:r>
-                        <a:rPr/>
-                        <a:t>499.35</a:t>
-                      </a:r>
-                    </a:p>
-                  </a:txBody>
-                </a:tc>
-                <a:tc>
-                  <a:txBody>
-                    <a:bodyPr/>
-                    <a:lstStyle/>
-                    <a:p>
-                      <a:pPr lvl="0" indent="0" marL="0">
-                        <a:buNone/>
-                      </a:pPr>
-                      <a:r>
-                        <a:rPr/>
-                        <a:t>balsam fir</a:t>
+                        <a:t>14</a:t>
+                      </a:r>
+                    </a:p>
+                  </a:txBody>
+                </a:tc>
+                <a:tc>
+                  <a:txBody>
+                    <a:bodyPr/>
+                    <a:lstStyle/>
+                    <a:p>
+                      <a:pPr lvl="0" indent="0" marL="0">
+                        <a:buNone/>
+                      </a:pPr>
+                      <a:r>
+                        <a:rPr/>
+                        <a:t>Santa Lucia or bristlecone fir</a:t>
                       </a:r>
                     </a:p>
                   </a:txBody>
@@ -6854,67 +5627,22 @@
                       </a:pPr>
                       <a:r>
                         <a:rPr/>
-                        <a:t>12</a:t>
-                      </a:r>
-                    </a:p>
-                  </a:txBody>
-                </a:tc>
-                <a:tc>
-                  <a:txBody>
-                    <a:bodyPr/>
-                    <a:lstStyle/>
-                    <a:p>
-                      <a:pPr lvl="0" indent="0" marL="0">
-                        <a:buNone/>
-                      </a:pPr>
-                      <a:r>
-                        <a:rPr/>
-                        <a:t>6.4</a:t>
-                      </a:r>
-                    </a:p>
-                  </a:txBody>
-                </a:tc>
-                <a:tc>
-                  <a:txBody>
-                    <a:bodyPr/>
-                    <a:lstStyle/>
-                    <a:p>
-                      <a:pPr lvl="0" indent="0" marL="0">
-                        <a:buNone/>
-                      </a:pPr>
-                      <a:r>
-                        <a:rPr/>
-                        <a:t>51.8</a:t>
-                      </a:r>
-                    </a:p>
-                  </a:txBody>
-                </a:tc>
-                <a:tc>
-                  <a:txBody>
-                    <a:bodyPr/>
-                    <a:lstStyle/>
-                    <a:p>
-                      <a:pPr lvl="0" indent="0" marL="0">
-                        <a:buNone/>
-                      </a:pPr>
-                      <a:r>
-                        <a:rPr/>
-                        <a:t>113.92</a:t>
-                      </a:r>
-                    </a:p>
-                  </a:txBody>
-                </a:tc>
-                <a:tc>
-                  <a:txBody>
-                    <a:bodyPr/>
-                    <a:lstStyle/>
-                    <a:p>
-                      <a:pPr lvl="0" indent="0" marL="0">
-                        <a:buNone/>
-                      </a:pPr>
-                      <a:r>
-                        <a:rPr/>
-                        <a:t>balsam fir</a:t>
+                        <a:t>15</a:t>
+                      </a:r>
+                    </a:p>
+                  </a:txBody>
+                </a:tc>
+                <a:tc>
+                  <a:txBody>
+                    <a:bodyPr/>
+                    <a:lstStyle/>
+                    <a:p>
+                      <a:pPr lvl="0" indent="0" marL="0">
+                        <a:buNone/>
+                      </a:pPr>
+                      <a:r>
+                        <a:rPr/>
+                        <a:t>white fir</a:t>
                       </a:r>
                     </a:p>
                   </a:txBody>
@@ -6966,11 +5694,595 @@
             </a:pPr>
             <a:r>
               <a:rPr/>
-              <a:t>Quality Assurance</a:t>
+              <a:t>Combined Dataset (species mapped onto bigger dataset):</a:t>
             </a:r>
           </a:p>
         </p:txBody>
       </p:sp>
+      <p:graphicFrame>
+        <p:nvGraphicFramePr>
+          <p:cNvPr id="6" name="Content Placeholder 5"/>
+          <p:cNvGraphicFramePr>
+            <a:graphicFrameLocks noGrp="1"/>
+          </p:cNvGraphicFramePr>
+          <p:nvPr>
+            <p:ph idx="1"/>
+          </p:nvPr>
+        </p:nvGraphicFramePr>
+        <p:xfrm>
+          <a:off x="457200" y="1193800"/>
+          <a:ext cx="8229600" cy="3390900"/>
+        </p:xfrm>
+        <a:graphic>
+          <a:graphicData uri="http://schemas.openxmlformats.org/drawingml/2006/table">
+            <a:tbl>
+              <a:tblPr firstRow="1" bandRow="1">
+                <a:tableStyleId>{5C22544A-7EE6-4342-B048-85BDC9FD1C3A}</a:tableStyleId>
+              </a:tblPr>
+              <a:tblGrid>
+                <a:gridCol w="1371600"/>
+                <a:gridCol w="1371600"/>
+                <a:gridCol w="1371600"/>
+                <a:gridCol w="1371600"/>
+                <a:gridCol w="1371600"/>
+                <a:gridCol w="1371600"/>
+              </a:tblGrid>
+              <a:tr h="0">
+                <a:tc>
+                  <a:txBody>
+                    <a:bodyPr/>
+                    <a:lstStyle/>
+                    <a:p>
+                      <a:endParaRPr/>
+                    </a:p>
+                  </a:txBody>
+                  <a:tcPr/>
+                </a:tc>
+                <a:tc>
+                  <a:txBody>
+                    <a:bodyPr/>
+                    <a:lstStyle/>
+                    <a:p>
+                      <a:pPr lvl="0" indent="0" marL="0">
+                        <a:buNone/>
+                      </a:pPr>
+                      <a:r>
+                        <a:rPr/>
+                        <a:t>SPCD</a:t>
+                      </a:r>
+                    </a:p>
+                  </a:txBody>
+                  <a:tcPr/>
+                </a:tc>
+                <a:tc>
+                  <a:txBody>
+                    <a:bodyPr/>
+                    <a:lstStyle/>
+                    <a:p>
+                      <a:pPr lvl="0" indent="0" marL="0">
+                        <a:buNone/>
+                      </a:pPr>
+                      <a:r>
+                        <a:rPr/>
+                        <a:t>DO_BH</a:t>
+                      </a:r>
+                    </a:p>
+                  </a:txBody>
+                  <a:tcPr/>
+                </a:tc>
+                <a:tc>
+                  <a:txBody>
+                    <a:bodyPr/>
+                    <a:lstStyle/>
+                    <a:p>
+                      <a:pPr lvl="0" indent="0" marL="0">
+                        <a:buNone/>
+                      </a:pPr>
+                      <a:r>
+                        <a:rPr/>
+                        <a:t>HT_TOT</a:t>
+                      </a:r>
+                    </a:p>
+                  </a:txBody>
+                  <a:tcPr/>
+                </a:tc>
+                <a:tc>
+                  <a:txBody>
+                    <a:bodyPr/>
+                    <a:lstStyle/>
+                    <a:p>
+                      <a:pPr lvl="0" indent="0" marL="0">
+                        <a:buNone/>
+                      </a:pPr>
+                      <a:r>
+                        <a:rPr/>
+                        <a:t>TT_DW_CRM</a:t>
+                      </a:r>
+                    </a:p>
+                  </a:txBody>
+                  <a:tcPr/>
+                </a:tc>
+                <a:tc>
+                  <a:txBody>
+                    <a:bodyPr/>
+                    <a:lstStyle/>
+                    <a:p>
+                      <a:pPr lvl="0" indent="0" marL="0">
+                        <a:buNone/>
+                      </a:pPr>
+                      <a:r>
+                        <a:rPr/>
+                        <a:t>COMMON_NAME</a:t>
+                      </a:r>
+                    </a:p>
+                  </a:txBody>
+                  <a:tcPr/>
+                </a:tc>
+              </a:tr>
+              <a:tr h="0">
+                <a:tc>
+                  <a:txBody>
+                    <a:bodyPr/>
+                    <a:lstStyle/>
+                    <a:p>
+                      <a:pPr lvl="0" indent="0" marL="0">
+                        <a:buNone/>
+                      </a:pPr>
+                      <a:r>
+                        <a:rPr/>
+                        <a:t>0</a:t>
+                      </a:r>
+                    </a:p>
+                  </a:txBody>
+                </a:tc>
+                <a:tc>
+                  <a:txBody>
+                    <a:bodyPr/>
+                    <a:lstStyle/>
+                    <a:p>
+                      <a:pPr lvl="0" indent="0" marL="0">
+                        <a:buNone/>
+                      </a:pPr>
+                      <a:r>
+                        <a:rPr/>
+                        <a:t>12</a:t>
+                      </a:r>
+                    </a:p>
+                  </a:txBody>
+                </a:tc>
+                <a:tc>
+                  <a:txBody>
+                    <a:bodyPr/>
+                    <a:lstStyle/>
+                    <a:p>
+                      <a:pPr lvl="0" indent="0" marL="0">
+                        <a:buNone/>
+                      </a:pPr>
+                      <a:r>
+                        <a:rPr/>
+                        <a:t>7.5</a:t>
+                      </a:r>
+                    </a:p>
+                  </a:txBody>
+                </a:tc>
+                <a:tc>
+                  <a:txBody>
+                    <a:bodyPr/>
+                    <a:lstStyle/>
+                    <a:p>
+                      <a:pPr lvl="0" indent="0" marL="0">
+                        <a:buNone/>
+                      </a:pPr>
+                      <a:r>
+                        <a:rPr/>
+                        <a:t>45.2</a:t>
+                      </a:r>
+                    </a:p>
+                  </a:txBody>
+                </a:tc>
+                <a:tc>
+                  <a:txBody>
+                    <a:bodyPr/>
+                    <a:lstStyle/>
+                    <a:p>
+                      <a:pPr lvl="0" indent="0" marL="0">
+                        <a:buNone/>
+                      </a:pPr>
+                      <a:r>
+                        <a:rPr/>
+                        <a:t>178.86</a:t>
+                      </a:r>
+                    </a:p>
+                  </a:txBody>
+                </a:tc>
+                <a:tc>
+                  <a:txBody>
+                    <a:bodyPr/>
+                    <a:lstStyle/>
+                    <a:p>
+                      <a:pPr lvl="0" indent="0" marL="0">
+                        <a:buNone/>
+                      </a:pPr>
+                      <a:r>
+                        <a:rPr/>
+                        <a:t>balsam fir</a:t>
+                      </a:r>
+                    </a:p>
+                  </a:txBody>
+                </a:tc>
+              </a:tr>
+              <a:tr h="0">
+                <a:tc>
+                  <a:txBody>
+                    <a:bodyPr/>
+                    <a:lstStyle/>
+                    <a:p>
+                      <a:pPr lvl="0" indent="0" marL="0">
+                        <a:buNone/>
+                      </a:pPr>
+                      <a:r>
+                        <a:rPr/>
+                        <a:t>1</a:t>
+                      </a:r>
+                    </a:p>
+                  </a:txBody>
+                </a:tc>
+                <a:tc>
+                  <a:txBody>
+                    <a:bodyPr/>
+                    <a:lstStyle/>
+                    <a:p>
+                      <a:pPr lvl="0" indent="0" marL="0">
+                        <a:buNone/>
+                      </a:pPr>
+                      <a:r>
+                        <a:rPr/>
+                        <a:t>12</a:t>
+                      </a:r>
+                    </a:p>
+                  </a:txBody>
+                </a:tc>
+                <a:tc>
+                  <a:txBody>
+                    <a:bodyPr/>
+                    <a:lstStyle/>
+                    <a:p>
+                      <a:pPr lvl="0" indent="0" marL="0">
+                        <a:buNone/>
+                      </a:pPr>
+                      <a:r>
+                        <a:rPr/>
+                        <a:t>9.3</a:t>
+                      </a:r>
+                    </a:p>
+                  </a:txBody>
+                </a:tc>
+                <a:tc>
+                  <a:txBody>
+                    <a:bodyPr/>
+                    <a:lstStyle/>
+                    <a:p>
+                      <a:pPr lvl="0" indent="0" marL="0">
+                        <a:buNone/>
+                      </a:pPr>
+                      <a:r>
+                        <a:rPr/>
+                        <a:t>62.7</a:t>
+                      </a:r>
+                    </a:p>
+                  </a:txBody>
+                </a:tc>
+                <a:tc>
+                  <a:txBody>
+                    <a:bodyPr/>
+                    <a:lstStyle/>
+                    <a:p>
+                      <a:pPr lvl="0" indent="0" marL="0">
+                        <a:buNone/>
+                      </a:pPr>
+                      <a:r>
+                        <a:rPr/>
+                        <a:t>323.46</a:t>
+                      </a:r>
+                    </a:p>
+                  </a:txBody>
+                </a:tc>
+                <a:tc>
+                  <a:txBody>
+                    <a:bodyPr/>
+                    <a:lstStyle/>
+                    <a:p>
+                      <a:pPr lvl="0" indent="0" marL="0">
+                        <a:buNone/>
+                      </a:pPr>
+                      <a:r>
+                        <a:rPr/>
+                        <a:t>balsam fir</a:t>
+                      </a:r>
+                    </a:p>
+                  </a:txBody>
+                </a:tc>
+              </a:tr>
+              <a:tr h="0">
+                <a:tc>
+                  <a:txBody>
+                    <a:bodyPr/>
+                    <a:lstStyle/>
+                    <a:p>
+                      <a:pPr lvl="0" indent="0" marL="0">
+                        <a:buNone/>
+                      </a:pPr>
+                      <a:r>
+                        <a:rPr/>
+                        <a:t>2</a:t>
+                      </a:r>
+                    </a:p>
+                  </a:txBody>
+                </a:tc>
+                <a:tc>
+                  <a:txBody>
+                    <a:bodyPr/>
+                    <a:lstStyle/>
+                    <a:p>
+                      <a:pPr lvl="0" indent="0" marL="0">
+                        <a:buNone/>
+                      </a:pPr>
+                      <a:r>
+                        <a:rPr/>
+                        <a:t>12</a:t>
+                      </a:r>
+                    </a:p>
+                  </a:txBody>
+                </a:tc>
+                <a:tc>
+                  <a:txBody>
+                    <a:bodyPr/>
+                    <a:lstStyle/>
+                    <a:p>
+                      <a:pPr lvl="0" indent="0" marL="0">
+                        <a:buNone/>
+                      </a:pPr>
+                      <a:r>
+                        <a:rPr/>
+                        <a:t>9.7</a:t>
+                      </a:r>
+                    </a:p>
+                  </a:txBody>
+                </a:tc>
+                <a:tc>
+                  <a:txBody>
+                    <a:bodyPr/>
+                    <a:lstStyle/>
+                    <a:p>
+                      <a:pPr lvl="0" indent="0" marL="0">
+                        <a:buNone/>
+                      </a:pPr>
+                      <a:r>
+                        <a:rPr/>
+                        <a:t>56.7</a:t>
+                      </a:r>
+                    </a:p>
+                  </a:txBody>
+                </a:tc>
+                <a:tc>
+                  <a:txBody>
+                    <a:bodyPr/>
+                    <a:lstStyle/>
+                    <a:p>
+                      <a:pPr lvl="0" indent="0" marL="0">
+                        <a:buNone/>
+                      </a:pPr>
+                      <a:r>
+                        <a:rPr/>
+                        <a:t>342.47</a:t>
+                      </a:r>
+                    </a:p>
+                  </a:txBody>
+                </a:tc>
+                <a:tc>
+                  <a:txBody>
+                    <a:bodyPr/>
+                    <a:lstStyle/>
+                    <a:p>
+                      <a:pPr lvl="0" indent="0" marL="0">
+                        <a:buNone/>
+                      </a:pPr>
+                      <a:r>
+                        <a:rPr/>
+                        <a:t>balsam fir</a:t>
+                      </a:r>
+                    </a:p>
+                  </a:txBody>
+                </a:tc>
+              </a:tr>
+              <a:tr h="0">
+                <a:tc>
+                  <a:txBody>
+                    <a:bodyPr/>
+                    <a:lstStyle/>
+                    <a:p>
+                      <a:pPr lvl="0" indent="0" marL="0">
+                        <a:buNone/>
+                      </a:pPr>
+                      <a:r>
+                        <a:rPr/>
+                        <a:t>3</a:t>
+                      </a:r>
+                    </a:p>
+                  </a:txBody>
+                </a:tc>
+                <a:tc>
+                  <a:txBody>
+                    <a:bodyPr/>
+                    <a:lstStyle/>
+                    <a:p>
+                      <a:pPr lvl="0" indent="0" marL="0">
+                        <a:buNone/>
+                      </a:pPr>
+                      <a:r>
+                        <a:rPr/>
+                        <a:t>12</a:t>
+                      </a:r>
+                    </a:p>
+                  </a:txBody>
+                </a:tc>
+                <a:tc>
+                  <a:txBody>
+                    <a:bodyPr/>
+                    <a:lstStyle/>
+                    <a:p>
+                      <a:pPr lvl="0" indent="0" marL="0">
+                        <a:buNone/>
+                      </a:pPr>
+                      <a:r>
+                        <a:rPr/>
+                        <a:t>11.4</a:t>
+                      </a:r>
+                    </a:p>
+                  </a:txBody>
+                </a:tc>
+                <a:tc>
+                  <a:txBody>
+                    <a:bodyPr/>
+                    <a:lstStyle/>
+                    <a:p>
+                      <a:pPr lvl="0" indent="0" marL="0">
+                        <a:buNone/>
+                      </a:pPr>
+                      <a:r>
+                        <a:rPr/>
+                        <a:t>66.1</a:t>
+                      </a:r>
+                    </a:p>
+                  </a:txBody>
+                </a:tc>
+                <a:tc>
+                  <a:txBody>
+                    <a:bodyPr/>
+                    <a:lstStyle/>
+                    <a:p>
+                      <a:pPr lvl="0" indent="0" marL="0">
+                        <a:buNone/>
+                      </a:pPr>
+                      <a:r>
+                        <a:rPr/>
+                        <a:t>499.35</a:t>
+                      </a:r>
+                    </a:p>
+                  </a:txBody>
+                </a:tc>
+                <a:tc>
+                  <a:txBody>
+                    <a:bodyPr/>
+                    <a:lstStyle/>
+                    <a:p>
+                      <a:pPr lvl="0" indent="0" marL="0">
+                        <a:buNone/>
+                      </a:pPr>
+                      <a:r>
+                        <a:rPr/>
+                        <a:t>balsam fir</a:t>
+                      </a:r>
+                    </a:p>
+                  </a:txBody>
+                </a:tc>
+              </a:tr>
+              <a:tr h="0">
+                <a:tc>
+                  <a:txBody>
+                    <a:bodyPr/>
+                    <a:lstStyle/>
+                    <a:p>
+                      <a:pPr lvl="0" indent="0" marL="0">
+                        <a:buNone/>
+                      </a:pPr>
+                      <a:r>
+                        <a:rPr/>
+                        <a:t>4</a:t>
+                      </a:r>
+                    </a:p>
+                  </a:txBody>
+                </a:tc>
+                <a:tc>
+                  <a:txBody>
+                    <a:bodyPr/>
+                    <a:lstStyle/>
+                    <a:p>
+                      <a:pPr lvl="0" indent="0" marL="0">
+                        <a:buNone/>
+                      </a:pPr>
+                      <a:r>
+                        <a:rPr/>
+                        <a:t>12</a:t>
+                      </a:r>
+                    </a:p>
+                  </a:txBody>
+                </a:tc>
+                <a:tc>
+                  <a:txBody>
+                    <a:bodyPr/>
+                    <a:lstStyle/>
+                    <a:p>
+                      <a:pPr lvl="0" indent="0" marL="0">
+                        <a:buNone/>
+                      </a:pPr>
+                      <a:r>
+                        <a:rPr/>
+                        <a:t>6.4</a:t>
+                      </a:r>
+                    </a:p>
+                  </a:txBody>
+                </a:tc>
+                <a:tc>
+                  <a:txBody>
+                    <a:bodyPr/>
+                    <a:lstStyle/>
+                    <a:p>
+                      <a:pPr lvl="0" indent="0" marL="0">
+                        <a:buNone/>
+                      </a:pPr>
+                      <a:r>
+                        <a:rPr/>
+                        <a:t>51.8</a:t>
+                      </a:r>
+                    </a:p>
+                  </a:txBody>
+                </a:tc>
+                <a:tc>
+                  <a:txBody>
+                    <a:bodyPr/>
+                    <a:lstStyle/>
+                    <a:p>
+                      <a:pPr lvl="0" indent="0" marL="0">
+                        <a:buNone/>
+                      </a:pPr>
+                      <a:r>
+                        <a:rPr/>
+                        <a:t>113.92</a:t>
+                      </a:r>
+                    </a:p>
+                  </a:txBody>
+                </a:tc>
+                <a:tc>
+                  <a:txBody>
+                    <a:bodyPr/>
+                    <a:lstStyle/>
+                    <a:p>
+                      <a:pPr lvl="0" indent="0" marL="0">
+                        <a:buNone/>
+                      </a:pPr>
+                      <a:r>
+                        <a:rPr/>
+                        <a:t>balsam fir</a:t>
+                      </a:r>
+                    </a:p>
+                  </a:txBody>
+                </a:tc>
+              </a:tr>
+            </a:tbl>
+          </a:graphicData>
+        </a:graphic>
+      </p:graphicFrame>
     </p:spTree>
   </p:cSld>
 </p:sld>
@@ -7052,6 +6364,1310 @@
             <a:r>
               <a:rPr/>
               <a:t>.</a:t>
+            </a:r>
+          </a:p>
+        </p:txBody>
+      </p:sp>
+    </p:spTree>
+  </p:cSld>
+</p:sld>
+</file>
+
+<file path=ppt/slides/slide20.xml><?xml version="1.0" encoding="utf-8"?>
+<p:sld xmlns:a="http://schemas.openxmlformats.org/drawingml/2006/main" xmlns:r="http://schemas.openxmlformats.org/officeDocument/2006/relationships" xmlns:p="http://schemas.openxmlformats.org/presentationml/2006/main">
+  <p:cSld>
+    <p:spTree>
+      <p:nvGrpSpPr>
+        <p:cNvPr id="1" name=""/>
+        <p:cNvGrpSpPr/>
+        <p:nvPr/>
+      </p:nvGrpSpPr>
+      <p:grpSpPr>
+        <a:xfrm>
+          <a:off x="0" y="0"/>
+          <a:ext cx="0" cy="0"/>
+          <a:chOff x="0" y="0"/>
+          <a:chExt cx="0" cy="0"/>
+        </a:xfrm>
+      </p:grpSpPr>
+      <p:sp>
+        <p:nvSpPr>
+          <p:cNvPr id="2" name="Title 1"/>
+          <p:cNvSpPr>
+            <a:spLocks noGrp="1"/>
+          </p:cNvSpPr>
+          <p:nvPr>
+            <p:ph type="title"/>
+          </p:nvPr>
+        </p:nvSpPr>
+        <p:spPr/>
+        <p:txBody>
+          <a:bodyPr/>
+          <a:lstStyle/>
+          <a:p>
+            <a:pPr lvl="0" indent="0" marL="0">
+              <a:buNone/>
+            </a:pPr>
+            <a:r>
+              <a:rPr/>
+              <a:t>Filtered data (minimum 100 data points)</a:t>
+            </a:r>
+          </a:p>
+        </p:txBody>
+      </p:sp>
+      <p:graphicFrame>
+        <p:nvGraphicFramePr>
+          <p:cNvPr id="6" name="Content Placeholder 5"/>
+          <p:cNvGraphicFramePr>
+            <a:graphicFrameLocks noGrp="1"/>
+          </p:cNvGraphicFramePr>
+          <p:nvPr>
+            <p:ph idx="1"/>
+          </p:nvPr>
+        </p:nvGraphicFramePr>
+        <p:xfrm>
+          <a:off x="457200" y="1193800"/>
+          <a:ext cx="8229600" cy="3390900"/>
+        </p:xfrm>
+        <a:graphic>
+          <a:graphicData uri="http://schemas.openxmlformats.org/drawingml/2006/table">
+            <a:tbl>
+              <a:tblPr firstRow="1" bandRow="1">
+                <a:tableStyleId>{5C22544A-7EE6-4342-B048-85BDC9FD1C3A}</a:tableStyleId>
+              </a:tblPr>
+              <a:tblGrid>
+                <a:gridCol w="1371600"/>
+                <a:gridCol w="1371600"/>
+                <a:gridCol w="1371600"/>
+                <a:gridCol w="1371600"/>
+                <a:gridCol w="1371600"/>
+                <a:gridCol w="1371600"/>
+              </a:tblGrid>
+              <a:tr h="0">
+                <a:tc>
+                  <a:txBody>
+                    <a:bodyPr/>
+                    <a:lstStyle/>
+                    <a:p>
+                      <a:endParaRPr/>
+                    </a:p>
+                  </a:txBody>
+                  <a:tcPr/>
+                </a:tc>
+                <a:tc>
+                  <a:txBody>
+                    <a:bodyPr/>
+                    <a:lstStyle/>
+                    <a:p>
+                      <a:pPr lvl="0" indent="0" marL="0">
+                        <a:buNone/>
+                      </a:pPr>
+                      <a:r>
+                        <a:rPr/>
+                        <a:t>SPCD</a:t>
+                      </a:r>
+                    </a:p>
+                  </a:txBody>
+                  <a:tcPr/>
+                </a:tc>
+                <a:tc>
+                  <a:txBody>
+                    <a:bodyPr/>
+                    <a:lstStyle/>
+                    <a:p>
+                      <a:pPr lvl="0" indent="0" marL="0">
+                        <a:buNone/>
+                      </a:pPr>
+                      <a:r>
+                        <a:rPr/>
+                        <a:t>DO_BH</a:t>
+                      </a:r>
+                    </a:p>
+                  </a:txBody>
+                  <a:tcPr/>
+                </a:tc>
+                <a:tc>
+                  <a:txBody>
+                    <a:bodyPr/>
+                    <a:lstStyle/>
+                    <a:p>
+                      <a:pPr lvl="0" indent="0" marL="0">
+                        <a:buNone/>
+                      </a:pPr>
+                      <a:r>
+                        <a:rPr/>
+                        <a:t>HT_TOT</a:t>
+                      </a:r>
+                    </a:p>
+                  </a:txBody>
+                  <a:tcPr/>
+                </a:tc>
+                <a:tc>
+                  <a:txBody>
+                    <a:bodyPr/>
+                    <a:lstStyle/>
+                    <a:p>
+                      <a:pPr lvl="0" indent="0" marL="0">
+                        <a:buNone/>
+                      </a:pPr>
+                      <a:r>
+                        <a:rPr/>
+                        <a:t>TT_DW_CRM</a:t>
+                      </a:r>
+                    </a:p>
+                  </a:txBody>
+                  <a:tcPr/>
+                </a:tc>
+                <a:tc>
+                  <a:txBody>
+                    <a:bodyPr/>
+                    <a:lstStyle/>
+                    <a:p>
+                      <a:pPr lvl="0" indent="0" marL="0">
+                        <a:buNone/>
+                      </a:pPr>
+                      <a:r>
+                        <a:rPr/>
+                        <a:t>COMMON_NAME</a:t>
+                      </a:r>
+                    </a:p>
+                  </a:txBody>
+                  <a:tcPr/>
+                </a:tc>
+              </a:tr>
+              <a:tr h="0">
+                <a:tc>
+                  <a:txBody>
+                    <a:bodyPr/>
+                    <a:lstStyle/>
+                    <a:p>
+                      <a:pPr lvl="0" indent="0" marL="0">
+                        <a:buNone/>
+                      </a:pPr>
+                      <a:r>
+                        <a:rPr/>
+                        <a:t>0</a:t>
+                      </a:r>
+                    </a:p>
+                  </a:txBody>
+                </a:tc>
+                <a:tc>
+                  <a:txBody>
+                    <a:bodyPr/>
+                    <a:lstStyle/>
+                    <a:p>
+                      <a:pPr lvl="0" indent="0" marL="0">
+                        <a:buNone/>
+                      </a:pPr>
+                      <a:r>
+                        <a:rPr/>
+                        <a:t>12</a:t>
+                      </a:r>
+                    </a:p>
+                  </a:txBody>
+                </a:tc>
+                <a:tc>
+                  <a:txBody>
+                    <a:bodyPr/>
+                    <a:lstStyle/>
+                    <a:p>
+                      <a:pPr lvl="0" indent="0" marL="0">
+                        <a:buNone/>
+                      </a:pPr>
+                      <a:r>
+                        <a:rPr/>
+                        <a:t>7.5</a:t>
+                      </a:r>
+                    </a:p>
+                  </a:txBody>
+                </a:tc>
+                <a:tc>
+                  <a:txBody>
+                    <a:bodyPr/>
+                    <a:lstStyle/>
+                    <a:p>
+                      <a:pPr lvl="0" indent="0" marL="0">
+                        <a:buNone/>
+                      </a:pPr>
+                      <a:r>
+                        <a:rPr/>
+                        <a:t>45.2</a:t>
+                      </a:r>
+                    </a:p>
+                  </a:txBody>
+                </a:tc>
+                <a:tc>
+                  <a:txBody>
+                    <a:bodyPr/>
+                    <a:lstStyle/>
+                    <a:p>
+                      <a:pPr lvl="0" indent="0" marL="0">
+                        <a:buNone/>
+                      </a:pPr>
+                      <a:r>
+                        <a:rPr/>
+                        <a:t>178.86</a:t>
+                      </a:r>
+                    </a:p>
+                  </a:txBody>
+                </a:tc>
+                <a:tc>
+                  <a:txBody>
+                    <a:bodyPr/>
+                    <a:lstStyle/>
+                    <a:p>
+                      <a:pPr lvl="0" indent="0" marL="0">
+                        <a:buNone/>
+                      </a:pPr>
+                      <a:r>
+                        <a:rPr/>
+                        <a:t>balsam fir</a:t>
+                      </a:r>
+                    </a:p>
+                  </a:txBody>
+                </a:tc>
+              </a:tr>
+              <a:tr h="0">
+                <a:tc>
+                  <a:txBody>
+                    <a:bodyPr/>
+                    <a:lstStyle/>
+                    <a:p>
+                      <a:pPr lvl="0" indent="0" marL="0">
+                        <a:buNone/>
+                      </a:pPr>
+                      <a:r>
+                        <a:rPr/>
+                        <a:t>1</a:t>
+                      </a:r>
+                    </a:p>
+                  </a:txBody>
+                </a:tc>
+                <a:tc>
+                  <a:txBody>
+                    <a:bodyPr/>
+                    <a:lstStyle/>
+                    <a:p>
+                      <a:pPr lvl="0" indent="0" marL="0">
+                        <a:buNone/>
+                      </a:pPr>
+                      <a:r>
+                        <a:rPr/>
+                        <a:t>12</a:t>
+                      </a:r>
+                    </a:p>
+                  </a:txBody>
+                </a:tc>
+                <a:tc>
+                  <a:txBody>
+                    <a:bodyPr/>
+                    <a:lstStyle/>
+                    <a:p>
+                      <a:pPr lvl="0" indent="0" marL="0">
+                        <a:buNone/>
+                      </a:pPr>
+                      <a:r>
+                        <a:rPr/>
+                        <a:t>9.3</a:t>
+                      </a:r>
+                    </a:p>
+                  </a:txBody>
+                </a:tc>
+                <a:tc>
+                  <a:txBody>
+                    <a:bodyPr/>
+                    <a:lstStyle/>
+                    <a:p>
+                      <a:pPr lvl="0" indent="0" marL="0">
+                        <a:buNone/>
+                      </a:pPr>
+                      <a:r>
+                        <a:rPr/>
+                        <a:t>62.7</a:t>
+                      </a:r>
+                    </a:p>
+                  </a:txBody>
+                </a:tc>
+                <a:tc>
+                  <a:txBody>
+                    <a:bodyPr/>
+                    <a:lstStyle/>
+                    <a:p>
+                      <a:pPr lvl="0" indent="0" marL="0">
+                        <a:buNone/>
+                      </a:pPr>
+                      <a:r>
+                        <a:rPr/>
+                        <a:t>323.46</a:t>
+                      </a:r>
+                    </a:p>
+                  </a:txBody>
+                </a:tc>
+                <a:tc>
+                  <a:txBody>
+                    <a:bodyPr/>
+                    <a:lstStyle/>
+                    <a:p>
+                      <a:pPr lvl="0" indent="0" marL="0">
+                        <a:buNone/>
+                      </a:pPr>
+                      <a:r>
+                        <a:rPr/>
+                        <a:t>balsam fir</a:t>
+                      </a:r>
+                    </a:p>
+                  </a:txBody>
+                </a:tc>
+              </a:tr>
+              <a:tr h="0">
+                <a:tc>
+                  <a:txBody>
+                    <a:bodyPr/>
+                    <a:lstStyle/>
+                    <a:p>
+                      <a:pPr lvl="0" indent="0" marL="0">
+                        <a:buNone/>
+                      </a:pPr>
+                      <a:r>
+                        <a:rPr/>
+                        <a:t>2</a:t>
+                      </a:r>
+                    </a:p>
+                  </a:txBody>
+                </a:tc>
+                <a:tc>
+                  <a:txBody>
+                    <a:bodyPr/>
+                    <a:lstStyle/>
+                    <a:p>
+                      <a:pPr lvl="0" indent="0" marL="0">
+                        <a:buNone/>
+                      </a:pPr>
+                      <a:r>
+                        <a:rPr/>
+                        <a:t>12</a:t>
+                      </a:r>
+                    </a:p>
+                  </a:txBody>
+                </a:tc>
+                <a:tc>
+                  <a:txBody>
+                    <a:bodyPr/>
+                    <a:lstStyle/>
+                    <a:p>
+                      <a:pPr lvl="0" indent="0" marL="0">
+                        <a:buNone/>
+                      </a:pPr>
+                      <a:r>
+                        <a:rPr/>
+                        <a:t>9.7</a:t>
+                      </a:r>
+                    </a:p>
+                  </a:txBody>
+                </a:tc>
+                <a:tc>
+                  <a:txBody>
+                    <a:bodyPr/>
+                    <a:lstStyle/>
+                    <a:p>
+                      <a:pPr lvl="0" indent="0" marL="0">
+                        <a:buNone/>
+                      </a:pPr>
+                      <a:r>
+                        <a:rPr/>
+                        <a:t>56.7</a:t>
+                      </a:r>
+                    </a:p>
+                  </a:txBody>
+                </a:tc>
+                <a:tc>
+                  <a:txBody>
+                    <a:bodyPr/>
+                    <a:lstStyle/>
+                    <a:p>
+                      <a:pPr lvl="0" indent="0" marL="0">
+                        <a:buNone/>
+                      </a:pPr>
+                      <a:r>
+                        <a:rPr/>
+                        <a:t>342.47</a:t>
+                      </a:r>
+                    </a:p>
+                  </a:txBody>
+                </a:tc>
+                <a:tc>
+                  <a:txBody>
+                    <a:bodyPr/>
+                    <a:lstStyle/>
+                    <a:p>
+                      <a:pPr lvl="0" indent="0" marL="0">
+                        <a:buNone/>
+                      </a:pPr>
+                      <a:r>
+                        <a:rPr/>
+                        <a:t>balsam fir</a:t>
+                      </a:r>
+                    </a:p>
+                  </a:txBody>
+                </a:tc>
+              </a:tr>
+              <a:tr h="0">
+                <a:tc>
+                  <a:txBody>
+                    <a:bodyPr/>
+                    <a:lstStyle/>
+                    <a:p>
+                      <a:pPr lvl="0" indent="0" marL="0">
+                        <a:buNone/>
+                      </a:pPr>
+                      <a:r>
+                        <a:rPr/>
+                        <a:t>3</a:t>
+                      </a:r>
+                    </a:p>
+                  </a:txBody>
+                </a:tc>
+                <a:tc>
+                  <a:txBody>
+                    <a:bodyPr/>
+                    <a:lstStyle/>
+                    <a:p>
+                      <a:pPr lvl="0" indent="0" marL="0">
+                        <a:buNone/>
+                      </a:pPr>
+                      <a:r>
+                        <a:rPr/>
+                        <a:t>12</a:t>
+                      </a:r>
+                    </a:p>
+                  </a:txBody>
+                </a:tc>
+                <a:tc>
+                  <a:txBody>
+                    <a:bodyPr/>
+                    <a:lstStyle/>
+                    <a:p>
+                      <a:pPr lvl="0" indent="0" marL="0">
+                        <a:buNone/>
+                      </a:pPr>
+                      <a:r>
+                        <a:rPr/>
+                        <a:t>11.4</a:t>
+                      </a:r>
+                    </a:p>
+                  </a:txBody>
+                </a:tc>
+                <a:tc>
+                  <a:txBody>
+                    <a:bodyPr/>
+                    <a:lstStyle/>
+                    <a:p>
+                      <a:pPr lvl="0" indent="0" marL="0">
+                        <a:buNone/>
+                      </a:pPr>
+                      <a:r>
+                        <a:rPr/>
+                        <a:t>66.1</a:t>
+                      </a:r>
+                    </a:p>
+                  </a:txBody>
+                </a:tc>
+                <a:tc>
+                  <a:txBody>
+                    <a:bodyPr/>
+                    <a:lstStyle/>
+                    <a:p>
+                      <a:pPr lvl="0" indent="0" marL="0">
+                        <a:buNone/>
+                      </a:pPr>
+                      <a:r>
+                        <a:rPr/>
+                        <a:t>499.35</a:t>
+                      </a:r>
+                    </a:p>
+                  </a:txBody>
+                </a:tc>
+                <a:tc>
+                  <a:txBody>
+                    <a:bodyPr/>
+                    <a:lstStyle/>
+                    <a:p>
+                      <a:pPr lvl="0" indent="0" marL="0">
+                        <a:buNone/>
+                      </a:pPr>
+                      <a:r>
+                        <a:rPr/>
+                        <a:t>balsam fir</a:t>
+                      </a:r>
+                    </a:p>
+                  </a:txBody>
+                </a:tc>
+              </a:tr>
+              <a:tr h="0">
+                <a:tc>
+                  <a:txBody>
+                    <a:bodyPr/>
+                    <a:lstStyle/>
+                    <a:p>
+                      <a:pPr lvl="0" indent="0" marL="0">
+                        <a:buNone/>
+                      </a:pPr>
+                      <a:r>
+                        <a:rPr/>
+                        <a:t>4</a:t>
+                      </a:r>
+                    </a:p>
+                  </a:txBody>
+                </a:tc>
+                <a:tc>
+                  <a:txBody>
+                    <a:bodyPr/>
+                    <a:lstStyle/>
+                    <a:p>
+                      <a:pPr lvl="0" indent="0" marL="0">
+                        <a:buNone/>
+                      </a:pPr>
+                      <a:r>
+                        <a:rPr/>
+                        <a:t>12</a:t>
+                      </a:r>
+                    </a:p>
+                  </a:txBody>
+                </a:tc>
+                <a:tc>
+                  <a:txBody>
+                    <a:bodyPr/>
+                    <a:lstStyle/>
+                    <a:p>
+                      <a:pPr lvl="0" indent="0" marL="0">
+                        <a:buNone/>
+                      </a:pPr>
+                      <a:r>
+                        <a:rPr/>
+                        <a:t>6.4</a:t>
+                      </a:r>
+                    </a:p>
+                  </a:txBody>
+                </a:tc>
+                <a:tc>
+                  <a:txBody>
+                    <a:bodyPr/>
+                    <a:lstStyle/>
+                    <a:p>
+                      <a:pPr lvl="0" indent="0" marL="0">
+                        <a:buNone/>
+                      </a:pPr>
+                      <a:r>
+                        <a:rPr/>
+                        <a:t>51.8</a:t>
+                      </a:r>
+                    </a:p>
+                  </a:txBody>
+                </a:tc>
+                <a:tc>
+                  <a:txBody>
+                    <a:bodyPr/>
+                    <a:lstStyle/>
+                    <a:p>
+                      <a:pPr lvl="0" indent="0" marL="0">
+                        <a:buNone/>
+                      </a:pPr>
+                      <a:r>
+                        <a:rPr/>
+                        <a:t>113.92</a:t>
+                      </a:r>
+                    </a:p>
+                  </a:txBody>
+                </a:tc>
+                <a:tc>
+                  <a:txBody>
+                    <a:bodyPr/>
+                    <a:lstStyle/>
+                    <a:p>
+                      <a:pPr lvl="0" indent="0" marL="0">
+                        <a:buNone/>
+                      </a:pPr>
+                      <a:r>
+                        <a:rPr/>
+                        <a:t>balsam fir</a:t>
+                      </a:r>
+                    </a:p>
+                  </a:txBody>
+                </a:tc>
+              </a:tr>
+              <a:tr h="0">
+                <a:tc>
+                  <a:txBody>
+                    <a:bodyPr/>
+                    <a:lstStyle/>
+                    <a:p>
+                      <a:pPr lvl="0" indent="0" marL="0">
+                        <a:buNone/>
+                      </a:pPr>
+                      <a:r>
+                        <a:rPr/>
+                        <a:t>...</a:t>
+                      </a:r>
+                    </a:p>
+                  </a:txBody>
+                </a:tc>
+                <a:tc>
+                  <a:txBody>
+                    <a:bodyPr/>
+                    <a:lstStyle/>
+                    <a:p>
+                      <a:pPr lvl="0" indent="0" marL="0">
+                        <a:buNone/>
+                      </a:pPr>
+                      <a:r>
+                        <a:rPr/>
+                        <a:t>...</a:t>
+                      </a:r>
+                    </a:p>
+                  </a:txBody>
+                </a:tc>
+                <a:tc>
+                  <a:txBody>
+                    <a:bodyPr/>
+                    <a:lstStyle/>
+                    <a:p>
+                      <a:pPr lvl="0" indent="0" marL="0">
+                        <a:buNone/>
+                      </a:pPr>
+                      <a:r>
+                        <a:rPr/>
+                        <a:t>...</a:t>
+                      </a:r>
+                    </a:p>
+                  </a:txBody>
+                </a:tc>
+                <a:tc>
+                  <a:txBody>
+                    <a:bodyPr/>
+                    <a:lstStyle/>
+                    <a:p>
+                      <a:pPr lvl="0" indent="0" marL="0">
+                        <a:buNone/>
+                      </a:pPr>
+                      <a:r>
+                        <a:rPr/>
+                        <a:t>...</a:t>
+                      </a:r>
+                    </a:p>
+                  </a:txBody>
+                </a:tc>
+                <a:tc>
+                  <a:txBody>
+                    <a:bodyPr/>
+                    <a:lstStyle/>
+                    <a:p>
+                      <a:pPr lvl="0" indent="0" marL="0">
+                        <a:buNone/>
+                      </a:pPr>
+                      <a:r>
+                        <a:rPr/>
+                        <a:t>...</a:t>
+                      </a:r>
+                    </a:p>
+                  </a:txBody>
+                </a:tc>
+                <a:tc>
+                  <a:txBody>
+                    <a:bodyPr/>
+                    <a:lstStyle/>
+                    <a:p>
+                      <a:pPr lvl="0" indent="0" marL="0">
+                        <a:buNone/>
+                      </a:pPr>
+                      <a:r>
+                        <a:rPr/>
+                        <a:t>...</a:t>
+                      </a:r>
+                    </a:p>
+                  </a:txBody>
+                </a:tc>
+              </a:tr>
+              <a:tr h="0">
+                <a:tc>
+                  <a:txBody>
+                    <a:bodyPr/>
+                    <a:lstStyle/>
+                    <a:p>
+                      <a:pPr lvl="0" indent="0" marL="0">
+                        <a:buNone/>
+                      </a:pPr>
+                      <a:r>
+                        <a:rPr/>
+                        <a:t>137035</a:t>
+                      </a:r>
+                    </a:p>
+                  </a:txBody>
+                </a:tc>
+                <a:tc>
+                  <a:txBody>
+                    <a:bodyPr/>
+                    <a:lstStyle/>
+                    <a:p>
+                      <a:pPr lvl="0" indent="0" marL="0">
+                        <a:buNone/>
+                      </a:pPr>
+                      <a:r>
+                        <a:rPr/>
+                        <a:t>691</a:t>
+                      </a:r>
+                    </a:p>
+                  </a:txBody>
+                </a:tc>
+                <a:tc>
+                  <a:txBody>
+                    <a:bodyPr/>
+                    <a:lstStyle/>
+                    <a:p>
+                      <a:pPr lvl="0" indent="0" marL="0">
+                        <a:buNone/>
+                      </a:pPr>
+                      <a:r>
+                        <a:rPr/>
+                        <a:t>3.7</a:t>
+                      </a:r>
+                    </a:p>
+                  </a:txBody>
+                </a:tc>
+                <a:tc>
+                  <a:txBody>
+                    <a:bodyPr/>
+                    <a:lstStyle/>
+                    <a:p>
+                      <a:pPr lvl="0" indent="0" marL="0">
+                        <a:buNone/>
+                      </a:pPr>
+                      <a:r>
+                        <a:rPr/>
+                        <a:t>25.4</a:t>
+                      </a:r>
+                    </a:p>
+                  </a:txBody>
+                </a:tc>
+                <a:tc>
+                  <a:txBody>
+                    <a:bodyPr/>
+                    <a:lstStyle/>
+                    <a:p>
+                      <a:pPr lvl="0" indent="0" marL="0">
+                        <a:buNone/>
+                      </a:pPr>
+                      <a:r>
+                        <a:rPr/>
+                        <a:t>40.76</a:t>
+                      </a:r>
+                    </a:p>
+                  </a:txBody>
+                </a:tc>
+                <a:tc>
+                  <a:txBody>
+                    <a:bodyPr/>
+                    <a:lstStyle/>
+                    <a:p>
+                      <a:pPr lvl="0" indent="0" marL="0">
+                        <a:buNone/>
+                      </a:pPr>
+                      <a:r>
+                        <a:rPr/>
+                        <a:t>water tupelo</a:t>
+                      </a:r>
+                    </a:p>
+                  </a:txBody>
+                </a:tc>
+              </a:tr>
+              <a:tr h="0">
+                <a:tc>
+                  <a:txBody>
+                    <a:bodyPr/>
+                    <a:lstStyle/>
+                    <a:p>
+                      <a:pPr lvl="0" indent="0" marL="0">
+                        <a:buNone/>
+                      </a:pPr>
+                      <a:r>
+                        <a:rPr/>
+                        <a:t>137036</a:t>
+                      </a:r>
+                    </a:p>
+                  </a:txBody>
+                </a:tc>
+                <a:tc>
+                  <a:txBody>
+                    <a:bodyPr/>
+                    <a:lstStyle/>
+                    <a:p>
+                      <a:pPr lvl="0" indent="0" marL="0">
+                        <a:buNone/>
+                      </a:pPr>
+                      <a:r>
+                        <a:rPr/>
+                        <a:t>691</a:t>
+                      </a:r>
+                    </a:p>
+                  </a:txBody>
+                </a:tc>
+                <a:tc>
+                  <a:txBody>
+                    <a:bodyPr/>
+                    <a:lstStyle/>
+                    <a:p>
+                      <a:pPr lvl="0" indent="0" marL="0">
+                        <a:buNone/>
+                      </a:pPr>
+                      <a:r>
+                        <a:rPr/>
+                        <a:t>3.2</a:t>
+                      </a:r>
+                    </a:p>
+                  </a:txBody>
+                </a:tc>
+                <a:tc>
+                  <a:txBody>
+                    <a:bodyPr/>
+                    <a:lstStyle/>
+                    <a:p>
+                      <a:pPr lvl="0" indent="0" marL="0">
+                        <a:buNone/>
+                      </a:pPr>
+                      <a:r>
+                        <a:rPr/>
+                        <a:t>28.8</a:t>
+                      </a:r>
+                    </a:p>
+                  </a:txBody>
+                </a:tc>
+                <a:tc>
+                  <a:txBody>
+                    <a:bodyPr/>
+                    <a:lstStyle/>
+                    <a:p>
+                      <a:pPr lvl="0" indent="0" marL="0">
+                        <a:buNone/>
+                      </a:pPr>
+                      <a:r>
+                        <a:rPr/>
+                        <a:t>28.44</a:t>
+                      </a:r>
+                    </a:p>
+                  </a:txBody>
+                </a:tc>
+                <a:tc>
+                  <a:txBody>
+                    <a:bodyPr/>
+                    <a:lstStyle/>
+                    <a:p>
+                      <a:pPr lvl="0" indent="0" marL="0">
+                        <a:buNone/>
+                      </a:pPr>
+                      <a:r>
+                        <a:rPr/>
+                        <a:t>water tupelo</a:t>
+                      </a:r>
+                    </a:p>
+                  </a:txBody>
+                </a:tc>
+              </a:tr>
+              <a:tr h="0">
+                <a:tc>
+                  <a:txBody>
+                    <a:bodyPr/>
+                    <a:lstStyle/>
+                    <a:p>
+                      <a:pPr lvl="0" indent="0" marL="0">
+                        <a:buNone/>
+                      </a:pPr>
+                      <a:r>
+                        <a:rPr/>
+                        <a:t>137037</a:t>
+                      </a:r>
+                    </a:p>
+                  </a:txBody>
+                </a:tc>
+                <a:tc>
+                  <a:txBody>
+                    <a:bodyPr/>
+                    <a:lstStyle/>
+                    <a:p>
+                      <a:pPr lvl="0" indent="0" marL="0">
+                        <a:buNone/>
+                      </a:pPr>
+                      <a:r>
+                        <a:rPr/>
+                        <a:t>691</a:t>
+                      </a:r>
+                    </a:p>
+                  </a:txBody>
+                </a:tc>
+                <a:tc>
+                  <a:txBody>
+                    <a:bodyPr/>
+                    <a:lstStyle/>
+                    <a:p>
+                      <a:pPr lvl="0" indent="0" marL="0">
+                        <a:buNone/>
+                      </a:pPr>
+                      <a:r>
+                        <a:rPr/>
+                        <a:t>4.7</a:t>
+                      </a:r>
+                    </a:p>
+                  </a:txBody>
+                </a:tc>
+                <a:tc>
+                  <a:txBody>
+                    <a:bodyPr/>
+                    <a:lstStyle/>
+                    <a:p>
+                      <a:pPr lvl="0" indent="0" marL="0">
+                        <a:buNone/>
+                      </a:pPr>
+                      <a:r>
+                        <a:rPr/>
+                        <a:t>31.4</a:t>
+                      </a:r>
+                    </a:p>
+                  </a:txBody>
+                </a:tc>
+                <a:tc>
+                  <a:txBody>
+                    <a:bodyPr/>
+                    <a:lstStyle/>
+                    <a:p>
+                      <a:pPr lvl="0" indent="0" marL="0">
+                        <a:buNone/>
+                      </a:pPr>
+                      <a:r>
+                        <a:rPr/>
+                        <a:t>73.78</a:t>
+                      </a:r>
+                    </a:p>
+                  </a:txBody>
+                </a:tc>
+                <a:tc>
+                  <a:txBody>
+                    <a:bodyPr/>
+                    <a:lstStyle/>
+                    <a:p>
+                      <a:pPr lvl="0" indent="0" marL="0">
+                        <a:buNone/>
+                      </a:pPr>
+                      <a:r>
+                        <a:rPr/>
+                        <a:t>water tupelo</a:t>
+                      </a:r>
+                    </a:p>
+                  </a:txBody>
+                </a:tc>
+              </a:tr>
+              <a:tr h="0">
+                <a:tc>
+                  <a:txBody>
+                    <a:bodyPr/>
+                    <a:lstStyle/>
+                    <a:p>
+                      <a:pPr lvl="0" indent="0" marL="0">
+                        <a:buNone/>
+                      </a:pPr>
+                      <a:r>
+                        <a:rPr/>
+                        <a:t>137038</a:t>
+                      </a:r>
+                    </a:p>
+                  </a:txBody>
+                </a:tc>
+                <a:tc>
+                  <a:txBody>
+                    <a:bodyPr/>
+                    <a:lstStyle/>
+                    <a:p>
+                      <a:pPr lvl="0" indent="0" marL="0">
+                        <a:buNone/>
+                      </a:pPr>
+                      <a:r>
+                        <a:rPr/>
+                        <a:t>691</a:t>
+                      </a:r>
+                    </a:p>
+                  </a:txBody>
+                </a:tc>
+                <a:tc>
+                  <a:txBody>
+                    <a:bodyPr/>
+                    <a:lstStyle/>
+                    <a:p>
+                      <a:pPr lvl="0" indent="0" marL="0">
+                        <a:buNone/>
+                      </a:pPr>
+                      <a:r>
+                        <a:rPr/>
+                        <a:t>4.4</a:t>
+                      </a:r>
+                    </a:p>
+                  </a:txBody>
+                </a:tc>
+                <a:tc>
+                  <a:txBody>
+                    <a:bodyPr/>
+                    <a:lstStyle/>
+                    <a:p>
+                      <a:pPr lvl="0" indent="0" marL="0">
+                        <a:buNone/>
+                      </a:pPr>
+                      <a:r>
+                        <a:rPr/>
+                        <a:t>26.9</a:t>
+                      </a:r>
+                    </a:p>
+                  </a:txBody>
+                </a:tc>
+                <a:tc>
+                  <a:txBody>
+                    <a:bodyPr/>
+                    <a:lstStyle/>
+                    <a:p>
+                      <a:pPr lvl="0" indent="0" marL="0">
+                        <a:buNone/>
+                      </a:pPr>
+                      <a:r>
+                        <a:rPr/>
+                        <a:t>62.64</a:t>
+                      </a:r>
+                    </a:p>
+                  </a:txBody>
+                </a:tc>
+                <a:tc>
+                  <a:txBody>
+                    <a:bodyPr/>
+                    <a:lstStyle/>
+                    <a:p>
+                      <a:pPr lvl="0" indent="0" marL="0">
+                        <a:buNone/>
+                      </a:pPr>
+                      <a:r>
+                        <a:rPr/>
+                        <a:t>water tupelo</a:t>
+                      </a:r>
+                    </a:p>
+                  </a:txBody>
+                </a:tc>
+              </a:tr>
+              <a:tr h="0">
+                <a:tc>
+                  <a:txBody>
+                    <a:bodyPr/>
+                    <a:lstStyle/>
+                    <a:p>
+                      <a:pPr lvl="0" indent="0" marL="0">
+                        <a:buNone/>
+                      </a:pPr>
+                      <a:r>
+                        <a:rPr/>
+                        <a:t>137039</a:t>
+                      </a:r>
+                    </a:p>
+                  </a:txBody>
+                </a:tc>
+                <a:tc>
+                  <a:txBody>
+                    <a:bodyPr/>
+                    <a:lstStyle/>
+                    <a:p>
+                      <a:pPr lvl="0" indent="0" marL="0">
+                        <a:buNone/>
+                      </a:pPr>
+                      <a:r>
+                        <a:rPr/>
+                        <a:t>691</a:t>
+                      </a:r>
+                    </a:p>
+                  </a:txBody>
+                </a:tc>
+                <a:tc>
+                  <a:txBody>
+                    <a:bodyPr/>
+                    <a:lstStyle/>
+                    <a:p>
+                      <a:pPr lvl="0" indent="0" marL="0">
+                        <a:buNone/>
+                      </a:pPr>
+                      <a:r>
+                        <a:rPr/>
+                        <a:t>4.2</a:t>
+                      </a:r>
+                    </a:p>
+                  </a:txBody>
+                </a:tc>
+                <a:tc>
+                  <a:txBody>
+                    <a:bodyPr/>
+                    <a:lstStyle/>
+                    <a:p>
+                      <a:pPr lvl="0" indent="0" marL="0">
+                        <a:buNone/>
+                      </a:pPr>
+                      <a:r>
+                        <a:rPr/>
+                        <a:t>28.1</a:t>
+                      </a:r>
+                    </a:p>
+                  </a:txBody>
+                </a:tc>
+                <a:tc>
+                  <a:txBody>
+                    <a:bodyPr/>
+                    <a:lstStyle/>
+                    <a:p>
+                      <a:pPr lvl="0" indent="0" marL="0">
+                        <a:buNone/>
+                      </a:pPr>
+                      <a:r>
+                        <a:rPr/>
+                        <a:t>55.82</a:t>
+                      </a:r>
+                    </a:p>
+                  </a:txBody>
+                </a:tc>
+                <a:tc>
+                  <a:txBody>
+                    <a:bodyPr/>
+                    <a:lstStyle/>
+                    <a:p>
+                      <a:pPr lvl="0" indent="0" marL="0">
+                        <a:buNone/>
+                      </a:pPr>
+                      <a:r>
+                        <a:rPr/>
+                        <a:t>water tupelo</a:t>
+                      </a:r>
+                    </a:p>
+                  </a:txBody>
+                </a:tc>
+              </a:tr>
+            </a:tbl>
+          </a:graphicData>
+        </a:graphic>
+      </p:graphicFrame>
+    </p:spTree>
+  </p:cSld>
+</p:sld>
+</file>
+
+<file path=ppt/slides/slide21.xml><?xml version="1.0" encoding="utf-8"?>
+<p:sld xmlns:a="http://schemas.openxmlformats.org/drawingml/2006/main" xmlns:r="http://schemas.openxmlformats.org/officeDocument/2006/relationships" xmlns:p="http://schemas.openxmlformats.org/presentationml/2006/main">
+  <p:cSld>
+    <p:spTree>
+      <p:nvGrpSpPr>
+        <p:cNvPr id="1" name=""/>
+        <p:cNvGrpSpPr/>
+        <p:nvPr/>
+      </p:nvGrpSpPr>
+      <p:grpSpPr>
+        <a:xfrm>
+          <a:off x="0" y="0"/>
+          <a:ext cx="0" cy="0"/>
+          <a:chOff x="0" y="0"/>
+          <a:chExt cx="0" cy="0"/>
+        </a:xfrm>
+      </p:grpSpPr>
+      <p:sp>
+        <p:nvSpPr>
+          <p:cNvPr id="2" name="Title 1"/>
+          <p:cNvSpPr>
+            <a:spLocks noGrp="1"/>
+          </p:cNvSpPr>
+          <p:nvPr>
+            <p:ph type="title"/>
+          </p:nvPr>
+        </p:nvSpPr>
+        <p:spPr/>
+        <p:txBody>
+          <a:bodyPr/>
+          <a:lstStyle/>
+          <a:p>
+            <a:pPr lvl="0" indent="0" marL="0">
+              <a:buNone/>
+            </a:pPr>
+            <a:r>
+              <a:rPr/>
+              <a:t>Base datset calculations:</a:t>
+            </a:r>
+          </a:p>
+        </p:txBody>
+      </p:sp>
+      <p:sp>
+        <p:nvSpPr>
+          <p:cNvPr id="3" name="Content Placeholder 2"/>
+          <p:cNvSpPr>
+            <a:spLocks noGrp="1"/>
+          </p:cNvSpPr>
+          <p:nvPr>
+            <p:ph idx="1"/>
+          </p:nvPr>
+        </p:nvSpPr>
+        <p:spPr/>
+        <p:txBody>
+          <a:bodyPr/>
+          <a:lstStyle/>
+          <a:p>
+            <a:pPr lvl="0" indent="0">
+              <a:buNone/>
+            </a:pPr>
+            <a:r>
+              <a:rPr>
+                <a:latin typeface="Courier"/>
+              </a:rPr>
+              <a:t>Average Root Mean Squared Log Error (RMSLE) for k = 3: 0.15806802121296354</a:t>
+            </a:r>
+          </a:p>
+        </p:txBody>
+      </p:sp>
+    </p:spTree>
+  </p:cSld>
+</p:sld>
+</file>
+
+<file path=ppt/slides/slide22.xml><?xml version="1.0" encoding="utf-8"?>
+<p:sld xmlns:a="http://schemas.openxmlformats.org/drawingml/2006/main" xmlns:r="http://schemas.openxmlformats.org/officeDocument/2006/relationships" xmlns:p="http://schemas.openxmlformats.org/presentationml/2006/main">
+  <p:cSld>
+    <p:spTree>
+      <p:nvGrpSpPr>
+        <p:cNvPr id="1" name=""/>
+        <p:cNvGrpSpPr/>
+        <p:nvPr/>
+      </p:nvGrpSpPr>
+      <p:grpSpPr>
+        <a:xfrm>
+          <a:off x="0" y="0"/>
+          <a:ext cx="0" cy="0"/>
+          <a:chOff x="0" y="0"/>
+          <a:chExt cx="0" cy="0"/>
+        </a:xfrm>
+      </p:grpSpPr>
+      <p:sp>
+        <p:nvSpPr>
+          <p:cNvPr id="2" name="Title 1"/>
+          <p:cNvSpPr>
+            <a:spLocks noGrp="1"/>
+          </p:cNvSpPr>
+          <p:nvPr>
+            <p:ph type="title"/>
+          </p:nvPr>
+        </p:nvSpPr>
+        <p:spPr/>
+        <p:txBody>
+          <a:bodyPr/>
+          <a:lstStyle/>
+          <a:p>
+            <a:pPr lvl="0" indent="0" marL="0">
+              <a:buNone/>
+            </a:pPr>
+            <a:r>
+              <a:rPr/>
+              <a:t>Quality Assurance</a:t>
             </a:r>
           </a:p>
         </p:txBody>

</xml_diff>

<commit_message>
small fixes and finished product
</commit_message>
<xml_diff>
--- a/Project-3/presentation.pptx
+++ b/Project-3/presentation.pptx
@@ -3487,14 +3487,14 @@
             <a:pPr lvl="0"/>
             <a:r>
               <a:rPr/>
-              <a:t>When predicting tree biomass, employ the performance metric root mean square logarithmic error since biomass data varies greatly, ranging from tiny saplings to enormous trees, majority of trees having exponential growth.</a:t>
+              <a:t>We choose kNN regression over linear regression because when looking at the graphs Dean made, we saw that the tree diameter/height vs. biomass graphs all have exponential growth.</a:t>
             </a:r>
           </a:p>
           <a:p>
             <a:pPr lvl="0"/>
             <a:r>
               <a:rPr/>
-              <a:t>We chose kNN regression over linear regression because when looking at the graphs Dean presented, we saw that the tree diameter/height vs. biomass graphs all have exponential growth.</a:t>
+              <a:t>When relations between biomass and trees’ diameter and height are complex and nonlinear, data is abundant, and the model needs to be adaptive without making major changes in the model. kNN excels in capturing patterns and irregular patterns.</a:t>
             </a:r>
           </a:p>
         </p:txBody>
@@ -3541,7 +3541,7 @@
             </a:pPr>
             <a:r>
               <a:rPr/>
-              <a:t>Consultation pt 2</a:t>
+              <a:t>Performance Metric</a:t>
             </a:r>
           </a:p>
         </p:txBody>
@@ -3564,7 +3564,18 @@
             <a:pPr lvl="0"/>
             <a:r>
               <a:rPr/>
-              <a:t>When relations between biomass and trees diameter and height are complex and non linear, data is abundent, and the model needs to be adaptive with out maksing major changes in the model. kNN excels in capturing patterns and irregular patterns.</a:t>
+              <a:t>When predicting tree biomass, we chose Root Mean Square Logarithmic Error for our performance metric since biomass data varies greatly, ranging from tiny saplings to enormous trees, and trees have exponential growth.</a:t>
+            </a:r>
+          </a:p>
+          <a:p>
+            <a:pPr lvl="0"/>
+            <a:r>
+              <a:rPr b="1"/>
+              <a:t>RMSLE over RMSE</a:t>
+            </a:r>
+            <a:r>
+              <a:rPr/>
+              <a:t>: focuses on percentage errors, making it fair to both small and large trees, unlike RMSE, which we believe penalizes errors on big trees. Fitting biomass estimations where scale matters more than absolute error. RMSLE provides a more balanced evaluation that considers the unique characteristics of tree biomass data.</a:t>
             </a:r>
           </a:p>
         </p:txBody>
@@ -3611,45 +3622,963 @@
             </a:pPr>
             <a:r>
               <a:rPr/>
-              <a:t>Performance Metric</a:t>
+              <a:t>Project Manager Model</a:t>
             </a:r>
           </a:p>
         </p:txBody>
       </p:sp>
-      <p:sp>
-        <p:nvSpPr>
-          <p:cNvPr id="3" name="Content Placeholder 2"/>
-          <p:cNvSpPr>
-            <a:spLocks noGrp="1"/>
-          </p:cNvSpPr>
+      <p:graphicFrame>
+        <p:nvGraphicFramePr>
+          <p:cNvPr id="6" name="Content Placeholder 5"/>
+          <p:cNvGraphicFramePr>
+            <a:graphicFrameLocks noGrp="1"/>
+          </p:cNvGraphicFramePr>
           <p:nvPr>
             <p:ph idx="1"/>
           </p:nvPr>
-        </p:nvSpPr>
-        <p:spPr/>
-        <p:txBody>
-          <a:bodyPr/>
-          <a:lstStyle/>
-          <a:p>
-            <a:pPr lvl="0"/>
-            <a:r>
-              <a:rPr b="1"/>
-              <a:t>RMSLE over RMSE</a:t>
-            </a:r>
-            <a:r>
-              <a:rPr/>
-              <a:t>: focuses on percentage errors, making it fair to both small and large trees, unlike RMSE, which we believe penalizes errors on big trees. Fitting biomass estimations where scale matters more than absolute error.</a:t>
-            </a:r>
-          </a:p>
-          <a:p>
-            <a:pPr lvl="0"/>
-            <a:r>
-              <a:rPr/>
-              <a:t>By prioritizing percentage errors, RMSLE provides a more balanced evaluation that considers the unique characteristics of tree biomass data.</a:t>
-            </a:r>
-          </a:p>
-        </p:txBody>
-      </p:sp>
+        </p:nvGraphicFramePr>
+        <p:xfrm>
+          <a:off x="457200" y="1193800"/>
+          <a:ext cx="8229600" cy="3390900"/>
+        </p:xfrm>
+        <a:graphic>
+          <a:graphicData uri="http://schemas.openxmlformats.org/drawingml/2006/table">
+            <a:tbl>
+              <a:tblPr firstRow="1" bandRow="1">
+                <a:tableStyleId>{5C22544A-7EE6-4342-B048-85BDC9FD1C3A}</a:tableStyleId>
+              </a:tblPr>
+              <a:tblGrid>
+                <a:gridCol w="1371600"/>
+                <a:gridCol w="1371600"/>
+                <a:gridCol w="1371600"/>
+                <a:gridCol w="1371600"/>
+                <a:gridCol w="1371600"/>
+                <a:gridCol w="1371600"/>
+              </a:tblGrid>
+              <a:tr h="0">
+                <a:tc>
+                  <a:txBody>
+                    <a:bodyPr/>
+                    <a:lstStyle/>
+                    <a:p>
+                      <a:endParaRPr/>
+                    </a:p>
+                  </a:txBody>
+                  <a:tcPr/>
+                </a:tc>
+                <a:tc>
+                  <a:txBody>
+                    <a:bodyPr/>
+                    <a:lstStyle/>
+                    <a:p>
+                      <a:pPr lvl="0" indent="0" marL="0">
+                        <a:buNone/>
+                      </a:pPr>
+                      <a:r>
+                        <a:rPr/>
+                        <a:t>Species</a:t>
+                      </a:r>
+                    </a:p>
+                  </a:txBody>
+                  <a:tcPr/>
+                </a:tc>
+                <a:tc>
+                  <a:txBody>
+                    <a:bodyPr/>
+                    <a:lstStyle/>
+                    <a:p>
+                      <a:pPr lvl="0" indent="0" marL="0">
+                        <a:buNone/>
+                      </a:pPr>
+                      <a:r>
+                        <a:rPr/>
+                        <a:t>k</a:t>
+                      </a:r>
+                    </a:p>
+                  </a:txBody>
+                  <a:tcPr/>
+                </a:tc>
+                <a:tc>
+                  <a:txBody>
+                    <a:bodyPr/>
+                    <a:lstStyle/>
+                    <a:p>
+                      <a:pPr lvl="0" indent="0" marL="0">
+                        <a:buNone/>
+                      </a:pPr>
+                      <a:r>
+                        <a:rPr/>
+                        <a:t>RMSE</a:t>
+                      </a:r>
+                    </a:p>
+                  </a:txBody>
+                  <a:tcPr/>
+                </a:tc>
+                <a:tc>
+                  <a:txBody>
+                    <a:bodyPr/>
+                    <a:lstStyle/>
+                    <a:p>
+                      <a:pPr lvl="0" indent="0" marL="0">
+                        <a:buNone/>
+                      </a:pPr>
+                      <a:r>
+                        <a:rPr/>
+                        <a:t>MAE</a:t>
+                      </a:r>
+                    </a:p>
+                  </a:txBody>
+                  <a:tcPr/>
+                </a:tc>
+                <a:tc>
+                  <a:txBody>
+                    <a:bodyPr/>
+                    <a:lstStyle/>
+                    <a:p>
+                      <a:pPr lvl="0" indent="0" marL="0">
+                        <a:buNone/>
+                      </a:pPr>
+                      <a:r>
+                        <a:rPr/>
+                        <a:t>RMSLE</a:t>
+                      </a:r>
+                    </a:p>
+                  </a:txBody>
+                  <a:tcPr/>
+                </a:tc>
+              </a:tr>
+              <a:tr h="0">
+                <a:tc>
+                  <a:txBody>
+                    <a:bodyPr/>
+                    <a:lstStyle/>
+                    <a:p>
+                      <a:pPr lvl="0" indent="0" marL="0">
+                        <a:buNone/>
+                      </a:pPr>
+                      <a:r>
+                        <a:rPr/>
+                        <a:t>0</a:t>
+                      </a:r>
+                    </a:p>
+                  </a:txBody>
+                </a:tc>
+                <a:tc>
+                  <a:txBody>
+                    <a:bodyPr/>
+                    <a:lstStyle/>
+                    <a:p>
+                      <a:pPr lvl="0" indent="0" marL="0">
+                        <a:buNone/>
+                      </a:pPr>
+                      <a:r>
+                        <a:rPr/>
+                        <a:t>balsam fir</a:t>
+                      </a:r>
+                    </a:p>
+                  </a:txBody>
+                </a:tc>
+                <a:tc>
+                  <a:txBody>
+                    <a:bodyPr/>
+                    <a:lstStyle/>
+                    <a:p>
+                      <a:pPr lvl="0" indent="0" marL="0">
+                        <a:buNone/>
+                      </a:pPr>
+                      <a:r>
+                        <a:rPr/>
+                        <a:t>2</a:t>
+                      </a:r>
+                    </a:p>
+                  </a:txBody>
+                </a:tc>
+                <a:tc>
+                  <a:txBody>
+                    <a:bodyPr/>
+                    <a:lstStyle/>
+                    <a:p>
+                      <a:pPr lvl="0" indent="0" marL="0">
+                        <a:buNone/>
+                      </a:pPr>
+                      <a:r>
+                        <a:rPr/>
+                        <a:t>125.827396</a:t>
+                      </a:r>
+                    </a:p>
+                  </a:txBody>
+                </a:tc>
+                <a:tc>
+                  <a:txBody>
+                    <a:bodyPr/>
+                    <a:lstStyle/>
+                    <a:p>
+                      <a:pPr lvl="0" indent="0" marL="0">
+                        <a:buNone/>
+                      </a:pPr>
+                      <a:r>
+                        <a:rPr/>
+                        <a:t>34.820565</a:t>
+                      </a:r>
+                    </a:p>
+                  </a:txBody>
+                </a:tc>
+                <a:tc>
+                  <a:txBody>
+                    <a:bodyPr/>
+                    <a:lstStyle/>
+                    <a:p>
+                      <a:pPr lvl="0" indent="0" marL="0">
+                        <a:buNone/>
+                      </a:pPr>
+                      <a:r>
+                        <a:rPr/>
+                        <a:t>0.119617</a:t>
+                      </a:r>
+                    </a:p>
+                  </a:txBody>
+                </a:tc>
+              </a:tr>
+              <a:tr h="0">
+                <a:tc>
+                  <a:txBody>
+                    <a:bodyPr/>
+                    <a:lstStyle/>
+                    <a:p>
+                      <a:pPr lvl="0" indent="0" marL="0">
+                        <a:buNone/>
+                      </a:pPr>
+                      <a:r>
+                        <a:rPr/>
+                        <a:t>1</a:t>
+                      </a:r>
+                    </a:p>
+                  </a:txBody>
+                </a:tc>
+                <a:tc>
+                  <a:txBody>
+                    <a:bodyPr/>
+                    <a:lstStyle/>
+                    <a:p>
+                      <a:pPr lvl="0" indent="0" marL="0">
+                        <a:buNone/>
+                      </a:pPr>
+                      <a:r>
+                        <a:rPr/>
+                        <a:t>balsam fir</a:t>
+                      </a:r>
+                    </a:p>
+                  </a:txBody>
+                </a:tc>
+                <a:tc>
+                  <a:txBody>
+                    <a:bodyPr/>
+                    <a:lstStyle/>
+                    <a:p>
+                      <a:pPr lvl="0" indent="0" marL="0">
+                        <a:buNone/>
+                      </a:pPr>
+                      <a:r>
+                        <a:rPr/>
+                        <a:t>3</a:t>
+                      </a:r>
+                    </a:p>
+                  </a:txBody>
+                </a:tc>
+                <a:tc>
+                  <a:txBody>
+                    <a:bodyPr/>
+                    <a:lstStyle/>
+                    <a:p>
+                      <a:pPr lvl="0" indent="0" marL="0">
+                        <a:buNone/>
+                      </a:pPr>
+                      <a:r>
+                        <a:rPr/>
+                        <a:t>129.650855</a:t>
+                      </a:r>
+                    </a:p>
+                  </a:txBody>
+                </a:tc>
+                <a:tc>
+                  <a:txBody>
+                    <a:bodyPr/>
+                    <a:lstStyle/>
+                    <a:p>
+                      <a:pPr lvl="0" indent="0" marL="0">
+                        <a:buNone/>
+                      </a:pPr>
+                      <a:r>
+                        <a:rPr/>
+                        <a:t>36.628377</a:t>
+                      </a:r>
+                    </a:p>
+                  </a:txBody>
+                </a:tc>
+                <a:tc>
+                  <a:txBody>
+                    <a:bodyPr/>
+                    <a:lstStyle/>
+                    <a:p>
+                      <a:pPr lvl="0" indent="0" marL="0">
+                        <a:buNone/>
+                      </a:pPr>
+                      <a:r>
+                        <a:rPr/>
+                        <a:t>0.123679</a:t>
+                      </a:r>
+                    </a:p>
+                  </a:txBody>
+                </a:tc>
+              </a:tr>
+              <a:tr h="0">
+                <a:tc>
+                  <a:txBody>
+                    <a:bodyPr/>
+                    <a:lstStyle/>
+                    <a:p>
+                      <a:pPr lvl="0" indent="0" marL="0">
+                        <a:buNone/>
+                      </a:pPr>
+                      <a:r>
+                        <a:rPr/>
+                        <a:t>2</a:t>
+                      </a:r>
+                    </a:p>
+                  </a:txBody>
+                </a:tc>
+                <a:tc>
+                  <a:txBody>
+                    <a:bodyPr/>
+                    <a:lstStyle/>
+                    <a:p>
+                      <a:pPr lvl="0" indent="0" marL="0">
+                        <a:buNone/>
+                      </a:pPr>
+                      <a:r>
+                        <a:rPr/>
+                        <a:t>balsam fir</a:t>
+                      </a:r>
+                    </a:p>
+                  </a:txBody>
+                </a:tc>
+                <a:tc>
+                  <a:txBody>
+                    <a:bodyPr/>
+                    <a:lstStyle/>
+                    <a:p>
+                      <a:pPr lvl="0" indent="0" marL="0">
+                        <a:buNone/>
+                      </a:pPr>
+                      <a:r>
+                        <a:rPr/>
+                        <a:t>4</a:t>
+                      </a:r>
+                    </a:p>
+                  </a:txBody>
+                </a:tc>
+                <a:tc>
+                  <a:txBody>
+                    <a:bodyPr/>
+                    <a:lstStyle/>
+                    <a:p>
+                      <a:pPr lvl="0" indent="0" marL="0">
+                        <a:buNone/>
+                      </a:pPr>
+                      <a:r>
+                        <a:rPr/>
+                        <a:t>134.599829</a:t>
+                      </a:r>
+                    </a:p>
+                  </a:txBody>
+                </a:tc>
+                <a:tc>
+                  <a:txBody>
+                    <a:bodyPr/>
+                    <a:lstStyle/>
+                    <a:p>
+                      <a:pPr lvl="0" indent="0" marL="0">
+                        <a:buNone/>
+                      </a:pPr>
+                      <a:r>
+                        <a:rPr/>
+                        <a:t>38.884870</a:t>
+                      </a:r>
+                    </a:p>
+                  </a:txBody>
+                </a:tc>
+                <a:tc>
+                  <a:txBody>
+                    <a:bodyPr/>
+                    <a:lstStyle/>
+                    <a:p>
+                      <a:pPr lvl="0" indent="0" marL="0">
+                        <a:buNone/>
+                      </a:pPr>
+                      <a:r>
+                        <a:rPr/>
+                        <a:t>0.133858</a:t>
+                      </a:r>
+                    </a:p>
+                  </a:txBody>
+                </a:tc>
+              </a:tr>
+              <a:tr h="0">
+                <a:tc>
+                  <a:txBody>
+                    <a:bodyPr/>
+                    <a:lstStyle/>
+                    <a:p>
+                      <a:pPr lvl="0" indent="0" marL="0">
+                        <a:buNone/>
+                      </a:pPr>
+                      <a:r>
+                        <a:rPr/>
+                        <a:t>3</a:t>
+                      </a:r>
+                    </a:p>
+                  </a:txBody>
+                </a:tc>
+                <a:tc>
+                  <a:txBody>
+                    <a:bodyPr/>
+                    <a:lstStyle/>
+                    <a:p>
+                      <a:pPr lvl="0" indent="0" marL="0">
+                        <a:buNone/>
+                      </a:pPr>
+                      <a:r>
+                        <a:rPr/>
+                        <a:t>balsam fir</a:t>
+                      </a:r>
+                    </a:p>
+                  </a:txBody>
+                </a:tc>
+                <a:tc>
+                  <a:txBody>
+                    <a:bodyPr/>
+                    <a:lstStyle/>
+                    <a:p>
+                      <a:pPr lvl="0" indent="0" marL="0">
+                        <a:buNone/>
+                      </a:pPr>
+                      <a:r>
+                        <a:rPr/>
+                        <a:t>5</a:t>
+                      </a:r>
+                    </a:p>
+                  </a:txBody>
+                </a:tc>
+                <a:tc>
+                  <a:txBody>
+                    <a:bodyPr/>
+                    <a:lstStyle/>
+                    <a:p>
+                      <a:pPr lvl="0" indent="0" marL="0">
+                        <a:buNone/>
+                      </a:pPr>
+                      <a:r>
+                        <a:rPr/>
+                        <a:t>145.002852</a:t>
+                      </a:r>
+                    </a:p>
+                  </a:txBody>
+                </a:tc>
+                <a:tc>
+                  <a:txBody>
+                    <a:bodyPr/>
+                    <a:lstStyle/>
+                    <a:p>
+                      <a:pPr lvl="0" indent="0" marL="0">
+                        <a:buNone/>
+                      </a:pPr>
+                      <a:r>
+                        <a:rPr/>
+                        <a:t>41.168470</a:t>
+                      </a:r>
+                    </a:p>
+                  </a:txBody>
+                </a:tc>
+                <a:tc>
+                  <a:txBody>
+                    <a:bodyPr/>
+                    <a:lstStyle/>
+                    <a:p>
+                      <a:pPr lvl="0" indent="0" marL="0">
+                        <a:buNone/>
+                      </a:pPr>
+                      <a:r>
+                        <a:rPr/>
+                        <a:t>0.144052</a:t>
+                      </a:r>
+                    </a:p>
+                  </a:txBody>
+                </a:tc>
+              </a:tr>
+              <a:tr h="0">
+                <a:tc>
+                  <a:txBody>
+                    <a:bodyPr/>
+                    <a:lstStyle/>
+                    <a:p>
+                      <a:pPr lvl="0" indent="0" marL="0">
+                        <a:buNone/>
+                      </a:pPr>
+                      <a:r>
+                        <a:rPr/>
+                        <a:t>4</a:t>
+                      </a:r>
+                    </a:p>
+                  </a:txBody>
+                </a:tc>
+                <a:tc>
+                  <a:txBody>
+                    <a:bodyPr/>
+                    <a:lstStyle/>
+                    <a:p>
+                      <a:pPr lvl="0" indent="0" marL="0">
+                        <a:buNone/>
+                      </a:pPr>
+                      <a:r>
+                        <a:rPr/>
+                        <a:t>balsam fir</a:t>
+                      </a:r>
+                    </a:p>
+                  </a:txBody>
+                </a:tc>
+                <a:tc>
+                  <a:txBody>
+                    <a:bodyPr/>
+                    <a:lstStyle/>
+                    <a:p>
+                      <a:pPr lvl="0" indent="0" marL="0">
+                        <a:buNone/>
+                      </a:pPr>
+                      <a:r>
+                        <a:rPr/>
+                        <a:t>6</a:t>
+                      </a:r>
+                    </a:p>
+                  </a:txBody>
+                </a:tc>
+                <a:tc>
+                  <a:txBody>
+                    <a:bodyPr/>
+                    <a:lstStyle/>
+                    <a:p>
+                      <a:pPr lvl="0" indent="0" marL="0">
+                        <a:buNone/>
+                      </a:pPr>
+                      <a:r>
+                        <a:rPr/>
+                        <a:t>147.449208</a:t>
+                      </a:r>
+                    </a:p>
+                  </a:txBody>
+                </a:tc>
+                <a:tc>
+                  <a:txBody>
+                    <a:bodyPr/>
+                    <a:lstStyle/>
+                    <a:p>
+                      <a:pPr lvl="0" indent="0" marL="0">
+                        <a:buNone/>
+                      </a:pPr>
+                      <a:r>
+                        <a:rPr/>
+                        <a:t>40.728609</a:t>
+                      </a:r>
+                    </a:p>
+                  </a:txBody>
+                </a:tc>
+                <a:tc>
+                  <a:txBody>
+                    <a:bodyPr/>
+                    <a:lstStyle/>
+                    <a:p>
+                      <a:pPr lvl="0" indent="0" marL="0">
+                        <a:buNone/>
+                      </a:pPr>
+                      <a:r>
+                        <a:rPr/>
+                        <a:t>0.142813</a:t>
+                      </a:r>
+                    </a:p>
+                  </a:txBody>
+                </a:tc>
+              </a:tr>
+              <a:tr h="0">
+                <a:tc>
+                  <a:txBody>
+                    <a:bodyPr/>
+                    <a:lstStyle/>
+                    <a:p>
+                      <a:pPr lvl="0" indent="0" marL="0">
+                        <a:buNone/>
+                      </a:pPr>
+                      <a:r>
+                        <a:rPr/>
+                        <a:t>5</a:t>
+                      </a:r>
+                    </a:p>
+                  </a:txBody>
+                </a:tc>
+                <a:tc>
+                  <a:txBody>
+                    <a:bodyPr/>
+                    <a:lstStyle/>
+                    <a:p>
+                      <a:pPr lvl="0" indent="0" marL="0">
+                        <a:buNone/>
+                      </a:pPr>
+                      <a:r>
+                        <a:rPr/>
+                        <a:t>balsam fir</a:t>
+                      </a:r>
+                    </a:p>
+                  </a:txBody>
+                </a:tc>
+                <a:tc>
+                  <a:txBody>
+                    <a:bodyPr/>
+                    <a:lstStyle/>
+                    <a:p>
+                      <a:pPr lvl="0" indent="0" marL="0">
+                        <a:buNone/>
+                      </a:pPr>
+                      <a:r>
+                        <a:rPr/>
+                        <a:t>7</a:t>
+                      </a:r>
+                    </a:p>
+                  </a:txBody>
+                </a:tc>
+                <a:tc>
+                  <a:txBody>
+                    <a:bodyPr/>
+                    <a:lstStyle/>
+                    <a:p>
+                      <a:pPr lvl="0" indent="0" marL="0">
+                        <a:buNone/>
+                      </a:pPr>
+                      <a:r>
+                        <a:rPr/>
+                        <a:t>153.474421</a:t>
+                      </a:r>
+                    </a:p>
+                  </a:txBody>
+                </a:tc>
+                <a:tc>
+                  <a:txBody>
+                    <a:bodyPr/>
+                    <a:lstStyle/>
+                    <a:p>
+                      <a:pPr lvl="0" indent="0" marL="0">
+                        <a:buNone/>
+                      </a:pPr>
+                      <a:r>
+                        <a:rPr/>
+                        <a:t>42.215118</a:t>
+                      </a:r>
+                    </a:p>
+                  </a:txBody>
+                </a:tc>
+                <a:tc>
+                  <a:txBody>
+                    <a:bodyPr/>
+                    <a:lstStyle/>
+                    <a:p>
+                      <a:pPr lvl="0" indent="0" marL="0">
+                        <a:buNone/>
+                      </a:pPr>
+                      <a:r>
+                        <a:rPr/>
+                        <a:t>0.149516</a:t>
+                      </a:r>
+                    </a:p>
+                  </a:txBody>
+                </a:tc>
+              </a:tr>
+              <a:tr h="0">
+                <a:tc>
+                  <a:txBody>
+                    <a:bodyPr/>
+                    <a:lstStyle/>
+                    <a:p>
+                      <a:pPr lvl="0" indent="0" marL="0">
+                        <a:buNone/>
+                      </a:pPr>
+                      <a:r>
+                        <a:rPr/>
+                        <a:t>6</a:t>
+                      </a:r>
+                    </a:p>
+                  </a:txBody>
+                </a:tc>
+                <a:tc>
+                  <a:txBody>
+                    <a:bodyPr/>
+                    <a:lstStyle/>
+                    <a:p>
+                      <a:pPr lvl="0" indent="0" marL="0">
+                        <a:buNone/>
+                      </a:pPr>
+                      <a:r>
+                        <a:rPr/>
+                        <a:t>balsam fir</a:t>
+                      </a:r>
+                    </a:p>
+                  </a:txBody>
+                </a:tc>
+                <a:tc>
+                  <a:txBody>
+                    <a:bodyPr/>
+                    <a:lstStyle/>
+                    <a:p>
+                      <a:pPr lvl="0" indent="0" marL="0">
+                        <a:buNone/>
+                      </a:pPr>
+                      <a:r>
+                        <a:rPr/>
+                        <a:t>8</a:t>
+                      </a:r>
+                    </a:p>
+                  </a:txBody>
+                </a:tc>
+                <a:tc>
+                  <a:txBody>
+                    <a:bodyPr/>
+                    <a:lstStyle/>
+                    <a:p>
+                      <a:pPr lvl="0" indent="0" marL="0">
+                        <a:buNone/>
+                      </a:pPr>
+                      <a:r>
+                        <a:rPr/>
+                        <a:t>156.768710</a:t>
+                      </a:r>
+                    </a:p>
+                  </a:txBody>
+                </a:tc>
+                <a:tc>
+                  <a:txBody>
+                    <a:bodyPr/>
+                    <a:lstStyle/>
+                    <a:p>
+                      <a:pPr lvl="0" indent="0" marL="0">
+                        <a:buNone/>
+                      </a:pPr>
+                      <a:r>
+                        <a:rPr/>
+                        <a:t>43.559217</a:t>
+                      </a:r>
+                    </a:p>
+                  </a:txBody>
+                </a:tc>
+                <a:tc>
+                  <a:txBody>
+                    <a:bodyPr/>
+                    <a:lstStyle/>
+                    <a:p>
+                      <a:pPr lvl="0" indent="0" marL="0">
+                        <a:buNone/>
+                      </a:pPr>
+                      <a:r>
+                        <a:rPr/>
+                        <a:t>0.154670</a:t>
+                      </a:r>
+                    </a:p>
+                  </a:txBody>
+                </a:tc>
+              </a:tr>
+              <a:tr h="0">
+                <a:tc>
+                  <a:txBody>
+                    <a:bodyPr/>
+                    <a:lstStyle/>
+                    <a:p>
+                      <a:pPr lvl="0" indent="0" marL="0">
+                        <a:buNone/>
+                      </a:pPr>
+                      <a:r>
+                        <a:rPr/>
+                        <a:t>7</a:t>
+                      </a:r>
+                    </a:p>
+                  </a:txBody>
+                </a:tc>
+                <a:tc>
+                  <a:txBody>
+                    <a:bodyPr/>
+                    <a:lstStyle/>
+                    <a:p>
+                      <a:pPr lvl="0" indent="0" marL="0">
+                        <a:buNone/>
+                      </a:pPr>
+                      <a:r>
+                        <a:rPr/>
+                        <a:t>balsam fir</a:t>
+                      </a:r>
+                    </a:p>
+                  </a:txBody>
+                </a:tc>
+                <a:tc>
+                  <a:txBody>
+                    <a:bodyPr/>
+                    <a:lstStyle/>
+                    <a:p>
+                      <a:pPr lvl="0" indent="0" marL="0">
+                        <a:buNone/>
+                      </a:pPr>
+                      <a:r>
+                        <a:rPr/>
+                        <a:t>9</a:t>
+                      </a:r>
+                    </a:p>
+                  </a:txBody>
+                </a:tc>
+                <a:tc>
+                  <a:txBody>
+                    <a:bodyPr/>
+                    <a:lstStyle/>
+                    <a:p>
+                      <a:pPr lvl="0" indent="0" marL="0">
+                        <a:buNone/>
+                      </a:pPr>
+                      <a:r>
+                        <a:rPr/>
+                        <a:t>161.016214</a:t>
+                      </a:r>
+                    </a:p>
+                  </a:txBody>
+                </a:tc>
+                <a:tc>
+                  <a:txBody>
+                    <a:bodyPr/>
+                    <a:lstStyle/>
+                    <a:p>
+                      <a:pPr lvl="0" indent="0" marL="0">
+                        <a:buNone/>
+                      </a:pPr>
+                      <a:r>
+                        <a:rPr/>
+                        <a:t>44.751469</a:t>
+                      </a:r>
+                    </a:p>
+                  </a:txBody>
+                </a:tc>
+                <a:tc>
+                  <a:txBody>
+                    <a:bodyPr/>
+                    <a:lstStyle/>
+                    <a:p>
+                      <a:pPr lvl="0" indent="0" marL="0">
+                        <a:buNone/>
+                      </a:pPr>
+                      <a:r>
+                        <a:rPr/>
+                        <a:t>0.160504</a:t>
+                      </a:r>
+                    </a:p>
+                  </a:txBody>
+                </a:tc>
+              </a:tr>
+              <a:tr h="0">
+                <a:tc>
+                  <a:txBody>
+                    <a:bodyPr/>
+                    <a:lstStyle/>
+                    <a:p>
+                      <a:pPr lvl="0" indent="0" marL="0">
+                        <a:buNone/>
+                      </a:pPr>
+                      <a:r>
+                        <a:rPr/>
+                        <a:t>8</a:t>
+                      </a:r>
+                    </a:p>
+                  </a:txBody>
+                </a:tc>
+                <a:tc>
+                  <a:txBody>
+                    <a:bodyPr/>
+                    <a:lstStyle/>
+                    <a:p>
+                      <a:pPr lvl="0" indent="0" marL="0">
+                        <a:buNone/>
+                      </a:pPr>
+                      <a:r>
+                        <a:rPr/>
+                        <a:t>balsam fir</a:t>
+                      </a:r>
+                    </a:p>
+                  </a:txBody>
+                </a:tc>
+                <a:tc>
+                  <a:txBody>
+                    <a:bodyPr/>
+                    <a:lstStyle/>
+                    <a:p>
+                      <a:pPr lvl="0" indent="0" marL="0">
+                        <a:buNone/>
+                      </a:pPr>
+                      <a:r>
+                        <a:rPr/>
+                        <a:t>10</a:t>
+                      </a:r>
+                    </a:p>
+                  </a:txBody>
+                </a:tc>
+                <a:tc>
+                  <a:txBody>
+                    <a:bodyPr/>
+                    <a:lstStyle/>
+                    <a:p>
+                      <a:pPr lvl="0" indent="0" marL="0">
+                        <a:buNone/>
+                      </a:pPr>
+                      <a:r>
+                        <a:rPr/>
+                        <a:t>157.999921</a:t>
+                      </a:r>
+                    </a:p>
+                  </a:txBody>
+                </a:tc>
+                <a:tc>
+                  <a:txBody>
+                    <a:bodyPr/>
+                    <a:lstStyle/>
+                    <a:p>
+                      <a:pPr lvl="0" indent="0" marL="0">
+                        <a:buNone/>
+                      </a:pPr>
+                      <a:r>
+                        <a:rPr/>
+                        <a:t>44.694861</a:t>
+                      </a:r>
+                    </a:p>
+                  </a:txBody>
+                </a:tc>
+                <a:tc>
+                  <a:txBody>
+                    <a:bodyPr/>
+                    <a:lstStyle/>
+                    <a:p>
+                      <a:pPr lvl="0" indent="0" marL="0">
+                        <a:buNone/>
+                      </a:pPr>
+                      <a:r>
+                        <a:rPr/>
+                        <a:t>0.160057</a:t>
+                      </a:r>
+                    </a:p>
+                  </a:txBody>
+                </a:tc>
+              </a:tr>
+            </a:tbl>
+          </a:graphicData>
+        </a:graphic>
+      </p:graphicFrame>
     </p:spTree>
   </p:cSld>
 </p:sld>
@@ -3692,1147 +4621,47 @@
             </a:pPr>
             <a:r>
               <a:rPr/>
-              <a:t>Model</a:t>
+              <a:t>Average Root Mean Square Logarithmic Error</a:t>
             </a:r>
           </a:p>
         </p:txBody>
       </p:sp>
-      <p:graphicFrame>
-        <p:nvGraphicFramePr>
-          <p:cNvPr id="6" name="Content Placeholder 5"/>
-          <p:cNvGraphicFramePr>
-            <a:graphicFrameLocks noGrp="1"/>
-          </p:cNvGraphicFramePr>
+      <p:sp>
+        <p:nvSpPr>
+          <p:cNvPr id="3" name="Content Placeholder 2"/>
+          <p:cNvSpPr>
+            <a:spLocks noGrp="1"/>
+          </p:cNvSpPr>
           <p:nvPr>
             <p:ph idx="1"/>
           </p:nvPr>
-        </p:nvGraphicFramePr>
-        <p:xfrm>
-          <a:off x="457200" y="1193800"/>
-          <a:ext cx="8229600" cy="3390900"/>
-        </p:xfrm>
-        <a:graphic>
-          <a:graphicData uri="http://schemas.openxmlformats.org/drawingml/2006/table">
-            <a:tbl>
-              <a:tblPr firstRow="1" bandRow="1">
-                <a:tableStyleId>{5C22544A-7EE6-4342-B048-85BDC9FD1C3A}</a:tableStyleId>
-              </a:tblPr>
-              <a:tblGrid>
-                <a:gridCol w="1371600"/>
-                <a:gridCol w="1371600"/>
-                <a:gridCol w="1371600"/>
-                <a:gridCol w="1371600"/>
-                <a:gridCol w="1371600"/>
-                <a:gridCol w="1371600"/>
-              </a:tblGrid>
-              <a:tr h="0">
-                <a:tc>
-                  <a:txBody>
-                    <a:bodyPr/>
-                    <a:lstStyle/>
-                    <a:p>
-                      <a:endParaRPr/>
-                    </a:p>
-                  </a:txBody>
-                  <a:tcPr/>
-                </a:tc>
-                <a:tc>
-                  <a:txBody>
-                    <a:bodyPr/>
-                    <a:lstStyle/>
-                    <a:p>
-                      <a:pPr lvl="0" indent="0" marL="0">
-                        <a:buNone/>
-                      </a:pPr>
-                      <a:r>
-                        <a:rPr/>
-                        <a:t>Species</a:t>
-                      </a:r>
-                    </a:p>
-                  </a:txBody>
-                  <a:tcPr/>
-                </a:tc>
-                <a:tc>
-                  <a:txBody>
-                    <a:bodyPr/>
-                    <a:lstStyle/>
-                    <a:p>
-                      <a:pPr lvl="0" indent="0" marL="0">
-                        <a:buNone/>
-                      </a:pPr>
-                      <a:r>
-                        <a:rPr/>
-                        <a:t>k</a:t>
-                      </a:r>
-                    </a:p>
-                  </a:txBody>
-                  <a:tcPr/>
-                </a:tc>
-                <a:tc>
-                  <a:txBody>
-                    <a:bodyPr/>
-                    <a:lstStyle/>
-                    <a:p>
-                      <a:pPr lvl="0" indent="0" marL="0">
-                        <a:buNone/>
-                      </a:pPr>
-                      <a:r>
-                        <a:rPr/>
-                        <a:t>RMSE</a:t>
-                      </a:r>
-                    </a:p>
-                  </a:txBody>
-                  <a:tcPr/>
-                </a:tc>
-                <a:tc>
-                  <a:txBody>
-                    <a:bodyPr/>
-                    <a:lstStyle/>
-                    <a:p>
-                      <a:pPr lvl="0" indent="0" marL="0">
-                        <a:buNone/>
-                      </a:pPr>
-                      <a:r>
-                        <a:rPr/>
-                        <a:t>MAE</a:t>
-                      </a:r>
-                    </a:p>
-                  </a:txBody>
-                  <a:tcPr/>
-                </a:tc>
-                <a:tc>
-                  <a:txBody>
-                    <a:bodyPr/>
-                    <a:lstStyle/>
-                    <a:p>
-                      <a:pPr lvl="0" indent="0" marL="0">
-                        <a:buNone/>
-                      </a:pPr>
-                      <a:r>
-                        <a:rPr/>
-                        <a:t>RMSLE</a:t>
-                      </a:r>
-                    </a:p>
-                  </a:txBody>
-                  <a:tcPr/>
-                </a:tc>
-              </a:tr>
-              <a:tr h="0">
-                <a:tc>
-                  <a:txBody>
-                    <a:bodyPr/>
-                    <a:lstStyle/>
-                    <a:p>
-                      <a:pPr lvl="0" indent="0" marL="0">
-                        <a:buNone/>
-                      </a:pPr>
-                      <a:r>
-                        <a:rPr/>
-                        <a:t>0</a:t>
-                      </a:r>
-                    </a:p>
-                  </a:txBody>
-                </a:tc>
-                <a:tc>
-                  <a:txBody>
-                    <a:bodyPr/>
-                    <a:lstStyle/>
-                    <a:p>
-                      <a:pPr lvl="0" indent="0" marL="0">
-                        <a:buNone/>
-                      </a:pPr>
-                      <a:r>
-                        <a:rPr/>
-                        <a:t>balsam fir</a:t>
-                      </a:r>
-                    </a:p>
-                  </a:txBody>
-                </a:tc>
-                <a:tc>
-                  <a:txBody>
-                    <a:bodyPr/>
-                    <a:lstStyle/>
-                    <a:p>
-                      <a:pPr lvl="0" indent="0" marL="0">
-                        <a:buNone/>
-                      </a:pPr>
-                      <a:r>
-                        <a:rPr/>
-                        <a:t>2</a:t>
-                      </a:r>
-                    </a:p>
-                  </a:txBody>
-                </a:tc>
-                <a:tc>
-                  <a:txBody>
-                    <a:bodyPr/>
-                    <a:lstStyle/>
-                    <a:p>
-                      <a:pPr lvl="0" indent="0" marL="0">
-                        <a:buNone/>
-                      </a:pPr>
-                      <a:r>
-                        <a:rPr/>
-                        <a:t>125.827396</a:t>
-                      </a:r>
-                    </a:p>
-                  </a:txBody>
-                </a:tc>
-                <a:tc>
-                  <a:txBody>
-                    <a:bodyPr/>
-                    <a:lstStyle/>
-                    <a:p>
-                      <a:pPr lvl="0" indent="0" marL="0">
-                        <a:buNone/>
-                      </a:pPr>
-                      <a:r>
-                        <a:rPr/>
-                        <a:t>34.820565</a:t>
-                      </a:r>
-                    </a:p>
-                  </a:txBody>
-                </a:tc>
-                <a:tc>
-                  <a:txBody>
-                    <a:bodyPr/>
-                    <a:lstStyle/>
-                    <a:p>
-                      <a:pPr lvl="0" indent="0" marL="0">
-                        <a:buNone/>
-                      </a:pPr>
-                      <a:r>
-                        <a:rPr/>
-                        <a:t>0.119617</a:t>
-                      </a:r>
-                    </a:p>
-                  </a:txBody>
-                </a:tc>
-              </a:tr>
-              <a:tr h="0">
-                <a:tc>
-                  <a:txBody>
-                    <a:bodyPr/>
-                    <a:lstStyle/>
-                    <a:p>
-                      <a:pPr lvl="0" indent="0" marL="0">
-                        <a:buNone/>
-                      </a:pPr>
-                      <a:r>
-                        <a:rPr/>
-                        <a:t>1</a:t>
-                      </a:r>
-                    </a:p>
-                  </a:txBody>
-                </a:tc>
-                <a:tc>
-                  <a:txBody>
-                    <a:bodyPr/>
-                    <a:lstStyle/>
-                    <a:p>
-                      <a:pPr lvl="0" indent="0" marL="0">
-                        <a:buNone/>
-                      </a:pPr>
-                      <a:r>
-                        <a:rPr/>
-                        <a:t>balsam fir</a:t>
-                      </a:r>
-                    </a:p>
-                  </a:txBody>
-                </a:tc>
-                <a:tc>
-                  <a:txBody>
-                    <a:bodyPr/>
-                    <a:lstStyle/>
-                    <a:p>
-                      <a:pPr lvl="0" indent="0" marL="0">
-                        <a:buNone/>
-                      </a:pPr>
-                      <a:r>
-                        <a:rPr/>
-                        <a:t>3</a:t>
-                      </a:r>
-                    </a:p>
-                  </a:txBody>
-                </a:tc>
-                <a:tc>
-                  <a:txBody>
-                    <a:bodyPr/>
-                    <a:lstStyle/>
-                    <a:p>
-                      <a:pPr lvl="0" indent="0" marL="0">
-                        <a:buNone/>
-                      </a:pPr>
-                      <a:r>
-                        <a:rPr/>
-                        <a:t>129.650855</a:t>
-                      </a:r>
-                    </a:p>
-                  </a:txBody>
-                </a:tc>
-                <a:tc>
-                  <a:txBody>
-                    <a:bodyPr/>
-                    <a:lstStyle/>
-                    <a:p>
-                      <a:pPr lvl="0" indent="0" marL="0">
-                        <a:buNone/>
-                      </a:pPr>
-                      <a:r>
-                        <a:rPr/>
-                        <a:t>36.628377</a:t>
-                      </a:r>
-                    </a:p>
-                  </a:txBody>
-                </a:tc>
-                <a:tc>
-                  <a:txBody>
-                    <a:bodyPr/>
-                    <a:lstStyle/>
-                    <a:p>
-                      <a:pPr lvl="0" indent="0" marL="0">
-                        <a:buNone/>
-                      </a:pPr>
-                      <a:r>
-                        <a:rPr/>
-                        <a:t>0.123679</a:t>
-                      </a:r>
-                    </a:p>
-                  </a:txBody>
-                </a:tc>
-              </a:tr>
-              <a:tr h="0">
-                <a:tc>
-                  <a:txBody>
-                    <a:bodyPr/>
-                    <a:lstStyle/>
-                    <a:p>
-                      <a:pPr lvl="0" indent="0" marL="0">
-                        <a:buNone/>
-                      </a:pPr>
-                      <a:r>
-                        <a:rPr/>
-                        <a:t>2</a:t>
-                      </a:r>
-                    </a:p>
-                  </a:txBody>
-                </a:tc>
-                <a:tc>
-                  <a:txBody>
-                    <a:bodyPr/>
-                    <a:lstStyle/>
-                    <a:p>
-                      <a:pPr lvl="0" indent="0" marL="0">
-                        <a:buNone/>
-                      </a:pPr>
-                      <a:r>
-                        <a:rPr/>
-                        <a:t>balsam fir</a:t>
-                      </a:r>
-                    </a:p>
-                  </a:txBody>
-                </a:tc>
-                <a:tc>
-                  <a:txBody>
-                    <a:bodyPr/>
-                    <a:lstStyle/>
-                    <a:p>
-                      <a:pPr lvl="0" indent="0" marL="0">
-                        <a:buNone/>
-                      </a:pPr>
-                      <a:r>
-                        <a:rPr/>
-                        <a:t>4</a:t>
-                      </a:r>
-                    </a:p>
-                  </a:txBody>
-                </a:tc>
-                <a:tc>
-                  <a:txBody>
-                    <a:bodyPr/>
-                    <a:lstStyle/>
-                    <a:p>
-                      <a:pPr lvl="0" indent="0" marL="0">
-                        <a:buNone/>
-                      </a:pPr>
-                      <a:r>
-                        <a:rPr/>
-                        <a:t>134.599829</a:t>
-                      </a:r>
-                    </a:p>
-                  </a:txBody>
-                </a:tc>
-                <a:tc>
-                  <a:txBody>
-                    <a:bodyPr/>
-                    <a:lstStyle/>
-                    <a:p>
-                      <a:pPr lvl="0" indent="0" marL="0">
-                        <a:buNone/>
-                      </a:pPr>
-                      <a:r>
-                        <a:rPr/>
-                        <a:t>38.884870</a:t>
-                      </a:r>
-                    </a:p>
-                  </a:txBody>
-                </a:tc>
-                <a:tc>
-                  <a:txBody>
-                    <a:bodyPr/>
-                    <a:lstStyle/>
-                    <a:p>
-                      <a:pPr lvl="0" indent="0" marL="0">
-                        <a:buNone/>
-                      </a:pPr>
-                      <a:r>
-                        <a:rPr/>
-                        <a:t>0.133858</a:t>
-                      </a:r>
-                    </a:p>
-                  </a:txBody>
-                </a:tc>
-              </a:tr>
-              <a:tr h="0">
-                <a:tc>
-                  <a:txBody>
-                    <a:bodyPr/>
-                    <a:lstStyle/>
-                    <a:p>
-                      <a:pPr lvl="0" indent="0" marL="0">
-                        <a:buNone/>
-                      </a:pPr>
-                      <a:r>
-                        <a:rPr/>
-                        <a:t>3</a:t>
-                      </a:r>
-                    </a:p>
-                  </a:txBody>
-                </a:tc>
-                <a:tc>
-                  <a:txBody>
-                    <a:bodyPr/>
-                    <a:lstStyle/>
-                    <a:p>
-                      <a:pPr lvl="0" indent="0" marL="0">
-                        <a:buNone/>
-                      </a:pPr>
-                      <a:r>
-                        <a:rPr/>
-                        <a:t>balsam fir</a:t>
-                      </a:r>
-                    </a:p>
-                  </a:txBody>
-                </a:tc>
-                <a:tc>
-                  <a:txBody>
-                    <a:bodyPr/>
-                    <a:lstStyle/>
-                    <a:p>
-                      <a:pPr lvl="0" indent="0" marL="0">
-                        <a:buNone/>
-                      </a:pPr>
-                      <a:r>
-                        <a:rPr/>
-                        <a:t>5</a:t>
-                      </a:r>
-                    </a:p>
-                  </a:txBody>
-                </a:tc>
-                <a:tc>
-                  <a:txBody>
-                    <a:bodyPr/>
-                    <a:lstStyle/>
-                    <a:p>
-                      <a:pPr lvl="0" indent="0" marL="0">
-                        <a:buNone/>
-                      </a:pPr>
-                      <a:r>
-                        <a:rPr/>
-                        <a:t>145.002852</a:t>
-                      </a:r>
-                    </a:p>
-                  </a:txBody>
-                </a:tc>
-                <a:tc>
-                  <a:txBody>
-                    <a:bodyPr/>
-                    <a:lstStyle/>
-                    <a:p>
-                      <a:pPr lvl="0" indent="0" marL="0">
-                        <a:buNone/>
-                      </a:pPr>
-                      <a:r>
-                        <a:rPr/>
-                        <a:t>41.168470</a:t>
-                      </a:r>
-                    </a:p>
-                  </a:txBody>
-                </a:tc>
-                <a:tc>
-                  <a:txBody>
-                    <a:bodyPr/>
-                    <a:lstStyle/>
-                    <a:p>
-                      <a:pPr lvl="0" indent="0" marL="0">
-                        <a:buNone/>
-                      </a:pPr>
-                      <a:r>
-                        <a:rPr/>
-                        <a:t>0.144052</a:t>
-                      </a:r>
-                    </a:p>
-                  </a:txBody>
-                </a:tc>
-              </a:tr>
-              <a:tr h="0">
-                <a:tc>
-                  <a:txBody>
-                    <a:bodyPr/>
-                    <a:lstStyle/>
-                    <a:p>
-                      <a:pPr lvl="0" indent="0" marL="0">
-                        <a:buNone/>
-                      </a:pPr>
-                      <a:r>
-                        <a:rPr/>
-                        <a:t>4</a:t>
-                      </a:r>
-                    </a:p>
-                  </a:txBody>
-                </a:tc>
-                <a:tc>
-                  <a:txBody>
-                    <a:bodyPr/>
-                    <a:lstStyle/>
-                    <a:p>
-                      <a:pPr lvl="0" indent="0" marL="0">
-                        <a:buNone/>
-                      </a:pPr>
-                      <a:r>
-                        <a:rPr/>
-                        <a:t>balsam fir</a:t>
-                      </a:r>
-                    </a:p>
-                  </a:txBody>
-                </a:tc>
-                <a:tc>
-                  <a:txBody>
-                    <a:bodyPr/>
-                    <a:lstStyle/>
-                    <a:p>
-                      <a:pPr lvl="0" indent="0" marL="0">
-                        <a:buNone/>
-                      </a:pPr>
-                      <a:r>
-                        <a:rPr/>
-                        <a:t>6</a:t>
-                      </a:r>
-                    </a:p>
-                  </a:txBody>
-                </a:tc>
-                <a:tc>
-                  <a:txBody>
-                    <a:bodyPr/>
-                    <a:lstStyle/>
-                    <a:p>
-                      <a:pPr lvl="0" indent="0" marL="0">
-                        <a:buNone/>
-                      </a:pPr>
-                      <a:r>
-                        <a:rPr/>
-                        <a:t>147.449208</a:t>
-                      </a:r>
-                    </a:p>
-                  </a:txBody>
-                </a:tc>
-                <a:tc>
-                  <a:txBody>
-                    <a:bodyPr/>
-                    <a:lstStyle/>
-                    <a:p>
-                      <a:pPr lvl="0" indent="0" marL="0">
-                        <a:buNone/>
-                      </a:pPr>
-                      <a:r>
-                        <a:rPr/>
-                        <a:t>40.728609</a:t>
-                      </a:r>
-                    </a:p>
-                  </a:txBody>
-                </a:tc>
-                <a:tc>
-                  <a:txBody>
-                    <a:bodyPr/>
-                    <a:lstStyle/>
-                    <a:p>
-                      <a:pPr lvl="0" indent="0" marL="0">
-                        <a:buNone/>
-                      </a:pPr>
-                      <a:r>
-                        <a:rPr/>
-                        <a:t>0.142813</a:t>
-                      </a:r>
-                    </a:p>
-                  </a:txBody>
-                </a:tc>
-              </a:tr>
-              <a:tr h="0">
-                <a:tc>
-                  <a:txBody>
-                    <a:bodyPr/>
-                    <a:lstStyle/>
-                    <a:p>
-                      <a:pPr lvl="0" indent="0" marL="0">
-                        <a:buNone/>
-                      </a:pPr>
-                      <a:r>
-                        <a:rPr/>
-                        <a:t>...</a:t>
-                      </a:r>
-                    </a:p>
-                  </a:txBody>
-                </a:tc>
-                <a:tc>
-                  <a:txBody>
-                    <a:bodyPr/>
-                    <a:lstStyle/>
-                    <a:p>
-                      <a:pPr lvl="0" indent="0" marL="0">
-                        <a:buNone/>
-                      </a:pPr>
-                      <a:r>
-                        <a:rPr/>
-                        <a:t>...</a:t>
-                      </a:r>
-                    </a:p>
-                  </a:txBody>
-                </a:tc>
-                <a:tc>
-                  <a:txBody>
-                    <a:bodyPr/>
-                    <a:lstStyle/>
-                    <a:p>
-                      <a:pPr lvl="0" indent="0" marL="0">
-                        <a:buNone/>
-                      </a:pPr>
-                      <a:r>
-                        <a:rPr/>
-                        <a:t>...</a:t>
-                      </a:r>
-                    </a:p>
-                  </a:txBody>
-                </a:tc>
-                <a:tc>
-                  <a:txBody>
-                    <a:bodyPr/>
-                    <a:lstStyle/>
-                    <a:p>
-                      <a:pPr lvl="0" indent="0" marL="0">
-                        <a:buNone/>
-                      </a:pPr>
-                      <a:r>
-                        <a:rPr/>
-                        <a:t>...</a:t>
-                      </a:r>
-                    </a:p>
-                  </a:txBody>
-                </a:tc>
-                <a:tc>
-                  <a:txBody>
-                    <a:bodyPr/>
-                    <a:lstStyle/>
-                    <a:p>
-                      <a:pPr lvl="0" indent="0" marL="0">
-                        <a:buNone/>
-                      </a:pPr>
-                      <a:r>
-                        <a:rPr/>
-                        <a:t>...</a:t>
-                      </a:r>
-                    </a:p>
-                  </a:txBody>
-                </a:tc>
-                <a:tc>
-                  <a:txBody>
-                    <a:bodyPr/>
-                    <a:lstStyle/>
-                    <a:p>
-                      <a:pPr lvl="0" indent="0" marL="0">
-                        <a:buNone/>
-                      </a:pPr>
-                      <a:r>
-                        <a:rPr/>
-                        <a:t>...</a:t>
-                      </a:r>
-                    </a:p>
-                  </a:txBody>
-                </a:tc>
-              </a:tr>
-              <a:tr h="0">
-                <a:tc>
-                  <a:txBody>
-                    <a:bodyPr/>
-                    <a:lstStyle/>
-                    <a:p>
-                      <a:pPr lvl="0" indent="0" marL="0">
-                        <a:buNone/>
-                      </a:pPr>
-                      <a:r>
-                        <a:rPr/>
-                        <a:t>895</a:t>
-                      </a:r>
-                    </a:p>
-                  </a:txBody>
-                </a:tc>
-                <a:tc>
-                  <a:txBody>
-                    <a:bodyPr/>
-                    <a:lstStyle/>
-                    <a:p>
-                      <a:pPr lvl="0" indent="0" marL="0">
-                        <a:buNone/>
-                      </a:pPr>
-                      <a:r>
-                        <a:rPr/>
-                        <a:t>sugarberry</a:t>
-                      </a:r>
-                    </a:p>
-                  </a:txBody>
-                </a:tc>
-                <a:tc>
-                  <a:txBody>
-                    <a:bodyPr/>
-                    <a:lstStyle/>
-                    <a:p>
-                      <a:pPr lvl="0" indent="0" marL="0">
-                        <a:buNone/>
-                      </a:pPr>
-                      <a:r>
-                        <a:rPr/>
-                        <a:t>6</a:t>
-                      </a:r>
-                    </a:p>
-                  </a:txBody>
-                </a:tc>
-                <a:tc>
-                  <a:txBody>
-                    <a:bodyPr/>
-                    <a:lstStyle/>
-                    <a:p>
-                      <a:pPr lvl="0" indent="0" marL="0">
-                        <a:buNone/>
-                      </a:pPr>
-                      <a:r>
-                        <a:rPr/>
-                        <a:t>32.431052</a:t>
-                      </a:r>
-                    </a:p>
-                  </a:txBody>
-                </a:tc>
-                <a:tc>
-                  <a:txBody>
-                    <a:bodyPr/>
-                    <a:lstStyle/>
-                    <a:p>
-                      <a:pPr lvl="0" indent="0" marL="0">
-                        <a:buNone/>
-                      </a:pPr>
-                      <a:r>
-                        <a:rPr/>
-                        <a:t>20.969306</a:t>
-                      </a:r>
-                    </a:p>
-                  </a:txBody>
-                </a:tc>
-                <a:tc>
-                  <a:txBody>
-                    <a:bodyPr/>
-                    <a:lstStyle/>
-                    <a:p>
-                      <a:pPr lvl="0" indent="0" marL="0">
-                        <a:buNone/>
-                      </a:pPr>
-                      <a:r>
-                        <a:rPr/>
-                        <a:t>0.565727</a:t>
-                      </a:r>
-                    </a:p>
-                  </a:txBody>
-                </a:tc>
-              </a:tr>
-              <a:tr h="0">
-                <a:tc>
-                  <a:txBody>
-                    <a:bodyPr/>
-                    <a:lstStyle/>
-                    <a:p>
-                      <a:pPr lvl="0" indent="0" marL="0">
-                        <a:buNone/>
-                      </a:pPr>
-                      <a:r>
-                        <a:rPr/>
-                        <a:t>896</a:t>
-                      </a:r>
-                    </a:p>
-                  </a:txBody>
-                </a:tc>
-                <a:tc>
-                  <a:txBody>
-                    <a:bodyPr/>
-                    <a:lstStyle/>
-                    <a:p>
-                      <a:pPr lvl="0" indent="0" marL="0">
-                        <a:buNone/>
-                      </a:pPr>
-                      <a:r>
-                        <a:rPr/>
-                        <a:t>sugarberry</a:t>
-                      </a:r>
-                    </a:p>
-                  </a:txBody>
-                </a:tc>
-                <a:tc>
-                  <a:txBody>
-                    <a:bodyPr/>
-                    <a:lstStyle/>
-                    <a:p>
-                      <a:pPr lvl="0" indent="0" marL="0">
-                        <a:buNone/>
-                      </a:pPr>
-                      <a:r>
-                        <a:rPr/>
-                        <a:t>7</a:t>
-                      </a:r>
-                    </a:p>
-                  </a:txBody>
-                </a:tc>
-                <a:tc>
-                  <a:txBody>
-                    <a:bodyPr/>
-                    <a:lstStyle/>
-                    <a:p>
-                      <a:pPr lvl="0" indent="0" marL="0">
-                        <a:buNone/>
-                      </a:pPr>
-                      <a:r>
-                        <a:rPr/>
-                        <a:t>37.324259</a:t>
-                      </a:r>
-                    </a:p>
-                  </a:txBody>
-                </a:tc>
-                <a:tc>
-                  <a:txBody>
-                    <a:bodyPr/>
-                    <a:lstStyle/>
-                    <a:p>
-                      <a:pPr lvl="0" indent="0" marL="0">
-                        <a:buNone/>
-                      </a:pPr>
-                      <a:r>
-                        <a:rPr/>
-                        <a:t>25.037024</a:t>
-                      </a:r>
-                    </a:p>
-                  </a:txBody>
-                </a:tc>
-                <a:tc>
-                  <a:txBody>
-                    <a:bodyPr/>
-                    <a:lstStyle/>
-                    <a:p>
-                      <a:pPr lvl="0" indent="0" marL="0">
-                        <a:buNone/>
-                      </a:pPr>
-                      <a:r>
-                        <a:rPr/>
-                        <a:t>0.637629</a:t>
-                      </a:r>
-                    </a:p>
-                  </a:txBody>
-                </a:tc>
-              </a:tr>
-              <a:tr h="0">
-                <a:tc>
-                  <a:txBody>
-                    <a:bodyPr/>
-                    <a:lstStyle/>
-                    <a:p>
-                      <a:pPr lvl="0" indent="0" marL="0">
-                        <a:buNone/>
-                      </a:pPr>
-                      <a:r>
-                        <a:rPr/>
-                        <a:t>897</a:t>
-                      </a:r>
-                    </a:p>
-                  </a:txBody>
-                </a:tc>
-                <a:tc>
-                  <a:txBody>
-                    <a:bodyPr/>
-                    <a:lstStyle/>
-                    <a:p>
-                      <a:pPr lvl="0" indent="0" marL="0">
-                        <a:buNone/>
-                      </a:pPr>
-                      <a:r>
-                        <a:rPr/>
-                        <a:t>sugarberry</a:t>
-                      </a:r>
-                    </a:p>
-                  </a:txBody>
-                </a:tc>
-                <a:tc>
-                  <a:txBody>
-                    <a:bodyPr/>
-                    <a:lstStyle/>
-                    <a:p>
-                      <a:pPr lvl="0" indent="0" marL="0">
-                        <a:buNone/>
-                      </a:pPr>
-                      <a:r>
-                        <a:rPr/>
-                        <a:t>8</a:t>
-                      </a:r>
-                    </a:p>
-                  </a:txBody>
-                </a:tc>
-                <a:tc>
-                  <a:txBody>
-                    <a:bodyPr/>
-                    <a:lstStyle/>
-                    <a:p>
-                      <a:pPr lvl="0" indent="0" marL="0">
-                        <a:buNone/>
-                      </a:pPr>
-                      <a:r>
-                        <a:rPr/>
-                        <a:t>38.144756</a:t>
-                      </a:r>
-                    </a:p>
-                  </a:txBody>
-                </a:tc>
-                <a:tc>
-                  <a:txBody>
-                    <a:bodyPr/>
-                    <a:lstStyle/>
-                    <a:p>
-                      <a:pPr lvl="0" indent="0" marL="0">
-                        <a:buNone/>
-                      </a:pPr>
-                      <a:r>
-                        <a:rPr/>
-                        <a:t>26.680208</a:t>
-                      </a:r>
-                    </a:p>
-                  </a:txBody>
-                </a:tc>
-                <a:tc>
-                  <a:txBody>
-                    <a:bodyPr/>
-                    <a:lstStyle/>
-                    <a:p>
-                      <a:pPr lvl="0" indent="0" marL="0">
-                        <a:buNone/>
-                      </a:pPr>
-                      <a:r>
-                        <a:rPr/>
-                        <a:t>0.665159</a:t>
-                      </a:r>
-                    </a:p>
-                  </a:txBody>
-                </a:tc>
-              </a:tr>
-              <a:tr h="0">
-                <a:tc>
-                  <a:txBody>
-                    <a:bodyPr/>
-                    <a:lstStyle/>
-                    <a:p>
-                      <a:pPr lvl="0" indent="0" marL="0">
-                        <a:buNone/>
-                      </a:pPr>
-                      <a:r>
-                        <a:rPr/>
-                        <a:t>898</a:t>
-                      </a:r>
-                    </a:p>
-                  </a:txBody>
-                </a:tc>
-                <a:tc>
-                  <a:txBody>
-                    <a:bodyPr/>
-                    <a:lstStyle/>
-                    <a:p>
-                      <a:pPr lvl="0" indent="0" marL="0">
-                        <a:buNone/>
-                      </a:pPr>
-                      <a:r>
-                        <a:rPr/>
-                        <a:t>sugarberry</a:t>
-                      </a:r>
-                    </a:p>
-                  </a:txBody>
-                </a:tc>
-                <a:tc>
-                  <a:txBody>
-                    <a:bodyPr/>
-                    <a:lstStyle/>
-                    <a:p>
-                      <a:pPr lvl="0" indent="0" marL="0">
-                        <a:buNone/>
-                      </a:pPr>
-                      <a:r>
-                        <a:rPr/>
-                        <a:t>9</a:t>
-                      </a:r>
-                    </a:p>
-                  </a:txBody>
-                </a:tc>
-                <a:tc>
-                  <a:txBody>
-                    <a:bodyPr/>
-                    <a:lstStyle/>
-                    <a:p>
-                      <a:pPr lvl="0" indent="0" marL="0">
-                        <a:buNone/>
-                      </a:pPr>
-                      <a:r>
-                        <a:rPr/>
-                        <a:t>36.853245</a:t>
-                      </a:r>
-                    </a:p>
-                  </a:txBody>
-                </a:tc>
-                <a:tc>
-                  <a:txBody>
-                    <a:bodyPr/>
-                    <a:lstStyle/>
-                    <a:p>
-                      <a:pPr lvl="0" indent="0" marL="0">
-                        <a:buNone/>
-                      </a:pPr>
-                      <a:r>
-                        <a:rPr/>
-                        <a:t>21.021667</a:t>
-                      </a:r>
-                    </a:p>
-                  </a:txBody>
-                </a:tc>
-                <a:tc>
-                  <a:txBody>
-                    <a:bodyPr/>
-                    <a:lstStyle/>
-                    <a:p>
-                      <a:pPr lvl="0" indent="0" marL="0">
-                        <a:buNone/>
-                      </a:pPr>
-                      <a:r>
-                        <a:rPr/>
-                        <a:t>0.685162</a:t>
-                      </a:r>
-                    </a:p>
-                  </a:txBody>
-                </a:tc>
-              </a:tr>
-              <a:tr h="0">
-                <a:tc>
-                  <a:txBody>
-                    <a:bodyPr/>
-                    <a:lstStyle/>
-                    <a:p>
-                      <a:pPr lvl="0" indent="0" marL="0">
-                        <a:buNone/>
-                      </a:pPr>
-                      <a:r>
-                        <a:rPr/>
-                        <a:t>899</a:t>
-                      </a:r>
-                    </a:p>
-                  </a:txBody>
-                </a:tc>
-                <a:tc>
-                  <a:txBody>
-                    <a:bodyPr/>
-                    <a:lstStyle/>
-                    <a:p>
-                      <a:pPr lvl="0" indent="0" marL="0">
-                        <a:buNone/>
-                      </a:pPr>
-                      <a:r>
-                        <a:rPr/>
-                        <a:t>sugarberry</a:t>
-                      </a:r>
-                    </a:p>
-                  </a:txBody>
-                </a:tc>
-                <a:tc>
-                  <a:txBody>
-                    <a:bodyPr/>
-                    <a:lstStyle/>
-                    <a:p>
-                      <a:pPr lvl="0" indent="0" marL="0">
-                        <a:buNone/>
-                      </a:pPr>
-                      <a:r>
-                        <a:rPr/>
-                        <a:t>10</a:t>
-                      </a:r>
-                    </a:p>
-                  </a:txBody>
-                </a:tc>
-                <a:tc>
-                  <a:txBody>
-                    <a:bodyPr/>
-                    <a:lstStyle/>
-                    <a:p>
-                      <a:pPr lvl="0" indent="0" marL="0">
-                        <a:buNone/>
-                      </a:pPr>
-                      <a:r>
-                        <a:rPr/>
-                        <a:t>40.091106</a:t>
-                      </a:r>
-                    </a:p>
-                  </a:txBody>
-                </a:tc>
-                <a:tc>
-                  <a:txBody>
-                    <a:bodyPr/>
-                    <a:lstStyle/>
-                    <a:p>
-                      <a:pPr lvl="0" indent="0" marL="0">
-                        <a:buNone/>
-                      </a:pPr>
-                      <a:r>
-                        <a:rPr/>
-                        <a:t>23.172083</a:t>
-                      </a:r>
-                    </a:p>
-                  </a:txBody>
-                </a:tc>
-                <a:tc>
-                  <a:txBody>
-                    <a:bodyPr/>
-                    <a:lstStyle/>
-                    <a:p>
-                      <a:pPr lvl="0" indent="0" marL="0">
-                        <a:buNone/>
-                      </a:pPr>
-                      <a:r>
-                        <a:rPr/>
-                        <a:t>0.677519</a:t>
-                      </a:r>
-                    </a:p>
-                  </a:txBody>
-                </a:tc>
-              </a:tr>
-            </a:tbl>
-          </a:graphicData>
-        </a:graphic>
-      </p:graphicFrame>
+        </p:nvSpPr>
+        <p:spPr/>
+        <p:txBody>
+          <a:bodyPr/>
+          <a:lstStyle/>
+          <a:p>
+            <a:pPr lvl="0" indent="0">
+              <a:buNone/>
+            </a:pPr>
+            <a:r>
+              <a:rPr>
+                <a:latin typeface="Courier"/>
+              </a:rPr>
+              <a:t>    k  Avg_RMSLE
+0   2   0.152783
+1   3   0.158068
+2   4   0.162118
+3   5   0.168001
+4   6   0.174249
+5   7   0.180282
+6   8   0.185071
+7   9   0.190148
+8  10   0.196831</a:t>
+            </a:r>
+          </a:p>
+        </p:txBody>
+      </p:sp>
     </p:spTree>
   </p:cSld>
 </p:sld>
@@ -5461,6 +5290,468 @@
                       <a:r>
                         <a:rPr/>
                         <a:t>113.92</a:t>
+                      </a:r>
+                    </a:p>
+                  </a:txBody>
+                </a:tc>
+              </a:tr>
+              <a:tr h="0">
+                <a:tc>
+                  <a:txBody>
+                    <a:bodyPr/>
+                    <a:lstStyle/>
+                    <a:p>
+                      <a:pPr lvl="0" indent="0" marL="0">
+                        <a:buNone/>
+                      </a:pPr>
+                      <a:r>
+                        <a:rPr/>
+                        <a:t>...</a:t>
+                      </a:r>
+                    </a:p>
+                  </a:txBody>
+                </a:tc>
+                <a:tc>
+                  <a:txBody>
+                    <a:bodyPr/>
+                    <a:lstStyle/>
+                    <a:p>
+                      <a:pPr lvl="0" indent="0" marL="0">
+                        <a:buNone/>
+                      </a:pPr>
+                      <a:r>
+                        <a:rPr/>
+                        <a:t>...</a:t>
+                      </a:r>
+                    </a:p>
+                  </a:txBody>
+                </a:tc>
+                <a:tc>
+                  <a:txBody>
+                    <a:bodyPr/>
+                    <a:lstStyle/>
+                    <a:p>
+                      <a:pPr lvl="0" indent="0" marL="0">
+                        <a:buNone/>
+                      </a:pPr>
+                      <a:r>
+                        <a:rPr/>
+                        <a:t>...</a:t>
+                      </a:r>
+                    </a:p>
+                  </a:txBody>
+                </a:tc>
+                <a:tc>
+                  <a:txBody>
+                    <a:bodyPr/>
+                    <a:lstStyle/>
+                    <a:p>
+                      <a:pPr lvl="0" indent="0" marL="0">
+                        <a:buNone/>
+                      </a:pPr>
+                      <a:r>
+                        <a:rPr/>
+                        <a:t>...</a:t>
+                      </a:r>
+                    </a:p>
+                  </a:txBody>
+                </a:tc>
+                <a:tc>
+                  <a:txBody>
+                    <a:bodyPr/>
+                    <a:lstStyle/>
+                    <a:p>
+                      <a:pPr lvl="0" indent="0" marL="0">
+                        <a:buNone/>
+                      </a:pPr>
+                      <a:r>
+                        <a:rPr/>
+                        <a:t>...</a:t>
+                      </a:r>
+                    </a:p>
+                  </a:txBody>
+                </a:tc>
+              </a:tr>
+              <a:tr h="0">
+                <a:tc>
+                  <a:txBody>
+                    <a:bodyPr/>
+                    <a:lstStyle/>
+                    <a:p>
+                      <a:pPr lvl="0" indent="0" marL="0">
+                        <a:buNone/>
+                      </a:pPr>
+                      <a:r>
+                        <a:rPr/>
+                        <a:t>137074</a:t>
+                      </a:r>
+                    </a:p>
+                  </a:txBody>
+                </a:tc>
+                <a:tc>
+                  <a:txBody>
+                    <a:bodyPr/>
+                    <a:lstStyle/>
+                    <a:p>
+                      <a:pPr lvl="0" indent="0" marL="0">
+                        <a:buNone/>
+                      </a:pPr>
+                      <a:r>
+                        <a:rPr/>
+                        <a:t>922</a:t>
+                      </a:r>
+                    </a:p>
+                  </a:txBody>
+                </a:tc>
+                <a:tc>
+                  <a:txBody>
+                    <a:bodyPr/>
+                    <a:lstStyle/>
+                    <a:p>
+                      <a:pPr lvl="0" indent="0" marL="0">
+                        <a:buNone/>
+                      </a:pPr>
+                      <a:r>
+                        <a:rPr/>
+                        <a:t>2.5</a:t>
+                      </a:r>
+                    </a:p>
+                  </a:txBody>
+                </a:tc>
+                <a:tc>
+                  <a:txBody>
+                    <a:bodyPr/>
+                    <a:lstStyle/>
+                    <a:p>
+                      <a:pPr lvl="0" indent="0" marL="0">
+                        <a:buNone/>
+                      </a:pPr>
+                      <a:r>
+                        <a:rPr/>
+                        <a:t>24.8</a:t>
+                      </a:r>
+                    </a:p>
+                  </a:txBody>
+                </a:tc>
+                <a:tc>
+                  <a:txBody>
+                    <a:bodyPr/>
+                    <a:lstStyle/>
+                    <a:p>
+                      <a:pPr lvl="0" indent="0" marL="0">
+                        <a:buNone/>
+                      </a:pPr>
+                      <a:r>
+                        <a:rPr/>
+                        <a:t>15.98</a:t>
+                      </a:r>
+                    </a:p>
+                  </a:txBody>
+                </a:tc>
+              </a:tr>
+              <a:tr h="0">
+                <a:tc>
+                  <a:txBody>
+                    <a:bodyPr/>
+                    <a:lstStyle/>
+                    <a:p>
+                      <a:pPr lvl="0" indent="0" marL="0">
+                        <a:buNone/>
+                      </a:pPr>
+                      <a:r>
+                        <a:rPr/>
+                        <a:t>137075</a:t>
+                      </a:r>
+                    </a:p>
+                  </a:txBody>
+                </a:tc>
+                <a:tc>
+                  <a:txBody>
+                    <a:bodyPr/>
+                    <a:lstStyle/>
+                    <a:p>
+                      <a:pPr lvl="0" indent="0" marL="0">
+                        <a:buNone/>
+                      </a:pPr>
+                      <a:r>
+                        <a:rPr/>
+                        <a:t>922</a:t>
+                      </a:r>
+                    </a:p>
+                  </a:txBody>
+                </a:tc>
+                <a:tc>
+                  <a:txBody>
+                    <a:bodyPr/>
+                    <a:lstStyle/>
+                    <a:p>
+                      <a:pPr lvl="0" indent="0" marL="0">
+                        <a:buNone/>
+                      </a:pPr>
+                      <a:r>
+                        <a:rPr/>
+                        <a:t>3.7</a:t>
+                      </a:r>
+                    </a:p>
+                  </a:txBody>
+                </a:tc>
+                <a:tc>
+                  <a:txBody>
+                    <a:bodyPr/>
+                    <a:lstStyle/>
+                    <a:p>
+                      <a:pPr lvl="0" indent="0" marL="0">
+                        <a:buNone/>
+                      </a:pPr>
+                      <a:r>
+                        <a:rPr/>
+                        <a:t>23.7</a:t>
+                      </a:r>
+                    </a:p>
+                  </a:txBody>
+                </a:tc>
+                <a:tc>
+                  <a:txBody>
+                    <a:bodyPr/>
+                    <a:lstStyle/>
+                    <a:p>
+                      <a:pPr lvl="0" indent="0" marL="0">
+                        <a:buNone/>
+                      </a:pPr>
+                      <a:r>
+                        <a:rPr/>
+                        <a:t>40.62</a:t>
+                      </a:r>
+                    </a:p>
+                  </a:txBody>
+                </a:tc>
+              </a:tr>
+              <a:tr h="0">
+                <a:tc>
+                  <a:txBody>
+                    <a:bodyPr/>
+                    <a:lstStyle/>
+                    <a:p>
+                      <a:pPr lvl="0" indent="0" marL="0">
+                        <a:buNone/>
+                      </a:pPr>
+                      <a:r>
+                        <a:rPr/>
+                        <a:t>137076</a:t>
+                      </a:r>
+                    </a:p>
+                  </a:txBody>
+                </a:tc>
+                <a:tc>
+                  <a:txBody>
+                    <a:bodyPr/>
+                    <a:lstStyle/>
+                    <a:p>
+                      <a:pPr lvl="0" indent="0" marL="0">
+                        <a:buNone/>
+                      </a:pPr>
+                      <a:r>
+                        <a:rPr/>
+                        <a:t>922</a:t>
+                      </a:r>
+                    </a:p>
+                  </a:txBody>
+                </a:tc>
+                <a:tc>
+                  <a:txBody>
+                    <a:bodyPr/>
+                    <a:lstStyle/>
+                    <a:p>
+                      <a:pPr lvl="0" indent="0" marL="0">
+                        <a:buNone/>
+                      </a:pPr>
+                      <a:r>
+                        <a:rPr/>
+                        <a:t>2.9</a:t>
+                      </a:r>
+                    </a:p>
+                  </a:txBody>
+                </a:tc>
+                <a:tc>
+                  <a:txBody>
+                    <a:bodyPr/>
+                    <a:lstStyle/>
+                    <a:p>
+                      <a:pPr lvl="0" indent="0" marL="0">
+                        <a:buNone/>
+                      </a:pPr>
+                      <a:r>
+                        <a:rPr/>
+                        <a:t>30.9</a:t>
+                      </a:r>
+                    </a:p>
+                  </a:txBody>
+                </a:tc>
+                <a:tc>
+                  <a:txBody>
+                    <a:bodyPr/>
+                    <a:lstStyle/>
+                    <a:p>
+                      <a:pPr lvl="0" indent="0" marL="0">
+                        <a:buNone/>
+                      </a:pPr>
+                      <a:r>
+                        <a:rPr/>
+                        <a:t>22.74</a:t>
+                      </a:r>
+                    </a:p>
+                  </a:txBody>
+                </a:tc>
+              </a:tr>
+              <a:tr h="0">
+                <a:tc>
+                  <a:txBody>
+                    <a:bodyPr/>
+                    <a:lstStyle/>
+                    <a:p>
+                      <a:pPr lvl="0" indent="0" marL="0">
+                        <a:buNone/>
+                      </a:pPr>
+                      <a:r>
+                        <a:rPr/>
+                        <a:t>137077</a:t>
+                      </a:r>
+                    </a:p>
+                  </a:txBody>
+                </a:tc>
+                <a:tc>
+                  <a:txBody>
+                    <a:bodyPr/>
+                    <a:lstStyle/>
+                    <a:p>
+                      <a:pPr lvl="0" indent="0" marL="0">
+                        <a:buNone/>
+                      </a:pPr>
+                      <a:r>
+                        <a:rPr/>
+                        <a:t>922</a:t>
+                      </a:r>
+                    </a:p>
+                  </a:txBody>
+                </a:tc>
+                <a:tc>
+                  <a:txBody>
+                    <a:bodyPr/>
+                    <a:lstStyle/>
+                    <a:p>
+                      <a:pPr lvl="0" indent="0" marL="0">
+                        <a:buNone/>
+                      </a:pPr>
+                      <a:r>
+                        <a:rPr/>
+                        <a:t>5.6</a:t>
+                      </a:r>
+                    </a:p>
+                  </a:txBody>
+                </a:tc>
+                <a:tc>
+                  <a:txBody>
+                    <a:bodyPr/>
+                    <a:lstStyle/>
+                    <a:p>
+                      <a:pPr lvl="0" indent="0" marL="0">
+                        <a:buNone/>
+                      </a:pPr>
+                      <a:r>
+                        <a:rPr/>
+                        <a:t>40.0</a:t>
+                      </a:r>
+                    </a:p>
+                  </a:txBody>
+                </a:tc>
+                <a:tc>
+                  <a:txBody>
+                    <a:bodyPr/>
+                    <a:lstStyle/>
+                    <a:p>
+                      <a:pPr lvl="0" indent="0" marL="0">
+                        <a:buNone/>
+                      </a:pPr>
+                      <a:r>
+                        <a:rPr/>
+                        <a:t>87.79</a:t>
+                      </a:r>
+                    </a:p>
+                  </a:txBody>
+                </a:tc>
+              </a:tr>
+              <a:tr h="0">
+                <a:tc>
+                  <a:txBody>
+                    <a:bodyPr/>
+                    <a:lstStyle/>
+                    <a:p>
+                      <a:pPr lvl="0" indent="0" marL="0">
+                        <a:buNone/>
+                      </a:pPr>
+                      <a:r>
+                        <a:rPr/>
+                        <a:t>137078</a:t>
+                      </a:r>
+                    </a:p>
+                  </a:txBody>
+                </a:tc>
+                <a:tc>
+                  <a:txBody>
+                    <a:bodyPr/>
+                    <a:lstStyle/>
+                    <a:p>
+                      <a:pPr lvl="0" indent="0" marL="0">
+                        <a:buNone/>
+                      </a:pPr>
+                      <a:r>
+                        <a:rPr/>
+                        <a:t>922</a:t>
+                      </a:r>
+                    </a:p>
+                  </a:txBody>
+                </a:tc>
+                <a:tc>
+                  <a:txBody>
+                    <a:bodyPr/>
+                    <a:lstStyle/>
+                    <a:p>
+                      <a:pPr lvl="0" indent="0" marL="0">
+                        <a:buNone/>
+                      </a:pPr>
+                      <a:r>
+                        <a:rPr/>
+                        <a:t>1.9</a:t>
+                      </a:r>
+                    </a:p>
+                  </a:txBody>
+                </a:tc>
+                <a:tc>
+                  <a:txBody>
+                    <a:bodyPr/>
+                    <a:lstStyle/>
+                    <a:p>
+                      <a:pPr lvl="0" indent="0" marL="0">
+                        <a:buNone/>
+                      </a:pPr>
+                      <a:r>
+                        <a:rPr/>
+                        <a:t>25.1</a:t>
+                      </a:r>
+                    </a:p>
+                  </a:txBody>
+                </a:tc>
+                <a:tc>
+                  <a:txBody>
+                    <a:bodyPr/>
+                    <a:lstStyle/>
+                    <a:p>
+                      <a:pPr lvl="0" indent="0" marL="0">
+                        <a:buNone/>
+                      </a:pPr>
+                      <a:r>
+                        <a:rPr/>
+                        <a:t>8.33</a:t>
                       </a:r>
                     </a:p>
                   </a:txBody>
@@ -5821,6 +6112,288 @@
                   </a:txBody>
                 </a:tc>
               </a:tr>
+              <a:tr h="0">
+                <a:tc>
+                  <a:txBody>
+                    <a:bodyPr/>
+                    <a:lstStyle/>
+                    <a:p>
+                      <a:pPr lvl="0" indent="0" marL="0">
+                        <a:buNone/>
+                      </a:pPr>
+                      <a:r>
+                        <a:rPr/>
+                        <a:t>...</a:t>
+                      </a:r>
+                    </a:p>
+                  </a:txBody>
+                </a:tc>
+                <a:tc>
+                  <a:txBody>
+                    <a:bodyPr/>
+                    <a:lstStyle/>
+                    <a:p>
+                      <a:pPr lvl="0" indent="0" marL="0">
+                        <a:buNone/>
+                      </a:pPr>
+                      <a:r>
+                        <a:rPr/>
+                        <a:t>...</a:t>
+                      </a:r>
+                    </a:p>
+                  </a:txBody>
+                </a:tc>
+                <a:tc>
+                  <a:txBody>
+                    <a:bodyPr/>
+                    <a:lstStyle/>
+                    <a:p>
+                      <a:pPr lvl="0" indent="0" marL="0">
+                        <a:buNone/>
+                      </a:pPr>
+                      <a:r>
+                        <a:rPr/>
+                        <a:t>...</a:t>
+                      </a:r>
+                    </a:p>
+                  </a:txBody>
+                </a:tc>
+              </a:tr>
+              <a:tr h="0">
+                <a:tc>
+                  <a:txBody>
+                    <a:bodyPr/>
+                    <a:lstStyle/>
+                    <a:p>
+                      <a:pPr lvl="0" indent="0" marL="0">
+                        <a:buNone/>
+                      </a:pPr>
+                      <a:r>
+                        <a:rPr/>
+                        <a:t>453</a:t>
+                      </a:r>
+                    </a:p>
+                  </a:txBody>
+                </a:tc>
+                <a:tc>
+                  <a:txBody>
+                    <a:bodyPr/>
+                    <a:lstStyle/>
+                    <a:p>
+                      <a:pPr lvl="0" indent="0" marL="0">
+                        <a:buNone/>
+                      </a:pPr>
+                      <a:r>
+                        <a:rPr/>
+                        <a:t>995</a:t>
+                      </a:r>
+                    </a:p>
+                  </a:txBody>
+                </a:tc>
+                <a:tc>
+                  <a:txBody>
+                    <a:bodyPr/>
+                    <a:lstStyle/>
+                    <a:p>
+                      <a:pPr lvl="0" indent="0" marL="0">
+                        <a:buNone/>
+                      </a:pPr>
+                      <a:r>
+                        <a:rPr/>
+                        <a:t>tungoil tree</a:t>
+                      </a:r>
+                    </a:p>
+                  </a:txBody>
+                </a:tc>
+              </a:tr>
+              <a:tr h="0">
+                <a:tc>
+                  <a:txBody>
+                    <a:bodyPr/>
+                    <a:lstStyle/>
+                    <a:p>
+                      <a:pPr lvl="0" indent="0" marL="0">
+                        <a:buNone/>
+                      </a:pPr>
+                      <a:r>
+                        <a:rPr/>
+                        <a:t>454</a:t>
+                      </a:r>
+                    </a:p>
+                  </a:txBody>
+                </a:tc>
+                <a:tc>
+                  <a:txBody>
+                    <a:bodyPr/>
+                    <a:lstStyle/>
+                    <a:p>
+                      <a:pPr lvl="0" indent="0" marL="0">
+                        <a:buNone/>
+                      </a:pPr>
+                      <a:r>
+                        <a:rPr/>
+                        <a:t>996</a:t>
+                      </a:r>
+                    </a:p>
+                  </a:txBody>
+                </a:tc>
+                <a:tc>
+                  <a:txBody>
+                    <a:bodyPr/>
+                    <a:lstStyle/>
+                    <a:p>
+                      <a:pPr lvl="0" indent="0" marL="0">
+                        <a:buNone/>
+                      </a:pPr>
+                      <a:r>
+                        <a:rPr/>
+                        <a:t>smoketree</a:t>
+                      </a:r>
+                    </a:p>
+                  </a:txBody>
+                </a:tc>
+              </a:tr>
+              <a:tr h="0">
+                <a:tc>
+                  <a:txBody>
+                    <a:bodyPr/>
+                    <a:lstStyle/>
+                    <a:p>
+                      <a:pPr lvl="0" indent="0" marL="0">
+                        <a:buNone/>
+                      </a:pPr>
+                      <a:r>
+                        <a:rPr/>
+                        <a:t>455</a:t>
+                      </a:r>
+                    </a:p>
+                  </a:txBody>
+                </a:tc>
+                <a:tc>
+                  <a:txBody>
+                    <a:bodyPr/>
+                    <a:lstStyle/>
+                    <a:p>
+                      <a:pPr lvl="0" indent="0" marL="0">
+                        <a:buNone/>
+                      </a:pPr>
+                      <a:r>
+                        <a:rPr/>
+                        <a:t>997</a:t>
+                      </a:r>
+                    </a:p>
+                  </a:txBody>
+                </a:tc>
+                <a:tc>
+                  <a:txBody>
+                    <a:bodyPr/>
+                    <a:lstStyle/>
+                    <a:p>
+                      <a:pPr lvl="0" indent="0" marL="0">
+                        <a:buNone/>
+                      </a:pPr>
+                      <a:r>
+                        <a:rPr/>
+                        <a:t>Russian-olive</a:t>
+                      </a:r>
+                    </a:p>
+                  </a:txBody>
+                </a:tc>
+              </a:tr>
+              <a:tr h="0">
+                <a:tc>
+                  <a:txBody>
+                    <a:bodyPr/>
+                    <a:lstStyle/>
+                    <a:p>
+                      <a:pPr lvl="0" indent="0" marL="0">
+                        <a:buNone/>
+                      </a:pPr>
+                      <a:r>
+                        <a:rPr/>
+                        <a:t>456</a:t>
+                      </a:r>
+                    </a:p>
+                  </a:txBody>
+                </a:tc>
+                <a:tc>
+                  <a:txBody>
+                    <a:bodyPr/>
+                    <a:lstStyle/>
+                    <a:p>
+                      <a:pPr lvl="0" indent="0" marL="0">
+                        <a:buNone/>
+                      </a:pPr>
+                      <a:r>
+                        <a:rPr/>
+                        <a:t>998</a:t>
+                      </a:r>
+                    </a:p>
+                  </a:txBody>
+                </a:tc>
+                <a:tc>
+                  <a:txBody>
+                    <a:bodyPr/>
+                    <a:lstStyle/>
+                    <a:p>
+                      <a:pPr lvl="0" indent="0" marL="0">
+                        <a:buNone/>
+                      </a:pPr>
+                      <a:r>
+                        <a:rPr/>
+                        <a:t>Unknown dead hardwood</a:t>
+                      </a:r>
+                    </a:p>
+                  </a:txBody>
+                </a:tc>
+              </a:tr>
+              <a:tr h="0">
+                <a:tc>
+                  <a:txBody>
+                    <a:bodyPr/>
+                    <a:lstStyle/>
+                    <a:p>
+                      <a:pPr lvl="0" indent="0" marL="0">
+                        <a:buNone/>
+                      </a:pPr>
+                      <a:r>
+                        <a:rPr/>
+                        <a:t>457</a:t>
+                      </a:r>
+                    </a:p>
+                  </a:txBody>
+                </a:tc>
+                <a:tc>
+                  <a:txBody>
+                    <a:bodyPr/>
+                    <a:lstStyle/>
+                    <a:p>
+                      <a:pPr lvl="0" indent="0" marL="0">
+                        <a:buNone/>
+                      </a:pPr>
+                      <a:r>
+                        <a:rPr/>
+                        <a:t>999</a:t>
+                      </a:r>
+                    </a:p>
+                  </a:txBody>
+                </a:tc>
+                <a:tc>
+                  <a:txBody>
+                    <a:bodyPr/>
+                    <a:lstStyle/>
+                    <a:p>
+                      <a:pPr lvl="0" indent="0" marL="0">
+                        <a:buNone/>
+                      </a:pPr>
+                      <a:r>
+                        <a:rPr/>
+                        <a:t>Other or unknown live tree</a:t>
+                      </a:r>
+                    </a:p>
+                  </a:txBody>
+                </a:tc>
+              </a:tr>
             </a:tbl>
           </a:graphicData>
         </a:graphic>
@@ -6447,6 +7020,558 @@
                       <a:r>
                         <a:rPr/>
                         <a:t>balsam fir</a:t>
+                      </a:r>
+                    </a:p>
+                  </a:txBody>
+                </a:tc>
+              </a:tr>
+              <a:tr h="0">
+                <a:tc>
+                  <a:txBody>
+                    <a:bodyPr/>
+                    <a:lstStyle/>
+                    <a:p>
+                      <a:pPr lvl="0" indent="0" marL="0">
+                        <a:buNone/>
+                      </a:pPr>
+                      <a:r>
+                        <a:rPr/>
+                        <a:t>...</a:t>
+                      </a:r>
+                    </a:p>
+                  </a:txBody>
+                </a:tc>
+                <a:tc>
+                  <a:txBody>
+                    <a:bodyPr/>
+                    <a:lstStyle/>
+                    <a:p>
+                      <a:pPr lvl="0" indent="0" marL="0">
+                        <a:buNone/>
+                      </a:pPr>
+                      <a:r>
+                        <a:rPr/>
+                        <a:t>...</a:t>
+                      </a:r>
+                    </a:p>
+                  </a:txBody>
+                </a:tc>
+                <a:tc>
+                  <a:txBody>
+                    <a:bodyPr/>
+                    <a:lstStyle/>
+                    <a:p>
+                      <a:pPr lvl="0" indent="0" marL="0">
+                        <a:buNone/>
+                      </a:pPr>
+                      <a:r>
+                        <a:rPr/>
+                        <a:t>...</a:t>
+                      </a:r>
+                    </a:p>
+                  </a:txBody>
+                </a:tc>
+                <a:tc>
+                  <a:txBody>
+                    <a:bodyPr/>
+                    <a:lstStyle/>
+                    <a:p>
+                      <a:pPr lvl="0" indent="0" marL="0">
+                        <a:buNone/>
+                      </a:pPr>
+                      <a:r>
+                        <a:rPr/>
+                        <a:t>...</a:t>
+                      </a:r>
+                    </a:p>
+                  </a:txBody>
+                </a:tc>
+                <a:tc>
+                  <a:txBody>
+                    <a:bodyPr/>
+                    <a:lstStyle/>
+                    <a:p>
+                      <a:pPr lvl="0" indent="0" marL="0">
+                        <a:buNone/>
+                      </a:pPr>
+                      <a:r>
+                        <a:rPr/>
+                        <a:t>...</a:t>
+                      </a:r>
+                    </a:p>
+                  </a:txBody>
+                </a:tc>
+                <a:tc>
+                  <a:txBody>
+                    <a:bodyPr/>
+                    <a:lstStyle/>
+                    <a:p>
+                      <a:pPr lvl="0" indent="0" marL="0">
+                        <a:buNone/>
+                      </a:pPr>
+                      <a:r>
+                        <a:rPr/>
+                        <a:t>...</a:t>
+                      </a:r>
+                    </a:p>
+                  </a:txBody>
+                </a:tc>
+              </a:tr>
+              <a:tr h="0">
+                <a:tc>
+                  <a:txBody>
+                    <a:bodyPr/>
+                    <a:lstStyle/>
+                    <a:p>
+                      <a:pPr lvl="0" indent="0" marL="0">
+                        <a:buNone/>
+                      </a:pPr>
+                      <a:r>
+                        <a:rPr/>
+                        <a:t>137074</a:t>
+                      </a:r>
+                    </a:p>
+                  </a:txBody>
+                </a:tc>
+                <a:tc>
+                  <a:txBody>
+                    <a:bodyPr/>
+                    <a:lstStyle/>
+                    <a:p>
+                      <a:pPr lvl="0" indent="0" marL="0">
+                        <a:buNone/>
+                      </a:pPr>
+                      <a:r>
+                        <a:rPr/>
+                        <a:t>922</a:t>
+                      </a:r>
+                    </a:p>
+                  </a:txBody>
+                </a:tc>
+                <a:tc>
+                  <a:txBody>
+                    <a:bodyPr/>
+                    <a:lstStyle/>
+                    <a:p>
+                      <a:pPr lvl="0" indent="0" marL="0">
+                        <a:buNone/>
+                      </a:pPr>
+                      <a:r>
+                        <a:rPr/>
+                        <a:t>2.5</a:t>
+                      </a:r>
+                    </a:p>
+                  </a:txBody>
+                </a:tc>
+                <a:tc>
+                  <a:txBody>
+                    <a:bodyPr/>
+                    <a:lstStyle/>
+                    <a:p>
+                      <a:pPr lvl="0" indent="0" marL="0">
+                        <a:buNone/>
+                      </a:pPr>
+                      <a:r>
+                        <a:rPr/>
+                        <a:t>24.8</a:t>
+                      </a:r>
+                    </a:p>
+                  </a:txBody>
+                </a:tc>
+                <a:tc>
+                  <a:txBody>
+                    <a:bodyPr/>
+                    <a:lstStyle/>
+                    <a:p>
+                      <a:pPr lvl="0" indent="0" marL="0">
+                        <a:buNone/>
+                      </a:pPr>
+                      <a:r>
+                        <a:rPr/>
+                        <a:t>15.98</a:t>
+                      </a:r>
+                    </a:p>
+                  </a:txBody>
+                </a:tc>
+                <a:tc>
+                  <a:txBody>
+                    <a:bodyPr/>
+                    <a:lstStyle/>
+                    <a:p>
+                      <a:pPr lvl="0" indent="0" marL="0">
+                        <a:buNone/>
+                      </a:pPr>
+                      <a:r>
+                        <a:rPr/>
+                        <a:t>black willow</a:t>
+                      </a:r>
+                    </a:p>
+                  </a:txBody>
+                </a:tc>
+              </a:tr>
+              <a:tr h="0">
+                <a:tc>
+                  <a:txBody>
+                    <a:bodyPr/>
+                    <a:lstStyle/>
+                    <a:p>
+                      <a:pPr lvl="0" indent="0" marL="0">
+                        <a:buNone/>
+                      </a:pPr>
+                      <a:r>
+                        <a:rPr/>
+                        <a:t>137075</a:t>
+                      </a:r>
+                    </a:p>
+                  </a:txBody>
+                </a:tc>
+                <a:tc>
+                  <a:txBody>
+                    <a:bodyPr/>
+                    <a:lstStyle/>
+                    <a:p>
+                      <a:pPr lvl="0" indent="0" marL="0">
+                        <a:buNone/>
+                      </a:pPr>
+                      <a:r>
+                        <a:rPr/>
+                        <a:t>922</a:t>
+                      </a:r>
+                    </a:p>
+                  </a:txBody>
+                </a:tc>
+                <a:tc>
+                  <a:txBody>
+                    <a:bodyPr/>
+                    <a:lstStyle/>
+                    <a:p>
+                      <a:pPr lvl="0" indent="0" marL="0">
+                        <a:buNone/>
+                      </a:pPr>
+                      <a:r>
+                        <a:rPr/>
+                        <a:t>3.7</a:t>
+                      </a:r>
+                    </a:p>
+                  </a:txBody>
+                </a:tc>
+                <a:tc>
+                  <a:txBody>
+                    <a:bodyPr/>
+                    <a:lstStyle/>
+                    <a:p>
+                      <a:pPr lvl="0" indent="0" marL="0">
+                        <a:buNone/>
+                      </a:pPr>
+                      <a:r>
+                        <a:rPr/>
+                        <a:t>23.7</a:t>
+                      </a:r>
+                    </a:p>
+                  </a:txBody>
+                </a:tc>
+                <a:tc>
+                  <a:txBody>
+                    <a:bodyPr/>
+                    <a:lstStyle/>
+                    <a:p>
+                      <a:pPr lvl="0" indent="0" marL="0">
+                        <a:buNone/>
+                      </a:pPr>
+                      <a:r>
+                        <a:rPr/>
+                        <a:t>40.62</a:t>
+                      </a:r>
+                    </a:p>
+                  </a:txBody>
+                </a:tc>
+                <a:tc>
+                  <a:txBody>
+                    <a:bodyPr/>
+                    <a:lstStyle/>
+                    <a:p>
+                      <a:pPr lvl="0" indent="0" marL="0">
+                        <a:buNone/>
+                      </a:pPr>
+                      <a:r>
+                        <a:rPr/>
+                        <a:t>black willow</a:t>
+                      </a:r>
+                    </a:p>
+                  </a:txBody>
+                </a:tc>
+              </a:tr>
+              <a:tr h="0">
+                <a:tc>
+                  <a:txBody>
+                    <a:bodyPr/>
+                    <a:lstStyle/>
+                    <a:p>
+                      <a:pPr lvl="0" indent="0" marL="0">
+                        <a:buNone/>
+                      </a:pPr>
+                      <a:r>
+                        <a:rPr/>
+                        <a:t>137076</a:t>
+                      </a:r>
+                    </a:p>
+                  </a:txBody>
+                </a:tc>
+                <a:tc>
+                  <a:txBody>
+                    <a:bodyPr/>
+                    <a:lstStyle/>
+                    <a:p>
+                      <a:pPr lvl="0" indent="0" marL="0">
+                        <a:buNone/>
+                      </a:pPr>
+                      <a:r>
+                        <a:rPr/>
+                        <a:t>922</a:t>
+                      </a:r>
+                    </a:p>
+                  </a:txBody>
+                </a:tc>
+                <a:tc>
+                  <a:txBody>
+                    <a:bodyPr/>
+                    <a:lstStyle/>
+                    <a:p>
+                      <a:pPr lvl="0" indent="0" marL="0">
+                        <a:buNone/>
+                      </a:pPr>
+                      <a:r>
+                        <a:rPr/>
+                        <a:t>2.9</a:t>
+                      </a:r>
+                    </a:p>
+                  </a:txBody>
+                </a:tc>
+                <a:tc>
+                  <a:txBody>
+                    <a:bodyPr/>
+                    <a:lstStyle/>
+                    <a:p>
+                      <a:pPr lvl="0" indent="0" marL="0">
+                        <a:buNone/>
+                      </a:pPr>
+                      <a:r>
+                        <a:rPr/>
+                        <a:t>30.9</a:t>
+                      </a:r>
+                    </a:p>
+                  </a:txBody>
+                </a:tc>
+                <a:tc>
+                  <a:txBody>
+                    <a:bodyPr/>
+                    <a:lstStyle/>
+                    <a:p>
+                      <a:pPr lvl="0" indent="0" marL="0">
+                        <a:buNone/>
+                      </a:pPr>
+                      <a:r>
+                        <a:rPr/>
+                        <a:t>22.74</a:t>
+                      </a:r>
+                    </a:p>
+                  </a:txBody>
+                </a:tc>
+                <a:tc>
+                  <a:txBody>
+                    <a:bodyPr/>
+                    <a:lstStyle/>
+                    <a:p>
+                      <a:pPr lvl="0" indent="0" marL="0">
+                        <a:buNone/>
+                      </a:pPr>
+                      <a:r>
+                        <a:rPr/>
+                        <a:t>black willow</a:t>
+                      </a:r>
+                    </a:p>
+                  </a:txBody>
+                </a:tc>
+              </a:tr>
+              <a:tr h="0">
+                <a:tc>
+                  <a:txBody>
+                    <a:bodyPr/>
+                    <a:lstStyle/>
+                    <a:p>
+                      <a:pPr lvl="0" indent="0" marL="0">
+                        <a:buNone/>
+                      </a:pPr>
+                      <a:r>
+                        <a:rPr/>
+                        <a:t>137077</a:t>
+                      </a:r>
+                    </a:p>
+                  </a:txBody>
+                </a:tc>
+                <a:tc>
+                  <a:txBody>
+                    <a:bodyPr/>
+                    <a:lstStyle/>
+                    <a:p>
+                      <a:pPr lvl="0" indent="0" marL="0">
+                        <a:buNone/>
+                      </a:pPr>
+                      <a:r>
+                        <a:rPr/>
+                        <a:t>922</a:t>
+                      </a:r>
+                    </a:p>
+                  </a:txBody>
+                </a:tc>
+                <a:tc>
+                  <a:txBody>
+                    <a:bodyPr/>
+                    <a:lstStyle/>
+                    <a:p>
+                      <a:pPr lvl="0" indent="0" marL="0">
+                        <a:buNone/>
+                      </a:pPr>
+                      <a:r>
+                        <a:rPr/>
+                        <a:t>5.6</a:t>
+                      </a:r>
+                    </a:p>
+                  </a:txBody>
+                </a:tc>
+                <a:tc>
+                  <a:txBody>
+                    <a:bodyPr/>
+                    <a:lstStyle/>
+                    <a:p>
+                      <a:pPr lvl="0" indent="0" marL="0">
+                        <a:buNone/>
+                      </a:pPr>
+                      <a:r>
+                        <a:rPr/>
+                        <a:t>40.0</a:t>
+                      </a:r>
+                    </a:p>
+                  </a:txBody>
+                </a:tc>
+                <a:tc>
+                  <a:txBody>
+                    <a:bodyPr/>
+                    <a:lstStyle/>
+                    <a:p>
+                      <a:pPr lvl="0" indent="0" marL="0">
+                        <a:buNone/>
+                      </a:pPr>
+                      <a:r>
+                        <a:rPr/>
+                        <a:t>87.79</a:t>
+                      </a:r>
+                    </a:p>
+                  </a:txBody>
+                </a:tc>
+                <a:tc>
+                  <a:txBody>
+                    <a:bodyPr/>
+                    <a:lstStyle/>
+                    <a:p>
+                      <a:pPr lvl="0" indent="0" marL="0">
+                        <a:buNone/>
+                      </a:pPr>
+                      <a:r>
+                        <a:rPr/>
+                        <a:t>black willow</a:t>
+                      </a:r>
+                    </a:p>
+                  </a:txBody>
+                </a:tc>
+              </a:tr>
+              <a:tr h="0">
+                <a:tc>
+                  <a:txBody>
+                    <a:bodyPr/>
+                    <a:lstStyle/>
+                    <a:p>
+                      <a:pPr lvl="0" indent="0" marL="0">
+                        <a:buNone/>
+                      </a:pPr>
+                      <a:r>
+                        <a:rPr/>
+                        <a:t>137078</a:t>
+                      </a:r>
+                    </a:p>
+                  </a:txBody>
+                </a:tc>
+                <a:tc>
+                  <a:txBody>
+                    <a:bodyPr/>
+                    <a:lstStyle/>
+                    <a:p>
+                      <a:pPr lvl="0" indent="0" marL="0">
+                        <a:buNone/>
+                      </a:pPr>
+                      <a:r>
+                        <a:rPr/>
+                        <a:t>922</a:t>
+                      </a:r>
+                    </a:p>
+                  </a:txBody>
+                </a:tc>
+                <a:tc>
+                  <a:txBody>
+                    <a:bodyPr/>
+                    <a:lstStyle/>
+                    <a:p>
+                      <a:pPr lvl="0" indent="0" marL="0">
+                        <a:buNone/>
+                      </a:pPr>
+                      <a:r>
+                        <a:rPr/>
+                        <a:t>1.9</a:t>
+                      </a:r>
+                    </a:p>
+                  </a:txBody>
+                </a:tc>
+                <a:tc>
+                  <a:txBody>
+                    <a:bodyPr/>
+                    <a:lstStyle/>
+                    <a:p>
+                      <a:pPr lvl="0" indent="0" marL="0">
+                        <a:buNone/>
+                      </a:pPr>
+                      <a:r>
+                        <a:rPr/>
+                        <a:t>25.1</a:t>
+                      </a:r>
+                    </a:p>
+                  </a:txBody>
+                </a:tc>
+                <a:tc>
+                  <a:txBody>
+                    <a:bodyPr/>
+                    <a:lstStyle/>
+                    <a:p>
+                      <a:pPr lvl="0" indent="0" marL="0">
+                        <a:buNone/>
+                      </a:pPr>
+                      <a:r>
+                        <a:rPr/>
+                        <a:t>8.33</a:t>
+                      </a:r>
+                    </a:p>
+                  </a:txBody>
+                </a:tc>
+                <a:tc>
+                  <a:txBody>
+                    <a:bodyPr/>
+                    <a:lstStyle/>
+                    <a:p>
+                      <a:pPr lvl="0" indent="0" marL="0">
+                        <a:buNone/>
+                      </a:pPr>
+                      <a:r>
+                        <a:rPr/>
+                        <a:t>black willow</a:t>
                       </a:r>
                     </a:p>
                   </a:txBody>
@@ -7793,11 +8918,11 @@
               <a:rPr>
                 <a:latin typeface="Courier"/>
               </a:rPr>
-              <a:t>Average Root Mean Squared Log Error (RMSLE) for k = 3: 0.15806802121296354
-Average Root Mean Squared Log Error (RMSLE) for k = 4: 0.16211832525051928
-Average Root Mean Squared Log Error (RMSLE) for k = 5: 0.16800130283205583
-Average Root Mean Squared Log Error (RMSLE) for k = 6: 0.1742492363008993
-Average Root Mean Squared Log Error (RMSLE) for k = 7: 0.18028213163724163</a:t>
+              <a:t>Average (RMSLE) for k = 3: 0.15806802121296354
+Average (RMSLE) for k = 4: 0.16211832525051928
+Average (RMSLE) for k = 5: 0.16800130283205583
+Average (RMSLE) for k = 6: 0.1742492363008993
+Average (RMSLE) for k = 7: 0.18028213163724163</a:t>
             </a:r>
           </a:p>
         </p:txBody>
@@ -8700,6 +9825,828 @@
                       <a:r>
                         <a:rPr/>
                         <a:t>2683.24</a:t>
+                      </a:r>
+                    </a:p>
+                  </a:txBody>
+                </a:tc>
+              </a:tr>
+              <a:tr h="0">
+                <a:tc>
+                  <a:txBody>
+                    <a:bodyPr/>
+                    <a:lstStyle/>
+                    <a:p>
+                      <a:pPr lvl="0" indent="0" marL="0">
+                        <a:buNone/>
+                      </a:pPr>
+                      <a:r>
+                        <a:rPr/>
+                        <a:t>...</a:t>
+                      </a:r>
+                    </a:p>
+                  </a:txBody>
+                </a:tc>
+                <a:tc>
+                  <a:txBody>
+                    <a:bodyPr/>
+                    <a:lstStyle/>
+                    <a:p>
+                      <a:pPr lvl="0" indent="0" marL="0">
+                        <a:buNone/>
+                      </a:pPr>
+                      <a:r>
+                        <a:rPr/>
+                        <a:t>...</a:t>
+                      </a:r>
+                    </a:p>
+                  </a:txBody>
+                </a:tc>
+                <a:tc>
+                  <a:txBody>
+                    <a:bodyPr/>
+                    <a:lstStyle/>
+                    <a:p>
+                      <a:pPr lvl="0" indent="0" marL="0">
+                        <a:buNone/>
+                      </a:pPr>
+                      <a:r>
+                        <a:rPr/>
+                        <a:t>...</a:t>
+                      </a:r>
+                    </a:p>
+                  </a:txBody>
+                </a:tc>
+                <a:tc>
+                  <a:txBody>
+                    <a:bodyPr/>
+                    <a:lstStyle/>
+                    <a:p>
+                      <a:pPr lvl="0" indent="0" marL="0">
+                        <a:buNone/>
+                      </a:pPr>
+                      <a:r>
+                        <a:rPr/>
+                        <a:t>...</a:t>
+                      </a:r>
+                    </a:p>
+                  </a:txBody>
+                </a:tc>
+                <a:tc>
+                  <a:txBody>
+                    <a:bodyPr/>
+                    <a:lstStyle/>
+                    <a:p>
+                      <a:pPr lvl="0" indent="0" marL="0">
+                        <a:buNone/>
+                      </a:pPr>
+                      <a:r>
+                        <a:rPr/>
+                        <a:t>...</a:t>
+                      </a:r>
+                    </a:p>
+                  </a:txBody>
+                </a:tc>
+                <a:tc>
+                  <a:txBody>
+                    <a:bodyPr/>
+                    <a:lstStyle/>
+                    <a:p>
+                      <a:pPr lvl="0" indent="0" marL="0">
+                        <a:buNone/>
+                      </a:pPr>
+                      <a:r>
+                        <a:rPr/>
+                        <a:t>...</a:t>
+                      </a:r>
+                    </a:p>
+                  </a:txBody>
+                </a:tc>
+                <a:tc>
+                  <a:txBody>
+                    <a:bodyPr/>
+                    <a:lstStyle/>
+                    <a:p>
+                      <a:pPr lvl="0" indent="0" marL="0">
+                        <a:buNone/>
+                      </a:pPr>
+                      <a:r>
+                        <a:rPr/>
+                        <a:t>...</a:t>
+                      </a:r>
+                    </a:p>
+                  </a:txBody>
+                </a:tc>
+                <a:tc>
+                  <a:txBody>
+                    <a:bodyPr/>
+                    <a:lstStyle/>
+                    <a:p>
+                      <a:pPr lvl="0" indent="0" marL="0">
+                        <a:buNone/>
+                      </a:pPr>
+                      <a:r>
+                        <a:rPr/>
+                        <a:t>...</a:t>
+                      </a:r>
+                    </a:p>
+                  </a:txBody>
+                </a:tc>
+                <a:tc>
+                  <a:txBody>
+                    <a:bodyPr/>
+                    <a:lstStyle/>
+                    <a:p>
+                      <a:pPr lvl="0" indent="0" marL="0">
+                        <a:buNone/>
+                      </a:pPr>
+                      <a:r>
+                        <a:rPr/>
+                        <a:t>...</a:t>
+                      </a:r>
+                    </a:p>
+                  </a:txBody>
+                </a:tc>
+              </a:tr>
+              <a:tr h="0">
+                <a:tc>
+                  <a:txBody>
+                    <a:bodyPr/>
+                    <a:lstStyle/>
+                    <a:p>
+                      <a:pPr lvl="0" indent="0" marL="0">
+                        <a:buNone/>
+                      </a:pPr>
+                      <a:r>
+                        <a:rPr/>
+                        <a:t>107641</a:t>
+                      </a:r>
+                    </a:p>
+                  </a:txBody>
+                </a:tc>
+                <a:tc>
+                  <a:txBody>
+                    <a:bodyPr/>
+                    <a:lstStyle/>
+                    <a:p>
+                      <a:pPr lvl="0" indent="0" marL="0">
+                        <a:buNone/>
+                      </a:pPr>
+                      <a:r>
+                        <a:rPr/>
+                        <a:t>461</a:t>
+                      </a:r>
+                    </a:p>
+                  </a:txBody>
+                </a:tc>
+                <a:tc>
+                  <a:txBody>
+                    <a:bodyPr/>
+                    <a:lstStyle/>
+                    <a:p>
+                      <a:pPr lvl="0" indent="0" marL="0">
+                        <a:buNone/>
+                      </a:pPr>
+                      <a:r>
+                        <a:rPr/>
+                        <a:t>17.5</a:t>
+                      </a:r>
+                    </a:p>
+                  </a:txBody>
+                </a:tc>
+                <a:tc>
+                  <a:txBody>
+                    <a:bodyPr/>
+                    <a:lstStyle/>
+                    <a:p>
+                      <a:pPr lvl="0" indent="0" marL="0">
+                        <a:buNone/>
+                      </a:pPr>
+                      <a:r>
+                        <a:rPr/>
+                        <a:t>87.4</a:t>
+                      </a:r>
+                    </a:p>
+                  </a:txBody>
+                </a:tc>
+                <a:tc>
+                  <a:txBody>
+                    <a:bodyPr/>
+                    <a:lstStyle/>
+                    <a:p>
+                      <a:pPr lvl="0" indent="0" marL="0">
+                        <a:buNone/>
+                      </a:pPr>
+                      <a:r>
+                        <a:rPr/>
+                        <a:t>2042.09</a:t>
+                      </a:r>
+                    </a:p>
+                  </a:txBody>
+                </a:tc>
+                <a:tc>
+                  <a:txBody>
+                    <a:bodyPr/>
+                    <a:lstStyle/>
+                    <a:p>
+                      <a:pPr lvl="0" indent="0" marL="0">
+                        <a:buNone/>
+                      </a:pPr>
+                      <a:r>
+                        <a:rPr/>
+                        <a:t>sugarberry</a:t>
+                      </a:r>
+                    </a:p>
+                  </a:txBody>
+                </a:tc>
+                <a:tc>
+                  <a:txBody>
+                    <a:bodyPr/>
+                    <a:lstStyle/>
+                    <a:p>
+                      <a:pPr lvl="0" indent="0" marL="0">
+                        <a:buNone/>
+                      </a:pPr>
+                      <a:r>
+                        <a:rPr/>
+                        <a:t>21022.145834</a:t>
+                      </a:r>
+                    </a:p>
+                  </a:txBody>
+                </a:tc>
+                <a:tc>
+                  <a:txBody>
+                    <a:bodyPr/>
+                    <a:lstStyle/>
+                    <a:p>
+                      <a:pPr lvl="0" indent="0" marL="0">
+                        <a:buNone/>
+                      </a:pPr>
+                      <a:r>
+                        <a:rPr/>
+                        <a:t>1529.50</a:t>
+                      </a:r>
+                    </a:p>
+                  </a:txBody>
+                </a:tc>
+                <a:tc>
+                  <a:txBody>
+                    <a:bodyPr/>
+                    <a:lstStyle/>
+                    <a:p>
+                      <a:pPr lvl="0" indent="0" marL="0">
+                        <a:buNone/>
+                      </a:pPr>
+                      <a:r>
+                        <a:rPr/>
+                        <a:t>7638.76</a:t>
+                      </a:r>
+                    </a:p>
+                  </a:txBody>
+                </a:tc>
+              </a:tr>
+              <a:tr h="0">
+                <a:tc>
+                  <a:txBody>
+                    <a:bodyPr/>
+                    <a:lstStyle/>
+                    <a:p>
+                      <a:pPr lvl="0" indent="0" marL="0">
+                        <a:buNone/>
+                      </a:pPr>
+                      <a:r>
+                        <a:rPr/>
+                        <a:t>107642</a:t>
+                      </a:r>
+                    </a:p>
+                  </a:txBody>
+                </a:tc>
+                <a:tc>
+                  <a:txBody>
+                    <a:bodyPr/>
+                    <a:lstStyle/>
+                    <a:p>
+                      <a:pPr lvl="0" indent="0" marL="0">
+                        <a:buNone/>
+                      </a:pPr>
+                      <a:r>
+                        <a:rPr/>
+                        <a:t>461</a:t>
+                      </a:r>
+                    </a:p>
+                  </a:txBody>
+                </a:tc>
+                <a:tc>
+                  <a:txBody>
+                    <a:bodyPr/>
+                    <a:lstStyle/>
+                    <a:p>
+                      <a:pPr lvl="0" indent="0" marL="0">
+                        <a:buNone/>
+                      </a:pPr>
+                      <a:r>
+                        <a:rPr/>
+                        <a:t>10.0</a:t>
+                      </a:r>
+                    </a:p>
+                  </a:txBody>
+                </a:tc>
+                <a:tc>
+                  <a:txBody>
+                    <a:bodyPr/>
+                    <a:lstStyle/>
+                    <a:p>
+                      <a:pPr lvl="0" indent="0" marL="0">
+                        <a:buNone/>
+                      </a:pPr>
+                      <a:r>
+                        <a:rPr/>
+                        <a:t>66.5</a:t>
+                      </a:r>
+                    </a:p>
+                  </a:txBody>
+                </a:tc>
+                <a:tc>
+                  <a:txBody>
+                    <a:bodyPr/>
+                    <a:lstStyle/>
+                    <a:p>
+                      <a:pPr lvl="0" indent="0" marL="0">
+                        <a:buNone/>
+                      </a:pPr>
+                      <a:r>
+                        <a:rPr/>
+                        <a:t>565.80</a:t>
+                      </a:r>
+                    </a:p>
+                  </a:txBody>
+                </a:tc>
+                <a:tc>
+                  <a:txBody>
+                    <a:bodyPr/>
+                    <a:lstStyle/>
+                    <a:p>
+                      <a:pPr lvl="0" indent="0" marL="0">
+                        <a:buNone/>
+                      </a:pPr>
+                      <a:r>
+                        <a:rPr/>
+                        <a:t>sugarberry</a:t>
+                      </a:r>
+                    </a:p>
+                  </a:txBody>
+                </a:tc>
+                <a:tc>
+                  <a:txBody>
+                    <a:bodyPr/>
+                    <a:lstStyle/>
+                    <a:p>
+                      <a:pPr lvl="0" indent="0" marL="0">
+                        <a:buNone/>
+                      </a:pPr>
+                      <a:r>
+                        <a:rPr/>
+                        <a:t>5222.893375</a:t>
+                      </a:r>
+                    </a:p>
+                  </a:txBody>
+                </a:tc>
+                <a:tc>
+                  <a:txBody>
+                    <a:bodyPr/>
+                    <a:lstStyle/>
+                    <a:p>
+                      <a:pPr lvl="0" indent="0" marL="0">
+                        <a:buNone/>
+                      </a:pPr>
+                      <a:r>
+                        <a:rPr/>
+                        <a:t>665.00</a:t>
+                      </a:r>
+                    </a:p>
+                  </a:txBody>
+                </a:tc>
+                <a:tc>
+                  <a:txBody>
+                    <a:bodyPr/>
+                    <a:lstStyle/>
+                    <a:p>
+                      <a:pPr lvl="0" indent="0" marL="0">
+                        <a:buNone/>
+                      </a:pPr>
+                      <a:r>
+                        <a:rPr/>
+                        <a:t>4422.25</a:t>
+                      </a:r>
+                    </a:p>
+                  </a:txBody>
+                </a:tc>
+              </a:tr>
+              <a:tr h="0">
+                <a:tc>
+                  <a:txBody>
+                    <a:bodyPr/>
+                    <a:lstStyle/>
+                    <a:p>
+                      <a:pPr lvl="0" indent="0" marL="0">
+                        <a:buNone/>
+                      </a:pPr>
+                      <a:r>
+                        <a:rPr/>
+                        <a:t>107643</a:t>
+                      </a:r>
+                    </a:p>
+                  </a:txBody>
+                </a:tc>
+                <a:tc>
+                  <a:txBody>
+                    <a:bodyPr/>
+                    <a:lstStyle/>
+                    <a:p>
+                      <a:pPr lvl="0" indent="0" marL="0">
+                        <a:buNone/>
+                      </a:pPr>
+                      <a:r>
+                        <a:rPr/>
+                        <a:t>461</a:t>
+                      </a:r>
+                    </a:p>
+                  </a:txBody>
+                </a:tc>
+                <a:tc>
+                  <a:txBody>
+                    <a:bodyPr/>
+                    <a:lstStyle/>
+                    <a:p>
+                      <a:pPr lvl="0" indent="0" marL="0">
+                        <a:buNone/>
+                      </a:pPr>
+                      <a:r>
+                        <a:rPr/>
+                        <a:t>6.2</a:t>
+                      </a:r>
+                    </a:p>
+                  </a:txBody>
+                </a:tc>
+                <a:tc>
+                  <a:txBody>
+                    <a:bodyPr/>
+                    <a:lstStyle/>
+                    <a:p>
+                      <a:pPr lvl="0" indent="0" marL="0">
+                        <a:buNone/>
+                      </a:pPr>
+                      <a:r>
+                        <a:rPr/>
+                        <a:t>54.2</a:t>
+                      </a:r>
+                    </a:p>
+                  </a:txBody>
+                </a:tc>
+                <a:tc>
+                  <a:txBody>
+                    <a:bodyPr/>
+                    <a:lstStyle/>
+                    <a:p>
+                      <a:pPr lvl="0" indent="0" marL="0">
+                        <a:buNone/>
+                      </a:pPr>
+                      <a:r>
+                        <a:rPr/>
+                        <a:t>191.04</a:t>
+                      </a:r>
+                    </a:p>
+                  </a:txBody>
+                </a:tc>
+                <a:tc>
+                  <a:txBody>
+                    <a:bodyPr/>
+                    <a:lstStyle/>
+                    <a:p>
+                      <a:pPr lvl="0" indent="0" marL="0">
+                        <a:buNone/>
+                      </a:pPr>
+                      <a:r>
+                        <a:rPr/>
+                        <a:t>sugarberry</a:t>
+                      </a:r>
+                    </a:p>
+                  </a:txBody>
+                </a:tc>
+                <a:tc>
+                  <a:txBody>
+                    <a:bodyPr/>
+                    <a:lstStyle/>
+                    <a:p>
+                      <a:pPr lvl="0" indent="0" marL="0">
+                        <a:buNone/>
+                      </a:pPr>
+                      <a:r>
+                        <a:rPr/>
+                        <a:t>1636.334851</a:t>
+                      </a:r>
+                    </a:p>
+                  </a:txBody>
+                </a:tc>
+                <a:tc>
+                  <a:txBody>
+                    <a:bodyPr/>
+                    <a:lstStyle/>
+                    <a:p>
+                      <a:pPr lvl="0" indent="0" marL="0">
+                        <a:buNone/>
+                      </a:pPr>
+                      <a:r>
+                        <a:rPr/>
+                        <a:t>336.04</a:t>
+                      </a:r>
+                    </a:p>
+                  </a:txBody>
+                </a:tc>
+                <a:tc>
+                  <a:txBody>
+                    <a:bodyPr/>
+                    <a:lstStyle/>
+                    <a:p>
+                      <a:pPr lvl="0" indent="0" marL="0">
+                        <a:buNone/>
+                      </a:pPr>
+                      <a:r>
+                        <a:rPr/>
+                        <a:t>2937.64</a:t>
+                      </a:r>
+                    </a:p>
+                  </a:txBody>
+                </a:tc>
+              </a:tr>
+              <a:tr h="0">
+                <a:tc>
+                  <a:txBody>
+                    <a:bodyPr/>
+                    <a:lstStyle/>
+                    <a:p>
+                      <a:pPr lvl="0" indent="0" marL="0">
+                        <a:buNone/>
+                      </a:pPr>
+                      <a:r>
+                        <a:rPr/>
+                        <a:t>107644</a:t>
+                      </a:r>
+                    </a:p>
+                  </a:txBody>
+                </a:tc>
+                <a:tc>
+                  <a:txBody>
+                    <a:bodyPr/>
+                    <a:lstStyle/>
+                    <a:p>
+                      <a:pPr lvl="0" indent="0" marL="0">
+                        <a:buNone/>
+                      </a:pPr>
+                      <a:r>
+                        <a:rPr/>
+                        <a:t>461</a:t>
+                      </a:r>
+                    </a:p>
+                  </a:txBody>
+                </a:tc>
+                <a:tc>
+                  <a:txBody>
+                    <a:bodyPr/>
+                    <a:lstStyle/>
+                    <a:p>
+                      <a:pPr lvl="0" indent="0" marL="0">
+                        <a:buNone/>
+                      </a:pPr>
+                      <a:r>
+                        <a:rPr/>
+                        <a:t>16.0</a:t>
+                      </a:r>
+                    </a:p>
+                  </a:txBody>
+                </a:tc>
+                <a:tc>
+                  <a:txBody>
+                    <a:bodyPr/>
+                    <a:lstStyle/>
+                    <a:p>
+                      <a:pPr lvl="0" indent="0" marL="0">
+                        <a:buNone/>
+                      </a:pPr>
+                      <a:r>
+                        <a:rPr/>
+                        <a:t>82.5</a:t>
+                      </a:r>
+                    </a:p>
+                  </a:txBody>
+                </a:tc>
+                <a:tc>
+                  <a:txBody>
+                    <a:bodyPr/>
+                    <a:lstStyle/>
+                    <a:p>
+                      <a:pPr lvl="0" indent="0" marL="0">
+                        <a:buNone/>
+                      </a:pPr>
+                      <a:r>
+                        <a:rPr/>
+                        <a:t>1632.64</a:t>
+                      </a:r>
+                    </a:p>
+                  </a:txBody>
+                </a:tc>
+                <a:tc>
+                  <a:txBody>
+                    <a:bodyPr/>
+                    <a:lstStyle/>
+                    <a:p>
+                      <a:pPr lvl="0" indent="0" marL="0">
+                        <a:buNone/>
+                      </a:pPr>
+                      <a:r>
+                        <a:rPr/>
+                        <a:t>sugarberry</a:t>
+                      </a:r>
+                    </a:p>
+                  </a:txBody>
+                </a:tc>
+                <a:tc>
+                  <a:txBody>
+                    <a:bodyPr/>
+                    <a:lstStyle/>
+                    <a:p>
+                      <a:pPr lvl="0" indent="0" marL="0">
+                        <a:buNone/>
+                      </a:pPr>
+                      <a:r>
+                        <a:rPr/>
+                        <a:t>16587.595200</a:t>
+                      </a:r>
+                    </a:p>
+                  </a:txBody>
+                </a:tc>
+                <a:tc>
+                  <a:txBody>
+                    <a:bodyPr/>
+                    <a:lstStyle/>
+                    <a:p>
+                      <a:pPr lvl="0" indent="0" marL="0">
+                        <a:buNone/>
+                      </a:pPr>
+                      <a:r>
+                        <a:rPr/>
+                        <a:t>1320.00</a:t>
+                      </a:r>
+                    </a:p>
+                  </a:txBody>
+                </a:tc>
+                <a:tc>
+                  <a:txBody>
+                    <a:bodyPr/>
+                    <a:lstStyle/>
+                    <a:p>
+                      <a:pPr lvl="0" indent="0" marL="0">
+                        <a:buNone/>
+                      </a:pPr>
+                      <a:r>
+                        <a:rPr/>
+                        <a:t>6806.25</a:t>
+                      </a:r>
+                    </a:p>
+                  </a:txBody>
+                </a:tc>
+              </a:tr>
+              <a:tr h="0">
+                <a:tc>
+                  <a:txBody>
+                    <a:bodyPr/>
+                    <a:lstStyle/>
+                    <a:p>
+                      <a:pPr lvl="0" indent="0" marL="0">
+                        <a:buNone/>
+                      </a:pPr>
+                      <a:r>
+                        <a:rPr/>
+                        <a:t>107645</a:t>
+                      </a:r>
+                    </a:p>
+                  </a:txBody>
+                </a:tc>
+                <a:tc>
+                  <a:txBody>
+                    <a:bodyPr/>
+                    <a:lstStyle/>
+                    <a:p>
+                      <a:pPr lvl="0" indent="0" marL="0">
+                        <a:buNone/>
+                      </a:pPr>
+                      <a:r>
+                        <a:rPr/>
+                        <a:t>461</a:t>
+                      </a:r>
+                    </a:p>
+                  </a:txBody>
+                </a:tc>
+                <a:tc>
+                  <a:txBody>
+                    <a:bodyPr/>
+                    <a:lstStyle/>
+                    <a:p>
+                      <a:pPr lvl="0" indent="0" marL="0">
+                        <a:buNone/>
+                      </a:pPr>
+                      <a:r>
+                        <a:rPr/>
+                        <a:t>16.7</a:t>
+                      </a:r>
+                    </a:p>
+                  </a:txBody>
+                </a:tc>
+                <a:tc>
+                  <a:txBody>
+                    <a:bodyPr/>
+                    <a:lstStyle/>
+                    <a:p>
+                      <a:pPr lvl="0" indent="0" marL="0">
+                        <a:buNone/>
+                      </a:pPr>
+                      <a:r>
+                        <a:rPr/>
+                        <a:t>76.5</a:t>
+                      </a:r>
+                    </a:p>
+                  </a:txBody>
+                </a:tc>
+                <a:tc>
+                  <a:txBody>
+                    <a:bodyPr/>
+                    <a:lstStyle/>
+                    <a:p>
+                      <a:pPr lvl="0" indent="0" marL="0">
+                        <a:buNone/>
+                      </a:pPr>
+                      <a:r>
+                        <a:rPr/>
+                        <a:t>1644.66</a:t>
+                      </a:r>
+                    </a:p>
+                  </a:txBody>
+                </a:tc>
+                <a:tc>
+                  <a:txBody>
+                    <a:bodyPr/>
+                    <a:lstStyle/>
+                    <a:p>
+                      <a:pPr lvl="0" indent="0" marL="0">
+                        <a:buNone/>
+                      </a:pPr>
+                      <a:r>
+                        <a:rPr/>
+                        <a:t>sugarberry</a:t>
+                      </a:r>
+                    </a:p>
+                  </a:txBody>
+                </a:tc>
+                <a:tc>
+                  <a:txBody>
+                    <a:bodyPr/>
+                    <a:lstStyle/>
+                    <a:p>
+                      <a:pPr lvl="0" indent="0" marL="0">
+                        <a:buNone/>
+                      </a:pPr>
+                      <a:r>
+                        <a:rPr/>
+                        <a:t>16756.522421</a:t>
+                      </a:r>
+                    </a:p>
+                  </a:txBody>
+                </a:tc>
+                <a:tc>
+                  <a:txBody>
+                    <a:bodyPr/>
+                    <a:lstStyle/>
+                    <a:p>
+                      <a:pPr lvl="0" indent="0" marL="0">
+                        <a:buNone/>
+                      </a:pPr>
+                      <a:r>
+                        <a:rPr/>
+                        <a:t>1277.55</a:t>
+                      </a:r>
+                    </a:p>
+                  </a:txBody>
+                </a:tc>
+                <a:tc>
+                  <a:txBody>
+                    <a:bodyPr/>
+                    <a:lstStyle/>
+                    <a:p>
+                      <a:pPr lvl="0" indent="0" marL="0">
+                        <a:buNone/>
+                      </a:pPr>
+                      <a:r>
+                        <a:rPr/>
+                        <a:t>5852.25</a:t>
                       </a:r>
                     </a:p>
                   </a:txBody>
@@ -8771,15 +10718,6 @@
           <a:bodyPr/>
           <a:lstStyle/>
           <a:p>
-            <a:pPr lvl="0" indent="0" marL="0">
-              <a:buNone/>
-            </a:pPr>
-            <a:r>
-              <a:rPr/>
-              <a:t>Height interaction</a:t>
-            </a:r>
-          </a:p>
-          <a:p>
             <a:pPr lvl="0" indent="0">
               <a:buNone/>
             </a:pPr>
@@ -8787,12 +10725,9 @@
               <a:rPr>
                 <a:latin typeface="Courier"/>
               </a:rPr>
-              <a:t>Height squared:
-Average RMSLE for k = 3: 0.5285519115388194
-Height and diameter interaction:
-Average RMSLE for k = 3: 0.8338320265770989
-Volume of cylinder feature:
-Average RMSLE for k = 3: 0.7418555665720403</a:t>
+              <a:t>Height squared average RMSLE: 0.17184054030163723
+Height * diameter interacion average RMSLE: 0.15621420330928676
+Volume feature average RMSLE: 0.1554593982967315</a:t>
             </a:r>
           </a:p>
         </p:txBody>

</xml_diff>

<commit_message>
pushing most updated pptx
</commit_message>
<xml_diff>
--- a/Project-3/presentation.pptx
+++ b/Project-3/presentation.pptx
@@ -11041,6 +11041,36 @@
           </a:p>
         </p:txBody>
       </p:sp>
+      <p:pic>
+        <p:nvPicPr>
+          <p:cNvPr descr="presentation_files/figure-pptx/cell-22-output-1.png" id="0" name="Picture 1"/>
+          <p:cNvPicPr>
+            <a:picLocks noGrp="1" noChangeAspect="1"/>
+          </p:cNvPicPr>
+          <p:nvPr/>
+        </p:nvPicPr>
+        <p:blipFill>
+          <a:blip r:embed="rId2"/>
+          <a:stretch>
+            <a:fillRect/>
+          </a:stretch>
+        </p:blipFill>
+        <p:spPr bwMode="auto">
+          <a:xfrm>
+            <a:off x="1155700" y="1193800"/>
+            <a:ext cx="6832600" cy="3390900"/>
+          </a:xfrm>
+          <a:prstGeom prst="rect">
+            <a:avLst/>
+          </a:prstGeom>
+          <a:noFill/>
+          <a:ln w="9525">
+            <a:noFill/>
+            <a:headEnd/>
+            <a:tailEnd/>
+          </a:ln>
+        </p:spPr>
+      </p:pic>
     </p:spTree>
   </p:cSld>
 </p:sld>

</xml_diff>